<commit_message>
feat(slides): natural Spanish wording pass on every slide, notes and diagram
- no "corrida"/"pasada"/"motor de lago integrado": plain terms throughout
- Quién soy in the speaker's voice; "Lo que anunció AWS" instead of "promete"
- performance and lake slides show RA3 vs RG times with what they mean
- demo explains why query96 is heavy; Kahoot questions reworded
- diagram labels reworded; contenido.md is now generated from the deck

Co-Authored-By: Claude Opus 5.5 <noreply@anthropic.com>
Claude-Session: https://claude.ai/code/session_01HgWRiJoTFne1e49sP1svEg
</commit_message>
<xml_diff>
--- a/slides/redshift-redemption.pptx
+++ b/slides/redshift-redemption.pptx
@@ -1474,10 +1474,10 @@
               <c:strCache>
                 <c:ptCount val="2"/>
                 <c:pt idx="0">
-                  <c:v>COPY store_returns</c:v>
+                  <c:v>Copiar store_returns</c:v>
                 </c:pt>
                 <c:pt idx="1">
-                  <c:v>CTAS pesado</c:v>
+                  <c:v>Tabla resumen (CTAS)</c:v>
                 </c:pt>
               </c:strCache>
             </c:strRef>
@@ -1586,10 +1586,10 @@
               <c:strCache>
                 <c:ptCount val="2"/>
                 <c:pt idx="0">
-                  <c:v>COPY store_returns</c:v>
+                  <c:v>Copiar store_returns</c:v>
                 </c:pt>
                 <c:pt idx="1">
-                  <c:v>CTAS pesado</c:v>
+                  <c:v>Tabla resumen (CTAS)</c:v>
                 </c:pt>
               </c:strCache>
             </c:strRef>
@@ -2740,7 +2740,7 @@
           <a:lstStyle/>
           <a:p>
             <a:r>
-              <a:t>Buenas tardes. Hoy no vengo a contarles lo que dice el anuncio de AWS; vengo a contarles qué pasó cuando lo medí. Ese 1,90x es uno de los números de hoy, y al final van a ver que no es el único que importa.</a:t>
+              <a:t>Buenas tardes. Hoy no vengo a repetir el anuncio de AWS: vengo a contarles qué pasó cuando lo puse a prueba. Ese 1,90 es uno de los resultados, y al final van a ver que no es el único que importa.</a:t>
             </a:r>
           </a:p>
         </p:txBody>
@@ -2810,7 +2810,7 @@
           <a:lstStyle/>
           <a:p>
             <a:r>
-              <a:t>Una VPC propia con enhanced VPC routing y endpoints para S3, Glue, Lake Formation y S3 Tables. RA3 con 2 nodos ra3.xlplus; RG con 2 nodos rg.xlarge restaurado del mismo snapshot, así que los dos clústeres tienen exactamente los mismos datos. El lago en S3: Iceberg y Parquet registrados en Glue. RA3 lee el lago con la flota de Spectrum, fuera de la VPC; RG con su motor integrado, desde la VPC por los endpoints. Las consultas las lanza un runner en Python por la Data API, y la infraestructura la crea GitHub Actions con OIDC, sin llaves guardadas en ningún lado.</a:t>
+              <a:t>Armé una VPC propia, con enhanced VPC routing y endpoints para S3, Glue, Lake Formation y S3 Tables. El clúster RA3 tiene 2 nodos ra3.xlplus, y el RG, 2 nodos rg.xlarge, creado a partir del mismo snapshot: los dos tienen exactamente los mismos datos. El data lake está en S3, con tablas Iceberg y Parquet registradas en Glue. RA3 lee esos datos con Spectrum, que corre fuera de la VPC; RG los lee con sus propios nodos, desde la VPC. Las consultas las lanza un programa en Python a través de la Data API, y la infraestructura la crea GitHub Actions con OIDC, sin claves guardadas en ningún lado.</a:t>
             </a:r>
           </a:p>
         </p:txBody>
@@ -2880,7 +2880,7 @@
           <a:lstStyle/>
           <a:p>
             <a:r>
-              <a:t>Lo más importante es el último punto: el runner revisa cada consulta y si alguna usó la caché de resultados, la corrida entera se descarta. Ninguna se descartó hoy.</a:t>
+              <a:t>Lo más importante es el último punto: el programa revisa cada consulta y, si alguna usó la caché de resultados, descarta la prueba completa. No hubo que descartar ninguna.</a:t>
             </a:r>
           </a:p>
         </p:txBody>
@@ -2950,7 +2950,7 @@
           <a:lstStyle/>
           <a:p>
             <a:r>
-              <a:t>Prefiero decirlo al principio. Con 100 GB los datos calientes caben en buena parte en memoria, y eso reduce la ventaja de RG en escaneos grandes. Si aun así vemos ventaja, es una buena señal; con más datos esperaría que la brecha de scan crezca, pero no lo medí.</a:t>
+              <a:t>Prefiero decirlo desde el principio. Con 100 GB, buena parte de los datos que se consultan cabe en memoria, y eso reduce la ventaja de RG cuando hay que leer mucho. Si aun así RG gana, es buena señal; con más datos esperaría una diferencia mayor, pero eso no lo medí.</a:t>
             </a:r>
           </a:p>
         </p:txBody>
@@ -3020,7 +3020,7 @@
           <a:lstStyle/>
           <a:p>
             <a:r>
-              <a:t>Empecemos por lo que hace todo warehouse: consultas sobre tablas propias.</a:t>
+              <a:t>Empecemos por lo básico de cualquier warehouse: consultas sobre sus propias tablas.</a:t>
             </a:r>
           </a:p>
         </p:txBody>
@@ -3090,7 +3090,7 @@
           <a:lstStyle/>
           <a:p>
             <a:r>
-              <a:t>Veinte consultas, cada una tres veces, la primera de calentamiento. RG fue más rápido en las veinte. La que más ganó, query48, 3,58 veces; la que menos, query57, 1,08 veces. La media geométrica, que es la forma justa de promediar aceleraciones, da 1,90x. En azul las consultas de scan, en naranja las de CPU.</a:t>
+              <a:t>Veinte consultas, cada una repetida tres veces, sin contar la primera. RG fue más rápido en las veinte. La que más mejoró, query48, fue 3,58 veces más rápida; la que menos, query57, 1,08 veces. En promedio, usando la media geométrica, que es la forma correcta de promediar este tipo de comparaciones, RG fue 1,90 veces más rápido. Para el total de las veinte consultas: RA3 tardó 148 segundos y RG, 97. En azul, las consultas que leen y agregan muchos datos; en naranja, las de cálculo pesado.</a:t>
             </a:r>
           </a:p>
         </p:txBody>
@@ -3160,7 +3160,7 @@
           <a:lstStyle/>
           <a:p>
             <a:r>
-              <a:t>Separé las consultas en dos clases antes de correrlas, no después. Las que leen mucho y agregan ganaron 2,28 veces: ahí es donde Graviton y el ancho de banda de memoria brillan. Las de CPU, con funciones de ventana y joins de quince tablas, ganaron 1,58. Si tu warehouse es mayormente dashboards con agregaciones, estás del lado bueno.</a:t>
+              <a:t>Separé las consultas en dos grupos antes de ejecutarlas, no después. Las que leen muchos datos y los agregan mejoraron 2,28 veces: ahí es donde Graviton y el ancho de banda de memoria hacen la diferencia. Las de cálculo pesado, con funciones de ventana y joins de quince tablas, mejoraron 1,58 veces. Si tu warehouse es sobre todo dashboards y reportes con agregaciones, estás en el lado que más gana.</a:t>
             </a:r>
           </a:p>
         </p:txBody>
@@ -3230,7 +3230,7 @@
           <a:lstStyle/>
           <a:p>
             <a:r>
-              <a:t>Cinco usuarios lanzando las mismas veinte consultas en orden aleatorio durante media hora. RG completó 1224 consultas por hora contra 680 de RA3. Ninguno tuvo que encolar consultas.</a:t>
+              <a:t>Simulé cinco usuarios lanzando las mismas veinte consultas, en distinto orden, durante media hora. RG completó 1224 consultas por hora y RA3, 680. En ninguno de los dos hubo consultas en espera.</a:t>
             </a:r>
           </a:p>
         </p:txBody>
@@ -3300,7 +3300,7 @@
           <a:lstStyle/>
           <a:p>
             <a:r>
-              <a:t>La carga inicial la hice una sola vez, en RA3, y RG nació del snapshot. El escenario de ELT repite un COPY y un CTAS en los dos: RG fue 1,5 y 1,6 veces más rápido. Son dos corridas por escenario, así que lo tomo como dirección, no como número exacto.</a:t>
+              <a:t>La carga inicial la hice una sola vez, en RA3, y RG se creó a partir del snapshot. La prueba de transformación repite una copia desde S3 y la creación de una tabla resumen en los dos clústeres: RG fue 1,5 y 1,6 veces más rápido. Cada una se ejecutó dos veces, así que lo tomo como tendencia, no como número exacto.</a:t>
             </a:r>
           </a:p>
         </p:txBody>
@@ -3370,7 +3370,7 @@
           <a:lstStyle/>
           <a:p>
             <a:r>
-              <a:t>Esto es lo que más le interesa a quien paga la factura. No es solo que el nodo sea más barato: como también termina antes, cada corrida cuesta menos de la mitad.</a:t>
+              <a:t>Esto es lo que más le interesa a quien paga la factura. No solo el nodo es más barato: como termina antes, cada ejecución cuesta menos de la mitad.</a:t>
             </a:r>
           </a:p>
         </p:txBody>
@@ -3440,7 +3440,7 @@
           <a:lstStyle/>
           <a:p>
             <a:r>
-              <a:t>Ahora la parte más interesante, y la que más depende de cómo tienes tus datos.</a:t>
+              <a:t>Ahora la parte más interesante, y la que más depende de cómo tienes guardados tus datos.</a:t>
             </a:r>
           </a:p>
         </p:txBody>
@@ -3510,7 +3510,7 @@
           <a:lstStyle/>
           <a:p>
             <a:r>
-              <a:t>Me gusta probar las cosas antes de recomendarlas. Esta charla es eso: un laboratorio que armé esta semana, con su costo y sus errores incluidos.</a:t>
+              <a:t>Me gusta probar las cosas antes de recomendarlas. Esta charla es justamente eso: un laboratorio que armé esta semana, con lo que costó y con los errores que me encontré en el camino.</a:t>
             </a:r>
           </a:p>
         </p:txBody>
@@ -3580,7 +3580,7 @@
           <a:lstStyle/>
           <a:p>
             <a:r>
-              <a:t>Escribí las mismas cinco tablas en Iceberg y en Parquet desde el warehouse, y comprobé que las seis consultas del lago devuelven exactamente las mismas 483 filas en las tres versiones. Así lo único que cambia es cómo se leen.</a:t>
+              <a:t>Escribí las mismas cinco tablas en Iceberg y en Parquet desde el warehouse, y comprobé que las seis consultas devuelven exactamente las mismas 483 filas en las tres versiones. Así, lo único que cambia es la forma de leer los datos.</a:t>
             </a:r>
           </a:p>
         </p:txBody>
@@ -3650,7 +3650,7 @@
           <a:lstStyle/>
           <a:p>
             <a:r>
-              <a:t>RG lee Iceberg casi dos veces más rápido que RA3, pero hay letra chica: la primera vez que RG toca los datos tarda bastante más, porque los trae y los guarda en caché. Mi método descarta la primera pasada, así que este número es con caché caliente. Si tus consultas al lago son esporádicas, cuenta con esa primera lectura.</a:t>
+              <a:t>RG lee Iceberg casi dos veces más rápido que RA3, con una salvedad: la primera vez que toca los datos tarda bastante más, porque los trae de S3 y los guarda en caché. Mi método no cuenta la primera repetición, así que este resultado es con la caché ya cargada. Si consultas el data lake de vez en cuando, ten en cuenta esa primera lectura.</a:t>
             </a:r>
           </a:p>
         </p:txBody>
@@ -3720,7 +3720,7 @@
           <a:lstStyle/>
           <a:p>
             <a:r>
-              <a:t>Este fue el resultado que más me sorprendió. Con Parquet, RG empezó siendo más lento que RA3. Revisé el plan de ejecución: idéntico en los dos. Lo distinto era el formato de los archivos: Redshift los había escrito en solo cuatro archivos enormes, uno por slice, porque el tope por defecto es 6.200 MB. Los reescribí en archivos de medio giga y RG pasó a ganar, mientras que RA3 empeoró. El mismo cambio ayuda a un motor y perjudica al otro.</a:t>
+              <a:t>Este fue el resultado que más me sorprendió. Con Parquet, RG empezó siendo más lento que RA3. Revisé el plan de ejecución y era idéntico en los dos. La diferencia estaba en los archivos: Redshift los había escrito en solo cuatro archivos enormes, uno por slice, porque por defecto cada archivo puede llegar a 6.200 MB. Los reescribí en archivos de medio giga y RG pasó a ganar, mientras que RA3 empeoró. El mismo cambio ayuda a uno y perjudica al otro.</a:t>
             </a:r>
           </a:p>
         </p:txBody>
@@ -3790,7 +3790,7 @@
           <a:lstStyle/>
           <a:p>
             <a:r>
-              <a:t>En nuestro lab son centavos, porque son 100 GB. Pero esto escala con el volumen y con la frecuencia: un equipo que escanea decenas de TB al mes en el lago lo nota en la factura. En RG ese cargo desaparece.</a:t>
+              <a:t>En el laboratorio son centavos, porque son 100 GB. Pero esto crece con el volumen y con la frecuencia: un equipo que lee decenas de TB al mes desde el data lake lo nota en la factura. En RG ese cobro desaparece.</a:t>
             </a:r>
           </a:p>
         </p:txBody>
@@ -3860,7 +3860,7 @@
           <a:lstStyle/>
           <a:p>
             <a:r>
-              <a:t>Quería medir S3 Tables y no pude, por una razón de diseño: las tablas de S3 Tables se leen por el catálogo montado automáticamente, que exige conectarse con identidad IAM, y el runner se conecta con un usuario de base de datos. Cambiar de usuario solo para esa variante habría medido otra ruta de permisos. Iceberg además no acepta CHAR, y Lake Formation exige permisos explícitos sobre las bases de Glue.</a:t>
+              <a:t>Quería probar S3 Tables y no pude, por una razón de diseño: esas tablas solo se leen conectándose con una identidad de IAM, y mi programa se conecta con un usuario de base de datos. Cambiar de usuario solo para esa prueba habría medido otra cosa. Además, Iceberg no acepta columnas CHAR, y Lake Formation exige permisos explícitos sobre las bases de Glue.</a:t>
             </a:r>
           </a:p>
         </p:txBody>
@@ -3930,7 +3930,7 @@
           <a:lstStyle/>
           <a:p>
             <a:r>
-              <a:t>Supongamos que decides migrar. ¿Cuánto duele?</a:t>
+              <a:t>Supongamos que decides migrar. ¿Cuánto cuesta en tiempo y en sustos?</a:t>
             </a:r>
           </a:p>
         </p:txBody>
@@ -4000,7 +4000,7 @@
           <a:lstStyle/>
           <a:p>
             <a:r>
-              <a:t>Restauré una copia de RA3 e hice el elastic resize a RG, probando una escritura cada 30 segundos. El resize empezó a las 19:05:47 y terminó a las 19:08:35. El clúster estuvo en solo lectura entre 1 minuto 35 y 2 minutos 42 segundos; el rango es por el sondeo cada 30 segundos. Con el mapeo 1 a 1 se conserva la cantidad de slices, así que la distribución de los datos no cambió. Ojo: eso vale para 2 nodos a 2 nodos; si cambias la cantidad de nodos, como en el 4 a 3 de los 4xlarge, el skew sí puede aparecer.</a:t>
+              <a:t>Restauré una copia del clúster RA3 y lo convertí a RG con un elastic resize, intentando escribir cada 30 segundos. Empezó a las 19:05:47 y terminó a las 19:08:35. El clúster quedó en solo lectura entre 1 minuto 35 y 2 minutos 42 segundos; el rango se debe a que revisábamos cada 30 segundos. Como pasamos de 2 nodos a 2 nodos, los datos quedaron repartidos igual. Ojo: si cambias la cantidad de nodos, como al pasar de 4 a 3 en el tamaño 4xlarge, el reparto sí puede desbalancearse.</a:t>
             </a:r>
           </a:p>
         </p:txBody>
@@ -4070,7 +4070,7 @@
           <a:lstStyle/>
           <a:p>
             <a:r>
-              <a:t>Las tres primeras me pasaron en el simulacro, en ese orden, y no las encontré en la guía de migración. Las dos últimas sí están en la documentación y en el blog de AWS. Todas quedaron resueltas en el script del repo.</a:t>
+              <a:t>Las tres primeras me pasaron en el simulacro, en ese orden, y no las encontré en la guía de migración. Las dos últimas sí aparecen en la documentación y en el blog de AWS. Todas quedaron resueltas en el script del repositorio.</a:t>
             </a:r>
           </a:p>
         </p:txBody>
@@ -4210,7 +4210,7 @@
           <a:lstStyle/>
           <a:p>
             <a:r>
-              <a:t>Una consulta típica de scan: cuenta ventas filtrando por tres dimensiones, sobre 288 millones de filas en la tabla de hechos. En RA3 tarda 1,77 segundos; en RG, 0,67.</a:t>
+              <a:t>Esta es una consulta típica de lectura: cuenta ventas filtrando por hora del día, por tipo de hogar y por tienda. Lo pesado es que tiene que recorrer las 288 millones de filas de la tabla de ventas y cruzarlas con tres tablas más. En RA3 tarda 1,77 segundos; en RG, 0,67.</a:t>
             </a:r>
           </a:p>
         </p:txBody>
@@ -4280,7 +4280,7 @@
           <a:lstStyle/>
           <a:p>
             <a:r>
-              <a:t>Cinco temas y una demo. Al final, una respuesta concreta a la pregunta del título, y tres preguntas de Kahoot.</a:t>
+              <a:t>Cinco temas y una demo. Al final les doy una respuesta concreta a la pregunta del título, y cerramos con tres preguntas de Kahoot.</a:t>
             </a:r>
           </a:p>
         </p:txBody>
@@ -4350,7 +4350,7 @@
           <a:lstStyle/>
           <a:p>
             <a:r>
-              <a:t>Así diagnostiqué el caso de Parquet. Si los planes fueran distintos, la diferencia sería el plan y no el motor. Son iguales; cambia el operador que lee S3. Cuando veas una diferencia rara entre clústeres, empieza por aquí.</a:t>
+              <a:t>Así encontré la explicación del caso de Parquet. Si los planes fueran distintos, la diferencia estaría en el plan y no en el clúster. Son iguales: lo único que cambia es la pieza que lee S3, Spectrum en RA3 y los propios nodos en RG. Cuando veas una diferencia rara entre dos clústeres, empieza por aquí.</a:t>
             </a:r>
           </a:p>
         </p:txBody>
@@ -4420,7 +4420,7 @@
           <a:lstStyle/>
           <a:p>
             <a:r>
-              <a:t>Esta página tiene todos los números de la charla, sacados directamente de los archivos del repo. La voy a abrir un momento para que vean cada consulta. Abrir: https://claude.ai/artifact/1MgMakVPq4URRXQMZp4aVk (privada, con la sesión del orador; copia local: slides/demo/resultados.html).</a:t>
+              <a:t>Esta página reúne todos los números de la charla, sacados directamente de los archivos del repositorio. La abro un momento para que vean cada consulta. Abrir: https://claude.ai/artifact/1MgMakVPq4URRXQMZp4aVk (privada, con la sesión del orador; copia local: slides/demo/resultados.html).</a:t>
             </a:r>
           </a:p>
         </p:txBody>
@@ -4490,7 +4490,7 @@
           <a:lstStyle/>
           <a:p>
             <a:r>
-              <a:t>Esta es mi respuesta a la pregunta del título. Para la mayoría de los equipos con RA3 la migración conviene: es más rápida y más barata, y el resize toma minutos. Pero prueba con tus datos, sobre todo si tu lago es Parquet o tu carga es de CPU. Serverless es otra decisión, sobre la forma de tu uso, y no la medí, así que no te doy un número.</a:t>
+              <a:t>Esta es mi respuesta a la pregunta del título. Para la mayoría de los equipos con RA3, migrar conviene: es más rápido, más barato y el cambio toma minutos. Pero prueba primero con tus datos, sobre todo si tu data lake está en Parquet o si tus consultas son de cálculo pesado. Serverless es otra decisión, que depende de cómo usas Redshift, y como no lo medí, no les doy un número.</a:t>
             </a:r>
           </a:p>
         </p:txBody>
@@ -4560,7 +4560,7 @@
           <a:lstStyle/>
           <a:p>
             <a:r>
-              <a:t>Todo lo que vieron está en el repo: la infraestructura, el runner, el runbook con cada paso y los errores que encontré. Cámbiale el dataset por el tuyo y repite las mediciones.</a:t>
+              <a:t>Todo lo que vieron está en el repositorio: la infraestructura, el programa que lanza las pruebas, el runbook con cada paso y los errores que me encontré. Cámbienle el dataset por el suyo y repitan las mediciones.</a:t>
             </a:r>
           </a:p>
         </p:txBody>
@@ -4630,7 +4630,7 @@
           <a:lstStyle/>
           <a:p>
             <a:r>
-              <a:t>Kahoot. 1) Con qué leen el lago los RG: b) un motor de lago integrado en el propio clúster (a Spectrum, c Athena, d Glue ETL). RA3 usa Spectrum, que cobra USD 5 por TB. 2) Qué consultas ganaron más: b) las de scan y agregación (a CPU, c ninguna, d solo lago). Scan 2,28x frente a CPU 1,58x. 3) 4 ra3.4xlarge a cuántos rg.4xlarge: b) 3 (a 4, c 2, d 8). 4 × 12 vCPU = 3 × 16 vCPU = 48.</a:t>
+              <a:t>Kahoot. Pregunta 1: ¿Con qué lee RG los datos del data lake? a) Redshift Spectrum; b) Con sus propios nodos, sin Spectrum (correcta); c) Amazon Athena; d) Trabajos de AWS Glue. Comentario: RA3 usa Spectrum, que cobra USD 5 por TB leído; RG lee el lago con sus nodos y sin ese cobro. Pregunta 2: ¿Qué tipo de consultas mejoró más al pasar de RA3 a RG? a) Las de cálculo pesado, con ventanas y joins grandes; b) Las que leen y agregan muchos datos (correcta); c) Ninguna, quedaron igual; d) Solo las del data lake. Comentario: 2,28 veces en lectura contra 1,58 en cálculo; el promedio de las 20 consultas fue 1,90. Pregunta 3: Si tienes 4 nodos ra3.4xlarge, ¿cuántos rg.4xlarge recomienda AWS? a) 4; b) 3 (correcta); c) 2; d) 8. Comentario: un ra3.4xlarge tiene 12 vCPU y un rg.4xlarge, 16; 4 por 12 y 3 por 16 dan 48. Migrar uno a uno en ese tamaño te deja con un tercio de capacidad de más.</a:t>
             </a:r>
           </a:p>
         </p:txBody>
@@ -4700,7 +4700,7 @@
           <a:lstStyle/>
           <a:p>
             <a:r>
-              <a:t>Gracias. Respondo preguntas en el chat. Si preguntan por Snowflake u otras plataformas: trabajo con varias y son buenas respuestas a contextos distintos; hoy vine a medir la decisión que los equipos nativos de AWS ya tienen enfrente: RA3 o RG.</a:t>
+              <a:t>Gracias. Respondo preguntas en el chat. Si alguien pregunta por Snowflake u otras plataformas: trabajo con varias y son buenas respuestas para contextos distintos; hoy vine a medir la decisión que ya tienen enfrente los equipos que usan AWS: RA3 o RG.</a:t>
             </a:r>
           </a:p>
         </p:txBody>
@@ -4770,7 +4770,7 @@
           <a:lstStyle/>
           <a:p>
             <a:r>
-              <a:t>La idea no es desmentir a nadie. AWS publica sus números; nosotros los verificamos en el tamaño de clúster que la mayoría opera. Cuando se cumplen, lo decimos; cuando dependen de algo, explicamos de qué.</a:t>
+              <a:t>La idea no es desmentir a nadie. AWS publicó sus números y yo los revisé en un clúster chico, como el que tienen muchos equipos. Donde se cumplen, lo digo; donde dependen de algo, les explico de qué.</a:t>
             </a:r>
           </a:p>
         </p:txBody>
@@ -4910,7 +4910,7 @@
           <a:lstStyle/>
           <a:p>
             <a:r>
-              <a:t>Esto es importante para entender los resultados del lago: cuando comparamos RA3 con RG en el lago no comparamos solo procesadores, comparamos dos motores distintos. Por eso siempre hablo de motor más chip y nunca de solo el chip. Fuente: documentación de Redshift, Amazon Redshift provisioned clusters.</a:t>
+              <a:t>Esto es clave para entender los resultados del data lake: cuando comparamos RA3 con RG ahí, no comparamos solo procesadores, comparamos dos formas distintas de leer S3. Por eso hablo del chip y de cómo se leen los datos, nunca del chip solo. Fuente: documentación de Redshift, Amazon Redshift provisioned clusters.</a:t>
             </a:r>
           </a:p>
         </p:txBody>
@@ -4980,7 +4980,7 @@
           <a:lstStyle/>
           <a:p>
             <a:r>
-              <a:t>El 30 % por vCPU se cumple al centavo: 1,086 entre 4 vCPU contra 0,7602 entre 4. Ojo con el 4xlarge: un ra3.4xlarge tiene 12 vCPU y un rg.4xlarge tiene 16. AWS recomienda pasar 4 nodos RA3 a 3 nodos RG; si migras 1 a 1 en ese tamaño compras un tercio más de capacidad de la que tenías.</a:t>
+              <a:t>El 30 % por vCPU se cumple al centavo: 1,086 dividido entre 4 vCPU contra 0,7602 entre 4. Ojo con el tamaño 4xlarge: un ra3.4xlarge tiene 12 vCPU y un rg.4xlarge tiene 16, por eso AWS recomienda pasar de 4 nodos a 3. Si migras uno a uno en ese tamaño, terminas pagando un tercio más de capacidad de la que tenías.</a:t>
             </a:r>
           </a:p>
         </p:txBody>
@@ -5050,7 +5050,7 @@
           <a:lstStyle/>
           <a:p>
             <a:r>
-              <a:t>Estas son las cuatro promesas que vamos a probar. Fíjense en el pie: AWS midió 10 TB en nodos 4xlarge. Yo medí el clúster que la mayoría de los equipos opera de verdad.</a:t>
+              <a:t>Estos son los cuatro números del anuncio, y son los que vamos a revisar. Fíjense en la última línea: AWS midió 10 TB en nodos grandes. Yo medí un clúster chico, más parecido al que tienen muchos equipos.</a:t>
             </a:r>
           </a:p>
         </p:txBody>
@@ -5120,7 +5120,7 @@
           <a:lstStyle/>
           <a:p>
             <a:r>
-              <a:t>Antes de mostrar un solo número, cómo lo obtuve, porque un benchmark sin método es una opinión con decimales.</a:t>
+              <a:t>Antes de mostrar un solo número, les cuento cómo lo obtuve, porque una comparación sin método es solo una opinión con decimales.</a:t>
             </a:r>
           </a:p>
         </p:txBody>
@@ -8537,7 +8537,7 @@
                 </a:solidFill>
                 <a:latin typeface="Arial"/>
               </a:rPr>
-              <a:t>Andrés Zeballos · Solutions Architect, phData</a:t>
+              <a:t>Andrés Zeballos · Solutions Architect en phData</a:t>
             </a:r>
           </a:p>
           <a:p>
@@ -8553,7 +8553,7 @@
                 </a:solidFill>
                 <a:latin typeface="Arial"/>
               </a:rPr>
-              <a:t>100 GB TPC-DS · RA3 frente a RG · 2026-10-05</a:t>
+              <a:t>Medido con 100 GB de TPC-DS · octubre de 2026</a:t>
             </a:r>
           </a:p>
         </p:txBody>
@@ -8631,7 +8631,7 @@
                 </a:solidFill>
                 <a:latin typeface="Arial"/>
               </a:rPr>
-              <a:t>más rápido en nuestro lab (media de 20 consultas)</a:t>
+              <a:t>más rápido, en promedio, en nuestras pruebas</a:t>
             </a:r>
           </a:p>
         </p:txBody>
@@ -9187,7 +9187,7 @@
                 <a:cs typeface="Raleway 1 Heavy"/>
                 <a:sym typeface="Raleway 1 Heavy"/>
               </a:rPr>
-              <a:t>Un método justo</a:t>
+              <a:t>Una comparación justa</a:t>
             </a:r>
           </a:p>
         </p:txBody>
@@ -9481,7 +9481,7 @@
         <p:spPr>
           <a:xfrm>
             <a:off x="914400" y="3200400"/>
-            <a:ext cx="14264640" cy="5303520"/>
+            <a:ext cx="13898880" cy="5303520"/>
           </a:xfrm>
           <a:prstGeom prst="rect">
             <a:avLst/>
@@ -9501,13 +9501,13 @@
               <a:buChar char="•"/>
             </a:pPr>
             <a:r>
-              <a:rPr sz="2600" b="0">
+              <a:rPr sz="2500" b="0">
                 <a:solidFill>
                   <a:srgbClr val="D9E2EC"/>
                 </a:solidFill>
                 <a:latin typeface="Arial"/>
               </a:rPr>
-              <a:t>Mismo snapshot y misma versión de Redshift (1.0.434008) en los dos clústeres</a:t>
+              <a:t>Los dos clústeres arrancan del mismo snapshot y con la misma versión de Redshift (1.0.434008)</a:t>
             </a:r>
           </a:p>
           <a:p>
@@ -9518,13 +9518,13 @@
               <a:buChar char="•"/>
             </a:pPr>
             <a:r>
-              <a:rPr sz="2600" b="0">
+              <a:rPr sz="2500" b="0">
                 <a:solidFill>
                   <a:srgbClr val="D9E2EC"/>
                 </a:solidFill>
                 <a:latin typeface="Arial"/>
               </a:rPr>
-              <a:t>Caché de resultados apagada y escalado de concurrencia en 0</a:t>
+              <a:t>Sin caché de resultados y sin escalado automático de concurrencia</a:t>
             </a:r>
           </a:p>
           <a:p>
@@ -9535,13 +9535,13 @@
               <a:buChar char="•"/>
             </a:pPr>
             <a:r>
-              <a:rPr sz="2600" b="0">
+              <a:rPr sz="2500" b="0">
                 <a:solidFill>
                   <a:srgbClr val="D9E2EC"/>
                 </a:solidFill>
                 <a:latin typeface="Arial"/>
               </a:rPr>
-              <a:t>Tiempos medidos en el servidor (SYS_QUERY_HISTORY), no en mi laptop</a:t>
+              <a:t>Los tiempos los mide Redshift (SYS_QUERY_HISTORY), no mi computadora</a:t>
             </a:r>
           </a:p>
           <a:p>
@@ -9552,13 +9552,13 @@
               <a:buChar char="•"/>
             </a:pPr>
             <a:r>
-              <a:rPr sz="2600" b="0">
+              <a:rPr sz="2500" b="0">
                 <a:solidFill>
                   <a:srgbClr val="D9E2EC"/>
                 </a:solidFill>
                 <a:latin typeface="Arial"/>
               </a:rPr>
-              <a:t>Mediana por consulta, sin la pasada de calentamiento</a:t>
+              <a:t>Cada consulta se repite tres veces: la primera no cuenta y nos quedamos con la mediana</a:t>
             </a:r>
           </a:p>
           <a:p>
@@ -9569,13 +9569,13 @@
               <a:buChar char="•"/>
             </a:pPr>
             <a:r>
-              <a:rPr sz="2600" b="1">
+              <a:rPr sz="2500" b="1">
                 <a:solidFill>
                   <a:srgbClr val="D9E2EC"/>
                 </a:solidFill>
                 <a:latin typeface="Arial"/>
               </a:rPr>
-              <a:t>Una corrida con caché o escalado se invalida sola y no se reporta. Hoy: ninguna.</a:t>
+              <a:t>Si alguna consulta usa la caché, la prueba entera se descarta. En este laboratorio no se descartó ninguna.</a:t>
             </a:r>
           </a:p>
         </p:txBody>
@@ -9701,7 +9701,7 @@
                 <a:cs typeface="Raleway 1 Heavy"/>
                 <a:sym typeface="Raleway 1 Heavy"/>
               </a:rPr>
-              <a:t>Lo que no medimos</a:t>
+              <a:t>Lo que no probamos</a:t>
             </a:r>
           </a:p>
         </p:txBody>
@@ -10056,7 +10056,7 @@
                 </a:solidFill>
                 <a:latin typeface="Arial"/>
               </a:rPr>
-              <a:t>Con este volumen pesan más los costos fijos de cada consulta</a:t>
+              <a:t>Con pocos datos, el costo fijo de cada consulta pesa más</a:t>
             </a:r>
           </a:p>
         </p:txBody>
@@ -10115,7 +10115,7 @@
                 </a:solidFill>
                 <a:latin typeface="Arial"/>
               </a:rPr>
-              <a:t>2 nodos xlarge</a:t>
+              <a:t>Solo el tamaño xlarge</a:t>
             </a:r>
           </a:p>
           <a:p>
@@ -10131,7 +10131,7 @@
                 </a:solidFill>
                 <a:latin typeface="Arial"/>
               </a:rPr>
-              <a:t>No medimos 4xlarge ni 12xlarge</a:t>
+              <a:t>No probamos 4xlarge ni 12xlarge</a:t>
             </a:r>
           </a:p>
         </p:txBody>
@@ -10190,7 +10190,7 @@
                 </a:solidFill>
                 <a:latin typeface="Arial"/>
               </a:rPr>
-              <a:t>Sin Serverless</a:t>
+              <a:t>Serverless</a:t>
             </a:r>
           </a:p>
           <a:p>
@@ -10206,7 +10206,7 @@
                 </a:solidFill>
                 <a:latin typeface="Arial"/>
               </a:rPr>
-              <a:t>Lo vemos solo con documentación y precios</a:t>
+              <a:t>Lo comentamos con precios y documentación, sin pruebas propias</a:t>
             </a:r>
           </a:p>
         </p:txBody>
@@ -10265,7 +10265,7 @@
                 </a:solidFill>
                 <a:latin typeface="Arial"/>
               </a:rPr>
-              <a:t>Sin S3 Tables</a:t>
+              <a:t>S3 Tables</a:t>
             </a:r>
           </a:p>
           <a:p>
@@ -10281,7 +10281,7 @@
                 </a:solidFill>
                 <a:latin typeface="Arial"/>
               </a:rPr>
-              <a:t>Más adelante, el porqué</a:t>
+              <a:t>No lo pudimos probar; más adelante les cuento por qué</a:t>
             </a:r>
           </a:p>
         </p:txBody>
@@ -10829,7 +10829,7 @@
                 <a:cs typeface="Raleway 1 Heavy"/>
                 <a:sym typeface="Raleway 1 Heavy"/>
               </a:rPr>
-              <a:t>1,90x más rápido</a:t>
+              <a:t>RG fue 1,90x más rápido</a:t>
             </a:r>
           </a:p>
         </p:txBody>
@@ -11124,7 +11124,7 @@
         </p:nvGraphicFramePr>
         <p:xfrm>
           <a:off x="822960" y="3108960"/>
-          <a:ext cx="9692640" cy="5669280"/>
+          <a:ext cx="9326880" cy="5669280"/>
         </p:xfrm>
         <a:graphic>
           <a:graphicData uri="http://schemas.openxmlformats.org/drawingml/2006/chart">
@@ -11140,8 +11140,8 @@
         </p:nvSpPr>
         <p:spPr>
           <a:xfrm>
-            <a:off x="10241280" y="3291840"/>
-            <a:ext cx="5120640" cy="457200"/>
+            <a:off x="10149840" y="3246120"/>
+            <a:ext cx="5303520" cy="822960"/>
           </a:xfrm>
           <a:prstGeom prst="rect">
             <a:avLst/>
@@ -11160,22 +11160,33 @@
               </a:spcAft>
             </a:pPr>
             <a:r>
-              <a:rPr sz="2000" b="0">
+              <a:rPr sz="1700" b="0">
+                <a:solidFill>
+                  <a:srgbClr val="D9E2EC"/>
+                </a:solidFill>
+                <a:latin typeface="Arial"/>
+              </a:rPr>
+              <a:t>Cuántas veces más rápido fue RG en cada consulta</a:t>
+            </a:r>
+          </a:p>
+          <a:p>
+            <a:r>
+              <a:rPr sz="1700" b="0">
                 <a:solidFill>
                   <a:srgbClr val="316CE3"/>
                 </a:solidFill>
                 <a:latin typeface="Arial"/>
               </a:rPr>
-              <a:t>■ scan</a:t>
-            </a:r>
-            <a:r>
-              <a:rPr sz="2000" b="0">
+              <a:t>■ lectura   </a:t>
+            </a:r>
+            <a:r>
+              <a:rPr sz="1700" b="0">
                 <a:solidFill>
                   <a:srgbClr val="F2A65A"/>
                 </a:solidFill>
                 <a:latin typeface="Arial"/>
               </a:rPr>
-              <a:t>     ■ cpu</a:t>
+              <a:t>■ cálculo</a:t>
             </a:r>
           </a:p>
         </p:txBody>
@@ -11188,8 +11199,8 @@
         </p:nvSpPr>
         <p:spPr>
           <a:xfrm>
-            <a:off x="10241280" y="3931920"/>
-            <a:ext cx="5120640" cy="1280160"/>
+            <a:off x="10149840" y="4343400"/>
+            <a:ext cx="5303520" cy="457200"/>
           </a:xfrm>
           <a:prstGeom prst="rect">
             <a:avLst/>
@@ -11197,7 +11208,7 @@
           <a:noFill/>
         </p:spPr>
         <p:txBody>
-          <a:bodyPr wrap="square" anchor="b" lIns="0" rIns="0" tIns="0" bIns="0">
+          <a:bodyPr wrap="square" anchor="t" lIns="0" rIns="0" tIns="0" bIns="0">
             <a:spAutoFit/>
           </a:bodyPr>
           <a:lstStyle/>
@@ -11208,13 +11219,13 @@
               </a:spcAft>
             </a:pPr>
             <a:r>
-              <a:rPr sz="4000" b="1">
-                <a:solidFill>
-                  <a:srgbClr val="FFFFFF"/>
+              <a:rPr sz="2000" b="0">
+                <a:solidFill>
+                  <a:srgbClr val="D9E2EC"/>
                 </a:solidFill>
                 <a:latin typeface="Arial"/>
               </a:rPr>
-              <a:t>148,3 → 96,7 s</a:t>
+              <a:t>Tiempo total de las 20 consultas</a:t>
             </a:r>
           </a:p>
         </p:txBody>
@@ -11227,8 +11238,8 @@
         </p:nvSpPr>
         <p:spPr>
           <a:xfrm>
-            <a:off x="10241280" y="5303520"/>
-            <a:ext cx="5120640" cy="1097280"/>
+            <a:off x="10149840" y="4846320"/>
+            <a:ext cx="2651760" cy="914400"/>
           </a:xfrm>
           <a:prstGeom prst="rect">
             <a:avLst/>
@@ -11247,13 +11258,13 @@
               </a:spcAft>
             </a:pPr>
             <a:r>
-              <a:rPr sz="2200" b="0">
-                <a:solidFill>
-                  <a:srgbClr val="D9E2EC"/>
+              <a:rPr sz="4000" b="1">
+                <a:solidFill>
+                  <a:srgbClr val="8FA3B8"/>
                 </a:solidFill>
                 <a:latin typeface="Arial"/>
               </a:rPr>
-              <a:t>tiempo total de las 20 consultas</a:t>
+              <a:t>148,3 s</a:t>
             </a:r>
           </a:p>
         </p:txBody>
@@ -11266,8 +11277,8 @@
         </p:nvSpPr>
         <p:spPr>
           <a:xfrm>
-            <a:off x="10241280" y="6309360"/>
-            <a:ext cx="5120640" cy="1280160"/>
+            <a:off x="12801600" y="4846320"/>
+            <a:ext cx="2651760" cy="914400"/>
           </a:xfrm>
           <a:prstGeom prst="rect">
             <a:avLst/>
@@ -11275,7 +11286,7 @@
           <a:noFill/>
         </p:spPr>
         <p:txBody>
-          <a:bodyPr wrap="square" anchor="b" lIns="0" rIns="0" tIns="0" bIns="0">
+          <a:bodyPr wrap="square" anchor="t" lIns="0" rIns="0" tIns="0" bIns="0">
             <a:spAutoFit/>
           </a:bodyPr>
           <a:lstStyle/>
@@ -11288,11 +11299,11 @@
             <a:r>
               <a:rPr sz="4000" b="1">
                 <a:solidFill>
-                  <a:srgbClr val="FFFFFF"/>
+                  <a:srgbClr val="316CE3"/>
                 </a:solidFill>
                 <a:latin typeface="Arial"/>
               </a:rPr>
-              <a:t>1,65 → 0,58 s</a:t>
+              <a:t>96,7 s</a:t>
             </a:r>
           </a:p>
         </p:txBody>
@@ -11305,8 +11316,8 @@
         </p:nvSpPr>
         <p:spPr>
           <a:xfrm>
-            <a:off x="10241280" y="7680960"/>
-            <a:ext cx="5120640" cy="1097280"/>
+            <a:off x="10149840" y="5623560"/>
+            <a:ext cx="2651760" cy="457200"/>
           </a:xfrm>
           <a:prstGeom prst="rect">
             <a:avLst/>
@@ -11325,13 +11336,286 @@
               </a:spcAft>
             </a:pPr>
             <a:r>
-              <a:rPr sz="2200" b="0">
+              <a:rPr sz="1800" b="0">
+                <a:solidFill>
+                  <a:srgbClr val="8FA3B8"/>
+                </a:solidFill>
+                <a:latin typeface="Arial"/>
+              </a:rPr>
+              <a:t>RA3</a:t>
+            </a:r>
+          </a:p>
+        </p:txBody>
+      </p:sp>
+      <p:sp>
+        <p:nvSpPr>
+          <p:cNvPr id="16" name="TextBox 15"/>
+          <p:cNvSpPr txBox="1"/>
+          <p:nvPr/>
+        </p:nvSpPr>
+        <p:spPr>
+          <a:xfrm>
+            <a:off x="12801600" y="5623560"/>
+            <a:ext cx="2651760" cy="457200"/>
+          </a:xfrm>
+          <a:prstGeom prst="rect">
+            <a:avLst/>
+          </a:prstGeom>
+          <a:noFill/>
+        </p:spPr>
+        <p:txBody>
+          <a:bodyPr wrap="square" anchor="t" lIns="0" rIns="0" tIns="0" bIns="0">
+            <a:spAutoFit/>
+          </a:bodyPr>
+          <a:lstStyle/>
+          <a:p>
+            <a:pPr algn="l">
+              <a:spcAft>
+                <a:spcPts val="1000"/>
+              </a:spcAft>
+            </a:pPr>
+            <a:r>
+              <a:rPr sz="1800" b="0">
+                <a:solidFill>
+                  <a:srgbClr val="316CE3"/>
+                </a:solidFill>
+                <a:latin typeface="Arial"/>
+              </a:rPr>
+              <a:t>RG</a:t>
+            </a:r>
+          </a:p>
+        </p:txBody>
+      </p:sp>
+      <p:sp>
+        <p:nvSpPr>
+          <p:cNvPr id="17" name="TextBox 16"/>
+          <p:cNvSpPr txBox="1"/>
+          <p:nvPr/>
+        </p:nvSpPr>
+        <p:spPr>
+          <a:xfrm>
+            <a:off x="10149840" y="6035040"/>
+            <a:ext cx="5303520" cy="457200"/>
+          </a:xfrm>
+          <a:prstGeom prst="rect">
+            <a:avLst/>
+          </a:prstGeom>
+          <a:noFill/>
+        </p:spPr>
+        <p:txBody>
+          <a:bodyPr wrap="square" anchor="t" lIns="0" rIns="0" tIns="0" bIns="0">
+            <a:spAutoFit/>
+          </a:bodyPr>
+          <a:lstStyle/>
+          <a:p>
+            <a:pPr algn="l">
+              <a:spcAft>
+                <a:spcPts val="1000"/>
+              </a:spcAft>
+            </a:pPr>
+            <a:r>
+              <a:rPr sz="1600" b="0">
+                <a:solidFill>
+                  <a:srgbClr val="9FB3C8"/>
+                </a:solidFill>
+                <a:latin typeface="Arial"/>
+              </a:rPr>
+              <a:t>menos tiempo es mejor</a:t>
+            </a:r>
+          </a:p>
+        </p:txBody>
+      </p:sp>
+      <p:sp>
+        <p:nvSpPr>
+          <p:cNvPr id="18" name="TextBox 17"/>
+          <p:cNvSpPr txBox="1"/>
+          <p:nvPr/>
+        </p:nvSpPr>
+        <p:spPr>
+          <a:xfrm>
+            <a:off x="10149840" y="6629400"/>
+            <a:ext cx="5303520" cy="457200"/>
+          </a:xfrm>
+          <a:prstGeom prst="rect">
+            <a:avLst/>
+          </a:prstGeom>
+          <a:noFill/>
+        </p:spPr>
+        <p:txBody>
+          <a:bodyPr wrap="square" anchor="t" lIns="0" rIns="0" tIns="0" bIns="0">
+            <a:spAutoFit/>
+          </a:bodyPr>
+          <a:lstStyle/>
+          <a:p>
+            <a:pPr algn="l">
+              <a:spcAft>
+                <a:spcPts val="1000"/>
+              </a:spcAft>
+            </a:pPr>
+            <a:r>
+              <a:rPr sz="2000" b="0">
                 <a:solidFill>
                   <a:srgbClr val="D9E2EC"/>
                 </a:solidFill>
                 <a:latin typeface="Arial"/>
               </a:rPr>
-              <a:t>mediana (p50) por consulta</a:t>
+              <a:t>Una consulta típica (mediana)</a:t>
+            </a:r>
+          </a:p>
+        </p:txBody>
+      </p:sp>
+      <p:sp>
+        <p:nvSpPr>
+          <p:cNvPr id="19" name="TextBox 18"/>
+          <p:cNvSpPr txBox="1"/>
+          <p:nvPr/>
+        </p:nvSpPr>
+        <p:spPr>
+          <a:xfrm>
+            <a:off x="10149840" y="7132320"/>
+            <a:ext cx="2651760" cy="914400"/>
+          </a:xfrm>
+          <a:prstGeom prst="rect">
+            <a:avLst/>
+          </a:prstGeom>
+          <a:noFill/>
+        </p:spPr>
+        <p:txBody>
+          <a:bodyPr wrap="square" anchor="t" lIns="0" rIns="0" tIns="0" bIns="0">
+            <a:spAutoFit/>
+          </a:bodyPr>
+          <a:lstStyle/>
+          <a:p>
+            <a:pPr algn="l">
+              <a:spcAft>
+                <a:spcPts val="1000"/>
+              </a:spcAft>
+            </a:pPr>
+            <a:r>
+              <a:rPr sz="4000" b="1">
+                <a:solidFill>
+                  <a:srgbClr val="8FA3B8"/>
+                </a:solidFill>
+                <a:latin typeface="Arial"/>
+              </a:rPr>
+              <a:t>1,65 s</a:t>
+            </a:r>
+          </a:p>
+        </p:txBody>
+      </p:sp>
+      <p:sp>
+        <p:nvSpPr>
+          <p:cNvPr id="20" name="TextBox 19"/>
+          <p:cNvSpPr txBox="1"/>
+          <p:nvPr/>
+        </p:nvSpPr>
+        <p:spPr>
+          <a:xfrm>
+            <a:off x="12801600" y="7132320"/>
+            <a:ext cx="2651760" cy="914400"/>
+          </a:xfrm>
+          <a:prstGeom prst="rect">
+            <a:avLst/>
+          </a:prstGeom>
+          <a:noFill/>
+        </p:spPr>
+        <p:txBody>
+          <a:bodyPr wrap="square" anchor="t" lIns="0" rIns="0" tIns="0" bIns="0">
+            <a:spAutoFit/>
+          </a:bodyPr>
+          <a:lstStyle/>
+          <a:p>
+            <a:pPr algn="l">
+              <a:spcAft>
+                <a:spcPts val="1000"/>
+              </a:spcAft>
+            </a:pPr>
+            <a:r>
+              <a:rPr sz="4000" b="1">
+                <a:solidFill>
+                  <a:srgbClr val="316CE3"/>
+                </a:solidFill>
+                <a:latin typeface="Arial"/>
+              </a:rPr>
+              <a:t>0,58 s</a:t>
+            </a:r>
+          </a:p>
+        </p:txBody>
+      </p:sp>
+      <p:sp>
+        <p:nvSpPr>
+          <p:cNvPr id="21" name="TextBox 20"/>
+          <p:cNvSpPr txBox="1"/>
+          <p:nvPr/>
+        </p:nvSpPr>
+        <p:spPr>
+          <a:xfrm>
+            <a:off x="10149840" y="7909560"/>
+            <a:ext cx="2651760" cy="457200"/>
+          </a:xfrm>
+          <a:prstGeom prst="rect">
+            <a:avLst/>
+          </a:prstGeom>
+          <a:noFill/>
+        </p:spPr>
+        <p:txBody>
+          <a:bodyPr wrap="square" anchor="t" lIns="0" rIns="0" tIns="0" bIns="0">
+            <a:spAutoFit/>
+          </a:bodyPr>
+          <a:lstStyle/>
+          <a:p>
+            <a:pPr algn="l">
+              <a:spcAft>
+                <a:spcPts val="1000"/>
+              </a:spcAft>
+            </a:pPr>
+            <a:r>
+              <a:rPr sz="1800" b="0">
+                <a:solidFill>
+                  <a:srgbClr val="8FA3B8"/>
+                </a:solidFill>
+                <a:latin typeface="Arial"/>
+              </a:rPr>
+              <a:t>RA3</a:t>
+            </a:r>
+          </a:p>
+        </p:txBody>
+      </p:sp>
+      <p:sp>
+        <p:nvSpPr>
+          <p:cNvPr id="22" name="TextBox 21"/>
+          <p:cNvSpPr txBox="1"/>
+          <p:nvPr/>
+        </p:nvSpPr>
+        <p:spPr>
+          <a:xfrm>
+            <a:off x="12801600" y="7909560"/>
+            <a:ext cx="2651760" cy="457200"/>
+          </a:xfrm>
+          <a:prstGeom prst="rect">
+            <a:avLst/>
+          </a:prstGeom>
+          <a:noFill/>
+        </p:spPr>
+        <p:txBody>
+          <a:bodyPr wrap="square" anchor="t" lIns="0" rIns="0" tIns="0" bIns="0">
+            <a:spAutoFit/>
+          </a:bodyPr>
+          <a:lstStyle/>
+          <a:p>
+            <a:pPr algn="l">
+              <a:spcAft>
+                <a:spcPts val="1000"/>
+              </a:spcAft>
+            </a:pPr>
+            <a:r>
+              <a:rPr sz="1800" b="0">
+                <a:solidFill>
+                  <a:srgbClr val="316CE3"/>
+                </a:solidFill>
+                <a:latin typeface="Arial"/>
+              </a:rPr>
+              <a:t>RG</a:t>
             </a:r>
           </a:p>
         </p:txBody>
@@ -11457,7 +11741,7 @@
                 <a:cs typeface="Raleway 1 Heavy"/>
                 <a:sym typeface="Raleway 1 Heavy"/>
               </a:rPr>
-              <a:t>Gana más el que escanea</a:t>
+              <a:t>Donde más gana: leer y agregar</a:t>
             </a:r>
           </a:p>
         </p:txBody>
@@ -11815,7 +12099,7 @@
                 </a:solidFill>
                 <a:latin typeface="Arial"/>
               </a:rPr>
-              <a:t>consultas de scan y agregación (10 consultas)</a:t>
+              <a:t>consultas que leen y agregan muchos datos (10 consultas)</a:t>
             </a:r>
           </a:p>
         </p:txBody>
@@ -11893,7 +12177,7 @@
                 </a:solidFill>
                 <a:latin typeface="Arial"/>
               </a:rPr>
-              <a:t>consultas de CPU: ventanas y joins grandes (10 consultas)</a:t>
+              <a:t>consultas de cálculo pesado: funciones de ventana y joins grandes (10 consultas)</a:t>
             </a:r>
           </a:p>
         </p:txBody>
@@ -11907,7 +12191,7 @@
         <p:spPr>
           <a:xfrm>
             <a:off x="914400" y="7315200"/>
-            <a:ext cx="14264640" cy="914400"/>
+            <a:ext cx="13898880" cy="914400"/>
           </a:xfrm>
           <a:prstGeom prst="rect">
             <a:avLst/>
@@ -11926,22 +12210,22 @@
               </a:spcAft>
             </a:pPr>
             <a:r>
-              <a:rPr sz="2600" b="0">
+              <a:rPr sz="2500" b="0">
                 <a:solidFill>
                   <a:srgbClr val="FFFFFF"/>
                 </a:solidFill>
                 <a:latin typeface="Arial"/>
               </a:rPr>
-              <a:t>La promesa de AWS es hasta 2,2x: </a:t>
-            </a:r>
-            <a:r>
-              <a:rPr sz="2600" b="1">
+              <a:t>AWS anuncia hasta 2,2x: </a:t>
+            </a:r>
+            <a:r>
+              <a:rPr sz="2500" b="1">
                 <a:solidFill>
                   <a:srgbClr val="FFFFFF"/>
                 </a:solidFill>
                 <a:latin typeface="Arial"/>
               </a:rPr>
-              <a:t>en scan la superamos; en CPU, no.</a:t>
+              <a:t>en las consultas de lectura lo superamos; en las de cálculo, no llegamos.</a:t>
             </a:r>
           </a:p>
         </p:txBody>
@@ -12058,7 +12342,7 @@
               </a:spcBef>
             </a:pPr>
             <a:r>
-              <a:rPr lang="en-US" b="true" sz="4400">
+              <a:rPr lang="en-US" b="true" sz="5000">
                 <a:solidFill>
                   <a:srgbClr val="FFFFFF"/>
                 </a:solidFill>
@@ -12067,7 +12351,7 @@
                 <a:cs typeface="Raleway 1 Heavy"/>
                 <a:sym typeface="Raleway 1 Heavy"/>
               </a:rPr>
-              <a:t>Concurrencia: 1,8x más consultas</a:t>
+              <a:t>Varios usuarios a la vez: 1,8x</a:t>
             </a:r>
           </a:p>
         </p:txBody>
@@ -12398,13 +12682,22 @@
               </a:spcAft>
             </a:pPr>
             <a:r>
-              <a:rPr sz="2600" b="1">
+              <a:rPr sz="2500" b="1">
                 <a:solidFill>
                   <a:srgbClr val="D9E2EC"/>
                 </a:solidFill>
                 <a:latin typeface="Arial"/>
               </a:rPr>
               <a:t>Consultas por hora</a:t>
+            </a:r>
+            <a:r>
+              <a:rPr sz="2500" b="0">
+                <a:solidFill>
+                  <a:srgbClr val="D9E2EC"/>
+                </a:solidFill>
+                <a:latin typeface="Arial"/>
+              </a:rPr>
+              <a:t> (más es mejor)</a:t>
             </a:r>
           </a:p>
           <a:p>
@@ -12414,13 +12707,13 @@
               </a:spcAft>
             </a:pPr>
             <a:r>
-              <a:rPr sz="2600" b="0">
+              <a:rPr sz="2500" b="0">
                 <a:solidFill>
                   <a:srgbClr val="D9E2EC"/>
                 </a:solidFill>
                 <a:latin typeface="Arial"/>
               </a:rPr>
-              <a:t>5 flujos durante 30 minutos</a:t>
+              <a:t>Cinco usuarios simulados durante 30 minutos</a:t>
             </a:r>
           </a:p>
           <a:p>
@@ -12430,13 +12723,13 @@
               </a:spcAft>
             </a:pPr>
             <a:r>
-              <a:rPr sz="2600" b="0">
+              <a:rPr sz="2500" b="0">
                 <a:solidFill>
                   <a:srgbClr val="D9E2EC"/>
                 </a:solidFill>
                 <a:latin typeface="Arial"/>
               </a:rPr>
-              <a:t>Sin cola en ninguno</a:t>
+              <a:t>Ninguna consulta quedó en espera</a:t>
             </a:r>
           </a:p>
           <a:p>
@@ -12446,13 +12739,13 @@
               </a:spcAft>
             </a:pPr>
             <a:r>
-              <a:rPr sz="2600" b="0">
+              <a:rPr sz="2500" b="0">
                 <a:solidFill>
                   <a:srgbClr val="D9E2EC"/>
                 </a:solidFill>
                 <a:latin typeface="Arial"/>
               </a:rPr>
-              <a:t>Cero fallas</a:t>
+              <a:t>Ningún error</a:t>
             </a:r>
           </a:p>
         </p:txBody>
@@ -12578,7 +12871,7 @@
                 <a:cs typeface="Raleway 1 Heavy"/>
                 <a:sym typeface="Raleway 1 Heavy"/>
               </a:rPr>
-              <a:t>Cargar y transformar</a:t>
+              <a:t>Carga y transformación</a:t>
             </a:r>
           </a:p>
         </p:txBody>
@@ -12891,13 +13184,13 @@
               </a:spcAft>
             </a:pPr>
             <a:r>
-              <a:rPr sz="2600" b="1">
+              <a:rPr sz="2500" b="1">
                 <a:solidFill>
                   <a:srgbClr val="D9E2EC"/>
                 </a:solidFill>
                 <a:latin typeface="Arial"/>
               </a:rPr>
-              <a:t>100 GB en 20 min 44 s</a:t>
+              <a:t>Cargar los 100 GB tomó 20 min 44 s</a:t>
             </a:r>
           </a:p>
           <a:p>
@@ -12907,13 +13200,13 @@
               </a:spcAft>
             </a:pPr>
             <a:r>
-              <a:rPr sz="2600" b="0">
+              <a:rPr sz="2500" b="0">
                 <a:solidFill>
                   <a:srgbClr val="D9E2EC"/>
                 </a:solidFill>
                 <a:latin typeface="Arial"/>
               </a:rPr>
-              <a:t>COPY desde S3 en 2 × ra3.xlplus (carga inicial, una vez)</a:t>
+              <a:t>Desde S3, en RA3, una sola vez</a:t>
             </a:r>
           </a:p>
           <a:p>
@@ -12923,16 +13216,16 @@
               </a:spcAft>
             </a:pPr>
             <a:r>
-              <a:rPr sz="2600" b="0">
+              <a:rPr sz="2500" b="0">
                 <a:solidFill>
                   <a:srgbClr val="D9E2EC"/>
                 </a:solidFill>
                 <a:latin typeface="Arial"/>
               </a:rPr>
-              <a:t>COPY store_returns: </a:t>
-            </a:r>
-            <a:r>
-              <a:rPr sz="2600" b="1">
+              <a:t>Copiar una tabla desde S3: </a:t>
+            </a:r>
+            <a:r>
+              <a:rPr sz="2500" b="1">
                 <a:solidFill>
                   <a:srgbClr val="D9E2EC"/>
                 </a:solidFill>
@@ -12948,16 +13241,16 @@
               </a:spcAft>
             </a:pPr>
             <a:r>
-              <a:rPr sz="2600" b="0">
+              <a:rPr sz="2500" b="0">
                 <a:solidFill>
                   <a:srgbClr val="D9E2EC"/>
                 </a:solidFill>
                 <a:latin typeface="Arial"/>
               </a:rPr>
-              <a:t>CTAS pesado: </a:t>
-            </a:r>
-            <a:r>
-              <a:rPr sz="2600" b="1">
+              <a:t>Crear una tabla resumen (CTAS): </a:t>
+            </a:r>
+            <a:r>
+              <a:rPr sz="2500" b="1">
                 <a:solidFill>
                   <a:srgbClr val="D9E2EC"/>
                 </a:solidFill>
@@ -12978,7 +13271,7 @@
         </p:nvGraphicFramePr>
         <p:xfrm>
           <a:off x="7315200" y="3017520"/>
-          <a:ext cx="8046720" cy="5486400"/>
+          <a:ext cx="7863840" cy="5486400"/>
         </p:xfrm>
         <a:graphic>
           <a:graphicData uri="http://schemas.openxmlformats.org/drawingml/2006/chart">
@@ -13098,7 +13391,7 @@
               </a:spcBef>
             </a:pPr>
             <a:r>
-              <a:rPr lang="en-US" b="true" sz="5400">
+              <a:rPr lang="en-US" b="true" sz="4400">
                 <a:solidFill>
                   <a:srgbClr val="FFFFFF"/>
                 </a:solidFill>
@@ -13107,7 +13400,7 @@
                 <a:cs typeface="Raleway 1 Heavy"/>
                 <a:sym typeface="Raleway 1 Heavy"/>
               </a:rPr>
-              <a:t>Más rápido y más barato</a:t>
+              <a:t>Más rápido y también más barato</a:t>
             </a:r>
           </a:p>
         </p:txBody>
@@ -13465,7 +13758,7 @@
                 </a:solidFill>
                 <a:latin typeface="Arial"/>
               </a:rPr>
-              <a:t>por corrida del escenario de potencia</a:t>
+              <a:t>lo que costó cada ejecución de las 20 consultas</a:t>
             </a:r>
           </a:p>
         </p:txBody>
@@ -13479,7 +13772,7 @@
         <p:spPr>
           <a:xfrm>
             <a:off x="9326880" y="3383280"/>
-            <a:ext cx="5852160" cy="1280160"/>
+            <a:ext cx="5669280" cy="1280160"/>
           </a:xfrm>
           <a:prstGeom prst="rect">
             <a:avLst/>
@@ -13518,7 +13811,7 @@
         <p:spPr>
           <a:xfrm>
             <a:off x="9326880" y="4754880"/>
-            <a:ext cx="5852160" cy="1097280"/>
+            <a:ext cx="5669280" cy="1097280"/>
           </a:xfrm>
           <a:prstGeom prst="rect">
             <a:avLst/>
@@ -13543,7 +13836,7 @@
                 </a:solidFill>
                 <a:latin typeface="Arial"/>
               </a:rPr>
-              <a:t>menos costo por la misma carga</a:t>
+              <a:t>menos costo por el mismo trabajo</a:t>
             </a:r>
           </a:p>
         </p:txBody>
@@ -13557,7 +13850,7 @@
         <p:spPr>
           <a:xfrm>
             <a:off x="914400" y="7223760"/>
-            <a:ext cx="14264640" cy="1097280"/>
+            <a:ext cx="13898880" cy="1097280"/>
           </a:xfrm>
           <a:prstGeom prst="rect">
             <a:avLst/>
@@ -13576,22 +13869,22 @@
               </a:spcAft>
             </a:pPr>
             <a:r>
-              <a:rPr sz="2600" b="0">
+              <a:rPr sz="2500" b="0">
                 <a:solidFill>
                   <a:srgbClr val="FFFFFF"/>
                 </a:solidFill>
                 <a:latin typeface="Arial"/>
               </a:rPr>
-              <a:t>Se suman dos efectos: </a:t>
-            </a:r>
-            <a:r>
-              <a:rPr sz="2600" b="1">
+              <a:t>Dos razones que se suman: </a:t>
+            </a:r>
+            <a:r>
+              <a:rPr sz="2500" b="1">
                 <a:solidFill>
                   <a:srgbClr val="FFFFFF"/>
                 </a:solidFill>
                 <a:latin typeface="Arial"/>
               </a:rPr>
-              <a:t>el nodo cuesta 30 % menos por hora y termina antes.</a:t>
+              <a:t>el nodo RG cuesta 30 % menos por hora y además termina antes.</a:t>
             </a:r>
           </a:p>
         </p:txBody>
@@ -14426,14 +14719,85 @@
       </p:sp>
       <p:sp>
         <p:nvSpPr>
-          <p:cNvPr id="10" name="Rounded Rectangle 9"/>
+          <p:cNvPr id="10" name="TextBox 9"/>
+          <p:cNvSpPr txBox="1"/>
+          <p:nvPr/>
+        </p:nvSpPr>
+        <p:spPr>
+          <a:xfrm>
+            <a:off x="914400" y="3291840"/>
+            <a:ext cx="9052560" cy="5120640"/>
+          </a:xfrm>
+          <a:prstGeom prst="rect">
+            <a:avLst/>
+          </a:prstGeom>
+          <a:noFill/>
+        </p:spPr>
+        <p:txBody>
+          <a:bodyPr wrap="square" anchor="t" lIns="0" rIns="0" tIns="0" bIns="0">
+            <a:spAutoFit/>
+          </a:bodyPr>
+          <a:lstStyle/>
+          <a:p>
+            <a:pPr algn="l">
+              <a:spcAft>
+                <a:spcPts val="2000"/>
+              </a:spcAft>
+            </a:pPr>
+            <a:r>
+              <a:rPr sz="2500" b="0">
+                <a:solidFill>
+                  <a:srgbClr val="D9E2EC"/>
+                </a:solidFill>
+                <a:latin typeface="Arial"/>
+              </a:rPr>
+              <a:t>Soy de Arequipa y trabajo como Solutions Architect en phData, casi siempre con AWS.</a:t>
+            </a:r>
+          </a:p>
+          <a:p>
+            <a:pPr algn="l">
+              <a:spcAft>
+                <a:spcPts val="2000"/>
+              </a:spcAft>
+            </a:pPr>
+            <a:r>
+              <a:rPr sz="2500" b="0">
+                <a:solidFill>
+                  <a:srgbClr val="D9E2EC"/>
+                </a:solidFill>
+                <a:latin typeface="Arial"/>
+              </a:rPr>
+              <a:t>Empecé en redes y fui pasando por infraestructura, Kubernetes y datos. Hoy ando metido con agentes de IA.</a:t>
+            </a:r>
+          </a:p>
+          <a:p>
+            <a:pPr algn="l">
+              <a:spcAft>
+                <a:spcPts val="2000"/>
+              </a:spcAft>
+            </a:pPr>
+            <a:r>
+              <a:rPr sz="2500" b="0">
+                <a:solidFill>
+                  <a:srgbClr val="D9E2EC"/>
+                </a:solidFill>
+                <a:latin typeface="Arial"/>
+              </a:rPr>
+              <a:t>Tengo el Golden Jacket de AWS y hace poco me invitaron a ayudar a crear las nuevas microcredenciales de análisis de datos.</a:t>
+            </a:r>
+          </a:p>
+        </p:txBody>
+      </p:sp>
+      <p:sp>
+        <p:nvSpPr>
+          <p:cNvPr id="11" name="Rounded Rectangle 10"/>
           <p:cNvSpPr/>
           <p:nvPr/>
         </p:nvSpPr>
         <p:spPr>
           <a:xfrm>
-            <a:off x="914400" y="3200400"/>
-            <a:ext cx="6903720" cy="2423160"/>
+            <a:off x="10424160" y="3383280"/>
+            <a:ext cx="4572000" cy="3291840"/>
           </a:xfrm>
           <a:prstGeom prst="roundRect">
             <a:avLst>
@@ -14472,13 +14836,13 @@
               </a:spcAft>
             </a:pPr>
             <a:r>
-              <a:rPr sz="2600" b="1">
-                <a:solidFill>
-                  <a:srgbClr val="FFFFFF"/>
+              <a:rPr sz="2800" b="1">
+                <a:solidFill>
+                  <a:srgbClr val="316CE3"/>
                 </a:solidFill>
                 <a:latin typeface="Arial"/>
               </a:rPr>
-              <a:t>De Arequipa</a:t>
+              <a:t>Probar antes de recomendar</a:t>
             </a:r>
           </a:p>
           <a:p>
@@ -14488,238 +14852,13 @@
               </a:spcAft>
             </a:pPr>
             <a:r>
-              <a:rPr sz="2200" b="0">
+              <a:rPr sz="2100" b="0">
                 <a:solidFill>
                   <a:srgbClr val="D9E2EC"/>
                 </a:solidFill>
                 <a:latin typeface="Arial"/>
               </a:rPr>
-              <a:t>Solutions Architect en phData, casi siempre con AWS</a:t>
-            </a:r>
-          </a:p>
-        </p:txBody>
-      </p:sp>
-      <p:sp>
-        <p:nvSpPr>
-          <p:cNvPr id="11" name="Rounded Rectangle 10"/>
-          <p:cNvSpPr/>
-          <p:nvPr/>
-        </p:nvSpPr>
-        <p:spPr>
-          <a:xfrm>
-            <a:off x="8092440" y="3200400"/>
-            <a:ext cx="6903720" cy="2423160"/>
-          </a:xfrm>
-          <a:prstGeom prst="roundRect">
-            <a:avLst>
-              <a:gd name="adj" fmla="val 8000"/>
-            </a:avLst>
-          </a:prstGeom>
-          <a:solidFill>
-            <a:srgbClr val="2F3D52"/>
-          </a:solidFill>
-          <a:ln>
-            <a:noFill/>
-          </a:ln>
-          <a:effectLst/>
-        </p:spPr>
-        <p:style>
-          <a:lnRef idx="1">
-            <a:schemeClr val="accent1"/>
-          </a:lnRef>
-          <a:fillRef idx="3">
-            <a:schemeClr val="accent1"/>
-          </a:fillRef>
-          <a:effectRef idx="2">
-            <a:schemeClr val="accent1"/>
-          </a:effectRef>
-          <a:fontRef idx="minor">
-            <a:schemeClr val="lt1"/>
-          </a:fontRef>
-        </p:style>
-        <p:txBody>
-          <a:bodyPr rtlCol="0" anchor="t" wrap="square" lIns="274320" rIns="274320" tIns="228600" bIns="228600"/>
-          <a:lstStyle/>
-          <a:p>
-            <a:pPr algn="ctr">
-              <a:spcAft>
-                <a:spcPts val="800"/>
-              </a:spcAft>
-            </a:pPr>
-            <a:r>
-              <a:rPr sz="2600" b="1">
-                <a:solidFill>
-                  <a:srgbClr val="FFFFFF"/>
-                </a:solidFill>
-                <a:latin typeface="Arial"/>
-              </a:rPr>
-              <a:t>Trayectoria</a:t>
-            </a:r>
-          </a:p>
-          <a:p>
-            <a:pPr>
-              <a:spcAft>
-                <a:spcPts val="600"/>
-              </a:spcAft>
-            </a:pPr>
-            <a:r>
-              <a:rPr sz="2200" b="0">
-                <a:solidFill>
-                  <a:srgbClr val="D9E2EC"/>
-                </a:solidFill>
-                <a:latin typeface="Arial"/>
-              </a:rPr>
-              <a:t>Redes → infraestructura → Kubernetes → datos → agentes de IA</a:t>
-            </a:r>
-          </a:p>
-        </p:txBody>
-      </p:sp>
-      <p:sp>
-        <p:nvSpPr>
-          <p:cNvPr id="12" name="Rounded Rectangle 11"/>
-          <p:cNvSpPr/>
-          <p:nvPr/>
-        </p:nvSpPr>
-        <p:spPr>
-          <a:xfrm>
-            <a:off x="914400" y="5897880"/>
-            <a:ext cx="6903720" cy="2423160"/>
-          </a:xfrm>
-          <a:prstGeom prst="roundRect">
-            <a:avLst>
-              <a:gd name="adj" fmla="val 8000"/>
-            </a:avLst>
-          </a:prstGeom>
-          <a:solidFill>
-            <a:srgbClr val="2F3D52"/>
-          </a:solidFill>
-          <a:ln>
-            <a:noFill/>
-          </a:ln>
-          <a:effectLst/>
-        </p:spPr>
-        <p:style>
-          <a:lnRef idx="1">
-            <a:schemeClr val="accent1"/>
-          </a:lnRef>
-          <a:fillRef idx="3">
-            <a:schemeClr val="accent1"/>
-          </a:fillRef>
-          <a:effectRef idx="2">
-            <a:schemeClr val="accent1"/>
-          </a:effectRef>
-          <a:fontRef idx="minor">
-            <a:schemeClr val="lt1"/>
-          </a:fontRef>
-        </p:style>
-        <p:txBody>
-          <a:bodyPr rtlCol="0" anchor="t" wrap="square" lIns="274320" rIns="274320" tIns="228600" bIns="228600"/>
-          <a:lstStyle/>
-          <a:p>
-            <a:pPr algn="ctr">
-              <a:spcAft>
-                <a:spcPts val="800"/>
-              </a:spcAft>
-            </a:pPr>
-            <a:r>
-              <a:rPr sz="2600" b="1">
-                <a:solidFill>
-                  <a:srgbClr val="FFFFFF"/>
-                </a:solidFill>
-                <a:latin typeface="Arial"/>
-              </a:rPr>
-              <a:t>Comunidad</a:t>
-            </a:r>
-          </a:p>
-          <a:p>
-            <a:pPr>
-              <a:spcAft>
-                <a:spcPts val="600"/>
-              </a:spcAft>
-            </a:pPr>
-            <a:r>
-              <a:rPr sz="2200" b="0">
-                <a:solidFill>
-                  <a:srgbClr val="D9E2EC"/>
-                </a:solidFill>
-                <a:latin typeface="Arial"/>
-              </a:rPr>
-              <a:t>AWS Golden Jacket · colaboré en las nuevas microcredenciales de análisis de datos de AWS</a:t>
-            </a:r>
-          </a:p>
-        </p:txBody>
-      </p:sp>
-      <p:sp>
-        <p:nvSpPr>
-          <p:cNvPr id="13" name="Rounded Rectangle 12"/>
-          <p:cNvSpPr/>
-          <p:nvPr/>
-        </p:nvSpPr>
-        <p:spPr>
-          <a:xfrm>
-            <a:off x="8092440" y="5897880"/>
-            <a:ext cx="6903720" cy="2423160"/>
-          </a:xfrm>
-          <a:prstGeom prst="roundRect">
-            <a:avLst>
-              <a:gd name="adj" fmla="val 8000"/>
-            </a:avLst>
-          </a:prstGeom>
-          <a:solidFill>
-            <a:srgbClr val="2F3D52"/>
-          </a:solidFill>
-          <a:ln>
-            <a:noFill/>
-          </a:ln>
-          <a:effectLst/>
-        </p:spPr>
-        <p:style>
-          <a:lnRef idx="1">
-            <a:schemeClr val="accent1"/>
-          </a:lnRef>
-          <a:fillRef idx="3">
-            <a:schemeClr val="accent1"/>
-          </a:fillRef>
-          <a:effectRef idx="2">
-            <a:schemeClr val="accent1"/>
-          </a:effectRef>
-          <a:fontRef idx="minor">
-            <a:schemeClr val="lt1"/>
-          </a:fontRef>
-        </p:style>
-        <p:txBody>
-          <a:bodyPr rtlCol="0" anchor="t" wrap="square" lIns="274320" rIns="274320" tIns="228600" bIns="228600"/>
-          <a:lstStyle/>
-          <a:p>
-            <a:pPr algn="ctr">
-              <a:spcAft>
-                <a:spcPts val="800"/>
-              </a:spcAft>
-            </a:pPr>
-            <a:r>
-              <a:rPr sz="2600" b="1">
-                <a:solidFill>
-                  <a:srgbClr val="FFFFFF"/>
-                </a:solidFill>
-                <a:latin typeface="Arial"/>
-              </a:rPr>
-              <a:t>Mi regla</a:t>
-            </a:r>
-          </a:p>
-          <a:p>
-            <a:pPr>
-              <a:spcAft>
-                <a:spcPts val="600"/>
-              </a:spcAft>
-            </a:pPr>
-            <a:r>
-              <a:rPr sz="2200" b="0">
-                <a:solidFill>
-                  <a:srgbClr val="D9E2EC"/>
-                </a:solidFill>
-                <a:latin typeface="Arial"/>
-              </a:rPr>
-              <a:t>Cada charla sale de un laboratorio que armo y publico para que lo repitas</a:t>
+              <a:t>Cada charla que doy sale de un laboratorio que armo y después publico para que cualquiera lo repita.</a:t>
             </a:r>
           </a:p>
         </p:txBody>
@@ -14845,7 +14984,7 @@
                 <a:cs typeface="Raleway 1 Heavy"/>
                 <a:sym typeface="Raleway 1 Heavy"/>
               </a:rPr>
-              <a:t>El mismo dato, tres formas</a:t>
+              <a:t>El mismo dato, de tres formas</a:t>
             </a:r>
           </a:p>
         </p:txBody>
@@ -15200,7 +15339,7 @@
                 </a:solidFill>
                 <a:latin typeface="Arial"/>
               </a:rPr>
-              <a:t>Tablas cargadas en el warehouse</a:t>
+              <a:t>Tablas dentro del warehouse</a:t>
             </a:r>
           </a:p>
         </p:txBody>
@@ -15275,7 +15414,7 @@
                 </a:solidFill>
                 <a:latin typeface="Arial"/>
               </a:rPr>
-              <a:t>Tablas en S3 registradas en Glue (ice.*)</a:t>
+              <a:t>Tablas Iceberg en S3, registradas en Glue</a:t>
             </a:r>
           </a:p>
         </p:txBody>
@@ -15350,7 +15489,7 @@
                 </a:solidFill>
                 <a:latin typeface="Arial"/>
               </a:rPr>
-              <a:t>Tablas externas en S3 registradas en Glue (pq.*)</a:t>
+              <a:t>Archivos Parquet en S3, registrados en Glue</a:t>
             </a:r>
           </a:p>
         </p:txBody>
@@ -15364,7 +15503,7 @@
         <p:spPr>
           <a:xfrm>
             <a:off x="914400" y="6309360"/>
-            <a:ext cx="14264640" cy="2194560"/>
+            <a:ext cx="13898880" cy="2194560"/>
           </a:xfrm>
           <a:prstGeom prst="rect">
             <a:avLst/>
@@ -15383,25 +15522,25 @@
               </a:spcAft>
             </a:pPr>
             <a:r>
-              <a:rPr sz="2500" b="0">
+              <a:rPr sz="2400" b="0">
                 <a:solidFill>
                   <a:srgbClr val="D9E2EC"/>
                 </a:solidFill>
                 <a:latin typeface="Arial"/>
               </a:rPr>
-              <a:t>Mismas 6 consultas en las tres, con las </a:t>
-            </a:r>
-            <a:r>
-              <a:rPr sz="2500" b="1">
+              <a:t>Las mismas 6 consultas en las tres versiones devuelven </a:t>
+            </a:r>
+            <a:r>
+              <a:rPr sz="2400" b="1">
                 <a:solidFill>
                   <a:srgbClr val="D9E2EC"/>
                 </a:solidFill>
                 <a:latin typeface="Arial"/>
               </a:rPr>
-              <a:t>mismas 483 filas de resultado</a:t>
-            </a:r>
-            <a:r>
-              <a:rPr sz="2500" b="0">
+              <a:t>exactamente las mismas 483 filas</a:t>
+            </a:r>
+            <a:r>
+              <a:rPr sz="2400" b="0">
                 <a:solidFill>
                   <a:srgbClr val="D9E2EC"/>
                 </a:solidFill>
@@ -15417,16 +15556,16 @@
               </a:spcAft>
             </a:pPr>
             <a:r>
-              <a:rPr sz="2500" b="0">
+              <a:rPr sz="2400" b="0">
                 <a:solidFill>
                   <a:srgbClr val="D9E2EC"/>
                 </a:solidFill>
                 <a:latin typeface="Arial"/>
               </a:rPr>
-              <a:t>RA3 lee S3 con </a:t>
-            </a:r>
-            <a:r>
-              <a:rPr sz="2500" b="1">
+              <a:t>RA3 lee S3 a través de </a:t>
+            </a:r>
+            <a:r>
+              <a:rPr sz="2400" b="1">
                 <a:solidFill>
                   <a:srgbClr val="D9E2EC"/>
                 </a:solidFill>
@@ -15435,31 +15574,31 @@
               <a:t>Spectrum</a:t>
             </a:r>
             <a:r>
-              <a:rPr sz="2500" b="0">
+              <a:rPr sz="2400" b="0">
                 <a:solidFill>
                   <a:srgbClr val="D9E2EC"/>
                 </a:solidFill>
                 <a:latin typeface="Arial"/>
               </a:rPr>
-              <a:t> (fuera de tu VPC); RG, con su </a:t>
-            </a:r>
-            <a:r>
-              <a:rPr sz="2500" b="1">
+              <a:t>, fuera de tu VPC; RG lo lee </a:t>
+            </a:r>
+            <a:r>
+              <a:rPr sz="2400" b="1">
                 <a:solidFill>
                   <a:srgbClr val="D9E2EC"/>
                 </a:solidFill>
                 <a:latin typeface="Arial"/>
               </a:rPr>
-              <a:t>motor integrado</a:t>
-            </a:r>
-            <a:r>
-              <a:rPr sz="2500" b="0">
+              <a:t>con sus propios nodos</a:t>
+            </a:r>
+            <a:r>
+              <a:rPr sz="2400" b="0">
                 <a:solidFill>
                   <a:srgbClr val="D9E2EC"/>
                 </a:solidFill>
                 <a:latin typeface="Arial"/>
               </a:rPr>
-              <a:t> (dentro de tu VPC).</a:t>
+              <a:t>, dentro de tu VPC.</a:t>
             </a:r>
           </a:p>
         </p:txBody>
@@ -15576,7 +15715,7 @@
               </a:spcBef>
             </a:pPr>
             <a:r>
-              <a:rPr lang="en-US" b="true" sz="4400">
+              <a:rPr lang="en-US" b="true" sz="4800">
                 <a:solidFill>
                   <a:srgbClr val="FFFFFF"/>
                 </a:solidFill>
@@ -15585,7 +15724,7 @@
                 <a:cs typeface="Raleway 1 Heavy"/>
                 <a:sym typeface="Raleway 1 Heavy"/>
               </a:rPr>
-              <a:t>Iceberg: 1,87x con caché caliente</a:t>
+              <a:t>Iceberg: 1,87x, ya con caché</a:t>
             </a:r>
           </a:p>
         </p:txBody>
@@ -15896,8 +16035,8 @@
         </p:nvSpPr>
         <p:spPr>
           <a:xfrm>
-            <a:off x="10058400" y="3383280"/>
-            <a:ext cx="5303520" cy="1280160"/>
+            <a:off x="10058400" y="3291840"/>
+            <a:ext cx="5303520" cy="457200"/>
           </a:xfrm>
           <a:prstGeom prst="rect">
             <a:avLst/>
@@ -15905,7 +16044,7 @@
           <a:noFill/>
         </p:spPr>
         <p:txBody>
-          <a:bodyPr wrap="square" anchor="b" lIns="0" rIns="0" tIns="0" bIns="0">
+          <a:bodyPr wrap="square" anchor="t" lIns="0" rIns="0" tIns="0" bIns="0">
             <a:spAutoFit/>
           </a:bodyPr>
           <a:lstStyle/>
@@ -15916,13 +16055,13 @@
               </a:spcAft>
             </a:pPr>
             <a:r>
-              <a:rPr sz="4400" b="1">
-                <a:solidFill>
-                  <a:srgbClr val="FFFFFF"/>
+              <a:rPr sz="2000" b="0">
+                <a:solidFill>
+                  <a:srgbClr val="D9E2EC"/>
                 </a:solidFill>
                 <a:latin typeface="Arial"/>
               </a:rPr>
-              <a:t>29,4 → 14,6 s</a:t>
+              <a:t>Tiempo total de las 6 consultas</a:t>
             </a:r>
           </a:p>
         </p:txBody>
@@ -15935,8 +16074,8 @@
         </p:nvSpPr>
         <p:spPr>
           <a:xfrm>
-            <a:off x="10058400" y="4754880"/>
-            <a:ext cx="5303520" cy="1097280"/>
+            <a:off x="10058400" y="3794760"/>
+            <a:ext cx="2651760" cy="914400"/>
           </a:xfrm>
           <a:prstGeom prst="rect">
             <a:avLst/>
@@ -15955,13 +16094,13 @@
               </a:spcAft>
             </a:pPr>
             <a:r>
-              <a:rPr sz="2200" b="0">
-                <a:solidFill>
-                  <a:srgbClr val="D9E2EC"/>
+              <a:rPr sz="4000" b="1">
+                <a:solidFill>
+                  <a:srgbClr val="8FA3B8"/>
                 </a:solidFill>
                 <a:latin typeface="Arial"/>
               </a:rPr>
-              <a:t>total de las 6 consultas</a:t>
+              <a:t>29,4 s</a:t>
             </a:r>
           </a:p>
         </p:txBody>
@@ -15974,8 +16113,8 @@
         </p:nvSpPr>
         <p:spPr>
           <a:xfrm>
-            <a:off x="10058400" y="5943600"/>
-            <a:ext cx="5303520" cy="2560320"/>
+            <a:off x="12710160" y="3794760"/>
+            <a:ext cx="2651760" cy="914400"/>
           </a:xfrm>
           <a:prstGeom prst="rect">
             <a:avLst/>
@@ -15994,22 +16133,178 @@
               </a:spcAft>
             </a:pPr>
             <a:r>
-              <a:rPr sz="2200" b="1">
+              <a:rPr sz="4000" b="1">
+                <a:solidFill>
+                  <a:srgbClr val="316CE3"/>
+                </a:solidFill>
+                <a:latin typeface="Arial"/>
+              </a:rPr>
+              <a:t>14,6 s</a:t>
+            </a:r>
+          </a:p>
+        </p:txBody>
+      </p:sp>
+      <p:sp>
+        <p:nvSpPr>
+          <p:cNvPr id="14" name="TextBox 13"/>
+          <p:cNvSpPr txBox="1"/>
+          <p:nvPr/>
+        </p:nvSpPr>
+        <p:spPr>
+          <a:xfrm>
+            <a:off x="10058400" y="4572000"/>
+            <a:ext cx="2651760" cy="457200"/>
+          </a:xfrm>
+          <a:prstGeom prst="rect">
+            <a:avLst/>
+          </a:prstGeom>
+          <a:noFill/>
+        </p:spPr>
+        <p:txBody>
+          <a:bodyPr wrap="square" anchor="t" lIns="0" rIns="0" tIns="0" bIns="0">
+            <a:spAutoFit/>
+          </a:bodyPr>
+          <a:lstStyle/>
+          <a:p>
+            <a:pPr algn="l">
+              <a:spcAft>
+                <a:spcPts val="1000"/>
+              </a:spcAft>
+            </a:pPr>
+            <a:r>
+              <a:rPr sz="1800" b="0">
+                <a:solidFill>
+                  <a:srgbClr val="8FA3B8"/>
+                </a:solidFill>
+                <a:latin typeface="Arial"/>
+              </a:rPr>
+              <a:t>RA3</a:t>
+            </a:r>
+          </a:p>
+        </p:txBody>
+      </p:sp>
+      <p:sp>
+        <p:nvSpPr>
+          <p:cNvPr id="15" name="TextBox 14"/>
+          <p:cNvSpPr txBox="1"/>
+          <p:nvPr/>
+        </p:nvSpPr>
+        <p:spPr>
+          <a:xfrm>
+            <a:off x="12710160" y="4572000"/>
+            <a:ext cx="2651760" cy="457200"/>
+          </a:xfrm>
+          <a:prstGeom prst="rect">
+            <a:avLst/>
+          </a:prstGeom>
+          <a:noFill/>
+        </p:spPr>
+        <p:txBody>
+          <a:bodyPr wrap="square" anchor="t" lIns="0" rIns="0" tIns="0" bIns="0">
+            <a:spAutoFit/>
+          </a:bodyPr>
+          <a:lstStyle/>
+          <a:p>
+            <a:pPr algn="l">
+              <a:spcAft>
+                <a:spcPts val="1000"/>
+              </a:spcAft>
+            </a:pPr>
+            <a:r>
+              <a:rPr sz="1800" b="0">
+                <a:solidFill>
+                  <a:srgbClr val="316CE3"/>
+                </a:solidFill>
+                <a:latin typeface="Arial"/>
+              </a:rPr>
+              <a:t>RG</a:t>
+            </a:r>
+          </a:p>
+        </p:txBody>
+      </p:sp>
+      <p:sp>
+        <p:nvSpPr>
+          <p:cNvPr id="16" name="TextBox 15"/>
+          <p:cNvSpPr txBox="1"/>
+          <p:nvPr/>
+        </p:nvSpPr>
+        <p:spPr>
+          <a:xfrm>
+            <a:off x="10058400" y="4983480"/>
+            <a:ext cx="5303520" cy="457200"/>
+          </a:xfrm>
+          <a:prstGeom prst="rect">
+            <a:avLst/>
+          </a:prstGeom>
+          <a:noFill/>
+        </p:spPr>
+        <p:txBody>
+          <a:bodyPr wrap="square" anchor="t" lIns="0" rIns="0" tIns="0" bIns="0">
+            <a:spAutoFit/>
+          </a:bodyPr>
+          <a:lstStyle/>
+          <a:p>
+            <a:pPr algn="l">
+              <a:spcAft>
+                <a:spcPts val="1000"/>
+              </a:spcAft>
+            </a:pPr>
+            <a:r>
+              <a:rPr sz="1600" b="0">
+                <a:solidFill>
+                  <a:srgbClr val="9FB3C8"/>
+                </a:solidFill>
+                <a:latin typeface="Arial"/>
+              </a:rPr>
+              <a:t>menos tiempo es mejor</a:t>
+            </a:r>
+          </a:p>
+        </p:txBody>
+      </p:sp>
+      <p:sp>
+        <p:nvSpPr>
+          <p:cNvPr id="17" name="TextBox 16"/>
+          <p:cNvSpPr txBox="1"/>
+          <p:nvPr/>
+        </p:nvSpPr>
+        <p:spPr>
+          <a:xfrm>
+            <a:off x="10058400" y="5852160"/>
+            <a:ext cx="5303520" cy="2560320"/>
+          </a:xfrm>
+          <a:prstGeom prst="rect">
+            <a:avLst/>
+          </a:prstGeom>
+          <a:noFill/>
+        </p:spPr>
+        <p:txBody>
+          <a:bodyPr wrap="square" anchor="t" lIns="0" rIns="0" tIns="0" bIns="0">
+            <a:spAutoFit/>
+          </a:bodyPr>
+          <a:lstStyle/>
+          <a:p>
+            <a:pPr algn="l">
+              <a:spcAft>
+                <a:spcPts val="1000"/>
+              </a:spcAft>
+            </a:pPr>
+            <a:r>
+              <a:rPr sz="2100" b="1">
                 <a:solidFill>
                   <a:srgbClr val="F2A65A"/>
                 </a:solidFill>
                 <a:latin typeface="Arial"/>
               </a:rPr>
-              <a:t>Letra chica:</a:t>
-            </a:r>
-            <a:r>
-              <a:rPr sz="2200" b="0">
+              <a:t>Ojo:</a:t>
+            </a:r>
+            <a:r>
+              <a:rPr sz="2100" b="0">
                 <a:solidFill>
                   <a:srgbClr val="F2A65A"/>
                 </a:solidFill>
                 <a:latin typeface="Arial"/>
               </a:rPr>
-              <a:t> la primera lectura en RG tardó hasta 27 s; después, unos 2 s. RG cachea el lago.</a:t>
+              <a:t> la primera vez que RG lee los datos tarda hasta 27 s. Desde la segunda, unos 2 s, porque los guarda en caché.</a:t>
             </a:r>
           </a:p>
         </p:txBody>
@@ -16126,7 +16421,7 @@
               </a:spcBef>
             </a:pPr>
             <a:r>
-              <a:rPr lang="en-US" b="true" sz="5400">
+              <a:rPr lang="en-US" b="true" sz="5000">
                 <a:solidFill>
                   <a:srgbClr val="FFFFFF"/>
                 </a:solidFill>
@@ -16135,7 +16430,7 @@
                 <a:cs typeface="Raleway 1 Heavy"/>
                 <a:sym typeface="Raleway 1 Heavy"/>
               </a:rPr>
-              <a:t>Parquet: mandan los archivos</a:t>
+              <a:t>Parquet: los archivos importan</a:t>
             </a:r>
           </a:p>
         </p:txBody>
@@ -16727,7 +17022,7 @@
         <p:spPr>
           <a:xfrm>
             <a:off x="914400" y="6217920"/>
-            <a:ext cx="14264640" cy="2377440"/>
+            <a:ext cx="13898880" cy="2377440"/>
           </a:xfrm>
           <a:prstGeom prst="rect">
             <a:avLst/>
@@ -16746,13 +17041,22 @@
               </a:spcAft>
             </a:pPr>
             <a:r>
+              <a:rPr sz="2400" b="0">
+                <a:solidFill>
+                  <a:srgbClr val="D9E2EC"/>
+                </a:solidFill>
+                <a:latin typeface="Arial"/>
+              </a:rPr>
+              <a:t>Los dos clústeres usan </a:t>
+            </a:r>
+            <a:r>
               <a:rPr sz="2400" b="1">
                 <a:solidFill>
                   <a:srgbClr val="D9E2EC"/>
                 </a:solidFill>
                 <a:latin typeface="Arial"/>
               </a:rPr>
-              <a:t>Mismo plan de ejecución</a:t>
+              <a:t>exactamente el mismo plan de ejecución</a:t>
             </a:r>
             <a:r>
               <a:rPr sz="2400" b="0">
@@ -16761,7 +17065,7 @@
                 </a:solidFill>
                 <a:latin typeface="Arial"/>
               </a:rPr>
-              <a:t> en los dos clústeres (EXPLAIN idéntico).</a:t>
+              <a:t>.</a:t>
             </a:r>
           </a:p>
           <a:p>
@@ -16777,7 +17081,7 @@
                 </a:solidFill>
                 <a:latin typeface="Arial"/>
               </a:rPr>
-              <a:t>El mismo cambio de archivos </a:t>
+              <a:t>Partir los archivos en pedazos más chicos </a:t>
             </a:r>
             <a:r>
               <a:rPr sz="2400" b="1">
@@ -16786,7 +17090,7 @@
                 </a:solidFill>
                 <a:latin typeface="Arial"/>
               </a:rPr>
-              <a:t>ayuda a RG y perjudica a Spectrum</a:t>
+              <a:t>ayuda a RG y perjudica a RA3</a:t>
             </a:r>
             <a:r>
               <a:rPr sz="2400" b="0">
@@ -16795,7 +17099,7 @@
                 </a:solidFill>
                 <a:latin typeface="Arial"/>
               </a:rPr>
-              <a:t> en RA3.</a:t>
+              <a:t>.</a:t>
             </a:r>
           </a:p>
           <a:p>
@@ -16811,7 +17115,7 @@
                 </a:solidFill>
                 <a:latin typeface="Arial"/>
               </a:rPr>
-              <a:t>Una sola repetición: confía en la dirección, no en el número exacto.</a:t>
+              <a:t>Lo repetimos una sola vez: la tendencia es clara; el número exacto, no tanto.</a:t>
             </a:r>
           </a:p>
         </p:txBody>
@@ -16937,7 +17241,7 @@
                 <a:cs typeface="Raleway 1 Heavy"/>
                 <a:sym typeface="Raleway 1 Heavy"/>
               </a:rPr>
-              <a:t>Spectrum se cobra aparte</a:t>
+              <a:t>Spectrum cobra aparte</a:t>
             </a:r>
           </a:p>
         </p:txBody>
@@ -17295,7 +17599,7 @@
                 </a:solidFill>
                 <a:latin typeface="Arial"/>
               </a:rPr>
-              <a:t>18,2 GB en Iceberg (2 pasadas)</a:t>
+              <a:t>18,2 GB leídos de Iceberg (2 repeticiones)</a:t>
             </a:r>
           </a:p>
         </p:txBody>
@@ -17308,7 +17612,7 @@
         </p:nvSpPr>
         <p:spPr>
           <a:xfrm>
-            <a:off x="5760720" y="3291840"/>
+            <a:off x="5669280" y="3291840"/>
             <a:ext cx="4572000" cy="1280160"/>
           </a:xfrm>
           <a:prstGeom prst="rect">
@@ -17347,7 +17651,7 @@
         </p:nvSpPr>
         <p:spPr>
           <a:xfrm>
-            <a:off x="5760720" y="4663440"/>
+            <a:off x="5669280" y="4663440"/>
             <a:ext cx="4572000" cy="1097280"/>
           </a:xfrm>
           <a:prstGeom prst="rect">
@@ -17373,7 +17677,7 @@
                 </a:solidFill>
                 <a:latin typeface="Arial"/>
               </a:rPr>
-              <a:t>20,2 GB en Parquet (2 pasadas)</a:t>
+              <a:t>20,2 GB leídos de Parquet (2 repeticiones)</a:t>
             </a:r>
           </a:p>
         </p:txBody>
@@ -17386,8 +17690,8 @@
         </p:nvSpPr>
         <p:spPr>
           <a:xfrm>
-            <a:off x="10607040" y="3291840"/>
-            <a:ext cx="4572000" cy="1280160"/>
+            <a:off x="10424160" y="3291840"/>
+            <a:ext cx="4389120" cy="1280160"/>
           </a:xfrm>
           <a:prstGeom prst="rect">
             <a:avLst/>
@@ -17425,8 +17729,8 @@
         </p:nvSpPr>
         <p:spPr>
           <a:xfrm>
-            <a:off x="10607040" y="4663440"/>
-            <a:ext cx="4572000" cy="1097280"/>
+            <a:off x="10424160" y="4663440"/>
+            <a:ext cx="4389120" cy="1097280"/>
           </a:xfrm>
           <a:prstGeom prst="rect">
             <a:avLst/>
@@ -17451,7 +17755,7 @@
                 </a:solidFill>
                 <a:latin typeface="Arial"/>
               </a:rPr>
-              <a:t>por escaneo en RG</a:t>
+              <a:t>por lectura en RG</a:t>
             </a:r>
           </a:p>
         </p:txBody>
@@ -17465,7 +17769,7 @@
         <p:spPr>
           <a:xfrm>
             <a:off x="914400" y="6766560"/>
-            <a:ext cx="14264640" cy="1371600"/>
+            <a:ext cx="13898880" cy="1371600"/>
           </a:xfrm>
           <a:prstGeom prst="rect">
             <a:avLst/>
@@ -17484,22 +17788,22 @@
               </a:spcAft>
             </a:pPr>
             <a:r>
-              <a:rPr sz="2600" b="0">
+              <a:rPr sz="2500" b="0">
                 <a:solidFill>
                   <a:srgbClr val="FFFFFF"/>
                 </a:solidFill>
                 <a:latin typeface="Arial"/>
               </a:rPr>
-              <a:t>USD 5 por TB escaneado en RA3. </a:t>
-            </a:r>
-            <a:r>
-              <a:rPr sz="2600" b="1">
+              <a:t>En RA3 se pagan USD 5 por cada TB leído. </a:t>
+            </a:r>
+            <a:r>
+              <a:rPr sz="2500" b="1">
                 <a:solidFill>
                   <a:srgbClr val="FFFFFF"/>
                 </a:solidFill>
                 <a:latin typeface="Arial"/>
               </a:rPr>
-              <a:t>Multiplica por tus consultas al lago de un mes.</a:t>
+              <a:t>Multiplícalo por todo lo que consultas del data lake en un mes.</a:t>
             </a:r>
           </a:p>
         </p:txBody>
@@ -17616,7 +17920,7 @@
               </a:spcBef>
             </a:pPr>
             <a:r>
-              <a:rPr lang="en-US" b="true" sz="5400">
+              <a:rPr lang="en-US" b="true" sz="4400">
                 <a:solidFill>
                   <a:srgbClr val="FFFFFF"/>
                 </a:solidFill>
@@ -17625,7 +17929,7 @@
                 <a:cs typeface="Raleway 1 Heavy"/>
                 <a:sym typeface="Raleway 1 Heavy"/>
               </a:rPr>
-              <a:t>Lo que el lago nos enseñó</a:t>
+              <a:t>Lo que aprendimos del data lake</a:t>
             </a:r>
           </a:p>
         </p:txBody>
@@ -17964,7 +18268,7 @@
                 </a:solidFill>
                 <a:latin typeface="Arial"/>
               </a:rPr>
-              <a:t>S3 Tables: IAM</a:t>
+              <a:t>S3 Tables pide IAM</a:t>
             </a:r>
           </a:p>
           <a:p>
@@ -18034,7 +18338,7 @@
                 </a:solidFill>
                 <a:latin typeface="Arial"/>
               </a:rPr>
-              <a:t>Iceberg: sin CHAR</a:t>
+              <a:t>Iceberg no acepta CHAR</a:t>
             </a:r>
           </a:p>
           <a:p>
@@ -18104,7 +18408,7 @@
                 </a:solidFill>
                 <a:latin typeface="Arial"/>
               </a:rPr>
-              <a:t>Lake Formation</a:t>
+              <a:t>Lake Formation manda</a:t>
             </a:r>
           </a:p>
           <a:p>
@@ -18154,7 +18458,7 @@
                 </a:solidFill>
                 <a:latin typeface="Arial"/>
               </a:rPr>
-              <a:t>Si piensas usar S3 Tables desde Redshift, </a:t>
+              <a:t>Si vas a usar S3 Tables desde Redshift, </a:t>
             </a:r>
             <a:r>
               <a:rPr sz="2400" b="1">
@@ -18163,7 +18467,7 @@
                 </a:solidFill>
                 <a:latin typeface="Arial"/>
               </a:rPr>
-              <a:t>define primero tu modelo de autenticación.</a:t>
+              <a:t>decide primero cómo se van a autenticar tus usuarios.</a:t>
             </a:r>
           </a:p>
         </p:txBody>
@@ -18711,7 +19015,7 @@
                 <a:cs typeface="Raleway 1 Heavy"/>
                 <a:sym typeface="Raleway 1 Heavy"/>
               </a:rPr>
-              <a:t>Migrar tomó 2 min 48 s</a:t>
+              <a:t>La migración tomó 2 min 48 s</a:t>
             </a:r>
           </a:p>
         </p:txBody>
@@ -19005,7 +19309,7 @@
         <p:spPr>
           <a:xfrm>
             <a:off x="1188720" y="4937760"/>
-            <a:ext cx="13716000" cy="0"/>
+            <a:ext cx="13441680" cy="0"/>
           </a:xfrm>
           <a:prstGeom prst="line">
             <a:avLst/>
@@ -19121,8 +19425,8 @@
         </p:nvSpPr>
         <p:spPr>
           <a:xfrm>
-            <a:off x="182879" y="5349240"/>
-            <a:ext cx="2011680" cy="548640"/>
+            <a:off x="91440" y="5349240"/>
+            <a:ext cx="2194560" cy="822960"/>
           </a:xfrm>
           <a:prstGeom prst="rect">
             <a:avLst/>
@@ -19141,7 +19445,7 @@
               </a:spcAft>
             </a:pPr>
             <a:r>
-              <a:rPr sz="1800" b="1">
+              <a:rPr sz="1700" b="1">
                 <a:solidFill>
                   <a:srgbClr val="FFFFFF"/>
                 </a:solidFill>
@@ -19160,7 +19464,7 @@
         </p:nvSpPr>
         <p:spPr>
           <a:xfrm>
-            <a:off x="3218687" y="4681728"/>
+            <a:off x="3172968" y="4681728"/>
             <a:ext cx="512064" cy="512064"/>
           </a:xfrm>
           <a:prstGeom prst="ellipse">
@@ -19203,7 +19507,7 @@
         </p:nvSpPr>
         <p:spPr>
           <a:xfrm>
-            <a:off x="2468879" y="3749040"/>
+            <a:off x="2423160" y="3749040"/>
             <a:ext cx="2011680" cy="548640"/>
           </a:xfrm>
           <a:prstGeom prst="rect">
@@ -19242,8 +19546,8 @@
         </p:nvSpPr>
         <p:spPr>
           <a:xfrm>
-            <a:off x="2468879" y="5349240"/>
-            <a:ext cx="2011680" cy="548640"/>
+            <a:off x="2331720" y="5349240"/>
+            <a:ext cx="2194560" cy="822960"/>
           </a:xfrm>
           <a:prstGeom prst="rect">
             <a:avLst/>
@@ -19262,13 +19566,13 @@
               </a:spcAft>
             </a:pPr>
             <a:r>
-              <a:rPr sz="1800" b="1">
+              <a:rPr sz="1700" b="1">
                 <a:solidFill>
                   <a:srgbClr val="8FB4FF"/>
                 </a:solidFill>
                 <a:latin typeface="Arial"/>
               </a:rPr>
-              <a:t>escribe</a:t>
+              <a:t>se puede escribir</a:t>
             </a:r>
           </a:p>
         </p:txBody>
@@ -19281,7 +19585,7 @@
         </p:nvSpPr>
         <p:spPr>
           <a:xfrm>
-            <a:off x="5504688" y="4681728"/>
+            <a:off x="5413247" y="4681728"/>
             <a:ext cx="512064" cy="512064"/>
           </a:xfrm>
           <a:prstGeom prst="ellipse">
@@ -19324,7 +19628,7 @@
         </p:nvSpPr>
         <p:spPr>
           <a:xfrm>
-            <a:off x="4754879" y="3749040"/>
+            <a:off x="4663440" y="3749040"/>
             <a:ext cx="2011680" cy="548640"/>
           </a:xfrm>
           <a:prstGeom prst="rect">
@@ -19363,8 +19667,8 @@
         </p:nvSpPr>
         <p:spPr>
           <a:xfrm>
-            <a:off x="4754879" y="5349240"/>
-            <a:ext cx="2011680" cy="548640"/>
+            <a:off x="4571999" y="5349240"/>
+            <a:ext cx="2194560" cy="822960"/>
           </a:xfrm>
           <a:prstGeom prst="rect">
             <a:avLst/>
@@ -19383,7 +19687,7 @@
               </a:spcAft>
             </a:pPr>
             <a:r>
-              <a:rPr sz="1800" b="1">
+              <a:rPr sz="1700" b="1">
                 <a:solidFill>
                   <a:srgbClr val="F2A65A"/>
                 </a:solidFill>
@@ -19402,7 +19706,7 @@
         </p:nvSpPr>
         <p:spPr>
           <a:xfrm>
-            <a:off x="7790688" y="4681728"/>
+            <a:off x="7653527" y="4681728"/>
             <a:ext cx="512064" cy="512064"/>
           </a:xfrm>
           <a:prstGeom prst="ellipse">
@@ -19445,7 +19749,7 @@
         </p:nvSpPr>
         <p:spPr>
           <a:xfrm>
-            <a:off x="7040880" y="3749040"/>
+            <a:off x="6903719" y="3749040"/>
             <a:ext cx="2011680" cy="548640"/>
           </a:xfrm>
           <a:prstGeom prst="rect">
@@ -19484,8 +19788,8 @@
         </p:nvSpPr>
         <p:spPr>
           <a:xfrm>
-            <a:off x="7040880" y="5349240"/>
-            <a:ext cx="2011680" cy="548640"/>
+            <a:off x="6812279" y="5349240"/>
+            <a:ext cx="2194560" cy="822960"/>
           </a:xfrm>
           <a:prstGeom prst="rect">
             <a:avLst/>
@@ -19504,7 +19808,7 @@
               </a:spcAft>
             </a:pPr>
             <a:r>
-              <a:rPr sz="1800" b="1">
+              <a:rPr sz="1700" b="1">
                 <a:solidFill>
                   <a:srgbClr val="F2A65A"/>
                 </a:solidFill>
@@ -19523,7 +19827,7 @@
         </p:nvSpPr>
         <p:spPr>
           <a:xfrm>
-            <a:off x="10076688" y="4681728"/>
+            <a:off x="9893808" y="4681728"/>
             <a:ext cx="512064" cy="512064"/>
           </a:xfrm>
           <a:prstGeom prst="ellipse">
@@ -19566,7 +19870,7 @@
         </p:nvSpPr>
         <p:spPr>
           <a:xfrm>
-            <a:off x="9326880" y="3749040"/>
+            <a:off x="9144000" y="3749040"/>
             <a:ext cx="2011680" cy="548640"/>
           </a:xfrm>
           <a:prstGeom prst="rect">
@@ -19605,8 +19909,8 @@
         </p:nvSpPr>
         <p:spPr>
           <a:xfrm>
-            <a:off x="9326880" y="5349240"/>
-            <a:ext cx="2011680" cy="548640"/>
+            <a:off x="9052560" y="5349240"/>
+            <a:ext cx="2194560" cy="822960"/>
           </a:xfrm>
           <a:prstGeom prst="rect">
             <a:avLst/>
@@ -19625,7 +19929,7 @@
               </a:spcAft>
             </a:pPr>
             <a:r>
-              <a:rPr sz="1800" b="1">
+              <a:rPr sz="1700" b="1">
                 <a:solidFill>
                   <a:srgbClr val="F2A65A"/>
                 </a:solidFill>
@@ -19644,7 +19948,7 @@
         </p:nvSpPr>
         <p:spPr>
           <a:xfrm>
-            <a:off x="12362688" y="4681728"/>
+            <a:off x="12134088" y="4681728"/>
             <a:ext cx="512064" cy="512064"/>
           </a:xfrm>
           <a:prstGeom prst="ellipse">
@@ -19687,7 +19991,7 @@
         </p:nvSpPr>
         <p:spPr>
           <a:xfrm>
-            <a:off x="11612880" y="3749040"/>
+            <a:off x="11384280" y="3749040"/>
             <a:ext cx="2011680" cy="548640"/>
           </a:xfrm>
           <a:prstGeom prst="rect">
@@ -19726,8 +20030,8 @@
         </p:nvSpPr>
         <p:spPr>
           <a:xfrm>
-            <a:off x="11612880" y="5349240"/>
-            <a:ext cx="2011680" cy="548640"/>
+            <a:off x="11292840" y="5349240"/>
+            <a:ext cx="2194560" cy="822960"/>
           </a:xfrm>
           <a:prstGeom prst="rect">
             <a:avLst/>
@@ -19746,7 +20050,7 @@
               </a:spcAft>
             </a:pPr>
             <a:r>
-              <a:rPr sz="1800" b="1">
+              <a:rPr sz="1700" b="1">
                 <a:solidFill>
                   <a:srgbClr val="F2A65A"/>
                 </a:solidFill>
@@ -19765,7 +20069,7 @@
         </p:nvSpPr>
         <p:spPr>
           <a:xfrm>
-            <a:off x="14648688" y="4681728"/>
+            <a:off x="14374367" y="4681728"/>
             <a:ext cx="512064" cy="512064"/>
           </a:xfrm>
           <a:prstGeom prst="ellipse">
@@ -19808,7 +20112,7 @@
         </p:nvSpPr>
         <p:spPr>
           <a:xfrm>
-            <a:off x="13898880" y="3749040"/>
+            <a:off x="13624559" y="3749040"/>
             <a:ext cx="2011680" cy="548640"/>
           </a:xfrm>
           <a:prstGeom prst="rect">
@@ -19847,8 +20151,8 @@
         </p:nvSpPr>
         <p:spPr>
           <a:xfrm>
-            <a:off x="13898880" y="5349240"/>
-            <a:ext cx="2011680" cy="548640"/>
+            <a:off x="13533119" y="5349240"/>
+            <a:ext cx="2194560" cy="822960"/>
           </a:xfrm>
           <a:prstGeom prst="rect">
             <a:avLst/>
@@ -19867,13 +20171,13 @@
               </a:spcAft>
             </a:pPr>
             <a:r>
-              <a:rPr sz="1800" b="1">
+              <a:rPr sz="1700" b="1">
                 <a:solidFill>
                   <a:srgbClr val="8FB4FF"/>
                 </a:solidFill>
                 <a:latin typeface="Arial"/>
               </a:rPr>
-              <a:t>escribe</a:t>
+              <a:t>se puede escribir</a:t>
             </a:r>
           </a:p>
         </p:txBody>
@@ -19912,7 +20216,7 @@
                 </a:solidFill>
                 <a:latin typeface="Arial"/>
               </a:rPr>
-              <a:t>1:35 – 2:42</a:t>
+              <a:t>1:35 a 2:42</a:t>
             </a:r>
           </a:p>
         </p:txBody>
@@ -19951,7 +20255,7 @@
                 </a:solidFill>
                 <a:latin typeface="Arial"/>
               </a:rPr>
-              <a:t>minutos en solo lectura (sondeo cada 30 s)</a:t>
+              <a:t>minutos sin poder escribir (lo revisamos cada 30 s)</a:t>
             </a:r>
           </a:p>
         </p:txBody>
@@ -19965,7 +20269,7 @@
         <p:spPr>
           <a:xfrm>
             <a:off x="8321040" y="5943600"/>
-            <a:ext cx="6949440" cy="1280160"/>
+            <a:ext cx="6766560" cy="1280160"/>
           </a:xfrm>
           <a:prstGeom prst="rect">
             <a:avLst/>
@@ -20004,7 +20308,7 @@
         <p:spPr>
           <a:xfrm>
             <a:off x="8321040" y="7315200"/>
-            <a:ext cx="6949440" cy="1097280"/>
+            <a:ext cx="6766560" cy="1097280"/>
           </a:xfrm>
           <a:prstGeom prst="rect">
             <a:avLst/>
@@ -20029,7 +20333,7 @@
                 </a:solidFill>
                 <a:latin typeface="Arial"/>
               </a:rPr>
-              <a:t>en el skew: 1:1 conserva los slices</a:t>
+              <a:t>en cómo se reparten los datos entre nodos</a:t>
             </a:r>
           </a:p>
         </p:txBody>
@@ -20155,7 +20459,7 @@
                 <a:cs typeface="Raleway 1 Heavy"/>
                 <a:sym typeface="Raleway 1 Heavy"/>
               </a:rPr>
-              <a:t>Trampas del camino</a:t>
+              <a:t>Lo que nadie te cuenta</a:t>
             </a:r>
           </a:p>
         </p:txBody>
@@ -20449,7 +20753,7 @@
         <p:spPr>
           <a:xfrm>
             <a:off x="914400" y="3200400"/>
-            <a:ext cx="14264640" cy="5394960"/>
+            <a:ext cx="13898880" cy="5394960"/>
           </a:xfrm>
           <a:prstGeom prst="rect">
             <a:avLst/>
@@ -20475,7 +20779,7 @@
                 </a:solidFill>
                 <a:latin typeface="Arial"/>
               </a:rPr>
-              <a:t>Contraseña administrada:</a:t>
+              <a:t>La contraseña administrada:</a:t>
             </a:r>
             <a:r>
               <a:rPr sz="2300" b="0">
@@ -20484,7 +20788,7 @@
                 </a:solidFill>
                 <a:latin typeface="Arial"/>
               </a:rPr>
-              <a:t> un snapshot con contraseña administrada solo se restaura con ‑‑manage‑master‑password</a:t>
+              <a:t> para restaurar el snapshot hay que volver a pedirla con ‑‑manage‑master‑password</a:t>
             </a:r>
           </a:p>
           <a:p>
@@ -20501,7 +20805,7 @@
                 </a:solidFill>
                 <a:latin typeface="Arial"/>
               </a:rPr>
-              <a:t>Primero un backup:</a:t>
+              <a:t>Primero, un snapshot:</a:t>
             </a:r>
             <a:r>
               <a:rPr sz="2300" b="0">
@@ -20510,7 +20814,7 @@
                 </a:solidFill>
                 <a:latin typeface="Arial"/>
               </a:rPr>
-              <a:t> un clúster restaurado no acepta elastic resize hasta tener un snapshot propio</a:t>
+              <a:t> un clúster recién restaurado no acepta el resize hasta tener un snapshot propio</a:t>
             </a:r>
           </a:p>
           <a:p>
@@ -20527,7 +20831,7 @@
                 </a:solidFill>
                 <a:latin typeface="Arial"/>
               </a:rPr>
-              <a:t>«Available» no siempre es disponible:</a:t>
+              <a:t>«Disponible» no es lo mismo que listo:</a:t>
             </a:r>
             <a:r>
               <a:rPr sz="2300" b="0">
@@ -20536,7 +20840,7 @@
                 </a:solidFill>
                 <a:latin typeface="Arial"/>
               </a:rPr>
-              <a:t> el estado dice available mientras otro campo sigue en Modifying</a:t>
+              <a:t> el estado dice available, pero otro campo sigue en Modifying y el resize falla</a:t>
             </a:r>
           </a:p>
           <a:p>
@@ -20553,7 +20857,7 @@
                 </a:solidFill>
                 <a:latin typeface="Arial"/>
               </a:rPr>
-              <a:t>El 4 → 3 y el skew:</a:t>
+              <a:t>De 4 a 3 nodos:</a:t>
             </a:r>
             <a:r>
               <a:rPr sz="2300" b="0">
@@ -20562,7 +20866,7 @@
                 </a:solidFill>
                 <a:latin typeface="Arial"/>
               </a:rPr>
-              <a:t> cambiar la cantidad de nodos puede desbalancear los slices</a:t>
+              <a:t> cambiar la cantidad de nodos puede desbalancear los datos</a:t>
             </a:r>
           </a:p>
           <a:p>
@@ -20579,7 +20883,7 @@
                 </a:solidFill>
                 <a:latin typeface="Arial"/>
               </a:rPr>
-              <a:t>Restore = endpoint nuevo:</a:t>
+              <a:t>Restaurar cambia el endpoint:</a:t>
             </a:r>
             <a:r>
               <a:rPr sz="2300" b="0">
@@ -20588,7 +20892,7 @@
                 </a:solidFill>
                 <a:latin typeface="Arial"/>
               </a:rPr>
-              <a:t> si migras restaurando, reconfigura zero-ETL, DMS y datashares</a:t>
+              <a:t> si migras desde un snapshot, hay que reconfigurar zero-ETL, DMS y datashares</a:t>
             </a:r>
           </a:p>
         </p:txBody>
@@ -21136,7 +21440,7 @@
                 <a:cs typeface="Raleway 1 Heavy"/>
                 <a:sym typeface="Raleway 1 Heavy"/>
               </a:rPr>
-              <a:t>Demo: una consulta, dos generaciones</a:t>
+              <a:t>Demo: una consulta, dos clústeres</a:t>
             </a:r>
           </a:p>
         </p:txBody>
@@ -21430,7 +21734,7 @@
         <p:spPr>
           <a:xfrm>
             <a:off x="914400" y="3200400"/>
-            <a:ext cx="9326880" cy="4572000"/>
+            <a:ext cx="9326880" cy="3931920"/>
           </a:xfrm>
           <a:prstGeom prst="roundRect">
             <a:avLst>
@@ -21464,7 +21768,7 @@
           <a:p>
             <a:pPr algn="l"/>
             <a:r>
-              <a:rPr sz="1800">
+              <a:rPr sz="1700">
                 <a:solidFill>
                   <a:srgbClr val="D9E2EC"/>
                 </a:solidFill>
@@ -21476,7 +21780,7 @@
           <a:p>
             <a:pPr algn="l"/>
             <a:r>
-              <a:rPr sz="1800">
+              <a:rPr sz="1700">
                 <a:solidFill>
                   <a:srgbClr val="D9E2EC"/>
                 </a:solidFill>
@@ -21488,7 +21792,7 @@
           <a:p>
             <a:pPr algn="l"/>
             <a:r>
-              <a:rPr sz="1800">
+              <a:rPr sz="1700">
                 <a:solidFill>
                   <a:srgbClr val="D9E2EC"/>
                 </a:solidFill>
@@ -21500,7 +21804,7 @@
           <a:p>
             <a:pPr algn="l"/>
             <a:r>
-              <a:rPr sz="1800">
+              <a:rPr sz="1700">
                 <a:solidFill>
                   <a:srgbClr val="D9E2EC"/>
                 </a:solidFill>
@@ -21512,7 +21816,7 @@
           <a:p>
             <a:pPr algn="l"/>
             <a:r>
-              <a:rPr sz="1800">
+              <a:rPr sz="1700">
                 <a:solidFill>
                   <a:srgbClr val="D9E2EC"/>
                 </a:solidFill>
@@ -21524,7 +21828,7 @@
           <a:p>
             <a:pPr algn="l"/>
             <a:r>
-              <a:rPr sz="1800">
+              <a:rPr sz="1700">
                 <a:solidFill>
                   <a:srgbClr val="D9E2EC"/>
                 </a:solidFill>
@@ -21536,7 +21840,7 @@
           <a:p>
             <a:pPr algn="l"/>
             <a:r>
-              <a:rPr sz="1800">
+              <a:rPr sz="1700">
                 <a:solidFill>
                   <a:srgbClr val="D9E2EC"/>
                 </a:solidFill>
@@ -21548,7 +21852,7 @@
           <a:p>
             <a:pPr algn="l"/>
             <a:r>
-              <a:rPr sz="1800">
+              <a:rPr sz="1700">
                 <a:solidFill>
                   <a:srgbClr val="D9E2EC"/>
                 </a:solidFill>
@@ -21560,7 +21864,7 @@
           <a:p>
             <a:pPr algn="l"/>
             <a:r>
-              <a:rPr sz="1800">
+              <a:rPr sz="1700">
                 <a:solidFill>
                   <a:srgbClr val="D9E2EC"/>
                 </a:solidFill>
@@ -21572,7 +21876,7 @@
           <a:p>
             <a:pPr algn="l"/>
             <a:r>
-              <a:rPr sz="1800">
+              <a:rPr sz="1700">
                 <a:solidFill>
                   <a:srgbClr val="D9E2EC"/>
                 </a:solidFill>
@@ -21584,7 +21888,7 @@
           <a:p>
             <a:pPr algn="l"/>
             <a:r>
-              <a:rPr sz="1800">
+              <a:rPr sz="1700">
                 <a:solidFill>
                   <a:srgbClr val="D9E2EC"/>
                 </a:solidFill>
@@ -21603,8 +21907,8 @@
         </p:nvSpPr>
         <p:spPr>
           <a:xfrm>
-            <a:off x="10607040" y="3200400"/>
-            <a:ext cx="4754880" cy="1280160"/>
+            <a:off x="914400" y="7315200"/>
+            <a:ext cx="9326880" cy="1280160"/>
           </a:xfrm>
           <a:prstGeom prst="rect">
             <a:avLst/>
@@ -21612,7 +21916,7 @@
           <a:noFill/>
         </p:spPr>
         <p:txBody>
-          <a:bodyPr wrap="square" anchor="b" lIns="0" rIns="0" tIns="0" bIns="0">
+          <a:bodyPr wrap="square" anchor="t" lIns="0" rIns="0" tIns="0" bIns="0">
             <a:spAutoFit/>
           </a:bodyPr>
           <a:lstStyle/>
@@ -21623,13 +21927,22 @@
               </a:spcAft>
             </a:pPr>
             <a:r>
-              <a:rPr sz="5600" b="1">
-                <a:solidFill>
-                  <a:srgbClr val="8FA3B8"/>
+              <a:rPr sz="2000" b="1">
+                <a:solidFill>
+                  <a:srgbClr val="D9E2EC"/>
                 </a:solidFill>
                 <a:latin typeface="Arial"/>
               </a:rPr>
-              <a:t>1,77 s</a:t>
+              <a:t>Por qué pesa:</a:t>
+            </a:r>
+            <a:r>
+              <a:rPr sz="2000" b="0">
+                <a:solidFill>
+                  <a:srgbClr val="D9E2EC"/>
+                </a:solidFill>
+                <a:latin typeface="Arial"/>
+              </a:rPr>
+              <a:t> recorre las 288 millones de ventas de store_sales y las cruza con tres tablas para quedarse con una franja horaria y un tipo de hogar.</a:t>
             </a:r>
           </a:p>
         </p:txBody>
@@ -21642,8 +21955,8 @@
         </p:nvSpPr>
         <p:spPr>
           <a:xfrm>
-            <a:off x="10607040" y="4572000"/>
-            <a:ext cx="4754880" cy="1097280"/>
+            <a:off x="10607040" y="3474720"/>
+            <a:ext cx="4572000" cy="457200"/>
           </a:xfrm>
           <a:prstGeom prst="rect">
             <a:avLst/>
@@ -21662,13 +21975,13 @@
               </a:spcAft>
             </a:pPr>
             <a:r>
-              <a:rPr sz="2200" b="0">
+              <a:rPr sz="2000" b="0">
                 <a:solidFill>
                   <a:srgbClr val="D9E2EC"/>
                 </a:solidFill>
                 <a:latin typeface="Arial"/>
               </a:rPr>
-              <a:t>RA3 (query96)</a:t>
+              <a:t>query96</a:t>
             </a:r>
           </a:p>
         </p:txBody>
@@ -21681,8 +21994,8 @@
         </p:nvSpPr>
         <p:spPr>
           <a:xfrm>
-            <a:off x="10607040" y="5852160"/>
-            <a:ext cx="4754880" cy="1280160"/>
+            <a:off x="10607040" y="3977639"/>
+            <a:ext cx="2286000" cy="914400"/>
           </a:xfrm>
           <a:prstGeom prst="rect">
             <a:avLst/>
@@ -21690,7 +22003,7 @@
           <a:noFill/>
         </p:spPr>
         <p:txBody>
-          <a:bodyPr wrap="square" anchor="b" lIns="0" rIns="0" tIns="0" bIns="0">
+          <a:bodyPr wrap="square" anchor="t" lIns="0" rIns="0" tIns="0" bIns="0">
             <a:spAutoFit/>
           </a:bodyPr>
           <a:lstStyle/>
@@ -21701,13 +22014,13 @@
               </a:spcAft>
             </a:pPr>
             <a:r>
-              <a:rPr sz="5600" b="1">
-                <a:solidFill>
-                  <a:srgbClr val="316CE3"/>
+              <a:rPr sz="4000" b="1">
+                <a:solidFill>
+                  <a:srgbClr val="8FA3B8"/>
                 </a:solidFill>
                 <a:latin typeface="Arial"/>
               </a:rPr>
-              <a:t>0,67 s</a:t>
+              <a:t>1,77 s</a:t>
             </a:r>
           </a:p>
         </p:txBody>
@@ -21720,8 +22033,8 @@
         </p:nvSpPr>
         <p:spPr>
           <a:xfrm>
-            <a:off x="10607040" y="7223760"/>
-            <a:ext cx="4754880" cy="1097280"/>
+            <a:off x="12893040" y="3977639"/>
+            <a:ext cx="2286000" cy="914400"/>
           </a:xfrm>
           <a:prstGeom prst="rect">
             <a:avLst/>
@@ -21740,13 +22053,187 @@
               </a:spcAft>
             </a:pPr>
             <a:r>
-              <a:rPr sz="2200" b="0">
-                <a:solidFill>
-                  <a:srgbClr val="D9E2EC"/>
+              <a:rPr sz="4000" b="1">
+                <a:solidFill>
+                  <a:srgbClr val="316CE3"/>
                 </a:solidFill>
                 <a:latin typeface="Arial"/>
               </a:rPr>
-              <a:t>RG · 2,64x</a:t>
+              <a:t>0,67 s</a:t>
+            </a:r>
+          </a:p>
+        </p:txBody>
+      </p:sp>
+      <p:sp>
+        <p:nvSpPr>
+          <p:cNvPr id="15" name="TextBox 14"/>
+          <p:cNvSpPr txBox="1"/>
+          <p:nvPr/>
+        </p:nvSpPr>
+        <p:spPr>
+          <a:xfrm>
+            <a:off x="10607040" y="4754879"/>
+            <a:ext cx="2286000" cy="457200"/>
+          </a:xfrm>
+          <a:prstGeom prst="rect">
+            <a:avLst/>
+          </a:prstGeom>
+          <a:noFill/>
+        </p:spPr>
+        <p:txBody>
+          <a:bodyPr wrap="square" anchor="t" lIns="0" rIns="0" tIns="0" bIns="0">
+            <a:spAutoFit/>
+          </a:bodyPr>
+          <a:lstStyle/>
+          <a:p>
+            <a:pPr algn="l">
+              <a:spcAft>
+                <a:spcPts val="1000"/>
+              </a:spcAft>
+            </a:pPr>
+            <a:r>
+              <a:rPr sz="1800" b="0">
+                <a:solidFill>
+                  <a:srgbClr val="8FA3B8"/>
+                </a:solidFill>
+                <a:latin typeface="Arial"/>
+              </a:rPr>
+              <a:t>RA3</a:t>
+            </a:r>
+          </a:p>
+        </p:txBody>
+      </p:sp>
+      <p:sp>
+        <p:nvSpPr>
+          <p:cNvPr id="16" name="TextBox 15"/>
+          <p:cNvSpPr txBox="1"/>
+          <p:nvPr/>
+        </p:nvSpPr>
+        <p:spPr>
+          <a:xfrm>
+            <a:off x="12893040" y="4754879"/>
+            <a:ext cx="2286000" cy="457200"/>
+          </a:xfrm>
+          <a:prstGeom prst="rect">
+            <a:avLst/>
+          </a:prstGeom>
+          <a:noFill/>
+        </p:spPr>
+        <p:txBody>
+          <a:bodyPr wrap="square" anchor="t" lIns="0" rIns="0" tIns="0" bIns="0">
+            <a:spAutoFit/>
+          </a:bodyPr>
+          <a:lstStyle/>
+          <a:p>
+            <a:pPr algn="l">
+              <a:spcAft>
+                <a:spcPts val="1000"/>
+              </a:spcAft>
+            </a:pPr>
+            <a:r>
+              <a:rPr sz="1800" b="0">
+                <a:solidFill>
+                  <a:srgbClr val="316CE3"/>
+                </a:solidFill>
+                <a:latin typeface="Arial"/>
+              </a:rPr>
+              <a:t>RG</a:t>
+            </a:r>
+          </a:p>
+        </p:txBody>
+      </p:sp>
+      <p:sp>
+        <p:nvSpPr>
+          <p:cNvPr id="17" name="TextBox 16"/>
+          <p:cNvSpPr txBox="1"/>
+          <p:nvPr/>
+        </p:nvSpPr>
+        <p:spPr>
+          <a:xfrm>
+            <a:off x="10607040" y="5166360"/>
+            <a:ext cx="4572000" cy="457200"/>
+          </a:xfrm>
+          <a:prstGeom prst="rect">
+            <a:avLst/>
+          </a:prstGeom>
+          <a:noFill/>
+        </p:spPr>
+        <p:txBody>
+          <a:bodyPr wrap="square" anchor="t" lIns="0" rIns="0" tIns="0" bIns="0">
+            <a:spAutoFit/>
+          </a:bodyPr>
+          <a:lstStyle/>
+          <a:p>
+            <a:pPr algn="l">
+              <a:spcAft>
+                <a:spcPts val="1000"/>
+              </a:spcAft>
+            </a:pPr>
+            <a:r>
+              <a:rPr sz="1600" b="0">
+                <a:solidFill>
+                  <a:srgbClr val="9FB3C8"/>
+                </a:solidFill>
+                <a:latin typeface="Arial"/>
+              </a:rPr>
+              <a:t>menos tiempo es mejor</a:t>
+            </a:r>
+          </a:p>
+        </p:txBody>
+      </p:sp>
+      <p:sp>
+        <p:nvSpPr>
+          <p:cNvPr id="18" name="TextBox 17"/>
+          <p:cNvSpPr txBox="1"/>
+          <p:nvPr/>
+        </p:nvSpPr>
+        <p:spPr>
+          <a:xfrm>
+            <a:off x="10607040" y="5943600"/>
+            <a:ext cx="4572000" cy="1097280"/>
+          </a:xfrm>
+          <a:prstGeom prst="rect">
+            <a:avLst/>
+          </a:prstGeom>
+          <a:noFill/>
+        </p:spPr>
+        <p:txBody>
+          <a:bodyPr wrap="square" anchor="t" lIns="0" rIns="0" tIns="0" bIns="0">
+            <a:spAutoFit/>
+          </a:bodyPr>
+          <a:lstStyle/>
+          <a:p>
+            <a:pPr algn="l">
+              <a:spcAft>
+                <a:spcPts val="1000"/>
+              </a:spcAft>
+            </a:pPr>
+            <a:r>
+              <a:rPr sz="2800" b="0">
+                <a:solidFill>
+                  <a:srgbClr val="FFFFFF"/>
+                </a:solidFill>
+                <a:latin typeface="Arial"/>
+              </a:rPr>
+              <a:t>RG fue </a:t>
+            </a:r>
+            <a:r>
+              <a:rPr sz="2800" b="1">
+                <a:solidFill>
+                  <a:srgbClr val="FFFFFF"/>
+                </a:solidFill>
+                <a:latin typeface="Arial"/>
+              </a:rPr>
+              <a:t>2,64x</a:t>
+            </a:r>
+            <a:r>
+              <a:rPr sz="2800" b="0">
+                <a:solidFill>
+                  <a:srgbClr val="FFFFFF"/>
+                </a:solidFill>
+                <a:latin typeface="Arial"/>
+              </a:rPr>
+              <a:t> más rápido</a:t>
             </a:r>
           </a:p>
         </p:txBody>
@@ -21927,7 +22414,7 @@
                 <a:cs typeface="Raleway 2"/>
                 <a:sym typeface="Raleway 2"/>
               </a:rPr>
-              <a:t>Qué cambió de RA3 a RG</a:t>
+              <a:t>Qué cambia con RG</a:t>
             </a:r>
           </a:p>
           <a:p>
@@ -21969,7 +22456,7 @@
                 <a:cs typeface="Raleway 2"/>
                 <a:sym typeface="Raleway 2"/>
               </a:rPr>
-              <a:t>Warehouse: potencia, concurrencia y costo</a:t>
+              <a:t>Warehouse: velocidad, concurrencia y costo</a:t>
             </a:r>
           </a:p>
           <a:p>
@@ -22011,7 +22498,7 @@
                 <a:cs typeface="Raleway 2"/>
                 <a:sym typeface="Raleway 2"/>
               </a:rPr>
-              <a:t>La migración y sus trampas</a:t>
+              <a:t>La migración y lo que nadie te cuenta</a:t>
             </a:r>
           </a:p>
           <a:p>
@@ -22377,7 +22864,7 @@
               </a:spcBef>
             </a:pPr>
             <a:r>
-              <a:rPr lang="en-US" b="true" sz="4400">
+              <a:rPr lang="en-US" b="true" sz="5000">
                 <a:solidFill>
                   <a:srgbClr val="FFFFFF"/>
                 </a:solidFill>
@@ -22386,7 +22873,7 @@
                 <a:cs typeface="Raleway 1 Heavy"/>
                 <a:sym typeface="Raleway 1 Heavy"/>
               </a:rPr>
-              <a:t>Demo: mismo plan, distinto motor</a:t>
+              <a:t>Demo: el mismo plan en los dos</a:t>
             </a:r>
           </a:p>
         </p:txBody>
@@ -22966,7 +23453,7 @@
                 </a:solidFill>
                 <a:latin typeface="Arial"/>
               </a:rPr>
-              <a:t>Lo único distinto: quién lee S3.</a:t>
+              <a:t>Lo único que cambia es quién lee los datos de S3.</a:t>
             </a:r>
           </a:p>
         </p:txBody>
@@ -23409,8 +23896,8 @@
         </p:nvSpPr>
         <p:spPr>
           <a:xfrm>
-            <a:off x="10789920" y="3383280"/>
-            <a:ext cx="4389120" cy="4937760"/>
+            <a:off x="10607040" y="3383280"/>
+            <a:ext cx="4389119" cy="4937760"/>
           </a:xfrm>
           <a:prstGeom prst="rect">
             <a:avLst/>
@@ -23429,13 +23916,13 @@
               </a:spcAft>
             </a:pPr>
             <a:r>
-              <a:rPr sz="2400" b="0">
+              <a:rPr sz="2300" b="0">
                 <a:solidFill>
                   <a:srgbClr val="D9E2EC"/>
                 </a:solidFill>
                 <a:latin typeface="Arial"/>
               </a:rPr>
-              <a:t>Página interactiva con todos los números de la charla:</a:t>
+              <a:t>Una página con todos los números de la charla:</a:t>
             </a:r>
           </a:p>
           <a:p>
@@ -23445,13 +23932,13 @@
               </a:spcAft>
             </a:pPr>
             <a:r>
-              <a:rPr sz="2400" b="0">
+              <a:rPr sz="2300" b="0">
                 <a:solidFill>
                   <a:srgbClr val="D9E2EC"/>
                 </a:solidFill>
                 <a:latin typeface="Arial"/>
               </a:rPr>
-              <a:t>Aceleración por consulta, filtrable por clase</a:t>
+              <a:t>Cuánto mejoró RG en cada consulta</a:t>
             </a:r>
           </a:p>
           <a:p>
@@ -23461,13 +23948,13 @@
               </a:spcAft>
             </a:pPr>
             <a:r>
-              <a:rPr sz="2400" b="0">
+              <a:rPr sz="2300" b="0">
                 <a:solidFill>
                   <a:srgbClr val="D9E2EC"/>
                 </a:solidFill>
                 <a:latin typeface="Arial"/>
               </a:rPr>
-              <a:t>El lago antes y después de reescribir Parquet</a:t>
+              <a:t>El data lake antes y después de reescribir los archivos Parquet</a:t>
             </a:r>
           </a:p>
           <a:p>
@@ -23477,13 +23964,13 @@
               </a:spcAft>
             </a:pPr>
             <a:r>
-              <a:rPr sz="2400" b="0">
+              <a:rPr sz="2300" b="0">
                 <a:solidFill>
                   <a:srgbClr val="D9E2EC"/>
                 </a:solidFill>
                 <a:latin typeface="Arial"/>
               </a:rPr>
-              <a:t>La línea de tiempo del simulacro</a:t>
+              <a:t>La línea de tiempo de la migración</a:t>
             </a:r>
           </a:p>
         </p:txBody>
@@ -23903,7 +24390,7 @@
         <p:spPr>
           <a:xfrm>
             <a:off x="914400" y="3200400"/>
-            <a:ext cx="4480560" cy="3931920"/>
+            <a:ext cx="4480560" cy="4023360"/>
           </a:xfrm>
           <a:prstGeom prst="roundRect">
             <a:avLst>
@@ -23964,7 +24451,7 @@
                 </a:solidFill>
                 <a:latin typeface="Arial"/>
               </a:rPr>
-              <a:t>• Tu carga es de scan y agregación</a:t>
+              <a:t>• Tus consultas leen y agregan muchos datos (dashboards, reportes)</a:t>
             </a:r>
           </a:p>
           <a:p>
@@ -23980,7 +24467,7 @@
                 </a:solidFill>
                 <a:latin typeface="Arial"/>
               </a:rPr>
-              <a:t>• Lees el data lake con frecuencia</a:t>
+              <a:t>• Consultas seguido el data lake</a:t>
             </a:r>
           </a:p>
           <a:p>
@@ -23996,7 +24483,7 @@
                 </a:solidFill>
                 <a:latin typeface="Arial"/>
               </a:rPr>
-              <a:t>• Estás en xlplus o 4xlarge: 30 % menos por vCPU</a:t>
+              <a:t>• Usas xlplus o 4xlarge: pagas 30 % menos por vCPU</a:t>
             </a:r>
           </a:p>
         </p:txBody>
@@ -24010,7 +24497,7 @@
         <p:spPr>
           <a:xfrm>
             <a:off x="5669280" y="3200400"/>
-            <a:ext cx="4480560" cy="3931920"/>
+            <a:ext cx="4480560" cy="4023360"/>
           </a:xfrm>
           <a:prstGeom prst="roundRect">
             <a:avLst>
@@ -24071,7 +24558,7 @@
                 </a:solidFill>
                 <a:latin typeface="Arial"/>
               </a:rPr>
-              <a:t>• Tu carga es de CPU: ventanas, joins grandes</a:t>
+              <a:t>• Tus consultas son de cálculo pesado (ventanas, joins grandes)</a:t>
             </a:r>
           </a:p>
           <a:p>
@@ -24087,7 +24574,7 @@
                 </a:solidFill>
                 <a:latin typeface="Arial"/>
               </a:rPr>
-              <a:t>• Tu lago es Parquet con archivos grandes</a:t>
+              <a:t>• Tu data lake está en Parquet con archivos grandes</a:t>
             </a:r>
           </a:p>
           <a:p>
@@ -24103,7 +24590,7 @@
                 </a:solidFill>
                 <a:latin typeface="Arial"/>
               </a:rPr>
-              <a:t>• Necesitas S3 Tables con usuarios de base de datos</a:t>
+              <a:t>• Quieres usar S3 Tables con usuarios de base de datos</a:t>
             </a:r>
           </a:p>
         </p:txBody>
@@ -24117,7 +24604,7 @@
         <p:spPr>
           <a:xfrm>
             <a:off x="10424160" y="3200400"/>
-            <a:ext cx="4480560" cy="3931920"/>
+            <a:ext cx="4480560" cy="4023360"/>
           </a:xfrm>
           <a:prstGeom prst="roundRect">
             <a:avLst>
@@ -24162,7 +24649,7 @@
                 </a:solidFill>
                 <a:latin typeface="Arial"/>
               </a:rPr>
-              <a:t>Serverless si</a:t>
+              <a:t>Mira Serverless si</a:t>
             </a:r>
           </a:p>
           <a:p>
@@ -24178,7 +24665,7 @@
                 </a:solidFill>
                 <a:latin typeface="Arial"/>
               </a:rPr>
-              <a:t>• Tu uso es intermitente</a:t>
+              <a:t>• Usas Redshift solo a ratos</a:t>
             </a:r>
           </a:p>
           <a:p>
@@ -24194,7 +24681,7 @@
                 </a:solidFill>
                 <a:latin typeface="Arial"/>
               </a:rPr>
-              <a:t>• No quieres operar un clúster</a:t>
+              <a:t>• No quieres administrar un clúster</a:t>
             </a:r>
           </a:p>
           <a:p>
@@ -24210,7 +24697,7 @@
                 </a:solidFill>
                 <a:latin typeface="Arial"/>
               </a:rPr>
-              <a:t>• USD 0,375 por RPU-hora (no lo medimos)</a:t>
+              <a:t>• Cuesta USD 0,375 por RPU-hora (no lo probamos)</a:t>
             </a:r>
           </a:p>
         </p:txBody>
@@ -24630,7 +25117,7 @@
         <p:spPr>
           <a:xfrm>
             <a:off x="914400" y="3291840"/>
-            <a:ext cx="14264640" cy="1097280"/>
+            <a:ext cx="13898880" cy="1097280"/>
           </a:xfrm>
           <a:prstGeom prst="rect">
             <a:avLst/>
@@ -24669,7 +25156,7 @@
         <p:spPr>
           <a:xfrm>
             <a:off x="914400" y="4754880"/>
-            <a:ext cx="14264640" cy="3657600"/>
+            <a:ext cx="13898880" cy="3657600"/>
           </a:xfrm>
           <a:prstGeom prst="rect">
             <a:avLst/>
@@ -24689,13 +25176,13 @@
               <a:buChar char="•"/>
             </a:pPr>
             <a:r>
-              <a:rPr sz="2600" b="0">
+              <a:rPr sz="2500" b="0">
                 <a:solidFill>
                   <a:srgbClr val="D9E2EC"/>
                 </a:solidFill>
                 <a:latin typeface="Arial"/>
               </a:rPr>
-              <a:t>Terraform + GitHub Actions con OIDC · runner en Python · runbook paso a paso</a:t>
+              <a:t>La infraestructura, con Terraform y GitHub Actions (OIDC)</a:t>
             </a:r>
           </a:p>
           <a:p>
@@ -24706,13 +25193,13 @@
               <a:buChar char="•"/>
             </a:pPr>
             <a:r>
-              <a:rPr sz="2600" b="0">
+              <a:rPr sz="2500" b="0">
                 <a:solidFill>
                   <a:srgbClr val="D9E2EC"/>
                 </a:solidFill>
                 <a:latin typeface="Arial"/>
               </a:rPr>
-              <a:t>Todos los resultados y su método en results/</a:t>
+              <a:t>El programa que lanza las pruebas, en Python, y un runbook paso a paso</a:t>
             </a:r>
           </a:p>
           <a:p>
@@ -24723,13 +25210,30 @@
               <a:buChar char="•"/>
             </a:pPr>
             <a:r>
-              <a:rPr sz="2600" b="0">
+              <a:rPr sz="2500" b="0">
                 <a:solidFill>
                   <a:srgbClr val="D9E2EC"/>
                 </a:solidFill>
                 <a:latin typeface="Arial"/>
               </a:rPr>
-              <a:t>Este lab, a 100 GB: un día de trabajo y unas decenas de dólares</a:t>
+              <a:t>Todos los resultados, con su método, en la carpeta results/</a:t>
+            </a:r>
+          </a:p>
+          <a:p>
+            <a:pPr algn="l" marL="347472" indent="-347472">
+              <a:spcAft>
+                <a:spcPts val="1800"/>
+              </a:spcAft>
+              <a:buChar char="•"/>
+            </a:pPr>
+            <a:r>
+              <a:rPr sz="2500" b="0">
+                <a:solidFill>
+                  <a:srgbClr val="D9E2EC"/>
+                </a:solidFill>
+                <a:latin typeface="Arial"/>
+              </a:rPr>
+              <a:t>Repetirlo con 100 GB toma un día de trabajo y unas decenas de dólares</a:t>
             </a:r>
           </a:p>
         </p:txBody>
@@ -25210,7 +25714,7 @@
                 </a:solidFill>
                 <a:latin typeface="Arial"/>
               </a:rPr>
-              <a:t>¿Con qué leen el data lake los clústeres RG?</a:t>
+              <a:t>¿Con qué lee RG los datos del data lake?</a:t>
             </a:r>
           </a:p>
         </p:txBody>
@@ -25285,7 +25789,7 @@
                 </a:solidFill>
                 <a:latin typeface="Arial"/>
               </a:rPr>
-              <a:t>¿Qué tipo de consultas ganó más al pasar de RA3 a RG?</a:t>
+              <a:t>¿Qué tipo de consultas mejoró más al pasar de RA3 a RG?</a:t>
             </a:r>
           </a:p>
         </p:txBody>
@@ -25360,7 +25864,7 @@
                 </a:solidFill>
                 <a:latin typeface="Arial"/>
               </a:rPr>
-              <a:t>Si migras 4 nodos ra3.4xlarge, ¿cuántos rg.4xlarge recomienda AWS?</a:t>
+              <a:t>Si tienes 4 nodos ra3.4xlarge, ¿cuántos rg.4xlarge recomienda AWS?</a:t>
             </a:r>
           </a:p>
         </p:txBody>
@@ -25399,7 +25903,7 @@
                 </a:solidFill>
                 <a:latin typeface="Arial"/>
               </a:rPr>
-              <a:t>Respuestas y comentarios en las notas del orador.</a:t>
+              <a:t>Las respuestas y los comentarios están en las notas.</a:t>
             </a:r>
           </a:p>
         </p:txBody>
@@ -25819,7 +26323,7 @@
         <p:spPr>
           <a:xfrm>
             <a:off x="914400" y="3566160"/>
-            <a:ext cx="14264640" cy="4114800"/>
+            <a:ext cx="13898880" cy="4114800"/>
           </a:xfrm>
           <a:prstGeom prst="rect">
             <a:avLst/>
@@ -25853,7 +26357,7 @@
                 </a:solidFill>
                 <a:latin typeface="Arial"/>
               </a:rPr>
-              <a:t> · Solutions Architect, phData</a:t>
+              <a:t> · Solutions Architect en phData</a:t>
             </a:r>
           </a:p>
           <a:p>
@@ -25885,7 +26389,7 @@
                 </a:solidFill>
                 <a:latin typeface="Arial"/>
               </a:rPr>
-              <a:t>Repo del lab: github.com/andrezc98/redshift-redemption</a:t>
+              <a:t>El laboratorio: github.com/andrezc98/redshift-redemption</a:t>
             </a:r>
           </a:p>
         </p:txBody>
@@ -26366,7 +26870,7 @@
                 </a:solidFill>
                 <a:latin typeface="Arial"/>
               </a:rPr>
-              <a:t>Lo que tienes hoy</a:t>
+              <a:t>Lo que usas hoy</a:t>
             </a:r>
           </a:p>
         </p:txBody>
@@ -26480,7 +26984,7 @@
                 </a:solidFill>
                 <a:latin typeface="Arial"/>
               </a:rPr>
-              <a:t>Graviton, desde mayo de 2026</a:t>
+              <a:t>Con Graviton, desde mayo de 2026</a:t>
             </a:r>
           </a:p>
         </p:txBody>
@@ -26494,7 +26998,7 @@
         <p:spPr>
           <a:xfrm>
             <a:off x="914400" y="6035040"/>
-            <a:ext cx="14264640" cy="2560320"/>
+            <a:ext cx="13898880" cy="2560320"/>
           </a:xfrm>
           <a:prstGeom prst="rect">
             <a:avLst/>
@@ -26519,7 +27023,7 @@
                 </a:solidFill>
                 <a:latin typeface="Arial"/>
               </a:rPr>
-              <a:t>Si administras un Redshift con RA3, o pagas su factura, la pregunta llegó sola.</a:t>
+              <a:t>Si tienes un Redshift con nodos RA3, o eres quien paga la factura, seguramente ya te hiciste esta pregunta.</a:t>
             </a:r>
           </a:p>
           <a:p>
@@ -26535,7 +27039,7 @@
                 </a:solidFill>
                 <a:latin typeface="Arial"/>
               </a:rPr>
-              <a:t>Hoy tomamos las promesas de AWS y las ponemos a prueba: </a:t>
+              <a:t>Hoy revisamos lo que anunció AWS con pruebas propias: </a:t>
             </a:r>
             <a:r>
               <a:rPr sz="2600" b="1">
@@ -26544,7 +27048,7 @@
                 </a:solidFill>
                 <a:latin typeface="Arial"/>
               </a:rPr>
-              <a:t>dónde se cumplen y dónde dependen de tu carga.</a:t>
+              <a:t>en qué se cumple y en qué depende de cómo usas Redshift.</a:t>
             </a:r>
           </a:p>
         </p:txBody>
@@ -26686,7 +27190,7 @@
                 <a:cs typeface="Raleway 1 Heavy"/>
                 <a:sym typeface="Raleway 1 Heavy"/>
               </a:rPr>
-              <a:t>        CAMBIÓ</a:t>
+              <a:t>        CAMBIA</a:t>
             </a:r>
           </a:p>
         </p:txBody>
@@ -27431,7 +27935,7 @@
                 </a:solidFill>
                 <a:latin typeface="Arial"/>
               </a:rPr>
-              <a:t>Graviton</a:t>
+              <a:t>Procesadores Graviton</a:t>
             </a:r>
           </a:p>
           <a:p>
@@ -27447,7 +27951,7 @@
                 </a:solidFill>
                 <a:latin typeface="Arial"/>
               </a:rPr>
-              <a:t>Instancias basadas en los procesadores Arm de AWS</a:t>
+              <a:t>Los chips Arm diseñados por AWS</a:t>
             </a:r>
           </a:p>
         </p:txBody>
@@ -27506,7 +28010,7 @@
                 </a:solidFill>
                 <a:latin typeface="Arial"/>
               </a:rPr>
-              <a:t>Motor de lago integrado</a:t>
+              <a:t>El data lake sin Spectrum</a:t>
             </a:r>
           </a:p>
           <a:p>
@@ -27522,7 +28026,7 @@
                 </a:solidFill>
                 <a:latin typeface="Arial"/>
               </a:rPr>
-              <a:t>Las consultas al lago corren en el propio clúster; RA3 usa Redshift Spectrum, una flota aparte</a:t>
+              <a:t>RG consulta los datos en S3 con sus propios nodos; RA3 depende de Spectrum, un servicio aparte</a:t>
             </a:r>
           </a:p>
         </p:txBody>
@@ -27581,7 +28085,7 @@
                 </a:solidFill>
                 <a:latin typeface="Arial"/>
               </a:rPr>
-              <a:t>Sin cargo por TB escaneado</a:t>
+              <a:t>Sin cobro por TB leído</a:t>
             </a:r>
           </a:p>
           <a:p>
@@ -27597,7 +28101,7 @@
                 </a:solidFill>
                 <a:latin typeface="Arial"/>
               </a:rPr>
-              <a:t>RA3 paga USD 5 por TB que lee Spectrum; RG no tiene ese cargo</a:t>
+              <a:t>En RA3, Spectrum cobra USD 5 por cada TB que lee; en RG ese cobro no existe</a:t>
             </a:r>
           </a:p>
         </p:txBody>
@@ -27656,7 +28160,7 @@
                 </a:solidFill>
                 <a:latin typeface="Arial"/>
               </a:rPr>
-              <a:t>Lo que no cambia</a:t>
+              <a:t>Lo que se mantiene</a:t>
             </a:r>
           </a:p>
           <a:p>
@@ -27672,7 +28176,7 @@
                 </a:solidFill>
                 <a:latin typeface="Arial"/>
               </a:rPr>
-              <a:t>Mismo motor de Redshift y mismo almacenamiento administrado (USD 0,024 por GB-mes)</a:t>
+              <a:t>El mismo Redshift de siempre y el mismo almacenamiento administrado (USD 0,024 por GB al mes)</a:t>
             </a:r>
           </a:p>
         </p:txBody>
@@ -27798,7 +28302,7 @@
                 <a:cs typeface="Raleway 1 Heavy"/>
                 <a:sym typeface="Raleway 1 Heavy"/>
               </a:rPr>
-              <a:t>Cuatro tamaños, 30 % menos por vCPU</a:t>
+              <a:t>Cuatro tamaños y 30 % menos por vCPU</a:t>
             </a:r>
           </a:p>
         </p:txBody>
@@ -28104,12 +28608,12 @@
               <a:tblGrid>
                 <a:gridCol w="2194560"/>
                 <a:gridCol w="1005840"/>
-                <a:gridCol w="1280160"/>
-                <a:gridCol w="1097280"/>
+                <a:gridCol w="1371600"/>
+                <a:gridCol w="914400"/>
                 <a:gridCol w="2286000"/>
                 <a:gridCol w="1005840"/>
-                <a:gridCol w="1645920"/>
-                <a:gridCol w="3383280"/>
+                <a:gridCol w="1463040"/>
+                <a:gridCol w="3657600"/>
               </a:tblGrid>
               <a:tr h="658368">
                 <a:tc>
@@ -28168,7 +28672,7 @@
                           </a:solidFill>
                           <a:latin typeface="Arial"/>
                         </a:rPr>
-                        <a:t>USD/h</a:t>
+                        <a:t>USD/hora</a:t>
                       </a:r>
                     </a:p>
                   </a:txBody>
@@ -28182,17 +28686,7 @@
                   <a:txBody>
                     <a:bodyPr/>
                     <a:lstStyle/>
-                    <a:p>
-                      <a:r>
-                        <a:rPr sz="2100" b="1">
-                          <a:solidFill>
-                            <a:srgbClr val="FFFFFF"/>
-                          </a:solidFill>
-                          <a:latin typeface="Arial"/>
-                        </a:rPr>
-                        <a:t>→</a:t>
-                      </a:r>
-                    </a:p>
+                    <a:p/>
                   </a:txBody>
                   <a:tcPr anchor="ctr" marL="109728" marR="109728">
                     <a:solidFill>
@@ -28256,7 +28750,7 @@
                           </a:solidFill>
                           <a:latin typeface="Arial"/>
                         </a:rPr>
-                        <a:t>USD/h</a:t>
+                        <a:t>USD/hora</a:t>
                       </a:r>
                     </a:p>
                   </a:txBody>
@@ -28278,7 +28772,7 @@
                           </a:solidFill>
                           <a:latin typeface="Arial"/>
                         </a:rPr>
-                        <a:t>USD por vCPU-h</a:t>
+                        <a:t>USD por vCPU y hora</a:t>
                       </a:r>
                     </a:p>
                   </a:txBody>
@@ -28604,7 +29098,7 @@
                           </a:solidFill>
                           <a:latin typeface="Arial"/>
                         </a:rPr>
-                        <a:t>0,272 → 0,190</a:t>
+                        <a:t>de 0,272 a 0,190</a:t>
                       </a:r>
                     </a:p>
                   </a:txBody>
@@ -28694,7 +29188,7 @@
                           </a:solidFill>
                           <a:latin typeface="Arial"/>
                         </a:rPr>
-                        <a:t>4 → 3</a:t>
+                        <a:t>4 : 3</a:t>
                       </a:r>
                     </a:p>
                   </a:txBody>
@@ -28782,7 +29276,7 @@
                           </a:solidFill>
                           <a:latin typeface="Arial"/>
                         </a:rPr>
-                        <a:t>0,272 → 0,190</a:t>
+                        <a:t>de 0,272 a 0,190</a:t>
                       </a:r>
                     </a:p>
                   </a:txBody>
@@ -28954,7 +29448,7 @@
         <p:spPr>
           <a:xfrm>
             <a:off x="914400" y="6858000"/>
-            <a:ext cx="14264640" cy="1463040"/>
+            <a:ext cx="13898880" cy="1463040"/>
           </a:xfrm>
           <a:prstGeom prst="rect">
             <a:avLst/>
@@ -28979,7 +29473,7 @@
                 </a:solidFill>
                 <a:latin typeface="Arial"/>
               </a:rPr>
-              <a:t>4 × ra3.4xlarge = 3 × rg.4xlarge = 48 vCPU</a:t>
+              <a:t>4 nodos ra3.4xlarge equivalen a 3 rg.4xlarge</a:t>
             </a:r>
             <a:r>
               <a:rPr sz="2600" b="0">
@@ -28988,7 +29482,7 @@
                 </a:solidFill>
                 <a:latin typeface="Arial"/>
               </a:rPr>
-              <a:t> → USD 13,04/h frente a 9,13/h</a:t>
+              <a:t> (48 vCPU en total): USD 13,04 frente a 9,13 por hora</a:t>
             </a:r>
           </a:p>
         </p:txBody>
@@ -29002,7 +29496,7 @@
         <p:spPr>
           <a:xfrm>
             <a:off x="914400" y="7909560"/>
-            <a:ext cx="14264640" cy="548640"/>
+            <a:ext cx="13898880" cy="548640"/>
           </a:xfrm>
           <a:prstGeom prst="rect">
             <a:avLst/>
@@ -29027,7 +29521,7 @@
                 </a:solidFill>
                 <a:latin typeface="Arial"/>
               </a:rPr>
-              <a:t>vCPU: documentación «Node type details». Precios on-demand us-east-1, Price List API (results/prices.md y spec).</a:t>
+              <a:t>vCPU: documentación de Redshift («Node type details»). Precios on-demand en us-east-1, Price List API.</a:t>
             </a:r>
           </a:p>
         </p:txBody>
@@ -29153,7 +29647,7 @@
                 <a:cs typeface="Raleway 1 Heavy"/>
                 <a:sym typeface="Raleway 1 Heavy"/>
               </a:rPr>
-              <a:t>Lo que promete AWS</a:t>
+              <a:t>Lo que anunció AWS</a:t>
             </a:r>
           </a:p>
         </p:txBody>
@@ -29508,7 +30002,7 @@
                 </a:solidFill>
                 <a:latin typeface="Arial"/>
               </a:rPr>
-              <a:t>más rápido en el warehouse</a:t>
+              <a:t>más rápido en las consultas del warehouse</a:t>
             </a:r>
           </a:p>
         </p:txBody>
@@ -29583,7 +30077,7 @@
                 </a:solidFill>
                 <a:latin typeface="Arial"/>
               </a:rPr>
-              <a:t>en el data lake (Iceberg; 1,5x en Parquet)</a:t>
+              <a:t>en el data lake con Iceberg (1,5x con Parquet)</a:t>
             </a:r>
           </a:p>
         </p:txBody>
@@ -29658,7 +30152,7 @@
                 </a:solidFill>
                 <a:latin typeface="Arial"/>
               </a:rPr>
-              <a:t>por vCPU</a:t>
+              <a:t>en el precio por vCPU</a:t>
             </a:r>
           </a:p>
         </p:txBody>
@@ -29717,7 +30211,7 @@
                 </a:solidFill>
                 <a:latin typeface="Arial"/>
               </a:rPr>
-              <a:t>Sin cargo</a:t>
+              <a:t>USD 0</a:t>
             </a:r>
           </a:p>
           <a:p>
@@ -29733,7 +30227,7 @@
                 </a:solidFill>
                 <a:latin typeface="Arial"/>
               </a:rPr>
-              <a:t>de Spectrum por TB escaneado</a:t>
+              <a:t>por TB leído desde el data lake</a:t>
             </a:r>
           </a:p>
         </p:txBody>
@@ -29772,7 +30266,7 @@
                 </a:solidFill>
                 <a:latin typeface="Arial"/>
               </a:rPr>
-              <a:t>AWS midió TPC-DS y TPC-H a </a:t>
+              <a:t>AWS lo midió con TPC-DS y TPC-H a </a:t>
             </a:r>
             <a:r>
               <a:rPr sz="2400" b="1">
@@ -29781,7 +30275,7 @@
                 </a:solidFill>
                 <a:latin typeface="Arial"/>
               </a:rPr>
-              <a:t>10 TB en rg.4xlarge</a:t>
+              <a:t>10 TB en nodos rg.4xlarge</a:t>
             </a:r>
             <a:r>
               <a:rPr sz="2400" b="0">
@@ -29790,7 +30284,7 @@
                 </a:solidFill>
                 <a:latin typeface="Arial"/>
               </a:rPr>
-              <a:t>. Nosotros: 100 GB en 2 × xlarge.</a:t>
+              <a:t>. Nosotros, con 100 GB en un clúster de 2 nodos xlarge.</a:t>
             </a:r>
           </a:p>
         </p:txBody>
@@ -29804,7 +30298,7 @@
         <p:spPr>
           <a:xfrm>
             <a:off x="914400" y="7909560"/>
-            <a:ext cx="14264640" cy="548640"/>
+            <a:ext cx="13898880" cy="548640"/>
           </a:xfrm>
           <a:prstGeom prst="rect">
             <a:avLst/>
@@ -29829,7 +30323,7 @@
                 </a:solidFill>
                 <a:latin typeface="Arial"/>
               </a:rPr>
-              <a:t>Fuente: blog de AWS Big Data «Meet Amazon Redshift RG…», 2026-05-19.</a:t>
+              <a:t>Fuente: blog de AWS Big Data «Meet Amazon Redshift RG…», 19 de mayo de 2026.</a:t>
             </a:r>
           </a:p>
         </p:txBody>

</xml_diff>

<commit_message>
fix(slides): headings in Arial Black - the template's embedded Raleway Heavy garbles letters in PowerPoint
PowerPoint for Mac rendered titles and transition slides with overlapping or
missing letters ("¿Migo o no migo?") from the template's embedded
"Raleway 1 Heavy". All headings now use Arial Black (Office on Mac/Windows and
Google Slides), auto-sized to one line; verified with PowerPoint's own PDF
export. Slide 7 table column widened.

Co-Authored-By: Claude Opus 5.5 <noreply@anthropic.com>
Claude-Session: https://claude.ai/code/session_01HgWRiJoTFne1e49sP1svEg
</commit_message>
<xml_diff>
--- a/slides/redshift-redemption.pptx
+++ b/slides/redshift-redemption.pptx
@@ -8184,14 +8184,14 @@
               </a:spcBef>
             </a:pPr>
             <a:r>
-              <a:rPr lang="en-US" b="true" sz="7200">
+              <a:rPr lang="en-US" b="0" sz="7200">
                 <a:solidFill>
                   <a:srgbClr val="FFFFFF"/>
                 </a:solidFill>
-                <a:latin typeface="Raleway 1 Heavy"/>
-                <a:ea typeface="Raleway 1 Heavy"/>
-                <a:cs typeface="Raleway 1 Heavy"/>
-                <a:sym typeface="Raleway 1 Heavy"/>
+                <a:latin typeface="Arial Black"/>
+                <a:ea typeface="Arial Black"/>
+                <a:cs typeface="Arial Black"/>
+                <a:sym typeface="Arial Black"/>
               </a:rPr>
               <a:t>Redshift Redemption</a:t>
             </a:r>
@@ -8748,14 +8748,14 @@
               </a:spcBef>
             </a:pPr>
             <a:r>
-              <a:rPr lang="en-US" b="true" sz="5400">
+              <a:rPr lang="en-US" b="0" sz="5400">
                 <a:solidFill>
                   <a:srgbClr val="FFFFFF"/>
                 </a:solidFill>
-                <a:latin typeface="Raleway 1 Heavy"/>
-                <a:ea typeface="Raleway 1 Heavy"/>
-                <a:cs typeface="Raleway 1 Heavy"/>
-                <a:sym typeface="Raleway 1 Heavy"/>
+                <a:latin typeface="Arial Black"/>
+                <a:ea typeface="Arial Black"/>
+                <a:cs typeface="Arial Black"/>
+                <a:sym typeface="Arial Black"/>
               </a:rPr>
               <a:t>El laboratorio</a:t>
             </a:r>
@@ -9178,14 +9178,14 @@
               </a:spcBef>
             </a:pPr>
             <a:r>
-              <a:rPr lang="en-US" b="true" sz="5400">
+              <a:rPr lang="en-US" b="0" sz="5400">
                 <a:solidFill>
                   <a:srgbClr val="FFFFFF"/>
                 </a:solidFill>
-                <a:latin typeface="Raleway 1 Heavy"/>
-                <a:ea typeface="Raleway 1 Heavy"/>
-                <a:cs typeface="Raleway 1 Heavy"/>
-                <a:sym typeface="Raleway 1 Heavy"/>
+                <a:latin typeface="Arial Black"/>
+                <a:ea typeface="Arial Black"/>
+                <a:cs typeface="Arial Black"/>
+                <a:sym typeface="Arial Black"/>
               </a:rPr>
               <a:t>Una comparación justa</a:t>
             </a:r>
@@ -9692,14 +9692,14 @@
               </a:spcBef>
             </a:pPr>
             <a:r>
-              <a:rPr lang="en-US" b="true" sz="5400">
+              <a:rPr lang="en-US" b="0" sz="5400">
                 <a:solidFill>
                   <a:srgbClr val="FFFFFF"/>
                 </a:solidFill>
-                <a:latin typeface="Raleway 1 Heavy"/>
-                <a:ea typeface="Raleway 1 Heavy"/>
-                <a:cs typeface="Raleway 1 Heavy"/>
-                <a:sym typeface="Raleway 1 Heavy"/>
+                <a:latin typeface="Arial Black"/>
+                <a:ea typeface="Arial Black"/>
+                <a:cs typeface="Arial Black"/>
+                <a:sym typeface="Arial Black"/>
               </a:rPr>
               <a:t>Lo que no probamos</a:t>
             </a:r>
@@ -10395,14 +10395,14 @@
               </a:lnSpc>
             </a:pPr>
             <a:r>
-              <a:rPr lang="en-US" b="true" sz="9999">
+              <a:rPr lang="en-US" b="0" sz="8800">
                 <a:solidFill>
                   <a:srgbClr val="FFFFFF"/>
                 </a:solidFill>
-                <a:latin typeface="Raleway 1 Heavy"/>
-                <a:ea typeface="Raleway 1 Heavy"/>
-                <a:cs typeface="Raleway 1 Heavy"/>
-                <a:sym typeface="Raleway 1 Heavy"/>
+                <a:latin typeface="Arial Black"/>
+                <a:ea typeface="Arial Black"/>
+                <a:cs typeface="Arial Black"/>
+                <a:sym typeface="Arial Black"/>
               </a:rPr>
               <a:t>WAREHOUSE</a:t>
             </a:r>
@@ -10414,14 +10414,14 @@
               </a:lnSpc>
             </a:pPr>
             <a:r>
-              <a:rPr lang="en-US" b="true" sz="9999">
+              <a:rPr lang="en-US" b="0" sz="8800">
                 <a:solidFill>
                   <a:srgbClr val="FFFFFF"/>
                 </a:solidFill>
-                <a:latin typeface="Raleway 1 Heavy"/>
-                <a:ea typeface="Raleway 1 Heavy"/>
-                <a:cs typeface="Raleway 1 Heavy"/>
-                <a:sym typeface="Raleway 1 Heavy"/>
+                <a:latin typeface="Arial Black"/>
+                <a:ea typeface="Arial Black"/>
+                <a:cs typeface="Arial Black"/>
+                <a:sym typeface="Arial Black"/>
               </a:rPr>
               <a:t/>
             </a:r>
@@ -10820,14 +10820,14 @@
               </a:spcBef>
             </a:pPr>
             <a:r>
-              <a:rPr lang="en-US" b="true" sz="5400">
+              <a:rPr lang="en-US" b="0" sz="5400">
                 <a:solidFill>
                   <a:srgbClr val="FFFFFF"/>
                 </a:solidFill>
-                <a:latin typeface="Raleway 1 Heavy"/>
-                <a:ea typeface="Raleway 1 Heavy"/>
-                <a:cs typeface="Raleway 1 Heavy"/>
-                <a:sym typeface="Raleway 1 Heavy"/>
+                <a:latin typeface="Arial Black"/>
+                <a:ea typeface="Arial Black"/>
+                <a:cs typeface="Arial Black"/>
+                <a:sym typeface="Arial Black"/>
               </a:rPr>
               <a:t>RG fue 1,90x más rápido</a:t>
             </a:r>
@@ -11732,14 +11732,14 @@
               </a:spcBef>
             </a:pPr>
             <a:r>
-              <a:rPr lang="en-US" b="true" sz="5400">
+              <a:rPr lang="en-US" b="0" sz="4500">
                 <a:solidFill>
                   <a:srgbClr val="FFFFFF"/>
                 </a:solidFill>
-                <a:latin typeface="Raleway 1 Heavy"/>
-                <a:ea typeface="Raleway 1 Heavy"/>
-                <a:cs typeface="Raleway 1 Heavy"/>
-                <a:sym typeface="Raleway 1 Heavy"/>
+                <a:latin typeface="Arial Black"/>
+                <a:ea typeface="Arial Black"/>
+                <a:cs typeface="Arial Black"/>
+                <a:sym typeface="Arial Black"/>
               </a:rPr>
               <a:t>Donde más gana: leer y agregar</a:t>
             </a:r>
@@ -12342,14 +12342,14 @@
               </a:spcBef>
             </a:pPr>
             <a:r>
-              <a:rPr lang="en-US" b="true" sz="5000">
+              <a:rPr lang="en-US" b="0" sz="4500">
                 <a:solidFill>
                   <a:srgbClr val="FFFFFF"/>
                 </a:solidFill>
-                <a:latin typeface="Raleway 1 Heavy"/>
-                <a:ea typeface="Raleway 1 Heavy"/>
-                <a:cs typeface="Raleway 1 Heavy"/>
-                <a:sym typeface="Raleway 1 Heavy"/>
+                <a:latin typeface="Arial Black"/>
+                <a:ea typeface="Arial Black"/>
+                <a:cs typeface="Arial Black"/>
+                <a:sym typeface="Arial Black"/>
               </a:rPr>
               <a:t>Varios usuarios a la vez: 1,8x</a:t>
             </a:r>
@@ -12862,14 +12862,14 @@
               </a:spcBef>
             </a:pPr>
             <a:r>
-              <a:rPr lang="en-US" b="true" sz="5400">
+              <a:rPr lang="en-US" b="0" sz="5400">
                 <a:solidFill>
                   <a:srgbClr val="FFFFFF"/>
                 </a:solidFill>
-                <a:latin typeface="Raleway 1 Heavy"/>
-                <a:ea typeface="Raleway 1 Heavy"/>
-                <a:cs typeface="Raleway 1 Heavy"/>
-                <a:sym typeface="Raleway 1 Heavy"/>
+                <a:latin typeface="Arial Black"/>
+                <a:ea typeface="Arial Black"/>
+                <a:cs typeface="Arial Black"/>
+                <a:sym typeface="Arial Black"/>
               </a:rPr>
               <a:t>Carga y transformación</a:t>
             </a:r>
@@ -13391,14 +13391,14 @@
               </a:spcBef>
             </a:pPr>
             <a:r>
-              <a:rPr lang="en-US" b="true" sz="4400">
+              <a:rPr lang="en-US" b="0" sz="4400">
                 <a:solidFill>
                   <a:srgbClr val="FFFFFF"/>
                 </a:solidFill>
-                <a:latin typeface="Raleway 1 Heavy"/>
-                <a:ea typeface="Raleway 1 Heavy"/>
-                <a:cs typeface="Raleway 1 Heavy"/>
-                <a:sym typeface="Raleway 1 Heavy"/>
+                <a:latin typeface="Arial Black"/>
+                <a:ea typeface="Arial Black"/>
+                <a:cs typeface="Arial Black"/>
+                <a:sym typeface="Arial Black"/>
               </a:rPr>
               <a:t>Más rápido y también más barato</a:t>
             </a:r>
@@ -13998,14 +13998,14 @@
               </a:lnSpc>
             </a:pPr>
             <a:r>
-              <a:rPr lang="en-US" b="true" sz="9999">
+              <a:rPr lang="en-US" b="0" sz="8800">
                 <a:solidFill>
                   <a:srgbClr val="FFFFFF"/>
                 </a:solidFill>
-                <a:latin typeface="Raleway 1 Heavy"/>
-                <a:ea typeface="Raleway 1 Heavy"/>
-                <a:cs typeface="Raleway 1 Heavy"/>
-                <a:sym typeface="Raleway 1 Heavy"/>
+                <a:latin typeface="Arial Black"/>
+                <a:ea typeface="Arial Black"/>
+                <a:cs typeface="Arial Black"/>
+                <a:sym typeface="Arial Black"/>
               </a:rPr>
               <a:t>DATA</a:t>
             </a:r>
@@ -14017,14 +14017,14 @@
               </a:lnSpc>
             </a:pPr>
             <a:r>
-              <a:rPr lang="en-US" b="true" sz="9999">
+              <a:rPr lang="en-US" b="0" sz="8800">
                 <a:solidFill>
                   <a:srgbClr val="FFFFFF"/>
                 </a:solidFill>
-                <a:latin typeface="Raleway 1 Heavy"/>
-                <a:ea typeface="Raleway 1 Heavy"/>
-                <a:cs typeface="Raleway 1 Heavy"/>
-                <a:sym typeface="Raleway 1 Heavy"/>
+                <a:latin typeface="Arial Black"/>
+                <a:ea typeface="Arial Black"/>
+                <a:cs typeface="Arial Black"/>
+                <a:sym typeface="Arial Black"/>
               </a:rPr>
               <a:t>        LAKE</a:t>
             </a:r>
@@ -14423,14 +14423,14 @@
               </a:spcBef>
             </a:pPr>
             <a:r>
-              <a:rPr lang="en-US" b="true" sz="5400">
+              <a:rPr lang="en-US" b="0" sz="5400">
                 <a:solidFill>
                   <a:srgbClr val="FFFFFF"/>
                 </a:solidFill>
-                <a:latin typeface="Raleway 1 Heavy"/>
-                <a:ea typeface="Raleway 1 Heavy"/>
-                <a:cs typeface="Raleway 1 Heavy"/>
-                <a:sym typeface="Raleway 1 Heavy"/>
+                <a:latin typeface="Arial Black"/>
+                <a:ea typeface="Arial Black"/>
+                <a:cs typeface="Arial Black"/>
+                <a:sym typeface="Arial Black"/>
               </a:rPr>
               <a:t>Quién soy</a:t>
             </a:r>
@@ -14975,14 +14975,14 @@
               </a:spcBef>
             </a:pPr>
             <a:r>
-              <a:rPr lang="en-US" b="true" sz="5400">
+              <a:rPr lang="en-US" b="0" sz="4700">
                 <a:solidFill>
                   <a:srgbClr val="FFFFFF"/>
                 </a:solidFill>
-                <a:latin typeface="Raleway 1 Heavy"/>
-                <a:ea typeface="Raleway 1 Heavy"/>
-                <a:cs typeface="Raleway 1 Heavy"/>
-                <a:sym typeface="Raleway 1 Heavy"/>
+                <a:latin typeface="Arial Black"/>
+                <a:ea typeface="Arial Black"/>
+                <a:cs typeface="Arial Black"/>
+                <a:sym typeface="Arial Black"/>
               </a:rPr>
               <a:t>El mismo dato, de tres formas</a:t>
             </a:r>
@@ -15715,14 +15715,14 @@
               </a:spcBef>
             </a:pPr>
             <a:r>
-              <a:rPr lang="en-US" b="true" sz="4800">
+              <a:rPr lang="en-US" b="0" sz="4800">
                 <a:solidFill>
                   <a:srgbClr val="FFFFFF"/>
                 </a:solidFill>
-                <a:latin typeface="Raleway 1 Heavy"/>
-                <a:ea typeface="Raleway 1 Heavy"/>
-                <a:cs typeface="Raleway 1 Heavy"/>
-                <a:sym typeface="Raleway 1 Heavy"/>
+                <a:latin typeface="Arial Black"/>
+                <a:ea typeface="Arial Black"/>
+                <a:cs typeface="Arial Black"/>
+                <a:sym typeface="Arial Black"/>
               </a:rPr>
               <a:t>Iceberg: 1,87x, ya con caché</a:t>
             </a:r>
@@ -16421,14 +16421,14 @@
               </a:spcBef>
             </a:pPr>
             <a:r>
-              <a:rPr lang="en-US" b="true" sz="5000">
+              <a:rPr lang="en-US" b="0" sz="4500">
                 <a:solidFill>
                   <a:srgbClr val="FFFFFF"/>
                 </a:solidFill>
-                <a:latin typeface="Raleway 1 Heavy"/>
-                <a:ea typeface="Raleway 1 Heavy"/>
-                <a:cs typeface="Raleway 1 Heavy"/>
-                <a:sym typeface="Raleway 1 Heavy"/>
+                <a:latin typeface="Arial Black"/>
+                <a:ea typeface="Arial Black"/>
+                <a:cs typeface="Arial Black"/>
+                <a:sym typeface="Arial Black"/>
               </a:rPr>
               <a:t>Parquet: los archivos importan</a:t>
             </a:r>
@@ -17232,14 +17232,14 @@
               </a:spcBef>
             </a:pPr>
             <a:r>
-              <a:rPr lang="en-US" b="true" sz="5400">
+              <a:rPr lang="en-US" b="0" sz="5400">
                 <a:solidFill>
                   <a:srgbClr val="FFFFFF"/>
                 </a:solidFill>
-                <a:latin typeface="Raleway 1 Heavy"/>
-                <a:ea typeface="Raleway 1 Heavy"/>
-                <a:cs typeface="Raleway 1 Heavy"/>
-                <a:sym typeface="Raleway 1 Heavy"/>
+                <a:latin typeface="Arial Black"/>
+                <a:ea typeface="Arial Black"/>
+                <a:cs typeface="Arial Black"/>
+                <a:sym typeface="Arial Black"/>
               </a:rPr>
               <a:t>Spectrum cobra aparte</a:t>
             </a:r>
@@ -17920,14 +17920,14 @@
               </a:spcBef>
             </a:pPr>
             <a:r>
-              <a:rPr lang="en-US" b="true" sz="4400">
+              <a:rPr lang="en-US" b="0" sz="4400">
                 <a:solidFill>
                   <a:srgbClr val="FFFFFF"/>
                 </a:solidFill>
-                <a:latin typeface="Raleway 1 Heavy"/>
-                <a:ea typeface="Raleway 1 Heavy"/>
-                <a:cs typeface="Raleway 1 Heavy"/>
-                <a:sym typeface="Raleway 1 Heavy"/>
+                <a:latin typeface="Arial Black"/>
+                <a:ea typeface="Arial Black"/>
+                <a:cs typeface="Arial Black"/>
+                <a:sym typeface="Arial Black"/>
               </a:rPr>
               <a:t>Lo que aprendimos del data lake</a:t>
             </a:r>
@@ -18581,14 +18581,14 @@
               </a:lnSpc>
             </a:pPr>
             <a:r>
-              <a:rPr lang="en-US" b="true" sz="9999">
+              <a:rPr lang="en-US" b="0" sz="8800">
                 <a:solidFill>
                   <a:srgbClr val="FFFFFF"/>
                 </a:solidFill>
-                <a:latin typeface="Raleway 1 Heavy"/>
-                <a:ea typeface="Raleway 1 Heavy"/>
-                <a:cs typeface="Raleway 1 Heavy"/>
-                <a:sym typeface="Raleway 1 Heavy"/>
+                <a:latin typeface="Arial Black"/>
+                <a:ea typeface="Arial Black"/>
+                <a:cs typeface="Arial Black"/>
+                <a:sym typeface="Arial Black"/>
               </a:rPr>
               <a:t>LA</a:t>
             </a:r>
@@ -18600,14 +18600,14 @@
               </a:lnSpc>
             </a:pPr>
             <a:r>
-              <a:rPr lang="en-US" b="true" sz="9999">
+              <a:rPr lang="en-US" b="0" sz="8800">
                 <a:solidFill>
                   <a:srgbClr val="FFFFFF"/>
                 </a:solidFill>
-                <a:latin typeface="Raleway 1 Heavy"/>
-                <a:ea typeface="Raleway 1 Heavy"/>
-                <a:cs typeface="Raleway 1 Heavy"/>
-                <a:sym typeface="Raleway 1 Heavy"/>
+                <a:latin typeface="Arial Black"/>
+                <a:ea typeface="Arial Black"/>
+                <a:cs typeface="Arial Black"/>
+                <a:sym typeface="Arial Black"/>
               </a:rPr>
               <a:t>        MIGRACIÓN</a:t>
             </a:r>
@@ -19006,14 +19006,14 @@
               </a:spcBef>
             </a:pPr>
             <a:r>
-              <a:rPr lang="en-US" b="true" sz="5400">
+              <a:rPr lang="en-US" b="0" sz="4900">
                 <a:solidFill>
                   <a:srgbClr val="FFFFFF"/>
                 </a:solidFill>
-                <a:latin typeface="Raleway 1 Heavy"/>
-                <a:ea typeface="Raleway 1 Heavy"/>
-                <a:cs typeface="Raleway 1 Heavy"/>
-                <a:sym typeface="Raleway 1 Heavy"/>
+                <a:latin typeface="Arial Black"/>
+                <a:ea typeface="Arial Black"/>
+                <a:cs typeface="Arial Black"/>
+                <a:sym typeface="Arial Black"/>
               </a:rPr>
               <a:t>La migración tomó 2 min 48 s</a:t>
             </a:r>
@@ -20450,14 +20450,14 @@
               </a:spcBef>
             </a:pPr>
             <a:r>
-              <a:rPr lang="en-US" b="true" sz="5400">
+              <a:rPr lang="en-US" b="0" sz="5400">
                 <a:solidFill>
                   <a:srgbClr val="FFFFFF"/>
                 </a:solidFill>
-                <a:latin typeface="Raleway 1 Heavy"/>
-                <a:ea typeface="Raleway 1 Heavy"/>
-                <a:cs typeface="Raleway 1 Heavy"/>
-                <a:sym typeface="Raleway 1 Heavy"/>
+                <a:latin typeface="Arial Black"/>
+                <a:ea typeface="Arial Black"/>
+                <a:cs typeface="Arial Black"/>
+                <a:sym typeface="Arial Black"/>
               </a:rPr>
               <a:t>Lo que nadie te cuenta</a:t>
             </a:r>
@@ -21006,14 +21006,14 @@
               </a:lnSpc>
             </a:pPr>
             <a:r>
-              <a:rPr lang="en-US" b="true" sz="9999">
+              <a:rPr lang="en-US" b="0" sz="8800">
                 <a:solidFill>
                   <a:srgbClr val="FFFFFF"/>
                 </a:solidFill>
-                <a:latin typeface="Raleway 1 Heavy"/>
-                <a:ea typeface="Raleway 1 Heavy"/>
-                <a:cs typeface="Raleway 1 Heavy"/>
-                <a:sym typeface="Raleway 1 Heavy"/>
+                <a:latin typeface="Arial Black"/>
+                <a:ea typeface="Arial Black"/>
+                <a:cs typeface="Arial Black"/>
+                <a:sym typeface="Arial Black"/>
               </a:rPr>
               <a:t>DEMO</a:t>
             </a:r>
@@ -21025,14 +21025,14 @@
               </a:lnSpc>
             </a:pPr>
             <a:r>
-              <a:rPr lang="en-US" b="true" sz="9999">
+              <a:rPr lang="en-US" b="0" sz="8800">
                 <a:solidFill>
                   <a:srgbClr val="FFFFFF"/>
                 </a:solidFill>
-                <a:latin typeface="Raleway 1 Heavy"/>
-                <a:ea typeface="Raleway 1 Heavy"/>
-                <a:cs typeface="Raleway 1 Heavy"/>
-                <a:sym typeface="Raleway 1 Heavy"/>
+                <a:latin typeface="Arial Black"/>
+                <a:ea typeface="Arial Black"/>
+                <a:cs typeface="Arial Black"/>
+                <a:sym typeface="Arial Black"/>
               </a:rPr>
               <a:t/>
             </a:r>
@@ -21431,14 +21431,14 @@
               </a:spcBef>
             </a:pPr>
             <a:r>
-              <a:rPr lang="en-US" b="true" sz="4400">
+              <a:rPr lang="en-US" b="0" sz="4100">
                 <a:solidFill>
                   <a:srgbClr val="FFFFFF"/>
                 </a:solidFill>
-                <a:latin typeface="Raleway 1 Heavy"/>
-                <a:ea typeface="Raleway 1 Heavy"/>
-                <a:cs typeface="Raleway 1 Heavy"/>
-                <a:sym typeface="Raleway 1 Heavy"/>
+                <a:latin typeface="Arial Black"/>
+                <a:ea typeface="Arial Black"/>
+                <a:cs typeface="Arial Black"/>
+                <a:sym typeface="Arial Black"/>
               </a:rPr>
               <a:t>Demo: una consulta, dos clústeres</a:t>
             </a:r>
@@ -22864,14 +22864,14 @@
               </a:spcBef>
             </a:pPr>
             <a:r>
-              <a:rPr lang="en-US" b="true" sz="5000">
+              <a:rPr lang="en-US" b="0" sz="4500">
                 <a:solidFill>
                   <a:srgbClr val="FFFFFF"/>
                 </a:solidFill>
-                <a:latin typeface="Raleway 1 Heavy"/>
-                <a:ea typeface="Raleway 1 Heavy"/>
-                <a:cs typeface="Raleway 1 Heavy"/>
-                <a:sym typeface="Raleway 1 Heavy"/>
+                <a:latin typeface="Arial Black"/>
+                <a:ea typeface="Arial Black"/>
+                <a:cs typeface="Arial Black"/>
+                <a:sym typeface="Arial Black"/>
               </a:rPr>
               <a:t>Demo: el mismo plan en los dos</a:t>
             </a:r>
@@ -23570,14 +23570,14 @@
               </a:spcBef>
             </a:pPr>
             <a:r>
-              <a:rPr lang="en-US" b="true" sz="5400">
+              <a:rPr lang="en-US" b="0" sz="5200">
                 <a:solidFill>
                   <a:srgbClr val="FFFFFF"/>
                 </a:solidFill>
-                <a:latin typeface="Raleway 1 Heavy"/>
-                <a:ea typeface="Raleway 1 Heavy"/>
-                <a:cs typeface="Raleway 1 Heavy"/>
-                <a:sym typeface="Raleway 1 Heavy"/>
+                <a:latin typeface="Arial Black"/>
+                <a:ea typeface="Arial Black"/>
+                <a:cs typeface="Arial Black"/>
+                <a:sym typeface="Arial Black"/>
               </a:rPr>
               <a:t>Demo: todos los resultados</a:t>
             </a:r>
@@ -24087,14 +24087,14 @@
               </a:spcBef>
             </a:pPr>
             <a:r>
-              <a:rPr lang="en-US" b="true" sz="5400">
+              <a:rPr lang="en-US" b="0" sz="5400">
                 <a:solidFill>
                   <a:srgbClr val="FFFFFF"/>
                 </a:solidFill>
-                <a:latin typeface="Raleway 1 Heavy"/>
-                <a:ea typeface="Raleway 1 Heavy"/>
-                <a:cs typeface="Raleway 1 Heavy"/>
-                <a:sym typeface="Raleway 1 Heavy"/>
+                <a:latin typeface="Arial Black"/>
+                <a:ea typeface="Arial Black"/>
+                <a:cs typeface="Arial Black"/>
+                <a:sym typeface="Arial Black"/>
               </a:rPr>
               <a:t>¿Migrar o no migrar?</a:t>
             </a:r>
@@ -24814,14 +24814,14 @@
               </a:spcBef>
             </a:pPr>
             <a:r>
-              <a:rPr lang="en-US" b="true" sz="5400">
+              <a:rPr lang="en-US" b="0" sz="5400">
                 <a:solidFill>
                   <a:srgbClr val="FFFFFF"/>
                 </a:solidFill>
-                <a:latin typeface="Raleway 1 Heavy"/>
-                <a:ea typeface="Raleway 1 Heavy"/>
-                <a:cs typeface="Raleway 1 Heavy"/>
-                <a:sym typeface="Raleway 1 Heavy"/>
+                <a:latin typeface="Arial Black"/>
+                <a:ea typeface="Arial Black"/>
+                <a:cs typeface="Arial Black"/>
+                <a:sym typeface="Arial Black"/>
               </a:rPr>
               <a:t>Llévate el laboratorio</a:t>
             </a:r>
@@ -25350,14 +25350,14 @@
               </a:spcBef>
             </a:pPr>
             <a:r>
-              <a:rPr lang="en-US" b="true" sz="5400">
+              <a:rPr lang="en-US" b="0" sz="5400">
                 <a:solidFill>
                   <a:srgbClr val="FFFFFF"/>
                 </a:solidFill>
-                <a:latin typeface="Raleway 1 Heavy"/>
-                <a:ea typeface="Raleway 1 Heavy"/>
-                <a:cs typeface="Raleway 1 Heavy"/>
-                <a:sym typeface="Raleway 1 Heavy"/>
+                <a:latin typeface="Arial Black"/>
+                <a:ea typeface="Arial Black"/>
+                <a:cs typeface="Arial Black"/>
+                <a:sym typeface="Arial Black"/>
               </a:rPr>
               <a:t>Kahoot</a:t>
             </a:r>
@@ -26020,14 +26020,14 @@
               </a:spcBef>
             </a:pPr>
             <a:r>
-              <a:rPr lang="en-US" b="true" sz="7200">
+              <a:rPr lang="en-US" b="0" sz="7200">
                 <a:solidFill>
                   <a:srgbClr val="FFFFFF"/>
                 </a:solidFill>
-                <a:latin typeface="Raleway 1 Heavy"/>
-                <a:ea typeface="Raleway 1 Heavy"/>
-                <a:cs typeface="Raleway 1 Heavy"/>
-                <a:sym typeface="Raleway 1 Heavy"/>
+                <a:latin typeface="Arial Black"/>
+                <a:ea typeface="Arial Black"/>
+                <a:cs typeface="Arial Black"/>
+                <a:sym typeface="Arial Black"/>
               </a:rPr>
               <a:t>¡Gracias!</a:t>
             </a:r>
@@ -26506,14 +26506,14 @@
               </a:spcBef>
             </a:pPr>
             <a:r>
-              <a:rPr lang="en-US" b="true" sz="5400">
+              <a:rPr lang="en-US" b="0" sz="5400">
                 <a:solidFill>
                   <a:srgbClr val="FFFFFF"/>
                 </a:solidFill>
-                <a:latin typeface="Raleway 1 Heavy"/>
-                <a:ea typeface="Raleway 1 Heavy"/>
-                <a:cs typeface="Raleway 1 Heavy"/>
-                <a:sym typeface="Raleway 1 Heavy"/>
+                <a:latin typeface="Arial Black"/>
+                <a:ea typeface="Arial Black"/>
+                <a:cs typeface="Arial Black"/>
+                <a:sym typeface="Arial Black"/>
               </a:rPr>
               <a:t>¿Migro o no migro?</a:t>
             </a:r>
@@ -27162,14 +27162,14 @@
               </a:lnSpc>
             </a:pPr>
             <a:r>
-              <a:rPr lang="en-US" b="true" sz="9999">
+              <a:rPr lang="en-US" b="0" sz="8800">
                 <a:solidFill>
                   <a:srgbClr val="FFFFFF"/>
                 </a:solidFill>
-                <a:latin typeface="Raleway 1 Heavy"/>
-                <a:ea typeface="Raleway 1 Heavy"/>
-                <a:cs typeface="Raleway 1 Heavy"/>
-                <a:sym typeface="Raleway 1 Heavy"/>
+                <a:latin typeface="Arial Black"/>
+                <a:ea typeface="Arial Black"/>
+                <a:cs typeface="Arial Black"/>
+                <a:sym typeface="Arial Black"/>
               </a:rPr>
               <a:t>QUÉ</a:t>
             </a:r>
@@ -27181,14 +27181,14 @@
               </a:lnSpc>
             </a:pPr>
             <a:r>
-              <a:rPr lang="en-US" b="true" sz="9999">
+              <a:rPr lang="en-US" b="0" sz="8800">
                 <a:solidFill>
                   <a:srgbClr val="FFFFFF"/>
                 </a:solidFill>
-                <a:latin typeface="Raleway 1 Heavy"/>
-                <a:ea typeface="Raleway 1 Heavy"/>
-                <a:cs typeface="Raleway 1 Heavy"/>
-                <a:sym typeface="Raleway 1 Heavy"/>
+                <a:latin typeface="Arial Black"/>
+                <a:ea typeface="Arial Black"/>
+                <a:cs typeface="Arial Black"/>
+                <a:sym typeface="Arial Black"/>
               </a:rPr>
               <a:t>        CAMBIA</a:t>
             </a:r>
@@ -27587,14 +27587,14 @@
               </a:spcBef>
             </a:pPr>
             <a:r>
-              <a:rPr lang="en-US" b="true" sz="5400">
+              <a:rPr lang="en-US" b="0" sz="5400">
                 <a:solidFill>
                   <a:srgbClr val="FFFFFF"/>
                 </a:solidFill>
-                <a:latin typeface="Raleway 1 Heavy"/>
-                <a:ea typeface="Raleway 1 Heavy"/>
-                <a:cs typeface="Raleway 1 Heavy"/>
-                <a:sym typeface="Raleway 1 Heavy"/>
+                <a:latin typeface="Arial Black"/>
+                <a:ea typeface="Arial Black"/>
+                <a:cs typeface="Arial Black"/>
+                <a:sym typeface="Arial Black"/>
               </a:rPr>
               <a:t>Qué trae RG</a:t>
             </a:r>
@@ -28293,14 +28293,14 @@
               </a:spcBef>
             </a:pPr>
             <a:r>
-              <a:rPr lang="en-US" b="true" sz="4400">
+              <a:rPr lang="en-US" b="0" sz="3800">
                 <a:solidFill>
                   <a:srgbClr val="FFFFFF"/>
                 </a:solidFill>
-                <a:latin typeface="Raleway 1 Heavy"/>
-                <a:ea typeface="Raleway 1 Heavy"/>
-                <a:cs typeface="Raleway 1 Heavy"/>
-                <a:sym typeface="Raleway 1 Heavy"/>
+                <a:latin typeface="Arial Black"/>
+                <a:ea typeface="Arial Black"/>
+                <a:cs typeface="Arial Black"/>
+                <a:sym typeface="Arial Black"/>
               </a:rPr>
               <a:t>Cuatro tamaños y 30 % menos por vCPU</a:t>
             </a:r>
@@ -28608,12 +28608,12 @@
               <a:tblGrid>
                 <a:gridCol w="2194560"/>
                 <a:gridCol w="1005840"/>
-                <a:gridCol w="1371600"/>
-                <a:gridCol w="914400"/>
+                <a:gridCol w="1600200"/>
+                <a:gridCol w="822960"/>
                 <a:gridCol w="2286000"/>
                 <a:gridCol w="1005840"/>
-                <a:gridCol w="1463040"/>
-                <a:gridCol w="3657600"/>
+                <a:gridCol w="1600200"/>
+                <a:gridCol w="3383280"/>
               </a:tblGrid>
               <a:tr h="658368">
                 <a:tc>
@@ -29638,14 +29638,14 @@
               </a:spcBef>
             </a:pPr>
             <a:r>
-              <a:rPr lang="en-US" b="true" sz="5400">
+              <a:rPr lang="en-US" b="0" sz="5400">
                 <a:solidFill>
                   <a:srgbClr val="FFFFFF"/>
                 </a:solidFill>
-                <a:latin typeface="Raleway 1 Heavy"/>
-                <a:ea typeface="Raleway 1 Heavy"/>
-                <a:cs typeface="Raleway 1 Heavy"/>
-                <a:sym typeface="Raleway 1 Heavy"/>
+                <a:latin typeface="Arial Black"/>
+                <a:ea typeface="Arial Black"/>
+                <a:cs typeface="Arial Black"/>
+                <a:sym typeface="Arial Black"/>
               </a:rPr>
               <a:t>Lo que anunció AWS</a:t>
             </a:r>
@@ -30437,14 +30437,14 @@
               </a:lnSpc>
             </a:pPr>
             <a:r>
-              <a:rPr lang="en-US" b="true" sz="9999">
+              <a:rPr lang="en-US" b="0" sz="8800">
                 <a:solidFill>
                   <a:srgbClr val="FFFFFF"/>
                 </a:solidFill>
-                <a:latin typeface="Raleway 1 Heavy"/>
-                <a:ea typeface="Raleway 1 Heavy"/>
-                <a:cs typeface="Raleway 1 Heavy"/>
-                <a:sym typeface="Raleway 1 Heavy"/>
+                <a:latin typeface="Arial Black"/>
+                <a:ea typeface="Arial Black"/>
+                <a:cs typeface="Arial Black"/>
+                <a:sym typeface="Arial Black"/>
               </a:rPr>
               <a:t>CÓMO LO</a:t>
             </a:r>
@@ -30456,14 +30456,14 @@
               </a:lnSpc>
             </a:pPr>
             <a:r>
-              <a:rPr lang="en-US" b="true" sz="9999">
+              <a:rPr lang="en-US" b="0" sz="8800">
                 <a:solidFill>
                   <a:srgbClr val="FFFFFF"/>
                 </a:solidFill>
-                <a:latin typeface="Raleway 1 Heavy"/>
-                <a:ea typeface="Raleway 1 Heavy"/>
-                <a:cs typeface="Raleway 1 Heavy"/>
-                <a:sym typeface="Raleway 1 Heavy"/>
+                <a:latin typeface="Arial Black"/>
+                <a:ea typeface="Arial Black"/>
+                <a:cs typeface="Arial Black"/>
+                <a:sym typeface="Arial Black"/>
               </a:rPr>
               <a:t>        MEDIMOS</a:t>
             </a:r>

</xml_diff>

<commit_message>
results+slides: Serverless 4 RPU as a third contender, from the same snapshot
- 4 RPU pinned (64 GB, the memory of 2x rg.xlarge; USD 1.50/h vs 1.52/h),
  verified at 4.0 RPU every minute in SYS_SERVERLESS_USAGE
- RG 3.09x faster than Serverless on the 20 queries (96.7 vs 243.9 s);
  concurrency 720 qph (RA3 680, RG 1224); Parquet 0.5 GB files ties RG;
  real bill for all Serverless tests USD 1.48
- new slide "¿Y Serverless?" (36 slides), slides 12 and 33 updated
- runbook 4b: restore, admin secret, lake grants, SSO expiry; Serverless destroyed

Co-Authored-By: Claude Opus 5.5 <noreply@anthropic.com>
Claude-Session: https://claude.ai/code/session_01HgWRiJoTFne1e49sP1svEg
</commit_message>
<xml_diff>
--- a/slides/redshift-redemption.pptx
+++ b/slides/redshift-redemption.pptx
@@ -40,6 +40,7 @@
     <p:sldId id="302" r:id="rId57"/>
     <p:sldId id="303" r:id="rId58"/>
     <p:sldId id="304" r:id="rId59"/>
+    <p:sldId id="305" r:id="rId60"/>
   </p:sldIdLst>
   <p:sldSz cx="18288000" cy="10287000"/>
   <p:notesSz cx="6858000" cy="9144000"/>
@@ -2950,7 +2951,7 @@
           <a:lstStyle/>
           <a:p>
             <a:r>
-              <a:t>Prefiero decirlo desde el principio. Con 100 GB, buena parte de los datos que se consultan cabe en memoria, y eso reduce la ventaja de RG cuando hay que leer mucho. Si aun así RG gana, es buena señal; con más datos esperaría una diferencia mayor, pero eso no lo medí.</a:t>
+              <a:t>Prefiero decirlo desde el principio. Con 100 GB, buena parte de los datos que se consultan cabe en memoria, y eso reduce la ventaja de RG cuando hay que leer mucho. Si aun así RG gana, es buena señal; con más datos esperaría una diferencia mayor, pero eso no lo medí. Serverless lo medimos solo con 4 RPU fijos, sin dejarlo escalar.</a:t>
             </a:r>
           </a:p>
         </p:txBody>
@@ -3440,7 +3441,7 @@
           <a:lstStyle/>
           <a:p>
             <a:r>
-              <a:t>Ahora la parte más interesante, y la que más depende de cómo tienes guardados tus datos.</a:t>
+              <a:t>Agregué Serverless con la misma memoria que el clúster RG: 4 RPU son 64 GB, y cuestan 1,50 dólares por hora contra 1,52 del clúster. Fijé la capacidad para que no escalara durante la prueba. En esas condiciones, RG fue unas tres veces más rápido en las consultas del warehouse, y Serverless quedó incluso por debajo de RA3 en casi todo. Pero ojo con la conclusión: 4 RPU es el tamaño de entrada, y lo que vende Serverless es otra cosa: escalar solo cuando hace falta y no cobrar cuando no hay consultas. Todas las pruebas de Serverless del día costaron 1,48 dólares. Fuente: results/2026-10-05/summary-serverless.md.</a:t>
             </a:r>
           </a:p>
         </p:txBody>
@@ -3580,7 +3581,7 @@
           <a:lstStyle/>
           <a:p>
             <a:r>
-              <a:t>Escribí las mismas cinco tablas en Iceberg y en Parquet desde el warehouse, y comprobé que las seis consultas devuelven exactamente las mismas 483 filas en las tres versiones. Así, lo único que cambia es la forma de leer los datos.</a:t>
+              <a:t>Ahora la parte más interesante, y la que más depende de cómo tienes guardados tus datos.</a:t>
             </a:r>
           </a:p>
         </p:txBody>
@@ -3650,7 +3651,7 @@
           <a:lstStyle/>
           <a:p>
             <a:r>
-              <a:t>RG lee Iceberg casi dos veces más rápido que RA3, con una salvedad: la primera vez que toca los datos tarda bastante más, porque los trae de S3 y los guarda en caché. Mi método no cuenta la primera repetición, así que este resultado es con la caché ya cargada. Si consultas el data lake de vez en cuando, ten en cuenta esa primera lectura.</a:t>
+              <a:t>Escribí las mismas cinco tablas en Iceberg y en Parquet desde el warehouse, y comprobé que las seis consultas devuelven exactamente las mismas 483 filas en las tres versiones. Así, lo único que cambia es la forma de leer los datos.</a:t>
             </a:r>
           </a:p>
         </p:txBody>
@@ -3720,7 +3721,7 @@
           <a:lstStyle/>
           <a:p>
             <a:r>
-              <a:t>Este fue el resultado que más me sorprendió. Con Parquet, RG empezó siendo más lento que RA3. Revisé el plan de ejecución y era idéntico en los dos. La diferencia estaba en los archivos: Redshift los había escrito en solo cuatro archivos enormes, uno por slice, porque por defecto cada archivo puede llegar a 6.200 MB. Los reescribí en archivos de medio giga y RG pasó a ganar, mientras que RA3 empeoró. El mismo cambio ayuda a uno y perjudica al otro.</a:t>
+              <a:t>RG lee Iceberg casi dos veces más rápido que RA3, con una salvedad: la primera vez que toca los datos tarda bastante más, porque los trae de S3 y los guarda en caché. Mi método no cuenta la primera repetición, así que este resultado es con la caché ya cargada. Si consultas el data lake de vez en cuando, ten en cuenta esa primera lectura.</a:t>
             </a:r>
           </a:p>
         </p:txBody>
@@ -3790,7 +3791,7 @@
           <a:lstStyle/>
           <a:p>
             <a:r>
-              <a:t>En el laboratorio son centavos, porque son 100 GB. Pero esto crece con el volumen y con la frecuencia: un equipo que lee decenas de TB al mes desde el data lake lo nota en la factura. En RG ese cobro desaparece.</a:t>
+              <a:t>Este fue el resultado que más me sorprendió. Con Parquet, RG empezó siendo más lento que RA3. Revisé el plan de ejecución y era idéntico en los dos. La diferencia estaba en los archivos: Redshift los había escrito en solo cuatro archivos enormes, uno por slice, porque por defecto cada archivo puede llegar a 6.200 MB. Los reescribí en archivos de medio giga y RG pasó a ganar, mientras que RA3 empeoró. El mismo cambio ayuda a uno y perjudica al otro.</a:t>
             </a:r>
           </a:p>
         </p:txBody>
@@ -3860,7 +3861,7 @@
           <a:lstStyle/>
           <a:p>
             <a:r>
-              <a:t>Quería probar S3 Tables y no pude, por una razón de diseño: esas tablas solo se leen conectándose con una identidad de IAM, y mi programa se conecta con un usuario de base de datos. Cambiar de usuario solo para esa prueba habría medido otra cosa. Además, Iceberg no acepta columnas CHAR, y Lake Formation exige permisos explícitos sobre las bases de Glue.</a:t>
+              <a:t>En el laboratorio son centavos, porque son 100 GB. Pero esto crece con el volumen y con la frecuencia: un equipo que lee decenas de TB al mes desde el data lake lo nota en la factura. En RG ese cobro desaparece.</a:t>
             </a:r>
           </a:p>
         </p:txBody>
@@ -3930,7 +3931,7 @@
           <a:lstStyle/>
           <a:p>
             <a:r>
-              <a:t>Supongamos que decides migrar. ¿Cuánto cuesta en tiempo y en sustos?</a:t>
+              <a:t>Quería probar S3 Tables y no pude, por una razón de diseño: esas tablas solo se leen conectándose con una identidad de IAM, y mi programa se conecta con un usuario de base de datos. Cambiar de usuario solo para esa prueba habría medido otra cosa. Además, Iceberg no acepta columnas CHAR, y Lake Formation exige permisos explícitos sobre las bases de Glue.</a:t>
             </a:r>
           </a:p>
         </p:txBody>
@@ -4000,7 +4001,7 @@
           <a:lstStyle/>
           <a:p>
             <a:r>
-              <a:t>Restauré una copia del clúster RA3 y lo convertí a RG con un elastic resize, intentando escribir cada 30 segundos. Empezó a las 19:05:47 y terminó a las 19:08:35. El clúster quedó en solo lectura entre 1 minuto 35 y 2 minutos 42 segundos; el rango se debe a que revisábamos cada 30 segundos. Como pasamos de 2 nodos a 2 nodos, los datos quedaron repartidos igual. Ojo: si cambias la cantidad de nodos, como al pasar de 4 a 3 en el tamaño 4xlarge, el reparto sí puede desbalancearse.</a:t>
+              <a:t>Supongamos que decides migrar. ¿Cuánto cuesta en tiempo y en sustos?</a:t>
             </a:r>
           </a:p>
         </p:txBody>
@@ -4070,7 +4071,7 @@
           <a:lstStyle/>
           <a:p>
             <a:r>
-              <a:t>Las tres primeras me pasaron en el simulacro, en ese orden, y no las encontré en la guía de migración. Las dos últimas sí aparecen en la documentación y en el blog de AWS. Todas quedaron resueltas en el script del repositorio.</a:t>
+              <a:t>Restauré una copia del clúster RA3 y lo convertí a RG con un elastic resize, intentando escribir cada 30 segundos. Empezó a las 19:05:47 y terminó a las 19:08:35. El clúster quedó en solo lectura entre 1 minuto 35 y 2 minutos 42 segundos; el rango se debe a que revisábamos cada 30 segundos. Como pasamos de 2 nodos a 2 nodos, los datos quedaron repartidos igual. Ojo: si cambias la cantidad de nodos, como al pasar de 4 a 3 en el tamaño 4xlarge, el reparto sí puede desbalancearse.</a:t>
             </a:r>
           </a:p>
         </p:txBody>
@@ -4140,7 +4141,7 @@
           <a:lstStyle/>
           <a:p>
             <a:r>
-              <a:t>Ahora veamos las consultas y los datos reales.</a:t>
+              <a:t>Las tres primeras me pasaron en el simulacro, en ese orden, y no las encontré en la guía de migración. Las dos últimas sí aparecen en la documentación y en el blog de AWS. Todas quedaron resueltas en el script del repositorio.</a:t>
             </a:r>
           </a:p>
         </p:txBody>
@@ -4210,7 +4211,7 @@
           <a:lstStyle/>
           <a:p>
             <a:r>
-              <a:t>Esta es una consulta típica de lectura: cuenta ventas filtrando por hora del día, por tipo de hogar y por tienda. Lo pesado es que tiene que recorrer las 288 millones de filas de la tabla de ventas y cruzarlas con tres tablas más. En RA3 tarda 1,77 segundos; en RG, 0,67.</a:t>
+              <a:t>Ahora veamos las consultas y los datos reales.</a:t>
             </a:r>
           </a:p>
         </p:txBody>
@@ -4350,7 +4351,7 @@
           <a:lstStyle/>
           <a:p>
             <a:r>
-              <a:t>Así encontré la explicación del caso de Parquet. Si los planes fueran distintos, la diferencia estaría en el plan y no en el clúster. Son iguales: lo único que cambia es la pieza que lee S3, Spectrum en RA3 y los propios nodos en RG. Cuando veas una diferencia rara entre dos clústeres, empieza por aquí.</a:t>
+              <a:t>Esta es una consulta típica de lectura: cuenta ventas filtrando por hora del día, por tipo de hogar y por tienda. Lo pesado es que tiene que recorrer las 288 millones de filas de la tabla de ventas y cruzarlas con tres tablas más. En RA3 tarda 1,77 segundos; en RG, 0,67.</a:t>
             </a:r>
           </a:p>
         </p:txBody>
@@ -4420,7 +4421,7 @@
           <a:lstStyle/>
           <a:p>
             <a:r>
-              <a:t>Esta página reúne todos los números de la charla, sacados directamente de los archivos del repositorio. La abro un momento para que vean cada consulta. Abrir: https://claude.ai/artifact/1MgMakVPq4URRXQMZp4aVk (privada, con la sesión del orador; copia local: slides/demo/resultados.html).</a:t>
+              <a:t>Así encontré la explicación del caso de Parquet. Si los planes fueran distintos, la diferencia estaría en el plan y no en el clúster. Son iguales: lo único que cambia es la pieza que lee S3, Spectrum en RA3 y los propios nodos en RG. Cuando veas una diferencia rara entre dos clústeres, empieza por aquí.</a:t>
             </a:r>
           </a:p>
         </p:txBody>
@@ -4490,7 +4491,7 @@
           <a:lstStyle/>
           <a:p>
             <a:r>
-              <a:t>Esta es mi respuesta a la pregunta del título. Para la mayoría de los equipos con RA3, migrar conviene: es más rápido, más barato y el cambio toma minutos. Pero prueba primero con tus datos, sobre todo si tu data lake está en Parquet o si tus consultas son de cálculo pesado. Serverless es otra decisión, que depende de cómo usas Redshift, y como no lo medí, no les doy un número.</a:t>
+              <a:t>Esta página reúne todos los números de la charla, sacados directamente de los archivos del repositorio. La abro un momento para que vean cada consulta. Abrir: https://claude.ai/artifact/1MgMakVPq4URRXQMZp4aVk (privada, con la sesión del orador; copia local: slides/demo/resultados.html).</a:t>
             </a:r>
           </a:p>
         </p:txBody>
@@ -4560,7 +4561,7 @@
           <a:lstStyle/>
           <a:p>
             <a:r>
-              <a:t>Todo lo que vieron está en el repositorio: la infraestructura, el programa que lanza las pruebas, el runbook con cada paso y los errores que me encontré. Cámbienle el dataset por el suyo y repitan las mediciones.</a:t>
+              <a:t>Esta es mi respuesta a la pregunta del título. Para la mayoría de los equipos con RA3, migrar conviene: es más rápido, más barato y el cambio toma minutos. Pero prueba primero con tus datos, sobre todo si tu data lake está en Parquet o si tus consultas son de cálculo pesado. Serverless es otra decisión, que depende de cómo usas Redshift: a 4 RPU fijos fue mucho más lento que RG, así que si lo eliges, dale más capacidad o deja que escale.</a:t>
             </a:r>
           </a:p>
         </p:txBody>
@@ -4630,7 +4631,7 @@
           <a:lstStyle/>
           <a:p>
             <a:r>
-              <a:t>Kahoot. Pregunta 1: ¿Con qué lee RG los datos del data lake? a) Redshift Spectrum; b) Con sus propios nodos, sin Spectrum (correcta); c) Amazon Athena; d) Trabajos de AWS Glue. Comentario: RA3 usa Spectrum, que cobra USD 5 por TB leído; RG lee el lago con sus nodos y sin ese cobro. Pregunta 2: ¿Qué tipo de consultas mejoró más al pasar de RA3 a RG? a) Las de cálculo pesado, con ventanas y joins grandes; b) Las que leen y agregan muchos datos (correcta); c) Ninguna, quedaron igual; d) Solo las del data lake. Comentario: 2,28 veces en lectura contra 1,58 en cálculo; el promedio de las 20 consultas fue 1,90. Pregunta 3: Si tienes 4 nodos ra3.4xlarge, ¿cuántos rg.4xlarge recomienda AWS? a) 4; b) 3 (correcta); c) 2; d) 8. Comentario: un ra3.4xlarge tiene 12 vCPU y un rg.4xlarge, 16; 4 por 12 y 3 por 16 dan 48. Migrar uno a uno en ese tamaño te deja con un tercio de capacidad de más.</a:t>
+              <a:t>Todo lo que vieron está en el repositorio: la infraestructura, el programa que lanza las pruebas, el runbook con cada paso y los errores que me encontré. Cámbienle el dataset por el suyo y repitan las mediciones.</a:t>
             </a:r>
           </a:p>
         </p:txBody>
@@ -4656,6 +4657,76 @@
 </file>
 
 <file path=ppt/notesSlides/notesSlide35.xml><?xml version="1.0" encoding="utf-8"?>
+<p:notes xmlns:a="http://schemas.openxmlformats.org/drawingml/2006/main" xmlns:p="http://schemas.openxmlformats.org/presentationml/2006/main" xmlns:r="http://schemas.openxmlformats.org/officeDocument/2006/relationships">
+  <p:cSld>
+    <p:spTree>
+      <p:nvGrpSpPr>
+        <p:cNvPr id="1" name=""/>
+        <p:cNvGrpSpPr/>
+        <p:nvPr/>
+      </p:nvGrpSpPr>
+      <p:grpSpPr>
+        <a:xfrm>
+          <a:off x="0" y="0"/>
+          <a:ext cx="0" cy="0"/>
+          <a:chOff x="0" y="0"/>
+          <a:chExt cx="0" cy="0"/>
+        </a:xfrm>
+      </p:grpSpPr>
+      <p:sp>
+        <p:nvSpPr>
+          <p:cNvPr id="2" name="Slide Image Placeholder 1"/>
+          <p:cNvSpPr>
+            <a:spLocks noGrp="1"/>
+          </p:cNvSpPr>
+          <p:nvPr>
+            <p:ph type="sldImg" idx="2"/>
+          </p:nvPr>
+        </p:nvSpPr>
+        <p:spPr/>
+      </p:sp>
+      <p:sp>
+        <p:nvSpPr>
+          <p:cNvPr id="3" name="Notes Placeholder 2"/>
+          <p:cNvSpPr>
+            <a:spLocks noGrp="1"/>
+          </p:cNvSpPr>
+          <p:nvPr>
+            <p:ph type="body" idx="3" sz="quarter"/>
+          </p:nvPr>
+        </p:nvSpPr>
+        <p:spPr/>
+        <p:txBody>
+          <a:bodyPr/>
+          <a:lstStyle/>
+          <a:p>
+            <a:r>
+              <a:t>Kahoot. Pregunta 1: ¿Con qué lee RG los datos del data lake? a) Redshift Spectrum; b) Con sus propios nodos, sin Spectrum (correcta); c) Amazon Athena; d) Trabajos de AWS Glue. Comentario: RA3 usa Spectrum, que cobra USD 5 por TB leído; RG lee el lago con sus nodos y sin ese cobro. Pregunta 2: ¿Qué tipo de consultas mejoró más al pasar de RA3 a RG? a) Las de cálculo pesado, con ventanas y joins grandes; b) Las que leen y agregan muchos datos (correcta); c) Ninguna, quedaron igual; d) Solo las del data lake. Comentario: 2,28 veces en lectura contra 1,58 en cálculo; el promedio de las 20 consultas fue 1,90. Pregunta 3: Si tienes 4 nodos ra3.4xlarge, ¿cuántos rg.4xlarge recomienda AWS? a) 4; b) 3 (correcta); c) 2; d) 8. Comentario: un ra3.4xlarge tiene 12 vCPU y un rg.4xlarge, 16; 4 por 12 y 3 por 16 dan 48. Migrar uno a uno en ese tamaño te deja con un tercio de capacidad de más.</a:t>
+            </a:r>
+          </a:p>
+        </p:txBody>
+      </p:sp>
+      <p:sp>
+        <p:nvSpPr>
+          <p:cNvPr id="4" name="Slide Number Placeholder 3"/>
+          <p:cNvSpPr>
+            <a:spLocks noGrp="1"/>
+          </p:cNvSpPr>
+          <p:nvPr>
+            <p:ph type="sldNum" idx="5" sz="quarter"/>
+          </p:nvPr>
+        </p:nvSpPr>
+        <p:spPr/>
+      </p:sp>
+    </p:spTree>
+  </p:cSld>
+  <p:clrMapOvr>
+    <a:masterClrMapping/>
+  </p:clrMapOvr>
+</p:notes>
+</file>
+
+<file path=ppt/notesSlides/notesSlide36.xml><?xml version="1.0" encoding="utf-8"?>
 <p:notes xmlns:a="http://schemas.openxmlformats.org/drawingml/2006/main" xmlns:p="http://schemas.openxmlformats.org/presentationml/2006/main" xmlns:r="http://schemas.openxmlformats.org/officeDocument/2006/relationships">
   <p:cSld>
     <p:spTree>
@@ -10190,7 +10261,7 @@
                 </a:solidFill>
                 <a:latin typeface="Arial"/>
               </a:rPr>
-              <a:t>Serverless</a:t>
+              <a:t>Serverless solo a 4 RPU</a:t>
             </a:r>
           </a:p>
           <a:p>
@@ -10206,7 +10277,7 @@
                 </a:solidFill>
                 <a:latin typeface="Arial"/>
               </a:rPr>
-              <a:t>Lo comentamos con precios y documentación, sin pruebas propias</a:t>
+              <a:t>Capacidad fija para comparar; no probamos cómo escala</a:t>
             </a:r>
           </a:p>
         </p:txBody>
@@ -13979,26 +14050,29 @@
         </p:nvSpPr>
         <p:spPr>
           <a:xfrm rot="0">
-            <a:off x="3444099" y="3763913"/>
-            <a:ext cx="13438018" cy="2238374"/>
+            <a:off x="3520440" y="868680"/>
+            <a:ext cx="12070080" cy="1874519"/>
           </a:xfrm>
           <a:prstGeom prst="rect">
             <a:avLst/>
           </a:prstGeom>
         </p:spPr>
         <p:txBody>
-          <a:bodyPr anchor="t" rtlCol="false" tIns="0" lIns="0" bIns="0" rIns="0">
+          <a:bodyPr anchor="ctr" rtlCol="false" tIns="0" lIns="0" bIns="0" rIns="0" wrap="square">
             <a:spAutoFit/>
           </a:bodyPr>
           <a:lstStyle/>
           <a:p>
-            <a:pPr algn="l">
+            <a:pPr algn="l" marL="0" indent="0" lvl="0">
               <a:lnSpc>
-                <a:spcPts val="8399"/>
+                <a:spcPts val="10481"/>
               </a:lnSpc>
+              <a:spcBef>
+                <a:spcPct val="0"/>
+              </a:spcBef>
             </a:pPr>
             <a:r>
-              <a:rPr lang="en-US" b="0" sz="8800">
+              <a:rPr lang="en-US" b="0" sz="5400">
                 <a:solidFill>
                   <a:srgbClr val="FFFFFF"/>
                 </a:solidFill>
@@ -14007,26 +14081,7 @@
                 <a:cs typeface="Arial Black"/>
                 <a:sym typeface="Arial Black"/>
               </a:rPr>
-              <a:t>DATA</a:t>
-            </a:r>
-          </a:p>
-          <a:p>
-            <a:pPr algn="l" marL="0" indent="0" lvl="0">
-              <a:lnSpc>
-                <a:spcPts val="8399"/>
-              </a:lnSpc>
-            </a:pPr>
-            <a:r>
-              <a:rPr lang="en-US" b="0" sz="8800">
-                <a:solidFill>
-                  <a:srgbClr val="FFFFFF"/>
-                </a:solidFill>
-                <a:latin typeface="Arial Black"/>
-                <a:ea typeface="Arial Black"/>
-                <a:cs typeface="Arial Black"/>
-                <a:sym typeface="Arial Black"/>
-              </a:rPr>
-              <a:t>        LAKE</a:t>
+              <a:t>¿Y Serverless?</a:t>
             </a:r>
           </a:p>
         </p:txBody>
@@ -14311,6 +14366,538 @@
           </a:p>
         </p:txBody>
       </p:sp>
+      <p:graphicFrame>
+        <p:nvGraphicFramePr>
+          <p:cNvPr id="10" name="Table 9"/>
+          <p:cNvGraphicFramePr>
+            <a:graphicFrameLocks noGrp="1"/>
+          </p:cNvGraphicFramePr>
+          <p:nvPr/>
+        </p:nvGraphicFramePr>
+        <p:xfrm>
+          <a:off x="914400" y="3200400"/>
+          <a:ext cx="13898880" cy="3200400"/>
+        </p:xfrm>
+        <a:graphic>
+          <a:graphicData uri="http://schemas.openxmlformats.org/drawingml/2006/table">
+            <a:tbl>
+              <a:tblPr firstRow="1" bandRow="1">
+                <a:tableStyleId>{5C22544A-7EE6-4342-B048-85BDC9FD1C3A}</a:tableStyleId>
+              </a:tblPr>
+              <a:tblGrid>
+                <a:gridCol w="4572000"/>
+                <a:gridCol w="2743200"/>
+                <a:gridCol w="2743200"/>
+                <a:gridCol w="3840480"/>
+              </a:tblGrid>
+              <a:tr h="640080">
+                <a:tc>
+                  <a:txBody>
+                    <a:bodyPr/>
+                    <a:lstStyle/>
+                    <a:p/>
+                  </a:txBody>
+                  <a:tcPr anchor="ctr" marL="109728" marR="109728">
+                    <a:solidFill>
+                      <a:srgbClr val="316CE3"/>
+                    </a:solidFill>
+                  </a:tcPr>
+                </a:tc>
+                <a:tc>
+                  <a:txBody>
+                    <a:bodyPr/>
+                    <a:lstStyle/>
+                    <a:p>
+                      <a:r>
+                        <a:rPr sz="2200" b="1">
+                          <a:solidFill>
+                            <a:srgbClr val="FFFFFF"/>
+                          </a:solidFill>
+                          <a:latin typeface="Arial"/>
+                        </a:rPr>
+                        <a:t>RA3</a:t>
+                      </a:r>
+                    </a:p>
+                  </a:txBody>
+                  <a:tcPr anchor="ctr" marL="109728" marR="109728">
+                    <a:solidFill>
+                      <a:srgbClr val="316CE3"/>
+                    </a:solidFill>
+                  </a:tcPr>
+                </a:tc>
+                <a:tc>
+                  <a:txBody>
+                    <a:bodyPr/>
+                    <a:lstStyle/>
+                    <a:p>
+                      <a:r>
+                        <a:rPr sz="2200" b="1">
+                          <a:solidFill>
+                            <a:srgbClr val="FFFFFF"/>
+                          </a:solidFill>
+                          <a:latin typeface="Arial"/>
+                        </a:rPr>
+                        <a:t>RG</a:t>
+                      </a:r>
+                    </a:p>
+                  </a:txBody>
+                  <a:tcPr anchor="ctr" marL="109728" marR="109728">
+                    <a:solidFill>
+                      <a:srgbClr val="316CE3"/>
+                    </a:solidFill>
+                  </a:tcPr>
+                </a:tc>
+                <a:tc>
+                  <a:txBody>
+                    <a:bodyPr/>
+                    <a:lstStyle/>
+                    <a:p>
+                      <a:r>
+                        <a:rPr sz="2200" b="1">
+                          <a:solidFill>
+                            <a:srgbClr val="FFFFFF"/>
+                          </a:solidFill>
+                          <a:latin typeface="Arial"/>
+                        </a:rPr>
+                        <a:t>Serverless 4 RPU</a:t>
+                      </a:r>
+                    </a:p>
+                  </a:txBody>
+                  <a:tcPr anchor="ctr" marL="109728" marR="109728">
+                    <a:solidFill>
+                      <a:srgbClr val="316CE3"/>
+                    </a:solidFill>
+                  </a:tcPr>
+                </a:tc>
+              </a:tr>
+              <a:tr h="640080">
+                <a:tc>
+                  <a:txBody>
+                    <a:bodyPr/>
+                    <a:lstStyle/>
+                    <a:p>
+                      <a:r>
+                        <a:rPr sz="2200" b="0">
+                          <a:solidFill>
+                            <a:srgbClr val="FFFFFF"/>
+                          </a:solidFill>
+                          <a:latin typeface="Arial"/>
+                        </a:rPr>
+                        <a:t>20 consultas (total)</a:t>
+                      </a:r>
+                    </a:p>
+                  </a:txBody>
+                  <a:tcPr anchor="ctr" marL="109728" marR="109728">
+                    <a:solidFill>
+                      <a:srgbClr val="2F3D52"/>
+                    </a:solidFill>
+                  </a:tcPr>
+                </a:tc>
+                <a:tc>
+                  <a:txBody>
+                    <a:bodyPr/>
+                    <a:lstStyle/>
+                    <a:p>
+                      <a:r>
+                        <a:rPr sz="2200" b="0">
+                          <a:solidFill>
+                            <a:srgbClr val="FFFFFF"/>
+                          </a:solidFill>
+                          <a:latin typeface="Arial"/>
+                        </a:rPr>
+                        <a:t>148,3 s</a:t>
+                      </a:r>
+                    </a:p>
+                  </a:txBody>
+                  <a:tcPr anchor="ctr" marL="109728" marR="109728">
+                    <a:solidFill>
+                      <a:srgbClr val="2F3D52"/>
+                    </a:solidFill>
+                  </a:tcPr>
+                </a:tc>
+                <a:tc>
+                  <a:txBody>
+                    <a:bodyPr/>
+                    <a:lstStyle/>
+                    <a:p>
+                      <a:r>
+                        <a:rPr sz="2200" b="1">
+                          <a:solidFill>
+                            <a:srgbClr val="FFFFFF"/>
+                          </a:solidFill>
+                          <a:latin typeface="Arial"/>
+                        </a:rPr>
+                        <a:t>96,7 s</a:t>
+                      </a:r>
+                    </a:p>
+                  </a:txBody>
+                  <a:tcPr anchor="ctr" marL="109728" marR="109728">
+                    <a:solidFill>
+                      <a:srgbClr val="2F3D52"/>
+                    </a:solidFill>
+                  </a:tcPr>
+                </a:tc>
+                <a:tc>
+                  <a:txBody>
+                    <a:bodyPr/>
+                    <a:lstStyle/>
+                    <a:p>
+                      <a:r>
+                        <a:rPr sz="2200" b="0">
+                          <a:solidFill>
+                            <a:srgbClr val="FFFFFF"/>
+                          </a:solidFill>
+                          <a:latin typeface="Arial"/>
+                        </a:rPr>
+                        <a:t>243,9 s</a:t>
+                      </a:r>
+                    </a:p>
+                  </a:txBody>
+                  <a:tcPr anchor="ctr" marL="109728" marR="109728">
+                    <a:solidFill>
+                      <a:srgbClr val="2F3D52"/>
+                    </a:solidFill>
+                  </a:tcPr>
+                </a:tc>
+              </a:tr>
+              <a:tr h="640080">
+                <a:tc>
+                  <a:txBody>
+                    <a:bodyPr/>
+                    <a:lstStyle/>
+                    <a:p>
+                      <a:r>
+                        <a:rPr sz="2200" b="0">
+                          <a:solidFill>
+                            <a:srgbClr val="FFFFFF"/>
+                          </a:solidFill>
+                          <a:latin typeface="Arial"/>
+                        </a:rPr>
+                        <a:t>Consultas por hora, 5 usuarios</a:t>
+                      </a:r>
+                    </a:p>
+                  </a:txBody>
+                  <a:tcPr anchor="ctr" marL="109728" marR="109728">
+                    <a:solidFill>
+                      <a:srgbClr val="2F3D52"/>
+                    </a:solidFill>
+                  </a:tcPr>
+                </a:tc>
+                <a:tc>
+                  <a:txBody>
+                    <a:bodyPr/>
+                    <a:lstStyle/>
+                    <a:p>
+                      <a:r>
+                        <a:rPr sz="2200" b="0">
+                          <a:solidFill>
+                            <a:srgbClr val="FFFFFF"/>
+                          </a:solidFill>
+                          <a:latin typeface="Arial"/>
+                        </a:rPr>
+                        <a:t>680</a:t>
+                      </a:r>
+                    </a:p>
+                  </a:txBody>
+                  <a:tcPr anchor="ctr" marL="109728" marR="109728">
+                    <a:solidFill>
+                      <a:srgbClr val="2F3D52"/>
+                    </a:solidFill>
+                  </a:tcPr>
+                </a:tc>
+                <a:tc>
+                  <a:txBody>
+                    <a:bodyPr/>
+                    <a:lstStyle/>
+                    <a:p>
+                      <a:r>
+                        <a:rPr sz="2200" b="1">
+                          <a:solidFill>
+                            <a:srgbClr val="FFFFFF"/>
+                          </a:solidFill>
+                          <a:latin typeface="Arial"/>
+                        </a:rPr>
+                        <a:t>1224</a:t>
+                      </a:r>
+                    </a:p>
+                  </a:txBody>
+                  <a:tcPr anchor="ctr" marL="109728" marR="109728">
+                    <a:solidFill>
+                      <a:srgbClr val="2F3D52"/>
+                    </a:solidFill>
+                  </a:tcPr>
+                </a:tc>
+                <a:tc>
+                  <a:txBody>
+                    <a:bodyPr/>
+                    <a:lstStyle/>
+                    <a:p>
+                      <a:r>
+                        <a:rPr sz="2200" b="0">
+                          <a:solidFill>
+                            <a:srgbClr val="FFFFFF"/>
+                          </a:solidFill>
+                          <a:latin typeface="Arial"/>
+                        </a:rPr>
+                        <a:t>720</a:t>
+                      </a:r>
+                    </a:p>
+                  </a:txBody>
+                  <a:tcPr anchor="ctr" marL="109728" marR="109728">
+                    <a:solidFill>
+                      <a:srgbClr val="2F3D52"/>
+                    </a:solidFill>
+                  </a:tcPr>
+                </a:tc>
+              </a:tr>
+              <a:tr h="640080">
+                <a:tc>
+                  <a:txBody>
+                    <a:bodyPr/>
+                    <a:lstStyle/>
+                    <a:p>
+                      <a:r>
+                        <a:rPr sz="2200" b="0">
+                          <a:solidFill>
+                            <a:srgbClr val="FFFFFF"/>
+                          </a:solidFill>
+                          <a:latin typeface="Arial"/>
+                        </a:rPr>
+                        <a:t>Iceberg (6 consultas)</a:t>
+                      </a:r>
+                    </a:p>
+                  </a:txBody>
+                  <a:tcPr anchor="ctr" marL="109728" marR="109728">
+                    <a:solidFill>
+                      <a:srgbClr val="2F3D52"/>
+                    </a:solidFill>
+                  </a:tcPr>
+                </a:tc>
+                <a:tc>
+                  <a:txBody>
+                    <a:bodyPr/>
+                    <a:lstStyle/>
+                    <a:p>
+                      <a:r>
+                        <a:rPr sz="2200" b="0">
+                          <a:solidFill>
+                            <a:srgbClr val="FFFFFF"/>
+                          </a:solidFill>
+                          <a:latin typeface="Arial"/>
+                        </a:rPr>
+                        <a:t>29,4 s</a:t>
+                      </a:r>
+                    </a:p>
+                  </a:txBody>
+                  <a:tcPr anchor="ctr" marL="109728" marR="109728">
+                    <a:solidFill>
+                      <a:srgbClr val="2F3D52"/>
+                    </a:solidFill>
+                  </a:tcPr>
+                </a:tc>
+                <a:tc>
+                  <a:txBody>
+                    <a:bodyPr/>
+                    <a:lstStyle/>
+                    <a:p>
+                      <a:r>
+                        <a:rPr sz="2200" b="1">
+                          <a:solidFill>
+                            <a:srgbClr val="FFFFFF"/>
+                          </a:solidFill>
+                          <a:latin typeface="Arial"/>
+                        </a:rPr>
+                        <a:t>14,6 s</a:t>
+                      </a:r>
+                    </a:p>
+                  </a:txBody>
+                  <a:tcPr anchor="ctr" marL="109728" marR="109728">
+                    <a:solidFill>
+                      <a:srgbClr val="2F3D52"/>
+                    </a:solidFill>
+                  </a:tcPr>
+                </a:tc>
+                <a:tc>
+                  <a:txBody>
+                    <a:bodyPr/>
+                    <a:lstStyle/>
+                    <a:p>
+                      <a:r>
+                        <a:rPr sz="2200" b="0">
+                          <a:solidFill>
+                            <a:srgbClr val="FFFFFF"/>
+                          </a:solidFill>
+                          <a:latin typeface="Arial"/>
+                        </a:rPr>
+                        <a:t>34,7 s</a:t>
+                      </a:r>
+                    </a:p>
+                  </a:txBody>
+                  <a:tcPr anchor="ctr" marL="109728" marR="109728">
+                    <a:solidFill>
+                      <a:srgbClr val="2F3D52"/>
+                    </a:solidFill>
+                  </a:tcPr>
+                </a:tc>
+              </a:tr>
+              <a:tr h="640080">
+                <a:tc>
+                  <a:txBody>
+                    <a:bodyPr/>
+                    <a:lstStyle/>
+                    <a:p>
+                      <a:r>
+                        <a:rPr sz="2200" b="0">
+                          <a:solidFill>
+                            <a:srgbClr val="FFFFFF"/>
+                          </a:solidFill>
+                          <a:latin typeface="Arial"/>
+                        </a:rPr>
+                        <a:t>Costo por ejecución de las 20</a:t>
+                      </a:r>
+                    </a:p>
+                  </a:txBody>
+                  <a:tcPr anchor="ctr" marL="109728" marR="109728">
+                    <a:solidFill>
+                      <a:srgbClr val="2F3D52"/>
+                    </a:solidFill>
+                  </a:tcPr>
+                </a:tc>
+                <a:tc>
+                  <a:txBody>
+                    <a:bodyPr/>
+                    <a:lstStyle/>
+                    <a:p>
+                      <a:r>
+                        <a:rPr sz="2200" b="0">
+                          <a:solidFill>
+                            <a:srgbClr val="FFFFFF"/>
+                          </a:solidFill>
+                          <a:latin typeface="Arial"/>
+                        </a:rPr>
+                        <a:t>USD 0,089</a:t>
+                      </a:r>
+                    </a:p>
+                  </a:txBody>
+                  <a:tcPr anchor="ctr" marL="109728" marR="109728">
+                    <a:solidFill>
+                      <a:srgbClr val="2F3D52"/>
+                    </a:solidFill>
+                  </a:tcPr>
+                </a:tc>
+                <a:tc>
+                  <a:txBody>
+                    <a:bodyPr/>
+                    <a:lstStyle/>
+                    <a:p>
+                      <a:r>
+                        <a:rPr sz="2200" b="1">
+                          <a:solidFill>
+                            <a:srgbClr val="FFFFFF"/>
+                          </a:solidFill>
+                          <a:latin typeface="Arial"/>
+                        </a:rPr>
+                        <a:t>USD 0,041</a:t>
+                      </a:r>
+                    </a:p>
+                  </a:txBody>
+                  <a:tcPr anchor="ctr" marL="109728" marR="109728">
+                    <a:solidFill>
+                      <a:srgbClr val="2F3D52"/>
+                    </a:solidFill>
+                  </a:tcPr>
+                </a:tc>
+                <a:tc>
+                  <a:txBody>
+                    <a:bodyPr/>
+                    <a:lstStyle/>
+                    <a:p>
+                      <a:r>
+                        <a:rPr sz="2200" b="0">
+                          <a:solidFill>
+                            <a:srgbClr val="FFFFFF"/>
+                          </a:solidFill>
+                          <a:latin typeface="Arial"/>
+                        </a:rPr>
+                        <a:t>USD 0,102</a:t>
+                      </a:r>
+                    </a:p>
+                  </a:txBody>
+                  <a:tcPr anchor="ctr" marL="109728" marR="109728">
+                    <a:solidFill>
+                      <a:srgbClr val="2F3D52"/>
+                    </a:solidFill>
+                  </a:tcPr>
+                </a:tc>
+              </a:tr>
+            </a:tbl>
+          </a:graphicData>
+        </a:graphic>
+      </p:graphicFrame>
+      <p:sp>
+        <p:nvSpPr>
+          <p:cNvPr id="11" name="TextBox 10"/>
+          <p:cNvSpPr txBox="1"/>
+          <p:nvPr/>
+        </p:nvSpPr>
+        <p:spPr>
+          <a:xfrm>
+            <a:off x="914400" y="6629400"/>
+            <a:ext cx="13898880" cy="1645920"/>
+          </a:xfrm>
+          <a:prstGeom prst="rect">
+            <a:avLst/>
+          </a:prstGeom>
+          <a:noFill/>
+        </p:spPr>
+        <p:txBody>
+          <a:bodyPr wrap="square" anchor="t" lIns="0" rIns="0" tIns="0" bIns="0">
+            <a:spAutoFit/>
+          </a:bodyPr>
+          <a:lstStyle/>
+          <a:p>
+            <a:pPr algn="l">
+              <a:spcAft>
+                <a:spcPts val="1200"/>
+              </a:spcAft>
+            </a:pPr>
+            <a:r>
+              <a:rPr sz="2200" b="0">
+                <a:solidFill>
+                  <a:srgbClr val="D9E2EC"/>
+                </a:solidFill>
+                <a:latin typeface="Arial"/>
+              </a:rPr>
+              <a:t>Con la misma memoria (64 GB) y casi el mismo precio por hora, </a:t>
+            </a:r>
+            <a:r>
+              <a:rPr sz="2200" b="1">
+                <a:solidFill>
+                  <a:srgbClr val="D9E2EC"/>
+                </a:solidFill>
+                <a:latin typeface="Arial"/>
+              </a:rPr>
+              <a:t>RG fue 3,1 veces más rápido que Serverless de 4 RPU.</a:t>
+            </a:r>
+          </a:p>
+          <a:p>
+            <a:pPr algn="l">
+              <a:spcAft>
+                <a:spcPts val="1200"/>
+              </a:spcAft>
+            </a:pPr>
+            <a:r>
+              <a:rPr sz="2200" b="0">
+                <a:solidFill>
+                  <a:srgbClr val="D9E2EC"/>
+                </a:solidFill>
+                <a:latin typeface="Arial"/>
+              </a:rPr>
+              <a:t>La capacidad quedó fija a propósito: la ventaja de Serverless es escalar cuando hace falta y no cobrar sin consultas.</a:t>
+            </a:r>
+          </a:p>
+        </p:txBody>
+      </p:sp>
     </p:spTree>
   </p:cSld>
   <p:clrMapOvr>
@@ -14953,29 +15540,26 @@
         </p:nvSpPr>
         <p:spPr>
           <a:xfrm rot="0">
-            <a:off x="3520440" y="868680"/>
-            <a:ext cx="12070080" cy="1874519"/>
+            <a:off x="3444099" y="3763913"/>
+            <a:ext cx="13438018" cy="2238374"/>
           </a:xfrm>
           <a:prstGeom prst="rect">
             <a:avLst/>
           </a:prstGeom>
         </p:spPr>
         <p:txBody>
-          <a:bodyPr anchor="ctr" rtlCol="false" tIns="0" lIns="0" bIns="0" rIns="0" wrap="square">
+          <a:bodyPr anchor="t" rtlCol="false" tIns="0" lIns="0" bIns="0" rIns="0">
             <a:spAutoFit/>
           </a:bodyPr>
           <a:lstStyle/>
           <a:p>
-            <a:pPr algn="l" marL="0" indent="0" lvl="0">
+            <a:pPr algn="l">
               <a:lnSpc>
-                <a:spcPts val="10481"/>
+                <a:spcPts val="8399"/>
               </a:lnSpc>
-              <a:spcBef>
-                <a:spcPct val="0"/>
-              </a:spcBef>
             </a:pPr>
             <a:r>
-              <a:rPr lang="en-US" b="0" sz="4700">
+              <a:rPr lang="en-US" b="0" sz="8800">
                 <a:solidFill>
                   <a:srgbClr val="FFFFFF"/>
                 </a:solidFill>
@@ -14984,7 +15568,26 @@
                 <a:cs typeface="Arial Black"/>
                 <a:sym typeface="Arial Black"/>
               </a:rPr>
-              <a:t>El mismo dato, de tres formas</a:t>
+              <a:t>DATA</a:t>
+            </a:r>
+          </a:p>
+          <a:p>
+            <a:pPr algn="l" marL="0" indent="0" lvl="0">
+              <a:lnSpc>
+                <a:spcPts val="8399"/>
+              </a:lnSpc>
+            </a:pPr>
+            <a:r>
+              <a:rPr lang="en-US" b="0" sz="8800">
+                <a:solidFill>
+                  <a:srgbClr val="FFFFFF"/>
+                </a:solidFill>
+                <a:latin typeface="Arial Black"/>
+                <a:ea typeface="Arial Black"/>
+                <a:cs typeface="Arial Black"/>
+                <a:sym typeface="Arial Black"/>
+              </a:rPr>
+              <a:t>        LAKE</a:t>
             </a:r>
           </a:p>
         </p:txBody>
@@ -15269,340 +15872,6 @@
           </a:p>
         </p:txBody>
       </p:sp>
-      <p:sp>
-        <p:nvSpPr>
-          <p:cNvPr id="10" name="Rounded Rectangle 9"/>
-          <p:cNvSpPr/>
-          <p:nvPr/>
-        </p:nvSpPr>
-        <p:spPr>
-          <a:xfrm>
-            <a:off x="914400" y="3200400"/>
-            <a:ext cx="4480560" cy="2651760"/>
-          </a:xfrm>
-          <a:prstGeom prst="roundRect">
-            <a:avLst>
-              <a:gd name="adj" fmla="val 8000"/>
-            </a:avLst>
-          </a:prstGeom>
-          <a:solidFill>
-            <a:srgbClr val="2F3D52"/>
-          </a:solidFill>
-          <a:ln>
-            <a:noFill/>
-          </a:ln>
-          <a:effectLst/>
-        </p:spPr>
-        <p:style>
-          <a:lnRef idx="1">
-            <a:schemeClr val="accent1"/>
-          </a:lnRef>
-          <a:fillRef idx="3">
-            <a:schemeClr val="accent1"/>
-          </a:fillRef>
-          <a:effectRef idx="2">
-            <a:schemeClr val="accent1"/>
-          </a:effectRef>
-          <a:fontRef idx="minor">
-            <a:schemeClr val="lt1"/>
-          </a:fontRef>
-        </p:style>
-        <p:txBody>
-          <a:bodyPr rtlCol="0" anchor="t" wrap="square" lIns="274320" rIns="274320" tIns="228600" bIns="228600"/>
-          <a:lstStyle/>
-          <a:p>
-            <a:pPr algn="ctr">
-              <a:spcAft>
-                <a:spcPts val="800"/>
-              </a:spcAft>
-            </a:pPr>
-            <a:r>
-              <a:rPr sz="3600" b="1">
-                <a:solidFill>
-                  <a:srgbClr val="316CE3"/>
-                </a:solidFill>
-                <a:latin typeface="Arial"/>
-              </a:rPr>
-              <a:t>Local</a:t>
-            </a:r>
-          </a:p>
-          <a:p>
-            <a:pPr>
-              <a:spcAft>
-                <a:spcPts val="600"/>
-              </a:spcAft>
-            </a:pPr>
-            <a:r>
-              <a:rPr sz="2200" b="0">
-                <a:solidFill>
-                  <a:srgbClr val="D9E2EC"/>
-                </a:solidFill>
-                <a:latin typeface="Arial"/>
-              </a:rPr>
-              <a:t>Tablas dentro del warehouse</a:t>
-            </a:r>
-          </a:p>
-        </p:txBody>
-      </p:sp>
-      <p:sp>
-        <p:nvSpPr>
-          <p:cNvPr id="11" name="Rounded Rectangle 10"/>
-          <p:cNvSpPr/>
-          <p:nvPr/>
-        </p:nvSpPr>
-        <p:spPr>
-          <a:xfrm>
-            <a:off x="5669280" y="3200400"/>
-            <a:ext cx="4480560" cy="2651760"/>
-          </a:xfrm>
-          <a:prstGeom prst="roundRect">
-            <a:avLst>
-              <a:gd name="adj" fmla="val 8000"/>
-            </a:avLst>
-          </a:prstGeom>
-          <a:solidFill>
-            <a:srgbClr val="2F3D52"/>
-          </a:solidFill>
-          <a:ln>
-            <a:noFill/>
-          </a:ln>
-          <a:effectLst/>
-        </p:spPr>
-        <p:style>
-          <a:lnRef idx="1">
-            <a:schemeClr val="accent1"/>
-          </a:lnRef>
-          <a:fillRef idx="3">
-            <a:schemeClr val="accent1"/>
-          </a:fillRef>
-          <a:effectRef idx="2">
-            <a:schemeClr val="accent1"/>
-          </a:effectRef>
-          <a:fontRef idx="minor">
-            <a:schemeClr val="lt1"/>
-          </a:fontRef>
-        </p:style>
-        <p:txBody>
-          <a:bodyPr rtlCol="0" anchor="t" wrap="square" lIns="274320" rIns="274320" tIns="228600" bIns="228600"/>
-          <a:lstStyle/>
-          <a:p>
-            <a:pPr algn="ctr">
-              <a:spcAft>
-                <a:spcPts val="800"/>
-              </a:spcAft>
-            </a:pPr>
-            <a:r>
-              <a:rPr sz="3600" b="1">
-                <a:solidFill>
-                  <a:srgbClr val="316CE3"/>
-                </a:solidFill>
-                <a:latin typeface="Arial"/>
-              </a:rPr>
-              <a:t>Iceberg</a:t>
-            </a:r>
-          </a:p>
-          <a:p>
-            <a:pPr>
-              <a:spcAft>
-                <a:spcPts val="600"/>
-              </a:spcAft>
-            </a:pPr>
-            <a:r>
-              <a:rPr sz="2200" b="0">
-                <a:solidFill>
-                  <a:srgbClr val="D9E2EC"/>
-                </a:solidFill>
-                <a:latin typeface="Arial"/>
-              </a:rPr>
-              <a:t>Tablas Iceberg en S3, registradas en Glue</a:t>
-            </a:r>
-          </a:p>
-        </p:txBody>
-      </p:sp>
-      <p:sp>
-        <p:nvSpPr>
-          <p:cNvPr id="12" name="Rounded Rectangle 11"/>
-          <p:cNvSpPr/>
-          <p:nvPr/>
-        </p:nvSpPr>
-        <p:spPr>
-          <a:xfrm>
-            <a:off x="10424160" y="3200400"/>
-            <a:ext cx="4480560" cy="2651760"/>
-          </a:xfrm>
-          <a:prstGeom prst="roundRect">
-            <a:avLst>
-              <a:gd name="adj" fmla="val 8000"/>
-            </a:avLst>
-          </a:prstGeom>
-          <a:solidFill>
-            <a:srgbClr val="2F3D52"/>
-          </a:solidFill>
-          <a:ln>
-            <a:noFill/>
-          </a:ln>
-          <a:effectLst/>
-        </p:spPr>
-        <p:style>
-          <a:lnRef idx="1">
-            <a:schemeClr val="accent1"/>
-          </a:lnRef>
-          <a:fillRef idx="3">
-            <a:schemeClr val="accent1"/>
-          </a:fillRef>
-          <a:effectRef idx="2">
-            <a:schemeClr val="accent1"/>
-          </a:effectRef>
-          <a:fontRef idx="minor">
-            <a:schemeClr val="lt1"/>
-          </a:fontRef>
-        </p:style>
-        <p:txBody>
-          <a:bodyPr rtlCol="0" anchor="t" wrap="square" lIns="274320" rIns="274320" tIns="228600" bIns="228600"/>
-          <a:lstStyle/>
-          <a:p>
-            <a:pPr algn="ctr">
-              <a:spcAft>
-                <a:spcPts val="800"/>
-              </a:spcAft>
-            </a:pPr>
-            <a:r>
-              <a:rPr sz="3600" b="1">
-                <a:solidFill>
-                  <a:srgbClr val="316CE3"/>
-                </a:solidFill>
-                <a:latin typeface="Arial"/>
-              </a:rPr>
-              <a:t>Parquet</a:t>
-            </a:r>
-          </a:p>
-          <a:p>
-            <a:pPr>
-              <a:spcAft>
-                <a:spcPts val="600"/>
-              </a:spcAft>
-            </a:pPr>
-            <a:r>
-              <a:rPr sz="2200" b="0">
-                <a:solidFill>
-                  <a:srgbClr val="D9E2EC"/>
-                </a:solidFill>
-                <a:latin typeface="Arial"/>
-              </a:rPr>
-              <a:t>Archivos Parquet en S3, registrados en Glue</a:t>
-            </a:r>
-          </a:p>
-        </p:txBody>
-      </p:sp>
-      <p:sp>
-        <p:nvSpPr>
-          <p:cNvPr id="13" name="TextBox 12"/>
-          <p:cNvSpPr txBox="1"/>
-          <p:nvPr/>
-        </p:nvSpPr>
-        <p:spPr>
-          <a:xfrm>
-            <a:off x="914400" y="6309360"/>
-            <a:ext cx="13898880" cy="2194560"/>
-          </a:xfrm>
-          <a:prstGeom prst="rect">
-            <a:avLst/>
-          </a:prstGeom>
-          <a:noFill/>
-        </p:spPr>
-        <p:txBody>
-          <a:bodyPr wrap="square" anchor="t" lIns="0" rIns="0" tIns="0" bIns="0">
-            <a:spAutoFit/>
-          </a:bodyPr>
-          <a:lstStyle/>
-          <a:p>
-            <a:pPr algn="l">
-              <a:spcAft>
-                <a:spcPts val="1400"/>
-              </a:spcAft>
-            </a:pPr>
-            <a:r>
-              <a:rPr sz="2400" b="0">
-                <a:solidFill>
-                  <a:srgbClr val="D9E2EC"/>
-                </a:solidFill>
-                <a:latin typeface="Arial"/>
-              </a:rPr>
-              <a:t>Las mismas 6 consultas en las tres versiones devuelven </a:t>
-            </a:r>
-            <a:r>
-              <a:rPr sz="2400" b="1">
-                <a:solidFill>
-                  <a:srgbClr val="D9E2EC"/>
-                </a:solidFill>
-                <a:latin typeface="Arial"/>
-              </a:rPr>
-              <a:t>exactamente las mismas 483 filas</a:t>
-            </a:r>
-            <a:r>
-              <a:rPr sz="2400" b="0">
-                <a:solidFill>
-                  <a:srgbClr val="D9E2EC"/>
-                </a:solidFill>
-                <a:latin typeface="Arial"/>
-              </a:rPr>
-              <a:t>.</a:t>
-            </a:r>
-          </a:p>
-          <a:p>
-            <a:pPr algn="l">
-              <a:spcAft>
-                <a:spcPts val="1400"/>
-              </a:spcAft>
-            </a:pPr>
-            <a:r>
-              <a:rPr sz="2400" b="0">
-                <a:solidFill>
-                  <a:srgbClr val="D9E2EC"/>
-                </a:solidFill>
-                <a:latin typeface="Arial"/>
-              </a:rPr>
-              <a:t>RA3 lee S3 a través de </a:t>
-            </a:r>
-            <a:r>
-              <a:rPr sz="2400" b="1">
-                <a:solidFill>
-                  <a:srgbClr val="D9E2EC"/>
-                </a:solidFill>
-                <a:latin typeface="Arial"/>
-              </a:rPr>
-              <a:t>Spectrum</a:t>
-            </a:r>
-            <a:r>
-              <a:rPr sz="2400" b="0">
-                <a:solidFill>
-                  <a:srgbClr val="D9E2EC"/>
-                </a:solidFill>
-                <a:latin typeface="Arial"/>
-              </a:rPr>
-              <a:t>, fuera de tu VPC; RG lo lee </a:t>
-            </a:r>
-            <a:r>
-              <a:rPr sz="2400" b="1">
-                <a:solidFill>
-                  <a:srgbClr val="D9E2EC"/>
-                </a:solidFill>
-                <a:latin typeface="Arial"/>
-              </a:rPr>
-              <a:t>con sus propios nodos</a:t>
-            </a:r>
-            <a:r>
-              <a:rPr sz="2400" b="0">
-                <a:solidFill>
-                  <a:srgbClr val="D9E2EC"/>
-                </a:solidFill>
-                <a:latin typeface="Arial"/>
-              </a:rPr>
-              <a:t>, dentro de tu VPC.</a:t>
-            </a:r>
-          </a:p>
-        </p:txBody>
-      </p:sp>
     </p:spTree>
   </p:cSld>
   <p:clrMapOvr>
@@ -15715,7 +15984,7 @@
               </a:spcBef>
             </a:pPr>
             <a:r>
-              <a:rPr lang="en-US" b="0" sz="4800">
+              <a:rPr lang="en-US" b="0" sz="4700">
                 <a:solidFill>
                   <a:srgbClr val="FFFFFF"/>
                 </a:solidFill>
@@ -15724,7 +15993,7 @@
                 <a:cs typeface="Arial Black"/>
                 <a:sym typeface="Arial Black"/>
               </a:rPr>
-              <a:t>Iceberg: 1,87x, ya con caché</a:t>
+              <a:t>El mismo dato, de tres formas</a:t>
             </a:r>
           </a:p>
         </p:txBody>
@@ -16009,6 +16278,746 @@
           </a:p>
         </p:txBody>
       </p:sp>
+      <p:sp>
+        <p:nvSpPr>
+          <p:cNvPr id="10" name="Rounded Rectangle 9"/>
+          <p:cNvSpPr/>
+          <p:nvPr/>
+        </p:nvSpPr>
+        <p:spPr>
+          <a:xfrm>
+            <a:off x="914400" y="3200400"/>
+            <a:ext cx="4480560" cy="2651760"/>
+          </a:xfrm>
+          <a:prstGeom prst="roundRect">
+            <a:avLst>
+              <a:gd name="adj" fmla="val 8000"/>
+            </a:avLst>
+          </a:prstGeom>
+          <a:solidFill>
+            <a:srgbClr val="2F3D52"/>
+          </a:solidFill>
+          <a:ln>
+            <a:noFill/>
+          </a:ln>
+          <a:effectLst/>
+        </p:spPr>
+        <p:style>
+          <a:lnRef idx="1">
+            <a:schemeClr val="accent1"/>
+          </a:lnRef>
+          <a:fillRef idx="3">
+            <a:schemeClr val="accent1"/>
+          </a:fillRef>
+          <a:effectRef idx="2">
+            <a:schemeClr val="accent1"/>
+          </a:effectRef>
+          <a:fontRef idx="minor">
+            <a:schemeClr val="lt1"/>
+          </a:fontRef>
+        </p:style>
+        <p:txBody>
+          <a:bodyPr rtlCol="0" anchor="t" wrap="square" lIns="274320" rIns="274320" tIns="228600" bIns="228600"/>
+          <a:lstStyle/>
+          <a:p>
+            <a:pPr algn="ctr">
+              <a:spcAft>
+                <a:spcPts val="800"/>
+              </a:spcAft>
+            </a:pPr>
+            <a:r>
+              <a:rPr sz="3600" b="1">
+                <a:solidFill>
+                  <a:srgbClr val="316CE3"/>
+                </a:solidFill>
+                <a:latin typeface="Arial"/>
+              </a:rPr>
+              <a:t>Local</a:t>
+            </a:r>
+          </a:p>
+          <a:p>
+            <a:pPr>
+              <a:spcAft>
+                <a:spcPts val="600"/>
+              </a:spcAft>
+            </a:pPr>
+            <a:r>
+              <a:rPr sz="2200" b="0">
+                <a:solidFill>
+                  <a:srgbClr val="D9E2EC"/>
+                </a:solidFill>
+                <a:latin typeface="Arial"/>
+              </a:rPr>
+              <a:t>Tablas dentro del warehouse</a:t>
+            </a:r>
+          </a:p>
+        </p:txBody>
+      </p:sp>
+      <p:sp>
+        <p:nvSpPr>
+          <p:cNvPr id="11" name="Rounded Rectangle 10"/>
+          <p:cNvSpPr/>
+          <p:nvPr/>
+        </p:nvSpPr>
+        <p:spPr>
+          <a:xfrm>
+            <a:off x="5669280" y="3200400"/>
+            <a:ext cx="4480560" cy="2651760"/>
+          </a:xfrm>
+          <a:prstGeom prst="roundRect">
+            <a:avLst>
+              <a:gd name="adj" fmla="val 8000"/>
+            </a:avLst>
+          </a:prstGeom>
+          <a:solidFill>
+            <a:srgbClr val="2F3D52"/>
+          </a:solidFill>
+          <a:ln>
+            <a:noFill/>
+          </a:ln>
+          <a:effectLst/>
+        </p:spPr>
+        <p:style>
+          <a:lnRef idx="1">
+            <a:schemeClr val="accent1"/>
+          </a:lnRef>
+          <a:fillRef idx="3">
+            <a:schemeClr val="accent1"/>
+          </a:fillRef>
+          <a:effectRef idx="2">
+            <a:schemeClr val="accent1"/>
+          </a:effectRef>
+          <a:fontRef idx="minor">
+            <a:schemeClr val="lt1"/>
+          </a:fontRef>
+        </p:style>
+        <p:txBody>
+          <a:bodyPr rtlCol="0" anchor="t" wrap="square" lIns="274320" rIns="274320" tIns="228600" bIns="228600"/>
+          <a:lstStyle/>
+          <a:p>
+            <a:pPr algn="ctr">
+              <a:spcAft>
+                <a:spcPts val="800"/>
+              </a:spcAft>
+            </a:pPr>
+            <a:r>
+              <a:rPr sz="3600" b="1">
+                <a:solidFill>
+                  <a:srgbClr val="316CE3"/>
+                </a:solidFill>
+                <a:latin typeface="Arial"/>
+              </a:rPr>
+              <a:t>Iceberg</a:t>
+            </a:r>
+          </a:p>
+          <a:p>
+            <a:pPr>
+              <a:spcAft>
+                <a:spcPts val="600"/>
+              </a:spcAft>
+            </a:pPr>
+            <a:r>
+              <a:rPr sz="2200" b="0">
+                <a:solidFill>
+                  <a:srgbClr val="D9E2EC"/>
+                </a:solidFill>
+                <a:latin typeface="Arial"/>
+              </a:rPr>
+              <a:t>Tablas Iceberg en S3, registradas en Glue</a:t>
+            </a:r>
+          </a:p>
+        </p:txBody>
+      </p:sp>
+      <p:sp>
+        <p:nvSpPr>
+          <p:cNvPr id="12" name="Rounded Rectangle 11"/>
+          <p:cNvSpPr/>
+          <p:nvPr/>
+        </p:nvSpPr>
+        <p:spPr>
+          <a:xfrm>
+            <a:off x="10424160" y="3200400"/>
+            <a:ext cx="4480560" cy="2651760"/>
+          </a:xfrm>
+          <a:prstGeom prst="roundRect">
+            <a:avLst>
+              <a:gd name="adj" fmla="val 8000"/>
+            </a:avLst>
+          </a:prstGeom>
+          <a:solidFill>
+            <a:srgbClr val="2F3D52"/>
+          </a:solidFill>
+          <a:ln>
+            <a:noFill/>
+          </a:ln>
+          <a:effectLst/>
+        </p:spPr>
+        <p:style>
+          <a:lnRef idx="1">
+            <a:schemeClr val="accent1"/>
+          </a:lnRef>
+          <a:fillRef idx="3">
+            <a:schemeClr val="accent1"/>
+          </a:fillRef>
+          <a:effectRef idx="2">
+            <a:schemeClr val="accent1"/>
+          </a:effectRef>
+          <a:fontRef idx="minor">
+            <a:schemeClr val="lt1"/>
+          </a:fontRef>
+        </p:style>
+        <p:txBody>
+          <a:bodyPr rtlCol="0" anchor="t" wrap="square" lIns="274320" rIns="274320" tIns="228600" bIns="228600"/>
+          <a:lstStyle/>
+          <a:p>
+            <a:pPr algn="ctr">
+              <a:spcAft>
+                <a:spcPts val="800"/>
+              </a:spcAft>
+            </a:pPr>
+            <a:r>
+              <a:rPr sz="3600" b="1">
+                <a:solidFill>
+                  <a:srgbClr val="316CE3"/>
+                </a:solidFill>
+                <a:latin typeface="Arial"/>
+              </a:rPr>
+              <a:t>Parquet</a:t>
+            </a:r>
+          </a:p>
+          <a:p>
+            <a:pPr>
+              <a:spcAft>
+                <a:spcPts val="600"/>
+              </a:spcAft>
+            </a:pPr>
+            <a:r>
+              <a:rPr sz="2200" b="0">
+                <a:solidFill>
+                  <a:srgbClr val="D9E2EC"/>
+                </a:solidFill>
+                <a:latin typeface="Arial"/>
+              </a:rPr>
+              <a:t>Archivos Parquet en S3, registrados en Glue</a:t>
+            </a:r>
+          </a:p>
+        </p:txBody>
+      </p:sp>
+      <p:sp>
+        <p:nvSpPr>
+          <p:cNvPr id="13" name="TextBox 12"/>
+          <p:cNvSpPr txBox="1"/>
+          <p:nvPr/>
+        </p:nvSpPr>
+        <p:spPr>
+          <a:xfrm>
+            <a:off x="914400" y="6309360"/>
+            <a:ext cx="13898880" cy="2194560"/>
+          </a:xfrm>
+          <a:prstGeom prst="rect">
+            <a:avLst/>
+          </a:prstGeom>
+          <a:noFill/>
+        </p:spPr>
+        <p:txBody>
+          <a:bodyPr wrap="square" anchor="t" lIns="0" rIns="0" tIns="0" bIns="0">
+            <a:spAutoFit/>
+          </a:bodyPr>
+          <a:lstStyle/>
+          <a:p>
+            <a:pPr algn="l">
+              <a:spcAft>
+                <a:spcPts val="1400"/>
+              </a:spcAft>
+            </a:pPr>
+            <a:r>
+              <a:rPr sz="2400" b="0">
+                <a:solidFill>
+                  <a:srgbClr val="D9E2EC"/>
+                </a:solidFill>
+                <a:latin typeface="Arial"/>
+              </a:rPr>
+              <a:t>Las mismas 6 consultas en las tres versiones devuelven </a:t>
+            </a:r>
+            <a:r>
+              <a:rPr sz="2400" b="1">
+                <a:solidFill>
+                  <a:srgbClr val="D9E2EC"/>
+                </a:solidFill>
+                <a:latin typeface="Arial"/>
+              </a:rPr>
+              <a:t>exactamente las mismas 483 filas</a:t>
+            </a:r>
+            <a:r>
+              <a:rPr sz="2400" b="0">
+                <a:solidFill>
+                  <a:srgbClr val="D9E2EC"/>
+                </a:solidFill>
+                <a:latin typeface="Arial"/>
+              </a:rPr>
+              <a:t>.</a:t>
+            </a:r>
+          </a:p>
+          <a:p>
+            <a:pPr algn="l">
+              <a:spcAft>
+                <a:spcPts val="1400"/>
+              </a:spcAft>
+            </a:pPr>
+            <a:r>
+              <a:rPr sz="2400" b="0">
+                <a:solidFill>
+                  <a:srgbClr val="D9E2EC"/>
+                </a:solidFill>
+                <a:latin typeface="Arial"/>
+              </a:rPr>
+              <a:t>RA3 lee S3 a través de </a:t>
+            </a:r>
+            <a:r>
+              <a:rPr sz="2400" b="1">
+                <a:solidFill>
+                  <a:srgbClr val="D9E2EC"/>
+                </a:solidFill>
+                <a:latin typeface="Arial"/>
+              </a:rPr>
+              <a:t>Spectrum</a:t>
+            </a:r>
+            <a:r>
+              <a:rPr sz="2400" b="0">
+                <a:solidFill>
+                  <a:srgbClr val="D9E2EC"/>
+                </a:solidFill>
+                <a:latin typeface="Arial"/>
+              </a:rPr>
+              <a:t>, fuera de tu VPC; RG lo lee </a:t>
+            </a:r>
+            <a:r>
+              <a:rPr sz="2400" b="1">
+                <a:solidFill>
+                  <a:srgbClr val="D9E2EC"/>
+                </a:solidFill>
+                <a:latin typeface="Arial"/>
+              </a:rPr>
+              <a:t>con sus propios nodos</a:t>
+            </a:r>
+            <a:r>
+              <a:rPr sz="2400" b="0">
+                <a:solidFill>
+                  <a:srgbClr val="D9E2EC"/>
+                </a:solidFill>
+                <a:latin typeface="Arial"/>
+              </a:rPr>
+              <a:t>, dentro de tu VPC.</a:t>
+            </a:r>
+          </a:p>
+        </p:txBody>
+      </p:sp>
+    </p:spTree>
+  </p:cSld>
+  <p:clrMapOvr>
+    <a:masterClrMapping/>
+  </p:clrMapOvr>
+</p:sld>
+</file>
+
+<file path=ppt/slides/slide22.xml><?xml version="1.0" encoding="utf-8"?>
+<p:sld xmlns:p="http://schemas.openxmlformats.org/presentationml/2006/main" xmlns:a="http://schemas.openxmlformats.org/drawingml/2006/main" xmlns:r="http://schemas.openxmlformats.org/officeDocument/2006/relationships">
+  <p:cSld>
+    <p:bg>
+      <p:bgPr>
+        <a:solidFill>
+          <a:srgbClr val="232E3E"/>
+        </a:solidFill>
+      </p:bgPr>
+    </p:bg>
+    <p:spTree>
+      <p:nvGrpSpPr>
+        <p:cNvPr id="1" name=""/>
+        <p:cNvGrpSpPr/>
+        <p:nvPr/>
+      </p:nvGrpSpPr>
+      <p:grpSpPr>
+        <a:xfrm>
+          <a:off x="0" y="0"/>
+          <a:ext cx="0" cy="0"/>
+          <a:chOff x="0" y="0"/>
+          <a:chExt cx="0" cy="0"/>
+        </a:xfrm>
+      </p:grpSpPr>
+      <p:sp>
+        <p:nvSpPr>
+          <p:cNvPr name="Freeform 2" id="2"/>
+          <p:cNvSpPr/>
+          <p:nvPr/>
+        </p:nvSpPr>
+        <p:spPr>
+          <a:xfrm flipH="false" flipV="false" rot="0">
+            <a:off x="0" y="0"/>
+            <a:ext cx="18288000" cy="10287000"/>
+          </a:xfrm>
+          <a:custGeom>
+            <a:avLst/>
+            <a:gdLst/>
+            <a:ahLst/>
+            <a:cxnLst/>
+            <a:rect r="r" b="b" t="t" l="l"/>
+            <a:pathLst>
+              <a:path h="10287000" w="18288000">
+                <a:moveTo>
+                  <a:pt x="0" y="0"/>
+                </a:moveTo>
+                <a:lnTo>
+                  <a:pt x="18288000" y="0"/>
+                </a:lnTo>
+                <a:lnTo>
+                  <a:pt x="18288000" y="10287000"/>
+                </a:lnTo>
+                <a:lnTo>
+                  <a:pt x="0" y="10287000"/>
+                </a:lnTo>
+                <a:lnTo>
+                  <a:pt x="0" y="0"/>
+                </a:lnTo>
+                <a:close/>
+              </a:path>
+            </a:pathLst>
+          </a:custGeom>
+          <a:blipFill>
+            <a:blip r:embed="rId2"/>
+            <a:stretch>
+              <a:fillRect l="0" t="0" r="0" b="0"/>
+            </a:stretch>
+          </a:blipFill>
+        </p:spPr>
+        <p:txBody>
+          <a:bodyPr/>
+          <a:p/>
+        </p:txBody>
+      </p:sp>
+      <p:sp>
+        <p:nvSpPr>
+          <p:cNvPr name="TextBox 3" id="3"/>
+          <p:cNvSpPr txBox="true"/>
+          <p:nvPr/>
+        </p:nvSpPr>
+        <p:spPr>
+          <a:xfrm rot="0">
+            <a:off x="3520440" y="868680"/>
+            <a:ext cx="12070080" cy="1874519"/>
+          </a:xfrm>
+          <a:prstGeom prst="rect">
+            <a:avLst/>
+          </a:prstGeom>
+        </p:spPr>
+        <p:txBody>
+          <a:bodyPr anchor="ctr" rtlCol="false" tIns="0" lIns="0" bIns="0" rIns="0" wrap="square">
+            <a:spAutoFit/>
+          </a:bodyPr>
+          <a:lstStyle/>
+          <a:p>
+            <a:pPr algn="l" marL="0" indent="0" lvl="0">
+              <a:lnSpc>
+                <a:spcPts val="10481"/>
+              </a:lnSpc>
+              <a:spcBef>
+                <a:spcPct val="0"/>
+              </a:spcBef>
+            </a:pPr>
+            <a:r>
+              <a:rPr lang="en-US" b="0" sz="4800">
+                <a:solidFill>
+                  <a:srgbClr val="FFFFFF"/>
+                </a:solidFill>
+                <a:latin typeface="Arial Black"/>
+                <a:ea typeface="Arial Black"/>
+                <a:cs typeface="Arial Black"/>
+                <a:sym typeface="Arial Black"/>
+              </a:rPr>
+              <a:t>Iceberg: 1,87x, ya con caché</a:t>
+            </a:r>
+          </a:p>
+        </p:txBody>
+      </p:sp>
+      <p:sp>
+        <p:nvSpPr>
+          <p:cNvPr name="Freeform 4" id="4"/>
+          <p:cNvSpPr/>
+          <p:nvPr/>
+        </p:nvSpPr>
+        <p:spPr>
+          <a:xfrm flipH="false" flipV="false" rot="0">
+            <a:off x="536304" y="308054"/>
+            <a:ext cx="650696" cy="409939"/>
+          </a:xfrm>
+          <a:custGeom>
+            <a:avLst/>
+            <a:gdLst/>
+            <a:ahLst/>
+            <a:cxnLst/>
+            <a:rect r="r" b="b" t="t" l="l"/>
+            <a:pathLst>
+              <a:path h="409939" w="650696">
+                <a:moveTo>
+                  <a:pt x="0" y="0"/>
+                </a:moveTo>
+                <a:lnTo>
+                  <a:pt x="650697" y="0"/>
+                </a:lnTo>
+                <a:lnTo>
+                  <a:pt x="650697" y="409938"/>
+                </a:lnTo>
+                <a:lnTo>
+                  <a:pt x="0" y="409938"/>
+                </a:lnTo>
+                <a:lnTo>
+                  <a:pt x="0" y="0"/>
+                </a:lnTo>
+                <a:close/>
+              </a:path>
+            </a:pathLst>
+          </a:custGeom>
+          <a:blipFill>
+            <a:blip r:embed="rId3">
+              <a:extLst>
+                <a:ext uri="{96DAC541-7B7A-43D3-8B79-37D633B846F1}">
+                  <asvg:svgBlip xmlns:asvg="http://schemas.microsoft.com/office/drawing/2016/SVG/main" r:embed="rId4"/>
+                </a:ext>
+              </a:extLst>
+            </a:blip>
+            <a:stretch>
+              <a:fillRect l="0" t="0" r="0" b="0"/>
+            </a:stretch>
+          </a:blipFill>
+        </p:spPr>
+      </p:sp>
+      <p:grpSp>
+        <p:nvGrpSpPr>
+          <p:cNvPr name="Group 5" id="5"/>
+          <p:cNvGrpSpPr/>
+          <p:nvPr/>
+        </p:nvGrpSpPr>
+        <p:grpSpPr>
+          <a:xfrm rot="0">
+            <a:off x="219785" y="9070932"/>
+            <a:ext cx="4151107" cy="986035"/>
+            <a:chOff x="0" y="0"/>
+            <a:chExt cx="5534810" cy="1314713"/>
+          </a:xfrm>
+        </p:grpSpPr>
+        <p:sp>
+          <p:nvSpPr>
+            <p:cNvPr name="Freeform 6" id="6"/>
+            <p:cNvSpPr/>
+            <p:nvPr/>
+          </p:nvSpPr>
+          <p:spPr>
+            <a:xfrm flipH="false" flipV="false" rot="0">
+              <a:off x="0" y="0"/>
+              <a:ext cx="1314713" cy="1314713"/>
+            </a:xfrm>
+            <a:custGeom>
+              <a:avLst/>
+              <a:gdLst/>
+              <a:ahLst/>
+              <a:cxnLst/>
+              <a:rect r="r" b="b" t="t" l="l"/>
+              <a:pathLst>
+                <a:path h="1314713" w="1314713">
+                  <a:moveTo>
+                    <a:pt x="0" y="0"/>
+                  </a:moveTo>
+                  <a:lnTo>
+                    <a:pt x="1314713" y="0"/>
+                  </a:lnTo>
+                  <a:lnTo>
+                    <a:pt x="1314713" y="1314713"/>
+                  </a:lnTo>
+                  <a:lnTo>
+                    <a:pt x="0" y="1314713"/>
+                  </a:lnTo>
+                  <a:lnTo>
+                    <a:pt x="0" y="0"/>
+                  </a:lnTo>
+                  <a:close/>
+                </a:path>
+              </a:pathLst>
+            </a:custGeom>
+            <a:blipFill>
+              <a:blip r:embed="rId5">
+                <a:extLst>
+                  <a:ext uri="{96DAC541-7B7A-43D3-8B79-37D633B846F1}">
+                    <asvg:svgBlip xmlns:asvg="http://schemas.microsoft.com/office/drawing/2016/SVG/main" r:embed="rId6"/>
+                  </a:ext>
+                </a:extLst>
+              </a:blip>
+              <a:stretch>
+                <a:fillRect l="0" t="0" r="0" b="0"/>
+              </a:stretch>
+            </a:blipFill>
+          </p:spPr>
+        </p:sp>
+        <p:sp>
+          <p:nvSpPr>
+            <p:cNvPr name="TextBox 7" id="7"/>
+            <p:cNvSpPr txBox="true"/>
+            <p:nvPr/>
+          </p:nvSpPr>
+          <p:spPr>
+            <a:xfrm rot="0">
+              <a:off x="1455753" y="151974"/>
+              <a:ext cx="3148240" cy="462308"/>
+            </a:xfrm>
+            <a:prstGeom prst="rect">
+              <a:avLst/>
+            </a:prstGeom>
+          </p:spPr>
+          <p:txBody>
+            <a:bodyPr anchor="t" rtlCol="false" tIns="0" lIns="0" bIns="0" rIns="0">
+              <a:spAutoFit/>
+            </a:bodyPr>
+            <a:lstStyle/>
+            <a:p>
+              <a:pPr algn="l">
+                <a:lnSpc>
+                  <a:spcPts val="2702"/>
+                </a:lnSpc>
+              </a:pPr>
+              <a:r>
+                <a:rPr lang="en-US" b="true" sz="2252">
+                  <a:solidFill>
+                    <a:srgbClr val="FFFFFF"/>
+                  </a:solidFill>
+                  <a:latin typeface="Raleway 1 Bold"/>
+                  <a:ea typeface="Raleway 1 Bold"/>
+                  <a:cs typeface="Raleway 1 Bold"/>
+                  <a:sym typeface="Raleway 1 Bold"/>
+                </a:rPr>
+                <a:t>OCTUBRE</a:t>
+              </a:r>
+            </a:p>
+          </p:txBody>
+        </p:sp>
+        <p:sp>
+          <p:nvSpPr>
+            <p:cNvPr name="TextBox 8" id="8"/>
+            <p:cNvSpPr txBox="true"/>
+            <p:nvPr/>
+          </p:nvSpPr>
+          <p:spPr>
+            <a:xfrm rot="0">
+              <a:off x="1468453" y="585710"/>
+              <a:ext cx="4066356" cy="565140"/>
+            </a:xfrm>
+            <a:prstGeom prst="rect">
+              <a:avLst/>
+            </a:prstGeom>
+          </p:spPr>
+          <p:txBody>
+            <a:bodyPr anchor="t" rtlCol="false" tIns="0" lIns="0" bIns="0" rIns="0">
+              <a:spAutoFit/>
+            </a:bodyPr>
+            <a:lstStyle/>
+            <a:p>
+              <a:pPr algn="l">
+                <a:lnSpc>
+                  <a:spcPts val="1130"/>
+                </a:lnSpc>
+              </a:pPr>
+              <a:r>
+                <a:rPr lang="en-US" sz="1097" b="true">
+                  <a:solidFill>
+                    <a:srgbClr val="FFFFFF"/>
+                  </a:solidFill>
+                  <a:latin typeface="Raleway 1 Bold"/>
+                  <a:ea typeface="Raleway 1 Bold"/>
+                  <a:cs typeface="Raleway 1 Bold"/>
+                  <a:sym typeface="Raleway 1 Bold"/>
+                </a:rPr>
+                <a:t>Mes de </a:t>
+              </a:r>
+            </a:p>
+            <a:p>
+              <a:pPr algn="l">
+                <a:lnSpc>
+                  <a:spcPts val="2059"/>
+                </a:lnSpc>
+              </a:pPr>
+              <a:r>
+                <a:rPr lang="en-US" b="true" sz="1999">
+                  <a:solidFill>
+                    <a:srgbClr val="FFFFFF"/>
+                  </a:solidFill>
+                  <a:latin typeface="Raleway 1 Bold"/>
+                  <a:ea typeface="Raleway 1 Bold"/>
+                  <a:cs typeface="Raleway 1 Bold"/>
+                  <a:sym typeface="Raleway 1 Bold"/>
+                </a:rPr>
+                <a:t>HAN SOLO</a:t>
+              </a:r>
+            </a:p>
+          </p:txBody>
+        </p:sp>
+      </p:grpSp>
+      <p:sp>
+        <p:nvSpPr>
+          <p:cNvPr name="TextBox 9" id="9"/>
+          <p:cNvSpPr txBox="true"/>
+          <p:nvPr/>
+        </p:nvSpPr>
+        <p:spPr>
+          <a:xfrm rot="0">
+            <a:off x="1258571" y="221658"/>
+            <a:ext cx="15091730" cy="563680"/>
+          </a:xfrm>
+          <a:prstGeom prst="rect">
+            <a:avLst/>
+          </a:prstGeom>
+        </p:spPr>
+        <p:txBody>
+          <a:bodyPr anchor="t" rtlCol="false" tIns="0" lIns="0" bIns="0" rIns="0">
+            <a:spAutoFit/>
+          </a:bodyPr>
+          <a:lstStyle/>
+          <a:p>
+            <a:pPr algn="l">
+              <a:lnSpc>
+                <a:spcPts val="1760"/>
+              </a:lnSpc>
+            </a:pPr>
+            <a:r>
+              <a:rPr lang="en-US" sz="2000">
+                <a:solidFill>
+                  <a:srgbClr val="316CE3"/>
+                </a:solidFill>
+                <a:latin typeface="Gotham"/>
+                <a:ea typeface="Gotham"/>
+                <a:cs typeface="Gotham"/>
+                <a:sym typeface="Gotham"/>
+              </a:rPr>
+              <a:t>HOY:</a:t>
+            </a:r>
+          </a:p>
+          <a:p>
+            <a:pPr algn="l">
+              <a:lnSpc>
+                <a:spcPts val="2528"/>
+              </a:lnSpc>
+            </a:pPr>
+            <a:r>
+              <a:rPr lang="en-US" sz="2873" b="true">
+                <a:solidFill>
+                  <a:srgbClr val="316CE3"/>
+                </a:solidFill>
+                <a:latin typeface="Gotham Bold"/>
+                <a:ea typeface="Gotham Bold"/>
+                <a:cs typeface="Gotham Bold"/>
+                <a:sym typeface="Gotham Bold"/>
+              </a:rPr>
+              <a:t>Episodio II — El Ataque de los Graviton: Infraestructura y rendimiento</a:t>
+            </a:r>
+          </a:p>
+        </p:txBody>
+      </p:sp>
       <p:graphicFrame>
         <p:nvGraphicFramePr>
           <p:cNvPr id="10" name="Chart 9"/>
@@ -16317,7 +17326,7 @@
 </p:sld>
 </file>
 
-<file path=ppt/slides/slide22.xml><?xml version="1.0" encoding="utf-8"?>
+<file path=ppt/slides/slide23.xml><?xml version="1.0" encoding="utf-8"?>
 <p:sld xmlns:p="http://schemas.openxmlformats.org/presentationml/2006/main" xmlns:a="http://schemas.openxmlformats.org/drawingml/2006/main" xmlns:r="http://schemas.openxmlformats.org/officeDocument/2006/relationships">
   <p:cSld>
     <p:bg>
@@ -17128,7 +18137,7 @@
 </p:sld>
 </file>
 
-<file path=ppt/slides/slide23.xml><?xml version="1.0" encoding="utf-8"?>
+<file path=ppt/slides/slide24.xml><?xml version="1.0" encoding="utf-8"?>
 <p:sld xmlns:p="http://schemas.openxmlformats.org/presentationml/2006/main" xmlns:a="http://schemas.openxmlformats.org/drawingml/2006/main" xmlns:r="http://schemas.openxmlformats.org/officeDocument/2006/relationships">
   <p:cSld>
     <p:bg>
@@ -17816,7 +18825,7 @@
 </p:sld>
 </file>
 
-<file path=ppt/slides/slide24.xml><?xml version="1.0" encoding="utf-8"?>
+<file path=ppt/slides/slide25.xml><?xml version="1.0" encoding="utf-8"?>
 <p:sld xmlns:p="http://schemas.openxmlformats.org/presentationml/2006/main" xmlns:a="http://schemas.openxmlformats.org/drawingml/2006/main" xmlns:r="http://schemas.openxmlformats.org/officeDocument/2006/relationships">
   <p:cSld>
     <p:bg>
@@ -18480,7 +19489,7 @@
 </p:sld>
 </file>
 
-<file path=ppt/slides/slide25.xml><?xml version="1.0" encoding="utf-8"?>
+<file path=ppt/slides/slide26.xml><?xml version="1.0" encoding="utf-8"?>
 <p:sld xmlns:p="http://schemas.openxmlformats.org/presentationml/2006/main" xmlns:a="http://schemas.openxmlformats.org/drawingml/2006/main" xmlns:r="http://schemas.openxmlformats.org/officeDocument/2006/relationships">
   <p:cSld>
     <p:bg>
@@ -18902,7 +19911,7 @@
 </p:sld>
 </file>
 
-<file path=ppt/slides/slide26.xml><?xml version="1.0" encoding="utf-8"?>
+<file path=ppt/slides/slide27.xml><?xml version="1.0" encoding="utf-8"?>
 <p:sld xmlns:p="http://schemas.openxmlformats.org/presentationml/2006/main" xmlns:a="http://schemas.openxmlformats.org/drawingml/2006/main" xmlns:r="http://schemas.openxmlformats.org/officeDocument/2006/relationships">
   <p:cSld>
     <p:bg>
@@ -20346,7 +21355,7 @@
 </p:sld>
 </file>
 
-<file path=ppt/slides/slide27.xml><?xml version="1.0" encoding="utf-8"?>
+<file path=ppt/slides/slide28.xml><?xml version="1.0" encoding="utf-8"?>
 <p:sld xmlns:p="http://schemas.openxmlformats.org/presentationml/2006/main" xmlns:a="http://schemas.openxmlformats.org/drawingml/2006/main" xmlns:r="http://schemas.openxmlformats.org/officeDocument/2006/relationships">
   <p:cSld>
     <p:bg>
@@ -20905,7 +21914,7 @@
 </p:sld>
 </file>
 
-<file path=ppt/slides/slide28.xml><?xml version="1.0" encoding="utf-8"?>
+<file path=ppt/slides/slide29.xml><?xml version="1.0" encoding="utf-8"?>
 <p:sld xmlns:p="http://schemas.openxmlformats.org/presentationml/2006/main" xmlns:a="http://schemas.openxmlformats.org/drawingml/2006/main" xmlns:r="http://schemas.openxmlformats.org/officeDocument/2006/relationships">
   <p:cSld>
     <p:bg>
@@ -21327,7 +22336,7 @@
 </p:sld>
 </file>
 
-<file path=ppt/slides/slide29.xml><?xml version="1.0" encoding="utf-8"?>
+<file path=ppt/slides/slide3.xml><?xml version="1.0" encoding="utf-8"?>
 <p:sld xmlns:p="http://schemas.openxmlformats.org/presentationml/2006/main" xmlns:a="http://schemas.openxmlformats.org/drawingml/2006/main" xmlns:r="http://schemas.openxmlformats.org/officeDocument/2006/relationships">
   <p:cSld>
     <p:bg>
@@ -21403,51 +22412,7 @@
       </p:sp>
       <p:sp>
         <p:nvSpPr>
-          <p:cNvPr name="TextBox 3" id="3"/>
-          <p:cNvSpPr txBox="true"/>
-          <p:nvPr/>
-        </p:nvSpPr>
-        <p:spPr>
-          <a:xfrm rot="0">
-            <a:off x="3520440" y="868680"/>
-            <a:ext cx="12070080" cy="1874519"/>
-          </a:xfrm>
-          <a:prstGeom prst="rect">
-            <a:avLst/>
-          </a:prstGeom>
-        </p:spPr>
-        <p:txBody>
-          <a:bodyPr anchor="ctr" rtlCol="false" tIns="0" lIns="0" bIns="0" rIns="0" wrap="square">
-            <a:spAutoFit/>
-          </a:bodyPr>
-          <a:lstStyle/>
-          <a:p>
-            <a:pPr algn="l" marL="0" indent="0" lvl="0">
-              <a:lnSpc>
-                <a:spcPts val="10481"/>
-              </a:lnSpc>
-              <a:spcBef>
-                <a:spcPct val="0"/>
-              </a:spcBef>
-            </a:pPr>
-            <a:r>
-              <a:rPr lang="en-US" b="0" sz="4100">
-                <a:solidFill>
-                  <a:srgbClr val="FFFFFF"/>
-                </a:solidFill>
-                <a:latin typeface="Arial Black"/>
-                <a:ea typeface="Arial Black"/>
-                <a:cs typeface="Arial Black"/>
-                <a:sym typeface="Arial Black"/>
-              </a:rPr>
-              <a:t>Demo: una consulta, dos clústeres</a:t>
-            </a:r>
-          </a:p>
-        </p:txBody>
-      </p:sp>
-      <p:sp>
-        <p:nvSpPr>
-          <p:cNvPr name="Freeform 4" id="4"/>
+          <p:cNvPr name="Freeform 3" id="3"/>
           <p:cNvSpPr/>
           <p:nvPr/>
         </p:nvSpPr>
@@ -21496,6 +22461,158 @@
             </a:stretch>
           </a:blipFill>
         </p:spPr>
+        <p:txBody>
+          <a:bodyPr/>
+          <a:p/>
+        </p:txBody>
+      </p:sp>
+      <p:sp>
+        <p:nvSpPr>
+          <p:cNvPr name="TextBox 4" id="4"/>
+          <p:cNvSpPr txBox="true"/>
+          <p:nvPr/>
+        </p:nvSpPr>
+        <p:spPr>
+          <a:xfrm rot="0">
+            <a:off x="7191614" y="3137838"/>
+            <a:ext cx="9158687" cy="4650270"/>
+          </a:xfrm>
+          <a:prstGeom prst="rect">
+            <a:avLst/>
+          </a:prstGeom>
+        </p:spPr>
+        <p:txBody>
+          <a:bodyPr anchor="t" rtlCol="false" tIns="0" lIns="0" bIns="0" rIns="0">
+            <a:spAutoFit/>
+          </a:bodyPr>
+          <a:lstStyle/>
+          <a:p>
+            <a:pPr algn="l" marL="691055" indent="-345528" lvl="1">
+              <a:lnSpc>
+                <a:spcPts val="6273"/>
+              </a:lnSpc>
+              <a:buFont typeface="Arial"/>
+              <a:buChar char="•"/>
+            </a:pPr>
+            <a:r>
+              <a:rPr lang="en-US" sz="3200">
+                <a:solidFill>
+                  <a:srgbClr val="FFFFFF"/>
+                </a:solidFill>
+                <a:latin typeface="Raleway 2"/>
+                <a:ea typeface="Raleway 2"/>
+                <a:cs typeface="Raleway 2"/>
+                <a:sym typeface="Raleway 2"/>
+              </a:rPr>
+              <a:t>Qué cambia con RG</a:t>
+            </a:r>
+          </a:p>
+          <a:p>
+            <a:pPr algn="l" marL="691055" indent="-345528" lvl="1">
+              <a:lnSpc>
+                <a:spcPts val="6273"/>
+              </a:lnSpc>
+              <a:buFont typeface="Arial"/>
+              <a:buChar char="•"/>
+            </a:pPr>
+            <a:r>
+              <a:rPr lang="en-US" sz="3200">
+                <a:solidFill>
+                  <a:srgbClr val="FFFFFF"/>
+                </a:solidFill>
+                <a:latin typeface="Raleway 2"/>
+                <a:ea typeface="Raleway 2"/>
+                <a:cs typeface="Raleway 2"/>
+                <a:sym typeface="Raleway 2"/>
+              </a:rPr>
+              <a:t>Cómo lo medimos</a:t>
+            </a:r>
+          </a:p>
+          <a:p>
+            <a:pPr algn="l" marL="691055" indent="-345528" lvl="1">
+              <a:lnSpc>
+                <a:spcPts val="6273"/>
+              </a:lnSpc>
+              <a:buFont typeface="Arial"/>
+              <a:buChar char="•"/>
+            </a:pPr>
+            <a:r>
+              <a:rPr lang="en-US" sz="3200">
+                <a:solidFill>
+                  <a:srgbClr val="FFFFFF"/>
+                </a:solidFill>
+                <a:latin typeface="Raleway 2"/>
+                <a:ea typeface="Raleway 2"/>
+                <a:cs typeface="Raleway 2"/>
+                <a:sym typeface="Raleway 2"/>
+              </a:rPr>
+              <a:t>Warehouse: velocidad, concurrencia y costo</a:t>
+            </a:r>
+          </a:p>
+          <a:p>
+            <a:pPr algn="l" marL="691055" indent="-345528" lvl="1">
+              <a:lnSpc>
+                <a:spcPts val="6273"/>
+              </a:lnSpc>
+              <a:buFont typeface="Arial"/>
+              <a:buChar char="•"/>
+            </a:pPr>
+            <a:r>
+              <a:rPr lang="en-US" sz="3200">
+                <a:solidFill>
+                  <a:srgbClr val="FFFFFF"/>
+                </a:solidFill>
+                <a:latin typeface="Raleway 2"/>
+                <a:ea typeface="Raleway 2"/>
+                <a:cs typeface="Raleway 2"/>
+                <a:sym typeface="Raleway 2"/>
+              </a:rPr>
+              <a:t>Data lake: Iceberg, Parquet y Spectrum</a:t>
+            </a:r>
+          </a:p>
+          <a:p>
+            <a:pPr algn="l" marL="691055" indent="-345528" lvl="1">
+              <a:lnSpc>
+                <a:spcPts val="6273"/>
+              </a:lnSpc>
+              <a:buFont typeface="Arial"/>
+              <a:buChar char="•"/>
+            </a:pPr>
+            <a:r>
+              <a:rPr lang="en-US" sz="3200">
+                <a:solidFill>
+                  <a:srgbClr val="FFFFFF"/>
+                </a:solidFill>
+                <a:latin typeface="Raleway 2"/>
+                <a:ea typeface="Raleway 2"/>
+                <a:cs typeface="Raleway 2"/>
+                <a:sym typeface="Raleway 2"/>
+              </a:rPr>
+              <a:t>La migración y lo que nadie te cuenta</a:t>
+            </a:r>
+          </a:p>
+          <a:p>
+            <a:pPr algn="l" marL="691055" indent="-345528" lvl="1">
+              <a:lnSpc>
+                <a:spcPts val="6273"/>
+              </a:lnSpc>
+              <a:buFont typeface="Arial"/>
+              <a:buChar char="•"/>
+            </a:pPr>
+            <a:r>
+              <a:rPr lang="en-US" sz="3200">
+                <a:solidFill>
+                  <a:srgbClr val="FFFFFF"/>
+                </a:solidFill>
+                <a:latin typeface="Raleway 2"/>
+                <a:ea typeface="Raleway 2"/>
+                <a:cs typeface="Raleway 2"/>
+                <a:sym typeface="Raleway 2"/>
+              </a:rPr>
+              <a:t>Demo</a:t>
+            </a:r>
+          </a:p>
+        </p:txBody>
       </p:sp>
       <p:grpSp>
         <p:nvGrpSpPr>
@@ -21725,519 +22842,6 @@
           </a:p>
         </p:txBody>
       </p:sp>
-      <p:sp>
-        <p:nvSpPr>
-          <p:cNvPr id="10" name="Rounded Rectangle 9"/>
-          <p:cNvSpPr/>
-          <p:nvPr/>
-        </p:nvSpPr>
-        <p:spPr>
-          <a:xfrm>
-            <a:off x="914400" y="3200400"/>
-            <a:ext cx="9326880" cy="3931920"/>
-          </a:xfrm>
-          <a:prstGeom prst="roundRect">
-            <a:avLst>
-              <a:gd name="adj" fmla="val 4000"/>
-            </a:avLst>
-          </a:prstGeom>
-          <a:solidFill>
-            <a:srgbClr val="1A2230"/>
-          </a:solidFill>
-          <a:ln>
-            <a:noFill/>
-          </a:ln>
-        </p:spPr>
-        <p:style>
-          <a:lnRef idx="1">
-            <a:schemeClr val="accent1"/>
-          </a:lnRef>
-          <a:fillRef idx="3">
-            <a:schemeClr val="accent1"/>
-          </a:fillRef>
-          <a:effectRef idx="2">
-            <a:schemeClr val="accent1"/>
-          </a:effectRef>
-          <a:fontRef idx="minor">
-            <a:schemeClr val="lt1"/>
-          </a:fontRef>
-        </p:style>
-        <p:txBody>
-          <a:bodyPr rtlCol="0" anchor="t" wrap="square" lIns="274320" rIns="274320" tIns="274320"/>
-          <a:lstStyle/>
-          <a:p>
-            <a:pPr algn="l"/>
-            <a:r>
-              <a:rPr sz="1700">
-                <a:solidFill>
-                  <a:srgbClr val="D9E2EC"/>
-                </a:solidFill>
-                <a:latin typeface="Courier New"/>
-              </a:rPr>
-              <a:t>SELECT count(*)</a:t>
-            </a:r>
-          </a:p>
-          <a:p>
-            <a:pPr algn="l"/>
-            <a:r>
-              <a:rPr sz="1700">
-                <a:solidFill>
-                  <a:srgbClr val="D9E2EC"/>
-                </a:solidFill>
-                <a:latin typeface="Courier New"/>
-              </a:rPr>
-              <a:t>FROM store_sales, household_demographics,</a:t>
-            </a:r>
-          </a:p>
-          <a:p>
-            <a:pPr algn="l"/>
-            <a:r>
-              <a:rPr sz="1700">
-                <a:solidFill>
-                  <a:srgbClr val="D9E2EC"/>
-                </a:solidFill>
-                <a:latin typeface="Courier New"/>
-              </a:rPr>
-              <a:t>     time_dim, store</a:t>
-            </a:r>
-          </a:p>
-          <a:p>
-            <a:pPr algn="l"/>
-            <a:r>
-              <a:rPr sz="1700">
-                <a:solidFill>
-                  <a:srgbClr val="D9E2EC"/>
-                </a:solidFill>
-                <a:latin typeface="Courier New"/>
-              </a:rPr>
-              <a:t>WHERE ss_sold_time_sk = time_dim.t_time_sk</a:t>
-            </a:r>
-          </a:p>
-          <a:p>
-            <a:pPr algn="l"/>
-            <a:r>
-              <a:rPr sz="1700">
-                <a:solidFill>
-                  <a:srgbClr val="D9E2EC"/>
-                </a:solidFill>
-                <a:latin typeface="Courier New"/>
-              </a:rPr>
-              <a:t>  AND ss_hdemo_sk = household_demographics.hd_demo_sk</a:t>
-            </a:r>
-          </a:p>
-          <a:p>
-            <a:pPr algn="l"/>
-            <a:r>
-              <a:rPr sz="1700">
-                <a:solidFill>
-                  <a:srgbClr val="D9E2EC"/>
-                </a:solidFill>
-                <a:latin typeface="Courier New"/>
-              </a:rPr>
-              <a:t>  AND ss_store_sk = s_store_sk</a:t>
-            </a:r>
-          </a:p>
-          <a:p>
-            <a:pPr algn="l"/>
-            <a:r>
-              <a:rPr sz="1700">
-                <a:solidFill>
-                  <a:srgbClr val="D9E2EC"/>
-                </a:solidFill>
-                <a:latin typeface="Courier New"/>
-              </a:rPr>
-              <a:t>  AND time_dim.t_hour = 15</a:t>
-            </a:r>
-          </a:p>
-          <a:p>
-            <a:pPr algn="l"/>
-            <a:r>
-              <a:rPr sz="1700">
-                <a:solidFill>
-                  <a:srgbClr val="D9E2EC"/>
-                </a:solidFill>
-                <a:latin typeface="Courier New"/>
-              </a:rPr>
-              <a:t>  AND time_dim.t_minute &gt;= 30</a:t>
-            </a:r>
-          </a:p>
-          <a:p>
-            <a:pPr algn="l"/>
-            <a:r>
-              <a:rPr sz="1700">
-                <a:solidFill>
-                  <a:srgbClr val="D9E2EC"/>
-                </a:solidFill>
-                <a:latin typeface="Courier New"/>
-              </a:rPr>
-              <a:t>  AND household_demographics.hd_dep_count = 7</a:t>
-            </a:r>
-          </a:p>
-          <a:p>
-            <a:pPr algn="l"/>
-            <a:r>
-              <a:rPr sz="1700">
-                <a:solidFill>
-                  <a:srgbClr val="D9E2EC"/>
-                </a:solidFill>
-                <a:latin typeface="Courier New"/>
-              </a:rPr>
-              <a:t>  AND store.s_store_name = 'ese'</a:t>
-            </a:r>
-          </a:p>
-          <a:p>
-            <a:pPr algn="l"/>
-            <a:r>
-              <a:rPr sz="1700">
-                <a:solidFill>
-                  <a:srgbClr val="D9E2EC"/>
-                </a:solidFill>
-                <a:latin typeface="Courier New"/>
-              </a:rPr>
-              <a:t>LIMIT 100;</a:t>
-            </a:r>
-          </a:p>
-        </p:txBody>
-      </p:sp>
-      <p:sp>
-        <p:nvSpPr>
-          <p:cNvPr id="11" name="TextBox 10"/>
-          <p:cNvSpPr txBox="1"/>
-          <p:nvPr/>
-        </p:nvSpPr>
-        <p:spPr>
-          <a:xfrm>
-            <a:off x="914400" y="7315200"/>
-            <a:ext cx="9326880" cy="1280160"/>
-          </a:xfrm>
-          <a:prstGeom prst="rect">
-            <a:avLst/>
-          </a:prstGeom>
-          <a:noFill/>
-        </p:spPr>
-        <p:txBody>
-          <a:bodyPr wrap="square" anchor="t" lIns="0" rIns="0" tIns="0" bIns="0">
-            <a:spAutoFit/>
-          </a:bodyPr>
-          <a:lstStyle/>
-          <a:p>
-            <a:pPr algn="l">
-              <a:spcAft>
-                <a:spcPts val="1000"/>
-              </a:spcAft>
-            </a:pPr>
-            <a:r>
-              <a:rPr sz="2000" b="1">
-                <a:solidFill>
-                  <a:srgbClr val="D9E2EC"/>
-                </a:solidFill>
-                <a:latin typeface="Arial"/>
-              </a:rPr>
-              <a:t>Por qué pesa:</a:t>
-            </a:r>
-            <a:r>
-              <a:rPr sz="2000" b="0">
-                <a:solidFill>
-                  <a:srgbClr val="D9E2EC"/>
-                </a:solidFill>
-                <a:latin typeface="Arial"/>
-              </a:rPr>
-              <a:t> recorre las 288 millones de ventas de store_sales y las cruza con tres tablas para quedarse con una franja horaria y un tipo de hogar.</a:t>
-            </a:r>
-          </a:p>
-        </p:txBody>
-      </p:sp>
-      <p:sp>
-        <p:nvSpPr>
-          <p:cNvPr id="12" name="TextBox 11"/>
-          <p:cNvSpPr txBox="1"/>
-          <p:nvPr/>
-        </p:nvSpPr>
-        <p:spPr>
-          <a:xfrm>
-            <a:off x="10607040" y="3474720"/>
-            <a:ext cx="4572000" cy="457200"/>
-          </a:xfrm>
-          <a:prstGeom prst="rect">
-            <a:avLst/>
-          </a:prstGeom>
-          <a:noFill/>
-        </p:spPr>
-        <p:txBody>
-          <a:bodyPr wrap="square" anchor="t" lIns="0" rIns="0" tIns="0" bIns="0">
-            <a:spAutoFit/>
-          </a:bodyPr>
-          <a:lstStyle/>
-          <a:p>
-            <a:pPr algn="l">
-              <a:spcAft>
-                <a:spcPts val="1000"/>
-              </a:spcAft>
-            </a:pPr>
-            <a:r>
-              <a:rPr sz="2000" b="0">
-                <a:solidFill>
-                  <a:srgbClr val="D9E2EC"/>
-                </a:solidFill>
-                <a:latin typeface="Arial"/>
-              </a:rPr>
-              <a:t>query96</a:t>
-            </a:r>
-          </a:p>
-        </p:txBody>
-      </p:sp>
-      <p:sp>
-        <p:nvSpPr>
-          <p:cNvPr id="13" name="TextBox 12"/>
-          <p:cNvSpPr txBox="1"/>
-          <p:nvPr/>
-        </p:nvSpPr>
-        <p:spPr>
-          <a:xfrm>
-            <a:off x="10607040" y="3977639"/>
-            <a:ext cx="2286000" cy="914400"/>
-          </a:xfrm>
-          <a:prstGeom prst="rect">
-            <a:avLst/>
-          </a:prstGeom>
-          <a:noFill/>
-        </p:spPr>
-        <p:txBody>
-          <a:bodyPr wrap="square" anchor="t" lIns="0" rIns="0" tIns="0" bIns="0">
-            <a:spAutoFit/>
-          </a:bodyPr>
-          <a:lstStyle/>
-          <a:p>
-            <a:pPr algn="l">
-              <a:spcAft>
-                <a:spcPts val="1000"/>
-              </a:spcAft>
-            </a:pPr>
-            <a:r>
-              <a:rPr sz="4000" b="1">
-                <a:solidFill>
-                  <a:srgbClr val="8FA3B8"/>
-                </a:solidFill>
-                <a:latin typeface="Arial"/>
-              </a:rPr>
-              <a:t>1,77 s</a:t>
-            </a:r>
-          </a:p>
-        </p:txBody>
-      </p:sp>
-      <p:sp>
-        <p:nvSpPr>
-          <p:cNvPr id="14" name="TextBox 13"/>
-          <p:cNvSpPr txBox="1"/>
-          <p:nvPr/>
-        </p:nvSpPr>
-        <p:spPr>
-          <a:xfrm>
-            <a:off x="12893040" y="3977639"/>
-            <a:ext cx="2286000" cy="914400"/>
-          </a:xfrm>
-          <a:prstGeom prst="rect">
-            <a:avLst/>
-          </a:prstGeom>
-          <a:noFill/>
-        </p:spPr>
-        <p:txBody>
-          <a:bodyPr wrap="square" anchor="t" lIns="0" rIns="0" tIns="0" bIns="0">
-            <a:spAutoFit/>
-          </a:bodyPr>
-          <a:lstStyle/>
-          <a:p>
-            <a:pPr algn="l">
-              <a:spcAft>
-                <a:spcPts val="1000"/>
-              </a:spcAft>
-            </a:pPr>
-            <a:r>
-              <a:rPr sz="4000" b="1">
-                <a:solidFill>
-                  <a:srgbClr val="316CE3"/>
-                </a:solidFill>
-                <a:latin typeface="Arial"/>
-              </a:rPr>
-              <a:t>0,67 s</a:t>
-            </a:r>
-          </a:p>
-        </p:txBody>
-      </p:sp>
-      <p:sp>
-        <p:nvSpPr>
-          <p:cNvPr id="15" name="TextBox 14"/>
-          <p:cNvSpPr txBox="1"/>
-          <p:nvPr/>
-        </p:nvSpPr>
-        <p:spPr>
-          <a:xfrm>
-            <a:off x="10607040" y="4754879"/>
-            <a:ext cx="2286000" cy="457200"/>
-          </a:xfrm>
-          <a:prstGeom prst="rect">
-            <a:avLst/>
-          </a:prstGeom>
-          <a:noFill/>
-        </p:spPr>
-        <p:txBody>
-          <a:bodyPr wrap="square" anchor="t" lIns="0" rIns="0" tIns="0" bIns="0">
-            <a:spAutoFit/>
-          </a:bodyPr>
-          <a:lstStyle/>
-          <a:p>
-            <a:pPr algn="l">
-              <a:spcAft>
-                <a:spcPts val="1000"/>
-              </a:spcAft>
-            </a:pPr>
-            <a:r>
-              <a:rPr sz="1800" b="0">
-                <a:solidFill>
-                  <a:srgbClr val="8FA3B8"/>
-                </a:solidFill>
-                <a:latin typeface="Arial"/>
-              </a:rPr>
-              <a:t>RA3</a:t>
-            </a:r>
-          </a:p>
-        </p:txBody>
-      </p:sp>
-      <p:sp>
-        <p:nvSpPr>
-          <p:cNvPr id="16" name="TextBox 15"/>
-          <p:cNvSpPr txBox="1"/>
-          <p:nvPr/>
-        </p:nvSpPr>
-        <p:spPr>
-          <a:xfrm>
-            <a:off x="12893040" y="4754879"/>
-            <a:ext cx="2286000" cy="457200"/>
-          </a:xfrm>
-          <a:prstGeom prst="rect">
-            <a:avLst/>
-          </a:prstGeom>
-          <a:noFill/>
-        </p:spPr>
-        <p:txBody>
-          <a:bodyPr wrap="square" anchor="t" lIns="0" rIns="0" tIns="0" bIns="0">
-            <a:spAutoFit/>
-          </a:bodyPr>
-          <a:lstStyle/>
-          <a:p>
-            <a:pPr algn="l">
-              <a:spcAft>
-                <a:spcPts val="1000"/>
-              </a:spcAft>
-            </a:pPr>
-            <a:r>
-              <a:rPr sz="1800" b="0">
-                <a:solidFill>
-                  <a:srgbClr val="316CE3"/>
-                </a:solidFill>
-                <a:latin typeface="Arial"/>
-              </a:rPr>
-              <a:t>RG</a:t>
-            </a:r>
-          </a:p>
-        </p:txBody>
-      </p:sp>
-      <p:sp>
-        <p:nvSpPr>
-          <p:cNvPr id="17" name="TextBox 16"/>
-          <p:cNvSpPr txBox="1"/>
-          <p:nvPr/>
-        </p:nvSpPr>
-        <p:spPr>
-          <a:xfrm>
-            <a:off x="10607040" y="5166360"/>
-            <a:ext cx="4572000" cy="457200"/>
-          </a:xfrm>
-          <a:prstGeom prst="rect">
-            <a:avLst/>
-          </a:prstGeom>
-          <a:noFill/>
-        </p:spPr>
-        <p:txBody>
-          <a:bodyPr wrap="square" anchor="t" lIns="0" rIns="0" tIns="0" bIns="0">
-            <a:spAutoFit/>
-          </a:bodyPr>
-          <a:lstStyle/>
-          <a:p>
-            <a:pPr algn="l">
-              <a:spcAft>
-                <a:spcPts val="1000"/>
-              </a:spcAft>
-            </a:pPr>
-            <a:r>
-              <a:rPr sz="1600" b="0">
-                <a:solidFill>
-                  <a:srgbClr val="9FB3C8"/>
-                </a:solidFill>
-                <a:latin typeface="Arial"/>
-              </a:rPr>
-              <a:t>menos tiempo es mejor</a:t>
-            </a:r>
-          </a:p>
-        </p:txBody>
-      </p:sp>
-      <p:sp>
-        <p:nvSpPr>
-          <p:cNvPr id="18" name="TextBox 17"/>
-          <p:cNvSpPr txBox="1"/>
-          <p:nvPr/>
-        </p:nvSpPr>
-        <p:spPr>
-          <a:xfrm>
-            <a:off x="10607040" y="5943600"/>
-            <a:ext cx="4572000" cy="1097280"/>
-          </a:xfrm>
-          <a:prstGeom prst="rect">
-            <a:avLst/>
-          </a:prstGeom>
-          <a:noFill/>
-        </p:spPr>
-        <p:txBody>
-          <a:bodyPr wrap="square" anchor="t" lIns="0" rIns="0" tIns="0" bIns="0">
-            <a:spAutoFit/>
-          </a:bodyPr>
-          <a:lstStyle/>
-          <a:p>
-            <a:pPr algn="l">
-              <a:spcAft>
-                <a:spcPts val="1000"/>
-              </a:spcAft>
-            </a:pPr>
-            <a:r>
-              <a:rPr sz="2800" b="0">
-                <a:solidFill>
-                  <a:srgbClr val="FFFFFF"/>
-                </a:solidFill>
-                <a:latin typeface="Arial"/>
-              </a:rPr>
-              <a:t>RG fue </a:t>
-            </a:r>
-            <a:r>
-              <a:rPr sz="2800" b="1">
-                <a:solidFill>
-                  <a:srgbClr val="FFFFFF"/>
-                </a:solidFill>
-                <a:latin typeface="Arial"/>
-              </a:rPr>
-              <a:t>2,64x</a:t>
-            </a:r>
-            <a:r>
-              <a:rPr sz="2800" b="0">
-                <a:solidFill>
-                  <a:srgbClr val="FFFFFF"/>
-                </a:solidFill>
-                <a:latin typeface="Arial"/>
-              </a:rPr>
-              <a:t> más rápido</a:t>
-            </a:r>
-          </a:p>
-        </p:txBody>
-      </p:sp>
     </p:spTree>
   </p:cSld>
   <p:clrMapOvr>
@@ -22246,7 +22850,7 @@
 </p:sld>
 </file>
 
-<file path=ppt/slides/slide3.xml><?xml version="1.0" encoding="utf-8"?>
+<file path=ppt/slides/slide30.xml><?xml version="1.0" encoding="utf-8"?>
 <p:sld xmlns:p="http://schemas.openxmlformats.org/presentationml/2006/main" xmlns:a="http://schemas.openxmlformats.org/drawingml/2006/main" xmlns:r="http://schemas.openxmlformats.org/officeDocument/2006/relationships">
   <p:cSld>
     <p:bg>
@@ -22322,7 +22926,51 @@
       </p:sp>
       <p:sp>
         <p:nvSpPr>
-          <p:cNvPr name="Freeform 3" id="3"/>
+          <p:cNvPr name="TextBox 3" id="3"/>
+          <p:cNvSpPr txBox="true"/>
+          <p:nvPr/>
+        </p:nvSpPr>
+        <p:spPr>
+          <a:xfrm rot="0">
+            <a:off x="3520440" y="868680"/>
+            <a:ext cx="12070080" cy="1874519"/>
+          </a:xfrm>
+          <a:prstGeom prst="rect">
+            <a:avLst/>
+          </a:prstGeom>
+        </p:spPr>
+        <p:txBody>
+          <a:bodyPr anchor="ctr" rtlCol="false" tIns="0" lIns="0" bIns="0" rIns="0" wrap="square">
+            <a:spAutoFit/>
+          </a:bodyPr>
+          <a:lstStyle/>
+          <a:p>
+            <a:pPr algn="l" marL="0" indent="0" lvl="0">
+              <a:lnSpc>
+                <a:spcPts val="10481"/>
+              </a:lnSpc>
+              <a:spcBef>
+                <a:spcPct val="0"/>
+              </a:spcBef>
+            </a:pPr>
+            <a:r>
+              <a:rPr lang="en-US" b="0" sz="4100">
+                <a:solidFill>
+                  <a:srgbClr val="FFFFFF"/>
+                </a:solidFill>
+                <a:latin typeface="Arial Black"/>
+                <a:ea typeface="Arial Black"/>
+                <a:cs typeface="Arial Black"/>
+                <a:sym typeface="Arial Black"/>
+              </a:rPr>
+              <a:t>Demo: una consulta, dos clústeres</a:t>
+            </a:r>
+          </a:p>
+        </p:txBody>
+      </p:sp>
+      <p:sp>
+        <p:nvSpPr>
+          <p:cNvPr name="Freeform 4" id="4"/>
           <p:cNvSpPr/>
           <p:nvPr/>
         </p:nvSpPr>
@@ -22371,158 +23019,6 @@
             </a:stretch>
           </a:blipFill>
         </p:spPr>
-        <p:txBody>
-          <a:bodyPr/>
-          <a:p/>
-        </p:txBody>
-      </p:sp>
-      <p:sp>
-        <p:nvSpPr>
-          <p:cNvPr name="TextBox 4" id="4"/>
-          <p:cNvSpPr txBox="true"/>
-          <p:nvPr/>
-        </p:nvSpPr>
-        <p:spPr>
-          <a:xfrm rot="0">
-            <a:off x="7191614" y="3137838"/>
-            <a:ext cx="9158687" cy="4650270"/>
-          </a:xfrm>
-          <a:prstGeom prst="rect">
-            <a:avLst/>
-          </a:prstGeom>
-        </p:spPr>
-        <p:txBody>
-          <a:bodyPr anchor="t" rtlCol="false" tIns="0" lIns="0" bIns="0" rIns="0">
-            <a:spAutoFit/>
-          </a:bodyPr>
-          <a:lstStyle/>
-          <a:p>
-            <a:pPr algn="l" marL="691055" indent="-345528" lvl="1">
-              <a:lnSpc>
-                <a:spcPts val="6273"/>
-              </a:lnSpc>
-              <a:buFont typeface="Arial"/>
-              <a:buChar char="•"/>
-            </a:pPr>
-            <a:r>
-              <a:rPr lang="en-US" sz="3200">
-                <a:solidFill>
-                  <a:srgbClr val="FFFFFF"/>
-                </a:solidFill>
-                <a:latin typeface="Raleway 2"/>
-                <a:ea typeface="Raleway 2"/>
-                <a:cs typeface="Raleway 2"/>
-                <a:sym typeface="Raleway 2"/>
-              </a:rPr>
-              <a:t>Qué cambia con RG</a:t>
-            </a:r>
-          </a:p>
-          <a:p>
-            <a:pPr algn="l" marL="691055" indent="-345528" lvl="1">
-              <a:lnSpc>
-                <a:spcPts val="6273"/>
-              </a:lnSpc>
-              <a:buFont typeface="Arial"/>
-              <a:buChar char="•"/>
-            </a:pPr>
-            <a:r>
-              <a:rPr lang="en-US" sz="3200">
-                <a:solidFill>
-                  <a:srgbClr val="FFFFFF"/>
-                </a:solidFill>
-                <a:latin typeface="Raleway 2"/>
-                <a:ea typeface="Raleway 2"/>
-                <a:cs typeface="Raleway 2"/>
-                <a:sym typeface="Raleway 2"/>
-              </a:rPr>
-              <a:t>Cómo lo medimos</a:t>
-            </a:r>
-          </a:p>
-          <a:p>
-            <a:pPr algn="l" marL="691055" indent="-345528" lvl="1">
-              <a:lnSpc>
-                <a:spcPts val="6273"/>
-              </a:lnSpc>
-              <a:buFont typeface="Arial"/>
-              <a:buChar char="•"/>
-            </a:pPr>
-            <a:r>
-              <a:rPr lang="en-US" sz="3200">
-                <a:solidFill>
-                  <a:srgbClr val="FFFFFF"/>
-                </a:solidFill>
-                <a:latin typeface="Raleway 2"/>
-                <a:ea typeface="Raleway 2"/>
-                <a:cs typeface="Raleway 2"/>
-                <a:sym typeface="Raleway 2"/>
-              </a:rPr>
-              <a:t>Warehouse: velocidad, concurrencia y costo</a:t>
-            </a:r>
-          </a:p>
-          <a:p>
-            <a:pPr algn="l" marL="691055" indent="-345528" lvl="1">
-              <a:lnSpc>
-                <a:spcPts val="6273"/>
-              </a:lnSpc>
-              <a:buFont typeface="Arial"/>
-              <a:buChar char="•"/>
-            </a:pPr>
-            <a:r>
-              <a:rPr lang="en-US" sz="3200">
-                <a:solidFill>
-                  <a:srgbClr val="FFFFFF"/>
-                </a:solidFill>
-                <a:latin typeface="Raleway 2"/>
-                <a:ea typeface="Raleway 2"/>
-                <a:cs typeface="Raleway 2"/>
-                <a:sym typeface="Raleway 2"/>
-              </a:rPr>
-              <a:t>Data lake: Iceberg, Parquet y Spectrum</a:t>
-            </a:r>
-          </a:p>
-          <a:p>
-            <a:pPr algn="l" marL="691055" indent="-345528" lvl="1">
-              <a:lnSpc>
-                <a:spcPts val="6273"/>
-              </a:lnSpc>
-              <a:buFont typeface="Arial"/>
-              <a:buChar char="•"/>
-            </a:pPr>
-            <a:r>
-              <a:rPr lang="en-US" sz="3200">
-                <a:solidFill>
-                  <a:srgbClr val="FFFFFF"/>
-                </a:solidFill>
-                <a:latin typeface="Raleway 2"/>
-                <a:ea typeface="Raleway 2"/>
-                <a:cs typeface="Raleway 2"/>
-                <a:sym typeface="Raleway 2"/>
-              </a:rPr>
-              <a:t>La migración y lo que nadie te cuenta</a:t>
-            </a:r>
-          </a:p>
-          <a:p>
-            <a:pPr algn="l" marL="691055" indent="-345528" lvl="1">
-              <a:lnSpc>
-                <a:spcPts val="6273"/>
-              </a:lnSpc>
-              <a:buFont typeface="Arial"/>
-              <a:buChar char="•"/>
-            </a:pPr>
-            <a:r>
-              <a:rPr lang="en-US" sz="3200">
-                <a:solidFill>
-                  <a:srgbClr val="FFFFFF"/>
-                </a:solidFill>
-                <a:latin typeface="Raleway 2"/>
-                <a:ea typeface="Raleway 2"/>
-                <a:cs typeface="Raleway 2"/>
-                <a:sym typeface="Raleway 2"/>
-              </a:rPr>
-              <a:t>Demo</a:t>
-            </a:r>
-          </a:p>
-        </p:txBody>
       </p:sp>
       <p:grpSp>
         <p:nvGrpSpPr>
@@ -22752,6 +23248,519 @@
           </a:p>
         </p:txBody>
       </p:sp>
+      <p:sp>
+        <p:nvSpPr>
+          <p:cNvPr id="10" name="Rounded Rectangle 9"/>
+          <p:cNvSpPr/>
+          <p:nvPr/>
+        </p:nvSpPr>
+        <p:spPr>
+          <a:xfrm>
+            <a:off x="914400" y="3200400"/>
+            <a:ext cx="9326880" cy="3931920"/>
+          </a:xfrm>
+          <a:prstGeom prst="roundRect">
+            <a:avLst>
+              <a:gd name="adj" fmla="val 4000"/>
+            </a:avLst>
+          </a:prstGeom>
+          <a:solidFill>
+            <a:srgbClr val="1A2230"/>
+          </a:solidFill>
+          <a:ln>
+            <a:noFill/>
+          </a:ln>
+        </p:spPr>
+        <p:style>
+          <a:lnRef idx="1">
+            <a:schemeClr val="accent1"/>
+          </a:lnRef>
+          <a:fillRef idx="3">
+            <a:schemeClr val="accent1"/>
+          </a:fillRef>
+          <a:effectRef idx="2">
+            <a:schemeClr val="accent1"/>
+          </a:effectRef>
+          <a:fontRef idx="minor">
+            <a:schemeClr val="lt1"/>
+          </a:fontRef>
+        </p:style>
+        <p:txBody>
+          <a:bodyPr rtlCol="0" anchor="t" wrap="square" lIns="274320" rIns="274320" tIns="274320"/>
+          <a:lstStyle/>
+          <a:p>
+            <a:pPr algn="l"/>
+            <a:r>
+              <a:rPr sz="1700">
+                <a:solidFill>
+                  <a:srgbClr val="D9E2EC"/>
+                </a:solidFill>
+                <a:latin typeface="Courier New"/>
+              </a:rPr>
+              <a:t>SELECT count(*)</a:t>
+            </a:r>
+          </a:p>
+          <a:p>
+            <a:pPr algn="l"/>
+            <a:r>
+              <a:rPr sz="1700">
+                <a:solidFill>
+                  <a:srgbClr val="D9E2EC"/>
+                </a:solidFill>
+                <a:latin typeface="Courier New"/>
+              </a:rPr>
+              <a:t>FROM store_sales, household_demographics,</a:t>
+            </a:r>
+          </a:p>
+          <a:p>
+            <a:pPr algn="l"/>
+            <a:r>
+              <a:rPr sz="1700">
+                <a:solidFill>
+                  <a:srgbClr val="D9E2EC"/>
+                </a:solidFill>
+                <a:latin typeface="Courier New"/>
+              </a:rPr>
+              <a:t>     time_dim, store</a:t>
+            </a:r>
+          </a:p>
+          <a:p>
+            <a:pPr algn="l"/>
+            <a:r>
+              <a:rPr sz="1700">
+                <a:solidFill>
+                  <a:srgbClr val="D9E2EC"/>
+                </a:solidFill>
+                <a:latin typeface="Courier New"/>
+              </a:rPr>
+              <a:t>WHERE ss_sold_time_sk = time_dim.t_time_sk</a:t>
+            </a:r>
+          </a:p>
+          <a:p>
+            <a:pPr algn="l"/>
+            <a:r>
+              <a:rPr sz="1700">
+                <a:solidFill>
+                  <a:srgbClr val="D9E2EC"/>
+                </a:solidFill>
+                <a:latin typeface="Courier New"/>
+              </a:rPr>
+              <a:t>  AND ss_hdemo_sk = household_demographics.hd_demo_sk</a:t>
+            </a:r>
+          </a:p>
+          <a:p>
+            <a:pPr algn="l"/>
+            <a:r>
+              <a:rPr sz="1700">
+                <a:solidFill>
+                  <a:srgbClr val="D9E2EC"/>
+                </a:solidFill>
+                <a:latin typeface="Courier New"/>
+              </a:rPr>
+              <a:t>  AND ss_store_sk = s_store_sk</a:t>
+            </a:r>
+          </a:p>
+          <a:p>
+            <a:pPr algn="l"/>
+            <a:r>
+              <a:rPr sz="1700">
+                <a:solidFill>
+                  <a:srgbClr val="D9E2EC"/>
+                </a:solidFill>
+                <a:latin typeface="Courier New"/>
+              </a:rPr>
+              <a:t>  AND time_dim.t_hour = 15</a:t>
+            </a:r>
+          </a:p>
+          <a:p>
+            <a:pPr algn="l"/>
+            <a:r>
+              <a:rPr sz="1700">
+                <a:solidFill>
+                  <a:srgbClr val="D9E2EC"/>
+                </a:solidFill>
+                <a:latin typeface="Courier New"/>
+              </a:rPr>
+              <a:t>  AND time_dim.t_minute &gt;= 30</a:t>
+            </a:r>
+          </a:p>
+          <a:p>
+            <a:pPr algn="l"/>
+            <a:r>
+              <a:rPr sz="1700">
+                <a:solidFill>
+                  <a:srgbClr val="D9E2EC"/>
+                </a:solidFill>
+                <a:latin typeface="Courier New"/>
+              </a:rPr>
+              <a:t>  AND household_demographics.hd_dep_count = 7</a:t>
+            </a:r>
+          </a:p>
+          <a:p>
+            <a:pPr algn="l"/>
+            <a:r>
+              <a:rPr sz="1700">
+                <a:solidFill>
+                  <a:srgbClr val="D9E2EC"/>
+                </a:solidFill>
+                <a:latin typeface="Courier New"/>
+              </a:rPr>
+              <a:t>  AND store.s_store_name = 'ese'</a:t>
+            </a:r>
+          </a:p>
+          <a:p>
+            <a:pPr algn="l"/>
+            <a:r>
+              <a:rPr sz="1700">
+                <a:solidFill>
+                  <a:srgbClr val="D9E2EC"/>
+                </a:solidFill>
+                <a:latin typeface="Courier New"/>
+              </a:rPr>
+              <a:t>LIMIT 100;</a:t>
+            </a:r>
+          </a:p>
+        </p:txBody>
+      </p:sp>
+      <p:sp>
+        <p:nvSpPr>
+          <p:cNvPr id="11" name="TextBox 10"/>
+          <p:cNvSpPr txBox="1"/>
+          <p:nvPr/>
+        </p:nvSpPr>
+        <p:spPr>
+          <a:xfrm>
+            <a:off x="914400" y="7315200"/>
+            <a:ext cx="9326880" cy="1280160"/>
+          </a:xfrm>
+          <a:prstGeom prst="rect">
+            <a:avLst/>
+          </a:prstGeom>
+          <a:noFill/>
+        </p:spPr>
+        <p:txBody>
+          <a:bodyPr wrap="square" anchor="t" lIns="0" rIns="0" tIns="0" bIns="0">
+            <a:spAutoFit/>
+          </a:bodyPr>
+          <a:lstStyle/>
+          <a:p>
+            <a:pPr algn="l">
+              <a:spcAft>
+                <a:spcPts val="1000"/>
+              </a:spcAft>
+            </a:pPr>
+            <a:r>
+              <a:rPr sz="2000" b="1">
+                <a:solidFill>
+                  <a:srgbClr val="D9E2EC"/>
+                </a:solidFill>
+                <a:latin typeface="Arial"/>
+              </a:rPr>
+              <a:t>Por qué pesa:</a:t>
+            </a:r>
+            <a:r>
+              <a:rPr sz="2000" b="0">
+                <a:solidFill>
+                  <a:srgbClr val="D9E2EC"/>
+                </a:solidFill>
+                <a:latin typeface="Arial"/>
+              </a:rPr>
+              <a:t> recorre las 288 millones de ventas de store_sales y las cruza con tres tablas para quedarse con una franja horaria y un tipo de hogar.</a:t>
+            </a:r>
+          </a:p>
+        </p:txBody>
+      </p:sp>
+      <p:sp>
+        <p:nvSpPr>
+          <p:cNvPr id="12" name="TextBox 11"/>
+          <p:cNvSpPr txBox="1"/>
+          <p:nvPr/>
+        </p:nvSpPr>
+        <p:spPr>
+          <a:xfrm>
+            <a:off x="10607040" y="3474720"/>
+            <a:ext cx="4572000" cy="457200"/>
+          </a:xfrm>
+          <a:prstGeom prst="rect">
+            <a:avLst/>
+          </a:prstGeom>
+          <a:noFill/>
+        </p:spPr>
+        <p:txBody>
+          <a:bodyPr wrap="square" anchor="t" lIns="0" rIns="0" tIns="0" bIns="0">
+            <a:spAutoFit/>
+          </a:bodyPr>
+          <a:lstStyle/>
+          <a:p>
+            <a:pPr algn="l">
+              <a:spcAft>
+                <a:spcPts val="1000"/>
+              </a:spcAft>
+            </a:pPr>
+            <a:r>
+              <a:rPr sz="2000" b="0">
+                <a:solidFill>
+                  <a:srgbClr val="D9E2EC"/>
+                </a:solidFill>
+                <a:latin typeface="Arial"/>
+              </a:rPr>
+              <a:t>query96</a:t>
+            </a:r>
+          </a:p>
+        </p:txBody>
+      </p:sp>
+      <p:sp>
+        <p:nvSpPr>
+          <p:cNvPr id="13" name="TextBox 12"/>
+          <p:cNvSpPr txBox="1"/>
+          <p:nvPr/>
+        </p:nvSpPr>
+        <p:spPr>
+          <a:xfrm>
+            <a:off x="10607040" y="3977639"/>
+            <a:ext cx="2286000" cy="914400"/>
+          </a:xfrm>
+          <a:prstGeom prst="rect">
+            <a:avLst/>
+          </a:prstGeom>
+          <a:noFill/>
+        </p:spPr>
+        <p:txBody>
+          <a:bodyPr wrap="square" anchor="t" lIns="0" rIns="0" tIns="0" bIns="0">
+            <a:spAutoFit/>
+          </a:bodyPr>
+          <a:lstStyle/>
+          <a:p>
+            <a:pPr algn="l">
+              <a:spcAft>
+                <a:spcPts val="1000"/>
+              </a:spcAft>
+            </a:pPr>
+            <a:r>
+              <a:rPr sz="4000" b="1">
+                <a:solidFill>
+                  <a:srgbClr val="8FA3B8"/>
+                </a:solidFill>
+                <a:latin typeface="Arial"/>
+              </a:rPr>
+              <a:t>1,77 s</a:t>
+            </a:r>
+          </a:p>
+        </p:txBody>
+      </p:sp>
+      <p:sp>
+        <p:nvSpPr>
+          <p:cNvPr id="14" name="TextBox 13"/>
+          <p:cNvSpPr txBox="1"/>
+          <p:nvPr/>
+        </p:nvSpPr>
+        <p:spPr>
+          <a:xfrm>
+            <a:off x="12893040" y="3977639"/>
+            <a:ext cx="2286000" cy="914400"/>
+          </a:xfrm>
+          <a:prstGeom prst="rect">
+            <a:avLst/>
+          </a:prstGeom>
+          <a:noFill/>
+        </p:spPr>
+        <p:txBody>
+          <a:bodyPr wrap="square" anchor="t" lIns="0" rIns="0" tIns="0" bIns="0">
+            <a:spAutoFit/>
+          </a:bodyPr>
+          <a:lstStyle/>
+          <a:p>
+            <a:pPr algn="l">
+              <a:spcAft>
+                <a:spcPts val="1000"/>
+              </a:spcAft>
+            </a:pPr>
+            <a:r>
+              <a:rPr sz="4000" b="1">
+                <a:solidFill>
+                  <a:srgbClr val="316CE3"/>
+                </a:solidFill>
+                <a:latin typeface="Arial"/>
+              </a:rPr>
+              <a:t>0,67 s</a:t>
+            </a:r>
+          </a:p>
+        </p:txBody>
+      </p:sp>
+      <p:sp>
+        <p:nvSpPr>
+          <p:cNvPr id="15" name="TextBox 14"/>
+          <p:cNvSpPr txBox="1"/>
+          <p:nvPr/>
+        </p:nvSpPr>
+        <p:spPr>
+          <a:xfrm>
+            <a:off x="10607040" y="4754879"/>
+            <a:ext cx="2286000" cy="457200"/>
+          </a:xfrm>
+          <a:prstGeom prst="rect">
+            <a:avLst/>
+          </a:prstGeom>
+          <a:noFill/>
+        </p:spPr>
+        <p:txBody>
+          <a:bodyPr wrap="square" anchor="t" lIns="0" rIns="0" tIns="0" bIns="0">
+            <a:spAutoFit/>
+          </a:bodyPr>
+          <a:lstStyle/>
+          <a:p>
+            <a:pPr algn="l">
+              <a:spcAft>
+                <a:spcPts val="1000"/>
+              </a:spcAft>
+            </a:pPr>
+            <a:r>
+              <a:rPr sz="1800" b="0">
+                <a:solidFill>
+                  <a:srgbClr val="8FA3B8"/>
+                </a:solidFill>
+                <a:latin typeface="Arial"/>
+              </a:rPr>
+              <a:t>RA3</a:t>
+            </a:r>
+          </a:p>
+        </p:txBody>
+      </p:sp>
+      <p:sp>
+        <p:nvSpPr>
+          <p:cNvPr id="16" name="TextBox 15"/>
+          <p:cNvSpPr txBox="1"/>
+          <p:nvPr/>
+        </p:nvSpPr>
+        <p:spPr>
+          <a:xfrm>
+            <a:off x="12893040" y="4754879"/>
+            <a:ext cx="2286000" cy="457200"/>
+          </a:xfrm>
+          <a:prstGeom prst="rect">
+            <a:avLst/>
+          </a:prstGeom>
+          <a:noFill/>
+        </p:spPr>
+        <p:txBody>
+          <a:bodyPr wrap="square" anchor="t" lIns="0" rIns="0" tIns="0" bIns="0">
+            <a:spAutoFit/>
+          </a:bodyPr>
+          <a:lstStyle/>
+          <a:p>
+            <a:pPr algn="l">
+              <a:spcAft>
+                <a:spcPts val="1000"/>
+              </a:spcAft>
+            </a:pPr>
+            <a:r>
+              <a:rPr sz="1800" b="0">
+                <a:solidFill>
+                  <a:srgbClr val="316CE3"/>
+                </a:solidFill>
+                <a:latin typeface="Arial"/>
+              </a:rPr>
+              <a:t>RG</a:t>
+            </a:r>
+          </a:p>
+        </p:txBody>
+      </p:sp>
+      <p:sp>
+        <p:nvSpPr>
+          <p:cNvPr id="17" name="TextBox 16"/>
+          <p:cNvSpPr txBox="1"/>
+          <p:nvPr/>
+        </p:nvSpPr>
+        <p:spPr>
+          <a:xfrm>
+            <a:off x="10607040" y="5166360"/>
+            <a:ext cx="4572000" cy="457200"/>
+          </a:xfrm>
+          <a:prstGeom prst="rect">
+            <a:avLst/>
+          </a:prstGeom>
+          <a:noFill/>
+        </p:spPr>
+        <p:txBody>
+          <a:bodyPr wrap="square" anchor="t" lIns="0" rIns="0" tIns="0" bIns="0">
+            <a:spAutoFit/>
+          </a:bodyPr>
+          <a:lstStyle/>
+          <a:p>
+            <a:pPr algn="l">
+              <a:spcAft>
+                <a:spcPts val="1000"/>
+              </a:spcAft>
+            </a:pPr>
+            <a:r>
+              <a:rPr sz="1600" b="0">
+                <a:solidFill>
+                  <a:srgbClr val="9FB3C8"/>
+                </a:solidFill>
+                <a:latin typeface="Arial"/>
+              </a:rPr>
+              <a:t>menos tiempo es mejor</a:t>
+            </a:r>
+          </a:p>
+        </p:txBody>
+      </p:sp>
+      <p:sp>
+        <p:nvSpPr>
+          <p:cNvPr id="18" name="TextBox 17"/>
+          <p:cNvSpPr txBox="1"/>
+          <p:nvPr/>
+        </p:nvSpPr>
+        <p:spPr>
+          <a:xfrm>
+            <a:off x="10607040" y="5943600"/>
+            <a:ext cx="4572000" cy="1097280"/>
+          </a:xfrm>
+          <a:prstGeom prst="rect">
+            <a:avLst/>
+          </a:prstGeom>
+          <a:noFill/>
+        </p:spPr>
+        <p:txBody>
+          <a:bodyPr wrap="square" anchor="t" lIns="0" rIns="0" tIns="0" bIns="0">
+            <a:spAutoFit/>
+          </a:bodyPr>
+          <a:lstStyle/>
+          <a:p>
+            <a:pPr algn="l">
+              <a:spcAft>
+                <a:spcPts val="1000"/>
+              </a:spcAft>
+            </a:pPr>
+            <a:r>
+              <a:rPr sz="2800" b="0">
+                <a:solidFill>
+                  <a:srgbClr val="FFFFFF"/>
+                </a:solidFill>
+                <a:latin typeface="Arial"/>
+              </a:rPr>
+              <a:t>RG fue </a:t>
+            </a:r>
+            <a:r>
+              <a:rPr sz="2800" b="1">
+                <a:solidFill>
+                  <a:srgbClr val="FFFFFF"/>
+                </a:solidFill>
+                <a:latin typeface="Arial"/>
+              </a:rPr>
+              <a:t>2,64x</a:t>
+            </a:r>
+            <a:r>
+              <a:rPr sz="2800" b="0">
+                <a:solidFill>
+                  <a:srgbClr val="FFFFFF"/>
+                </a:solidFill>
+                <a:latin typeface="Arial"/>
+              </a:rPr>
+              <a:t> más rápido</a:t>
+            </a:r>
+          </a:p>
+        </p:txBody>
+      </p:sp>
     </p:spTree>
   </p:cSld>
   <p:clrMapOvr>
@@ -22760,7 +23769,7 @@
 </p:sld>
 </file>
 
-<file path=ppt/slides/slide30.xml><?xml version="1.0" encoding="utf-8"?>
+<file path=ppt/slides/slide31.xml><?xml version="1.0" encoding="utf-8"?>
 <p:sld xmlns:p="http://schemas.openxmlformats.org/presentationml/2006/main" xmlns:a="http://schemas.openxmlformats.org/drawingml/2006/main" xmlns:r="http://schemas.openxmlformats.org/officeDocument/2006/relationships">
   <p:cSld>
     <p:bg>
@@ -23466,7 +24475,7 @@
 </p:sld>
 </file>
 
-<file path=ppt/slides/slide31.xml><?xml version="1.0" encoding="utf-8"?>
+<file path=ppt/slides/slide32.xml><?xml version="1.0" encoding="utf-8"?>
 <p:sld xmlns:p="http://schemas.openxmlformats.org/presentationml/2006/main" xmlns:a="http://schemas.openxmlformats.org/drawingml/2006/main" xmlns:r="http://schemas.openxmlformats.org/officeDocument/2006/relationships">
   <p:cSld>
     <p:bg>
@@ -23983,7 +24992,7 @@
 </p:sld>
 </file>
 
-<file path=ppt/slides/slide32.xml><?xml version="1.0" encoding="utf-8"?>
+<file path=ppt/slides/slide33.xml><?xml version="1.0" encoding="utf-8"?>
 <p:sld xmlns:p="http://schemas.openxmlformats.org/presentationml/2006/main" xmlns:a="http://schemas.openxmlformats.org/drawingml/2006/main" xmlns:r="http://schemas.openxmlformats.org/officeDocument/2006/relationships">
   <p:cSld>
     <p:bg>
@@ -24697,7 +25706,7 @@
                 </a:solidFill>
                 <a:latin typeface="Arial"/>
               </a:rPr>
-              <a:t>• Cuesta USD 0,375 por RPU-hora (no lo probamos)</a:t>
+              <a:t>• A 4 RPU fue 3 veces más lento que RG: dale más capacidad</a:t>
             </a:r>
           </a:p>
         </p:txBody>
@@ -24710,7 +25719,7 @@
 </p:sld>
 </file>
 
-<file path=ppt/slides/slide33.xml><?xml version="1.0" encoding="utf-8"?>
+<file path=ppt/slides/slide34.xml><?xml version="1.0" encoding="utf-8"?>
 <p:sld xmlns:p="http://schemas.openxmlformats.org/presentationml/2006/main" xmlns:a="http://schemas.openxmlformats.org/drawingml/2006/main" xmlns:r="http://schemas.openxmlformats.org/officeDocument/2006/relationships">
   <p:cSld>
     <p:bg>
@@ -25246,7 +26255,7 @@
 </p:sld>
 </file>
 
-<file path=ppt/slides/slide34.xml><?xml version="1.0" encoding="utf-8"?>
+<file path=ppt/slides/slide35.xml><?xml version="1.0" encoding="utf-8"?>
 <p:sld xmlns:p="http://schemas.openxmlformats.org/presentationml/2006/main" xmlns:a="http://schemas.openxmlformats.org/drawingml/2006/main" xmlns:r="http://schemas.openxmlformats.org/officeDocument/2006/relationships">
   <p:cSld>
     <p:bg>
@@ -25916,7 +26925,7 @@
 </p:sld>
 </file>
 
-<file path=ppt/slides/slide35.xml><?xml version="1.0" encoding="utf-8"?>
+<file path=ppt/slides/slide36.xml><?xml version="1.0" encoding="utf-8"?>
 <p:sld xmlns:p="http://schemas.openxmlformats.org/presentationml/2006/main" xmlns:a="http://schemas.openxmlformats.org/drawingml/2006/main" xmlns:r="http://schemas.openxmlformats.org/officeDocument/2006/relationships">
   <p:cSld>
     <p:bg>

</xml_diff>

<commit_message>
feat(slides): GitHub and LinkedIn QR codes on the lab and thank-you slides
QRs generated with segno (error level M, quiet zone 4) and decoded back from
PowerPoint's own render of slide 36 to the exact URLs.

Co-Authored-By: Claude Opus 5.5 <noreply@anthropic.com>
Claude-Session: https://claude.ai/code/session_01HgWRiJoTFne1e49sP1svEg
</commit_message>
<xml_diff>
--- a/slides/redshift-redemption.pptx
+++ b/slides/redshift-redemption.pptx
@@ -26126,7 +26126,7 @@
         <p:spPr>
           <a:xfrm>
             <a:off x="914400" y="3291840"/>
-            <a:ext cx="13898880" cy="1097280"/>
+            <a:ext cx="10607040" cy="1097280"/>
           </a:xfrm>
           <a:prstGeom prst="rect">
             <a:avLst/>
@@ -26145,7 +26145,7 @@
               </a:spcAft>
             </a:pPr>
             <a:r>
-              <a:rPr sz="4400" b="1">
+              <a:rPr sz="3600" b="1">
                 <a:solidFill>
                   <a:srgbClr val="316CE3"/>
                 </a:solidFill>
@@ -26158,14 +26158,122 @@
       </p:sp>
       <p:sp>
         <p:nvSpPr>
-          <p:cNvPr id="11" name="TextBox 10"/>
+          <p:cNvPr id="11" name="Rounded Rectangle 10"/>
+          <p:cNvSpPr/>
+          <p:nvPr/>
+        </p:nvSpPr>
+        <p:spPr>
+          <a:xfrm>
+            <a:off x="11905488" y="3355848"/>
+            <a:ext cx="3346703" cy="3346703"/>
+          </a:xfrm>
+          <a:prstGeom prst="roundRect">
+            <a:avLst>
+              <a:gd name="adj" fmla="val 6000"/>
+            </a:avLst>
+          </a:prstGeom>
+          <a:solidFill>
+            <a:srgbClr val="FFFFFF"/>
+          </a:solidFill>
+          <a:ln>
+            <a:noFill/>
+          </a:ln>
+        </p:spPr>
+        <p:style>
+          <a:lnRef idx="1">
+            <a:schemeClr val="accent1"/>
+          </a:lnRef>
+          <a:fillRef idx="3">
+            <a:schemeClr val="accent1"/>
+          </a:fillRef>
+          <a:effectRef idx="2">
+            <a:schemeClr val="accent1"/>
+          </a:effectRef>
+          <a:fontRef idx="minor">
+            <a:schemeClr val="lt1"/>
+          </a:fontRef>
+        </p:style>
+        <p:txBody>
+          <a:bodyPr rtlCol="0" anchor="ctr"/>
+          <a:lstStyle/>
+          <a:p>
+            <a:pPr algn="ctr"/>
+          </a:p>
+        </p:txBody>
+      </p:sp>
+      <p:pic>
+        <p:nvPicPr>
+          <p:cNvPr id="12" name="Picture 11" descr="qr-github.png"/>
+          <p:cNvPicPr>
+            <a:picLocks noChangeAspect="1"/>
+          </p:cNvPicPr>
+          <p:nvPr/>
+        </p:nvPicPr>
+        <p:blipFill>
+          <a:blip r:embed="rId7"/>
+          <a:stretch>
+            <a:fillRect/>
+          </a:stretch>
+        </p:blipFill>
+        <p:spPr>
+          <a:xfrm>
+            <a:off x="12070080" y="3520440"/>
+            <a:ext cx="3017520" cy="3017520"/>
+          </a:xfrm>
+          <a:prstGeom prst="rect">
+            <a:avLst/>
+          </a:prstGeom>
+        </p:spPr>
+      </p:pic>
+      <p:sp>
+        <p:nvSpPr>
+          <p:cNvPr id="13" name="TextBox 12"/>
           <p:cNvSpPr txBox="1"/>
           <p:nvPr/>
         </p:nvSpPr>
         <p:spPr>
           <a:xfrm>
-            <a:off x="914400" y="4754880"/>
-            <a:ext cx="13898880" cy="3657600"/>
+            <a:off x="11612880" y="6812280"/>
+            <a:ext cx="3931920" cy="457200"/>
+          </a:xfrm>
+          <a:prstGeom prst="rect">
+            <a:avLst/>
+          </a:prstGeom>
+          <a:noFill/>
+        </p:spPr>
+        <p:txBody>
+          <a:bodyPr wrap="square" anchor="t" lIns="0" rIns="0" tIns="0" bIns="0">
+            <a:spAutoFit/>
+          </a:bodyPr>
+          <a:lstStyle/>
+          <a:p>
+            <a:pPr algn="ctr">
+              <a:spcAft>
+                <a:spcPts val="1000"/>
+              </a:spcAft>
+            </a:pPr>
+            <a:r>
+              <a:rPr sz="1800" b="0">
+                <a:solidFill>
+                  <a:srgbClr val="D9E2EC"/>
+                </a:solidFill>
+                <a:latin typeface="Arial"/>
+              </a:rPr>
+              <a:t>Escanea para ir al repo</a:t>
+            </a:r>
+          </a:p>
+        </p:txBody>
+      </p:sp>
+      <p:sp>
+        <p:nvSpPr>
+          <p:cNvPr id="14" name="TextBox 13"/>
+          <p:cNvSpPr txBox="1"/>
+          <p:nvPr/>
+        </p:nvSpPr>
+        <p:spPr>
+          <a:xfrm>
+            <a:off x="914400" y="4663440"/>
+            <a:ext cx="10607040" cy="3657600"/>
           </a:xfrm>
           <a:prstGeom prst="rect">
             <a:avLst/>
@@ -26208,7 +26316,7 @@
                 </a:solidFill>
                 <a:latin typeface="Arial"/>
               </a:rPr>
-              <a:t>El programa que lanza las pruebas, en Python, y un runbook paso a paso</a:t>
+              <a:t>El programa de pruebas, en Python, y el runbook paso a paso</a:t>
             </a:r>
           </a:p>
           <a:p>
@@ -27332,7 +27440,7 @@
         <p:spPr>
           <a:xfrm>
             <a:off x="914400" y="3566160"/>
-            <a:ext cx="13898880" cy="4114800"/>
+            <a:ext cx="7863840" cy="4114800"/>
           </a:xfrm>
           <a:prstGeom prst="rect">
             <a:avLst/>
@@ -27347,58 +27455,281 @@
           <a:p>
             <a:pPr algn="l">
               <a:spcAft>
-                <a:spcPts val="2200"/>
+                <a:spcPts val="2000"/>
               </a:spcAft>
             </a:pPr>
             <a:r>
-              <a:rPr sz="3000" b="1">
+              <a:rPr sz="2800" b="1">
                 <a:solidFill>
                   <a:srgbClr val="D9E2EC"/>
                 </a:solidFill>
                 <a:latin typeface="Arial"/>
               </a:rPr>
               <a:t>Andrés Zeballos</a:t>
-            </a:r>
-            <a:r>
-              <a:rPr sz="3000" b="0">
-                <a:solidFill>
-                  <a:srgbClr val="D9E2EC"/>
-                </a:solidFill>
-                <a:latin typeface="Arial"/>
-              </a:rPr>
-              <a:t> · Solutions Architect en phData</a:t>
             </a:r>
           </a:p>
           <a:p>
             <a:pPr algn="l">
               <a:spcAft>
-                <a:spcPts val="2200"/>
+                <a:spcPts val="2000"/>
               </a:spcAft>
             </a:pPr>
             <a:r>
-              <a:rPr sz="3000" b="0">
+              <a:rPr sz="2800" b="0">
                 <a:solidFill>
                   <a:srgbClr val="D9E2EC"/>
                 </a:solidFill>
                 <a:latin typeface="Arial"/>
               </a:rPr>
-              <a:t>GitHub: andrezc98</a:t>
+              <a:t>Solutions Architect en phData</a:t>
             </a:r>
           </a:p>
           <a:p>
             <a:pPr algn="l">
               <a:spcAft>
-                <a:spcPts val="2200"/>
+                <a:spcPts val="2000"/>
               </a:spcAft>
             </a:pPr>
             <a:r>
-              <a:rPr sz="3000" b="0">
+              <a:rPr sz="2800" b="0">
                 <a:solidFill>
                   <a:srgbClr val="D9E2EC"/>
                 </a:solidFill>
                 <a:latin typeface="Arial"/>
               </a:rPr>
-              <a:t>El laboratorio: github.com/andrezc98/redshift-redemption</a:t>
+              <a:t>LinkedIn: linkedin.com/in/andreszc</a:t>
+            </a:r>
+          </a:p>
+          <a:p>
+            <a:pPr algn="l">
+              <a:spcAft>
+                <a:spcPts val="2000"/>
+              </a:spcAft>
+            </a:pPr>
+            <a:r>
+              <a:rPr sz="2800" b="0">
+                <a:solidFill>
+                  <a:srgbClr val="D9E2EC"/>
+                </a:solidFill>
+                <a:latin typeface="Arial"/>
+              </a:rPr>
+              <a:t>GitHub: andrezc98</a:t>
+            </a:r>
+          </a:p>
+        </p:txBody>
+      </p:sp>
+      <p:sp>
+        <p:nvSpPr>
+          <p:cNvPr id="11" name="Rounded Rectangle 10"/>
+          <p:cNvSpPr/>
+          <p:nvPr/>
+        </p:nvSpPr>
+        <p:spPr>
+          <a:xfrm>
+            <a:off x="8979408" y="3355848"/>
+            <a:ext cx="3072384" cy="3072384"/>
+          </a:xfrm>
+          <a:prstGeom prst="roundRect">
+            <a:avLst>
+              <a:gd name="adj" fmla="val 6000"/>
+            </a:avLst>
+          </a:prstGeom>
+          <a:solidFill>
+            <a:srgbClr val="FFFFFF"/>
+          </a:solidFill>
+          <a:ln>
+            <a:noFill/>
+          </a:ln>
+        </p:spPr>
+        <p:style>
+          <a:lnRef idx="1">
+            <a:schemeClr val="accent1"/>
+          </a:lnRef>
+          <a:fillRef idx="3">
+            <a:schemeClr val="accent1"/>
+          </a:fillRef>
+          <a:effectRef idx="2">
+            <a:schemeClr val="accent1"/>
+          </a:effectRef>
+          <a:fontRef idx="minor">
+            <a:schemeClr val="lt1"/>
+          </a:fontRef>
+        </p:style>
+        <p:txBody>
+          <a:bodyPr rtlCol="0" anchor="ctr"/>
+          <a:lstStyle/>
+          <a:p>
+            <a:pPr algn="ctr"/>
+          </a:p>
+        </p:txBody>
+      </p:sp>
+      <p:pic>
+        <p:nvPicPr>
+          <p:cNvPr id="12" name="Picture 11" descr="qr-linkedin.png"/>
+          <p:cNvPicPr>
+            <a:picLocks noChangeAspect="1"/>
+          </p:cNvPicPr>
+          <p:nvPr/>
+        </p:nvPicPr>
+        <p:blipFill>
+          <a:blip r:embed="rId7"/>
+          <a:stretch>
+            <a:fillRect/>
+          </a:stretch>
+        </p:blipFill>
+        <p:spPr>
+          <a:xfrm>
+            <a:off x="9144000" y="3520440"/>
+            <a:ext cx="2743200" cy="2743200"/>
+          </a:xfrm>
+          <a:prstGeom prst="rect">
+            <a:avLst/>
+          </a:prstGeom>
+        </p:spPr>
+      </p:pic>
+      <p:sp>
+        <p:nvSpPr>
+          <p:cNvPr id="13" name="TextBox 12"/>
+          <p:cNvSpPr txBox="1"/>
+          <p:nvPr/>
+        </p:nvSpPr>
+        <p:spPr>
+          <a:xfrm>
+            <a:off x="8686800" y="6537959"/>
+            <a:ext cx="3657600" cy="457200"/>
+          </a:xfrm>
+          <a:prstGeom prst="rect">
+            <a:avLst/>
+          </a:prstGeom>
+          <a:noFill/>
+        </p:spPr>
+        <p:txBody>
+          <a:bodyPr wrap="square" anchor="t" lIns="0" rIns="0" tIns="0" bIns="0">
+            <a:spAutoFit/>
+          </a:bodyPr>
+          <a:lstStyle/>
+          <a:p>
+            <a:pPr algn="ctr">
+              <a:spcAft>
+                <a:spcPts val="1000"/>
+              </a:spcAft>
+            </a:pPr>
+            <a:r>
+              <a:rPr sz="1800" b="0">
+                <a:solidFill>
+                  <a:srgbClr val="D9E2EC"/>
+                </a:solidFill>
+                <a:latin typeface="Arial"/>
+              </a:rPr>
+              <a:t>LinkedIn</a:t>
+            </a:r>
+          </a:p>
+        </p:txBody>
+      </p:sp>
+      <p:sp>
+        <p:nvSpPr>
+          <p:cNvPr id="14" name="Rounded Rectangle 13"/>
+          <p:cNvSpPr/>
+          <p:nvPr/>
+        </p:nvSpPr>
+        <p:spPr>
+          <a:xfrm>
+            <a:off x="12271248" y="3355848"/>
+            <a:ext cx="3072384" cy="3072384"/>
+          </a:xfrm>
+          <a:prstGeom prst="roundRect">
+            <a:avLst>
+              <a:gd name="adj" fmla="val 6000"/>
+            </a:avLst>
+          </a:prstGeom>
+          <a:solidFill>
+            <a:srgbClr val="FFFFFF"/>
+          </a:solidFill>
+          <a:ln>
+            <a:noFill/>
+          </a:ln>
+        </p:spPr>
+        <p:style>
+          <a:lnRef idx="1">
+            <a:schemeClr val="accent1"/>
+          </a:lnRef>
+          <a:fillRef idx="3">
+            <a:schemeClr val="accent1"/>
+          </a:fillRef>
+          <a:effectRef idx="2">
+            <a:schemeClr val="accent1"/>
+          </a:effectRef>
+          <a:fontRef idx="minor">
+            <a:schemeClr val="lt1"/>
+          </a:fontRef>
+        </p:style>
+        <p:txBody>
+          <a:bodyPr rtlCol="0" anchor="ctr"/>
+          <a:lstStyle/>
+          <a:p>
+            <a:pPr algn="ctr"/>
+          </a:p>
+        </p:txBody>
+      </p:sp>
+      <p:pic>
+        <p:nvPicPr>
+          <p:cNvPr id="15" name="Picture 14" descr="qr-github.png"/>
+          <p:cNvPicPr>
+            <a:picLocks noChangeAspect="1"/>
+          </p:cNvPicPr>
+          <p:nvPr/>
+        </p:nvPicPr>
+        <p:blipFill>
+          <a:blip r:embed="rId8"/>
+          <a:stretch>
+            <a:fillRect/>
+          </a:stretch>
+        </p:blipFill>
+        <p:spPr>
+          <a:xfrm>
+            <a:off x="12435840" y="3520440"/>
+            <a:ext cx="2743200" cy="2743200"/>
+          </a:xfrm>
+          <a:prstGeom prst="rect">
+            <a:avLst/>
+          </a:prstGeom>
+        </p:spPr>
+      </p:pic>
+      <p:sp>
+        <p:nvSpPr>
+          <p:cNvPr id="16" name="TextBox 15"/>
+          <p:cNvSpPr txBox="1"/>
+          <p:nvPr/>
+        </p:nvSpPr>
+        <p:spPr>
+          <a:xfrm>
+            <a:off x="11978640" y="6537959"/>
+            <a:ext cx="3657600" cy="457200"/>
+          </a:xfrm>
+          <a:prstGeom prst="rect">
+            <a:avLst/>
+          </a:prstGeom>
+          <a:noFill/>
+        </p:spPr>
+        <p:txBody>
+          <a:bodyPr wrap="square" anchor="t" lIns="0" rIns="0" tIns="0" bIns="0">
+            <a:spAutoFit/>
+          </a:bodyPr>
+          <a:lstStyle/>
+          <a:p>
+            <a:pPr algn="ctr">
+              <a:spcAft>
+                <a:spcPts val="1000"/>
+              </a:spcAft>
+            </a:pPr>
+            <a:r>
+              <a:rPr sz="1800" b="0">
+                <a:solidFill>
+                  <a:srgbClr val="D9E2EC"/>
+                </a:solidFill>
+                <a:latin typeface="Arial"/>
+              </a:rPr>
+              <a:t>El laboratorio</a:t>
             </a:r>
           </a:p>
         </p:txBody>

</xml_diff>

<commit_message>
feat(slides): quiz (4 talk questions) and Kahoot (2 simpler ones), per the organizers' email
Separate Quiz and Kahoot slides (37 slides) built from one question list, with
answers and comments in the notes; correct answers spread across a-d.
slides/preguntas.md is generated from the same list, ready to send.

Co-Authored-By: Claude Opus 5.5 <noreply@anthropic.com>
Claude-Session: https://claude.ai/code/session_01HgWRiJoTFne1e49sP1svEg
</commit_message>
<xml_diff>
--- a/slides/redshift-redemption.pptx
+++ b/slides/redshift-redemption.pptx
@@ -41,6 +41,7 @@
     <p:sldId id="303" r:id="rId58"/>
     <p:sldId id="304" r:id="rId59"/>
     <p:sldId id="305" r:id="rId60"/>
+    <p:sldId id="306" r:id="rId61"/>
   </p:sldIdLst>
   <p:sldSz cx="18288000" cy="10287000"/>
   <p:notesSz cx="6858000" cy="9144000"/>
@@ -4701,7 +4702,7 @@
           <a:lstStyle/>
           <a:p>
             <a:r>
-              <a:t>Kahoot. Pregunta 1: ¿Con qué lee RG los datos del data lake? a) Redshift Spectrum; b) Con sus propios nodos, sin Spectrum (correcta); c) Amazon Athena; d) Trabajos de AWS Glue. Comentario: RA3 usa Spectrum, que cobra USD 5 por TB leído; RG lee el lago con sus nodos y sin ese cobro. Pregunta 2: ¿Qué tipo de consultas mejoró más al pasar de RA3 a RG? a) Las de cálculo pesado, con ventanas y joins grandes; b) Las que leen y agregan muchos datos (correcta); c) Ninguna, quedaron igual; d) Solo las del data lake. Comentario: 2,28 veces en lectura contra 1,58 en cálculo; el promedio de las 20 consultas fue 1,90. Pregunta 3: Si tienes 4 nodos ra3.4xlarge, ¿cuántos rg.4xlarge recomienda AWS? a) 4; b) 3 (correcta); c) 2; d) 8. Comentario: un ra3.4xlarge tiene 12 vCPU y un rg.4xlarge, 16; 4 por 12 y 3 por 16 dan 48. Migrar uno a uno en ese tamaño te deja con un tercio de capacidad de más.</a:t>
+              <a:t>Quiz. Pregunta 1: ¿Con qué lee RG los datos del data lake? a) Redshift Spectrum; b) Con sus propios nodos, sin Spectrum (correcta); c) Amazon Athena; d) Trabajos de AWS Glue. Comentario: RA3 usa Spectrum, que cobra USD 5 por TB leído; RG lee el data lake con sus propios nodos y sin ese cobro. Pregunta 2: ¿Qué tipo de consultas mejoró más al pasar de RA3 a RG? a) Las de cálculo pesado (ventanas, joins grandes); b) Ninguna, quedaron igual; c) Las que leen y agregan muchos datos (correcta); d) Solo las del data lake. Comentario: 2,28 veces en lectura contra 1,58 en cálculo; el promedio de las 20 consultas fue 1,90. Pregunta 3: Si tienes 4 nodos ra3.4xlarge, ¿cuántos rg.4xlarge recomienda AWS? a) 3 (correcta); b) 4; c) 2; d) 8. Comentario: Un ra3.4xlarge tiene 12 vCPU y un rg.4xlarge, 16: 4 × 12 = 3 × 16 = 48. Migrar uno a uno en ese tamaño deja un tercio de capacidad de más. Pregunta 4: En el simulacro de migración (elastic resize), ¿cuánto tiempo estuvo el clúster sin aceptar escrituras? a) Nada, siempre aceptó escrituras; b) Unos 30 minutos; c) Varias horas; d) Entre 1,5 y 3 minutos (correcta). Comentario: Entre 1 min 35 s y 2 min 42 s; el resize completo tomó 2 min 48 s.</a:t>
             </a:r>
           </a:p>
         </p:txBody>
@@ -4727,6 +4728,76 @@
 </file>
 
 <file path=ppt/notesSlides/notesSlide36.xml><?xml version="1.0" encoding="utf-8"?>
+<p:notes xmlns:a="http://schemas.openxmlformats.org/drawingml/2006/main" xmlns:p="http://schemas.openxmlformats.org/presentationml/2006/main" xmlns:r="http://schemas.openxmlformats.org/officeDocument/2006/relationships">
+  <p:cSld>
+    <p:spTree>
+      <p:nvGrpSpPr>
+        <p:cNvPr id="1" name=""/>
+        <p:cNvGrpSpPr/>
+        <p:nvPr/>
+      </p:nvGrpSpPr>
+      <p:grpSpPr>
+        <a:xfrm>
+          <a:off x="0" y="0"/>
+          <a:ext cx="0" cy="0"/>
+          <a:chOff x="0" y="0"/>
+          <a:chExt cx="0" cy="0"/>
+        </a:xfrm>
+      </p:grpSpPr>
+      <p:sp>
+        <p:nvSpPr>
+          <p:cNvPr id="2" name="Slide Image Placeholder 1"/>
+          <p:cNvSpPr>
+            <a:spLocks noGrp="1"/>
+          </p:cNvSpPr>
+          <p:nvPr>
+            <p:ph type="sldImg" idx="2"/>
+          </p:nvPr>
+        </p:nvSpPr>
+        <p:spPr/>
+      </p:sp>
+      <p:sp>
+        <p:nvSpPr>
+          <p:cNvPr id="3" name="Notes Placeholder 2"/>
+          <p:cNvSpPr>
+            <a:spLocks noGrp="1"/>
+          </p:cNvSpPr>
+          <p:nvPr>
+            <p:ph type="body" idx="3" sz="quarter"/>
+          </p:nvPr>
+        </p:nvSpPr>
+        <p:spPr/>
+        <p:txBody>
+          <a:bodyPr/>
+          <a:lstStyle/>
+          <a:p>
+            <a:r>
+              <a:t>Kahoot. Pregunta 1: ¿Qué procesadores usan los nuevos nodos RG de Redshift? a) Intel Xeon; b) AMD EPYC; c) AWS Graviton (correcta); d) Apple M. Comentario: RG usa Graviton, los procesadores Arm diseñados por AWS. Pregunta 2: ¿Cuánto menos cuesta RG por vCPU frente a RA3? a) 30 % (correcta); b) 10 %; c) 50 %; d) Cuesta lo mismo. Comentario: USD 1,086 entre 4 vCPU en ra3.xlplus contra 0,7602 entre 4 en rg.xlarge: 30 % menos.</a:t>
+            </a:r>
+          </a:p>
+        </p:txBody>
+      </p:sp>
+      <p:sp>
+        <p:nvSpPr>
+          <p:cNvPr id="4" name="Slide Number Placeholder 3"/>
+          <p:cNvSpPr>
+            <a:spLocks noGrp="1"/>
+          </p:cNvSpPr>
+          <p:nvPr>
+            <p:ph type="sldNum" idx="5" sz="quarter"/>
+          </p:nvPr>
+        </p:nvSpPr>
+        <p:spPr/>
+      </p:sp>
+    </p:spTree>
+  </p:cSld>
+  <p:clrMapOvr>
+    <a:masterClrMapping/>
+  </p:clrMapOvr>
+</p:notes>
+</file>
+
+<file path=ppt/notesSlides/notesSlide37.xml><?xml version="1.0" encoding="utf-8"?>
 <p:notes xmlns:a="http://schemas.openxmlformats.org/drawingml/2006/main" xmlns:p="http://schemas.openxmlformats.org/presentationml/2006/main" xmlns:r="http://schemas.openxmlformats.org/officeDocument/2006/relationships">
   <p:cSld>
     <p:spTree>
@@ -26476,7 +26547,7 @@
                 <a:cs typeface="Arial Black"/>
                 <a:sym typeface="Arial Black"/>
               </a:rPr>
-              <a:t>Kahoot</a:t>
+              <a:t>Quiz</a:t>
             </a:r>
           </a:p>
         </p:txBody>
@@ -26770,7 +26841,7 @@
         <p:spPr>
           <a:xfrm>
             <a:off x="914400" y="3200400"/>
-            <a:ext cx="4480560" cy="2926080"/>
+            <a:ext cx="3268979" cy="3108960"/>
           </a:xfrm>
           <a:prstGeom prst="roundRect">
             <a:avLst>
@@ -26809,7 +26880,7 @@
               </a:spcAft>
             </a:pPr>
             <a:r>
-              <a:rPr sz="2600" b="1">
+              <a:rPr sz="2400" b="1">
                 <a:solidFill>
                   <a:srgbClr val="316CE3"/>
                 </a:solidFill>
@@ -26825,7 +26896,7 @@
               </a:spcAft>
             </a:pPr>
             <a:r>
-              <a:rPr sz="2300" b="0">
+              <a:rPr sz="2100" b="0">
                 <a:solidFill>
                   <a:srgbClr val="D9E2EC"/>
                 </a:solidFill>
@@ -26844,8 +26915,8 @@
         </p:nvSpPr>
         <p:spPr>
           <a:xfrm>
-            <a:off x="5669280" y="3200400"/>
-            <a:ext cx="4480560" cy="2926080"/>
+            <a:off x="4457700" y="3200400"/>
+            <a:ext cx="3268979" cy="3108960"/>
           </a:xfrm>
           <a:prstGeom prst="roundRect">
             <a:avLst>
@@ -26884,7 +26955,7 @@
               </a:spcAft>
             </a:pPr>
             <a:r>
-              <a:rPr sz="2600" b="1">
+              <a:rPr sz="2400" b="1">
                 <a:solidFill>
                   <a:srgbClr val="316CE3"/>
                 </a:solidFill>
@@ -26900,7 +26971,7 @@
               </a:spcAft>
             </a:pPr>
             <a:r>
-              <a:rPr sz="2300" b="0">
+              <a:rPr sz="2100" b="0">
                 <a:solidFill>
                   <a:srgbClr val="D9E2EC"/>
                 </a:solidFill>
@@ -26919,8 +26990,8 @@
         </p:nvSpPr>
         <p:spPr>
           <a:xfrm>
-            <a:off x="10424160" y="3200400"/>
-            <a:ext cx="4480560" cy="2926080"/>
+            <a:off x="8001000" y="3200400"/>
+            <a:ext cx="3268979" cy="3108960"/>
           </a:xfrm>
           <a:prstGeom prst="roundRect">
             <a:avLst>
@@ -26959,7 +27030,7 @@
               </a:spcAft>
             </a:pPr>
             <a:r>
-              <a:rPr sz="2600" b="1">
+              <a:rPr sz="2400" b="1">
                 <a:solidFill>
                   <a:srgbClr val="316CE3"/>
                 </a:solidFill>
@@ -26975,7 +27046,7 @@
               </a:spcAft>
             </a:pPr>
             <a:r>
-              <a:rPr sz="2300" b="0">
+              <a:rPr sz="2100" b="0">
                 <a:solidFill>
                   <a:srgbClr val="D9E2EC"/>
                 </a:solidFill>
@@ -26988,13 +27059,88 @@
       </p:sp>
       <p:sp>
         <p:nvSpPr>
-          <p:cNvPr id="13" name="TextBox 12"/>
+          <p:cNvPr id="13" name="Rounded Rectangle 12"/>
+          <p:cNvSpPr/>
+          <p:nvPr/>
+        </p:nvSpPr>
+        <p:spPr>
+          <a:xfrm>
+            <a:off x="11544299" y="3200400"/>
+            <a:ext cx="3268979" cy="3108960"/>
+          </a:xfrm>
+          <a:prstGeom prst="roundRect">
+            <a:avLst>
+              <a:gd name="adj" fmla="val 8000"/>
+            </a:avLst>
+          </a:prstGeom>
+          <a:solidFill>
+            <a:srgbClr val="2F3D52"/>
+          </a:solidFill>
+          <a:ln>
+            <a:noFill/>
+          </a:ln>
+          <a:effectLst/>
+        </p:spPr>
+        <p:style>
+          <a:lnRef idx="1">
+            <a:schemeClr val="accent1"/>
+          </a:lnRef>
+          <a:fillRef idx="3">
+            <a:schemeClr val="accent1"/>
+          </a:fillRef>
+          <a:effectRef idx="2">
+            <a:schemeClr val="accent1"/>
+          </a:effectRef>
+          <a:fontRef idx="minor">
+            <a:schemeClr val="lt1"/>
+          </a:fontRef>
+        </p:style>
+        <p:txBody>
+          <a:bodyPr rtlCol="0" anchor="t" wrap="square" lIns="274320" rIns="274320" tIns="228600" bIns="228600"/>
+          <a:lstStyle/>
+          <a:p>
+            <a:pPr algn="ctr">
+              <a:spcAft>
+                <a:spcPts val="800"/>
+              </a:spcAft>
+            </a:pPr>
+            <a:r>
+              <a:rPr sz="2400" b="1">
+                <a:solidFill>
+                  <a:srgbClr val="316CE3"/>
+                </a:solidFill>
+                <a:latin typeface="Arial"/>
+              </a:rPr>
+              <a:t>Pregunta 4</a:t>
+            </a:r>
+          </a:p>
+          <a:p>
+            <a:pPr>
+              <a:spcAft>
+                <a:spcPts val="600"/>
+              </a:spcAft>
+            </a:pPr>
+            <a:r>
+              <a:rPr sz="2100" b="0">
+                <a:solidFill>
+                  <a:srgbClr val="D9E2EC"/>
+                </a:solidFill>
+                <a:latin typeface="Arial"/>
+              </a:rPr>
+              <a:t>En el simulacro de migración (elastic resize), ¿cuánto tiempo estuvo el clúster sin aceptar escrituras?</a:t>
+            </a:r>
+          </a:p>
+        </p:txBody>
+      </p:sp>
+      <p:sp>
+        <p:nvSpPr>
+          <p:cNvPr id="14" name="TextBox 13"/>
           <p:cNvSpPr txBox="1"/>
           <p:nvPr/>
         </p:nvSpPr>
         <p:spPr>
           <a:xfrm>
-            <a:off x="914400" y="6583680"/>
+            <a:off x="914400" y="6766560"/>
             <a:ext cx="13898880" cy="914400"/>
           </a:xfrm>
           <a:prstGeom prst="rect">
@@ -27034,6 +27180,601 @@
 </file>
 
 <file path=ppt/slides/slide36.xml><?xml version="1.0" encoding="utf-8"?>
+<p:sld xmlns:p="http://schemas.openxmlformats.org/presentationml/2006/main" xmlns:a="http://schemas.openxmlformats.org/drawingml/2006/main" xmlns:r="http://schemas.openxmlformats.org/officeDocument/2006/relationships">
+  <p:cSld>
+    <p:bg>
+      <p:bgPr>
+        <a:solidFill>
+          <a:srgbClr val="232E3E"/>
+        </a:solidFill>
+      </p:bgPr>
+    </p:bg>
+    <p:spTree>
+      <p:nvGrpSpPr>
+        <p:cNvPr id="1" name=""/>
+        <p:cNvGrpSpPr/>
+        <p:nvPr/>
+      </p:nvGrpSpPr>
+      <p:grpSpPr>
+        <a:xfrm>
+          <a:off x="0" y="0"/>
+          <a:ext cx="0" cy="0"/>
+          <a:chOff x="0" y="0"/>
+          <a:chExt cx="0" cy="0"/>
+        </a:xfrm>
+      </p:grpSpPr>
+      <p:sp>
+        <p:nvSpPr>
+          <p:cNvPr name="Freeform 2" id="2"/>
+          <p:cNvSpPr/>
+          <p:nvPr/>
+        </p:nvSpPr>
+        <p:spPr>
+          <a:xfrm flipH="false" flipV="false" rot="0">
+            <a:off x="0" y="0"/>
+            <a:ext cx="18288000" cy="10287000"/>
+          </a:xfrm>
+          <a:custGeom>
+            <a:avLst/>
+            <a:gdLst/>
+            <a:ahLst/>
+            <a:cxnLst/>
+            <a:rect r="r" b="b" t="t" l="l"/>
+            <a:pathLst>
+              <a:path h="10287000" w="18288000">
+                <a:moveTo>
+                  <a:pt x="0" y="0"/>
+                </a:moveTo>
+                <a:lnTo>
+                  <a:pt x="18288000" y="0"/>
+                </a:lnTo>
+                <a:lnTo>
+                  <a:pt x="18288000" y="10287000"/>
+                </a:lnTo>
+                <a:lnTo>
+                  <a:pt x="0" y="10287000"/>
+                </a:lnTo>
+                <a:lnTo>
+                  <a:pt x="0" y="0"/>
+                </a:lnTo>
+                <a:close/>
+              </a:path>
+            </a:pathLst>
+          </a:custGeom>
+          <a:blipFill>
+            <a:blip r:embed="rId2"/>
+            <a:stretch>
+              <a:fillRect l="0" t="0" r="0" b="0"/>
+            </a:stretch>
+          </a:blipFill>
+        </p:spPr>
+        <p:txBody>
+          <a:bodyPr/>
+          <a:p/>
+        </p:txBody>
+      </p:sp>
+      <p:sp>
+        <p:nvSpPr>
+          <p:cNvPr name="TextBox 3" id="3"/>
+          <p:cNvSpPr txBox="true"/>
+          <p:nvPr/>
+        </p:nvSpPr>
+        <p:spPr>
+          <a:xfrm rot="0">
+            <a:off x="3520440" y="868680"/>
+            <a:ext cx="12070080" cy="1874519"/>
+          </a:xfrm>
+          <a:prstGeom prst="rect">
+            <a:avLst/>
+          </a:prstGeom>
+        </p:spPr>
+        <p:txBody>
+          <a:bodyPr anchor="ctr" rtlCol="false" tIns="0" lIns="0" bIns="0" rIns="0" wrap="square">
+            <a:spAutoFit/>
+          </a:bodyPr>
+          <a:lstStyle/>
+          <a:p>
+            <a:pPr algn="l" marL="0" indent="0" lvl="0">
+              <a:lnSpc>
+                <a:spcPts val="10481"/>
+              </a:lnSpc>
+              <a:spcBef>
+                <a:spcPct val="0"/>
+              </a:spcBef>
+            </a:pPr>
+            <a:r>
+              <a:rPr lang="en-US" b="0" sz="5400">
+                <a:solidFill>
+                  <a:srgbClr val="FFFFFF"/>
+                </a:solidFill>
+                <a:latin typeface="Arial Black"/>
+                <a:ea typeface="Arial Black"/>
+                <a:cs typeface="Arial Black"/>
+                <a:sym typeface="Arial Black"/>
+              </a:rPr>
+              <a:t>Kahoot</a:t>
+            </a:r>
+          </a:p>
+        </p:txBody>
+      </p:sp>
+      <p:sp>
+        <p:nvSpPr>
+          <p:cNvPr name="Freeform 4" id="4"/>
+          <p:cNvSpPr/>
+          <p:nvPr/>
+        </p:nvSpPr>
+        <p:spPr>
+          <a:xfrm flipH="false" flipV="false" rot="0">
+            <a:off x="536304" y="308054"/>
+            <a:ext cx="650696" cy="409939"/>
+          </a:xfrm>
+          <a:custGeom>
+            <a:avLst/>
+            <a:gdLst/>
+            <a:ahLst/>
+            <a:cxnLst/>
+            <a:rect r="r" b="b" t="t" l="l"/>
+            <a:pathLst>
+              <a:path h="409939" w="650696">
+                <a:moveTo>
+                  <a:pt x="0" y="0"/>
+                </a:moveTo>
+                <a:lnTo>
+                  <a:pt x="650697" y="0"/>
+                </a:lnTo>
+                <a:lnTo>
+                  <a:pt x="650697" y="409938"/>
+                </a:lnTo>
+                <a:lnTo>
+                  <a:pt x="0" y="409938"/>
+                </a:lnTo>
+                <a:lnTo>
+                  <a:pt x="0" y="0"/>
+                </a:lnTo>
+                <a:close/>
+              </a:path>
+            </a:pathLst>
+          </a:custGeom>
+          <a:blipFill>
+            <a:blip r:embed="rId3">
+              <a:extLst>
+                <a:ext uri="{96DAC541-7B7A-43D3-8B79-37D633B846F1}">
+                  <asvg:svgBlip xmlns:asvg="http://schemas.microsoft.com/office/drawing/2016/SVG/main" r:embed="rId4"/>
+                </a:ext>
+              </a:extLst>
+            </a:blip>
+            <a:stretch>
+              <a:fillRect l="0" t="0" r="0" b="0"/>
+            </a:stretch>
+          </a:blipFill>
+        </p:spPr>
+      </p:sp>
+      <p:grpSp>
+        <p:nvGrpSpPr>
+          <p:cNvPr name="Group 5" id="5"/>
+          <p:cNvGrpSpPr/>
+          <p:nvPr/>
+        </p:nvGrpSpPr>
+        <p:grpSpPr>
+          <a:xfrm rot="0">
+            <a:off x="219785" y="9070932"/>
+            <a:ext cx="4151107" cy="986035"/>
+            <a:chOff x="0" y="0"/>
+            <a:chExt cx="5534810" cy="1314713"/>
+          </a:xfrm>
+        </p:grpSpPr>
+        <p:sp>
+          <p:nvSpPr>
+            <p:cNvPr name="Freeform 6" id="6"/>
+            <p:cNvSpPr/>
+            <p:nvPr/>
+          </p:nvSpPr>
+          <p:spPr>
+            <a:xfrm flipH="false" flipV="false" rot="0">
+              <a:off x="0" y="0"/>
+              <a:ext cx="1314713" cy="1314713"/>
+            </a:xfrm>
+            <a:custGeom>
+              <a:avLst/>
+              <a:gdLst/>
+              <a:ahLst/>
+              <a:cxnLst/>
+              <a:rect r="r" b="b" t="t" l="l"/>
+              <a:pathLst>
+                <a:path h="1314713" w="1314713">
+                  <a:moveTo>
+                    <a:pt x="0" y="0"/>
+                  </a:moveTo>
+                  <a:lnTo>
+                    <a:pt x="1314713" y="0"/>
+                  </a:lnTo>
+                  <a:lnTo>
+                    <a:pt x="1314713" y="1314713"/>
+                  </a:lnTo>
+                  <a:lnTo>
+                    <a:pt x="0" y="1314713"/>
+                  </a:lnTo>
+                  <a:lnTo>
+                    <a:pt x="0" y="0"/>
+                  </a:lnTo>
+                  <a:close/>
+                </a:path>
+              </a:pathLst>
+            </a:custGeom>
+            <a:blipFill>
+              <a:blip r:embed="rId5">
+                <a:extLst>
+                  <a:ext uri="{96DAC541-7B7A-43D3-8B79-37D633B846F1}">
+                    <asvg:svgBlip xmlns:asvg="http://schemas.microsoft.com/office/drawing/2016/SVG/main" r:embed="rId6"/>
+                  </a:ext>
+                </a:extLst>
+              </a:blip>
+              <a:stretch>
+                <a:fillRect l="0" t="0" r="0" b="0"/>
+              </a:stretch>
+            </a:blipFill>
+          </p:spPr>
+        </p:sp>
+        <p:sp>
+          <p:nvSpPr>
+            <p:cNvPr name="TextBox 7" id="7"/>
+            <p:cNvSpPr txBox="true"/>
+            <p:nvPr/>
+          </p:nvSpPr>
+          <p:spPr>
+            <a:xfrm rot="0">
+              <a:off x="1455753" y="151974"/>
+              <a:ext cx="3148240" cy="462308"/>
+            </a:xfrm>
+            <a:prstGeom prst="rect">
+              <a:avLst/>
+            </a:prstGeom>
+          </p:spPr>
+          <p:txBody>
+            <a:bodyPr anchor="t" rtlCol="false" tIns="0" lIns="0" bIns="0" rIns="0">
+              <a:spAutoFit/>
+            </a:bodyPr>
+            <a:lstStyle/>
+            <a:p>
+              <a:pPr algn="l">
+                <a:lnSpc>
+                  <a:spcPts val="2702"/>
+                </a:lnSpc>
+              </a:pPr>
+              <a:r>
+                <a:rPr lang="en-US" b="true" sz="2252">
+                  <a:solidFill>
+                    <a:srgbClr val="FFFFFF"/>
+                  </a:solidFill>
+                  <a:latin typeface="Raleway 1 Bold"/>
+                  <a:ea typeface="Raleway 1 Bold"/>
+                  <a:cs typeface="Raleway 1 Bold"/>
+                  <a:sym typeface="Raleway 1 Bold"/>
+                </a:rPr>
+                <a:t>OCTUBRE</a:t>
+              </a:r>
+            </a:p>
+          </p:txBody>
+        </p:sp>
+        <p:sp>
+          <p:nvSpPr>
+            <p:cNvPr name="TextBox 8" id="8"/>
+            <p:cNvSpPr txBox="true"/>
+            <p:nvPr/>
+          </p:nvSpPr>
+          <p:spPr>
+            <a:xfrm rot="0">
+              <a:off x="1468453" y="585710"/>
+              <a:ext cx="4066356" cy="565140"/>
+            </a:xfrm>
+            <a:prstGeom prst="rect">
+              <a:avLst/>
+            </a:prstGeom>
+          </p:spPr>
+          <p:txBody>
+            <a:bodyPr anchor="t" rtlCol="false" tIns="0" lIns="0" bIns="0" rIns="0">
+              <a:spAutoFit/>
+            </a:bodyPr>
+            <a:lstStyle/>
+            <a:p>
+              <a:pPr algn="l">
+                <a:lnSpc>
+                  <a:spcPts val="1130"/>
+                </a:lnSpc>
+              </a:pPr>
+              <a:r>
+                <a:rPr lang="en-US" sz="1097" b="true">
+                  <a:solidFill>
+                    <a:srgbClr val="FFFFFF"/>
+                  </a:solidFill>
+                  <a:latin typeface="Raleway 1 Bold"/>
+                  <a:ea typeface="Raleway 1 Bold"/>
+                  <a:cs typeface="Raleway 1 Bold"/>
+                  <a:sym typeface="Raleway 1 Bold"/>
+                </a:rPr>
+                <a:t>Mes de </a:t>
+              </a:r>
+            </a:p>
+            <a:p>
+              <a:pPr algn="l">
+                <a:lnSpc>
+                  <a:spcPts val="2059"/>
+                </a:lnSpc>
+              </a:pPr>
+              <a:r>
+                <a:rPr lang="en-US" b="true" sz="1999">
+                  <a:solidFill>
+                    <a:srgbClr val="FFFFFF"/>
+                  </a:solidFill>
+                  <a:latin typeface="Raleway 1 Bold"/>
+                  <a:ea typeface="Raleway 1 Bold"/>
+                  <a:cs typeface="Raleway 1 Bold"/>
+                  <a:sym typeface="Raleway 1 Bold"/>
+                </a:rPr>
+                <a:t>HAN SOLO</a:t>
+              </a:r>
+            </a:p>
+          </p:txBody>
+        </p:sp>
+      </p:grpSp>
+      <p:sp>
+        <p:nvSpPr>
+          <p:cNvPr name="TextBox 9" id="9"/>
+          <p:cNvSpPr txBox="true"/>
+          <p:nvPr/>
+        </p:nvSpPr>
+        <p:spPr>
+          <a:xfrm rot="0">
+            <a:off x="1258571" y="221658"/>
+            <a:ext cx="15091730" cy="563680"/>
+          </a:xfrm>
+          <a:prstGeom prst="rect">
+            <a:avLst/>
+          </a:prstGeom>
+        </p:spPr>
+        <p:txBody>
+          <a:bodyPr anchor="t" rtlCol="false" tIns="0" lIns="0" bIns="0" rIns="0">
+            <a:spAutoFit/>
+          </a:bodyPr>
+          <a:lstStyle/>
+          <a:p>
+            <a:pPr algn="l">
+              <a:lnSpc>
+                <a:spcPts val="1760"/>
+              </a:lnSpc>
+            </a:pPr>
+            <a:r>
+              <a:rPr lang="en-US" sz="2000">
+                <a:solidFill>
+                  <a:srgbClr val="316CE3"/>
+                </a:solidFill>
+                <a:latin typeface="Gotham"/>
+                <a:ea typeface="Gotham"/>
+                <a:cs typeface="Gotham"/>
+                <a:sym typeface="Gotham"/>
+              </a:rPr>
+              <a:t>HOY:</a:t>
+            </a:r>
+          </a:p>
+          <a:p>
+            <a:pPr algn="l">
+              <a:lnSpc>
+                <a:spcPts val="2528"/>
+              </a:lnSpc>
+            </a:pPr>
+            <a:r>
+              <a:rPr lang="en-US" sz="2873" b="true">
+                <a:solidFill>
+                  <a:srgbClr val="316CE3"/>
+                </a:solidFill>
+                <a:latin typeface="Gotham Bold"/>
+                <a:ea typeface="Gotham Bold"/>
+                <a:cs typeface="Gotham Bold"/>
+                <a:sym typeface="Gotham Bold"/>
+              </a:rPr>
+              <a:t>Episodio II — El Ataque de los Graviton: Infraestructura y rendimiento</a:t>
+            </a:r>
+          </a:p>
+        </p:txBody>
+      </p:sp>
+      <p:sp>
+        <p:nvSpPr>
+          <p:cNvPr id="10" name="Rounded Rectangle 9"/>
+          <p:cNvSpPr/>
+          <p:nvPr/>
+        </p:nvSpPr>
+        <p:spPr>
+          <a:xfrm>
+            <a:off x="914400" y="3200400"/>
+            <a:ext cx="6812279" cy="3108960"/>
+          </a:xfrm>
+          <a:prstGeom prst="roundRect">
+            <a:avLst>
+              <a:gd name="adj" fmla="val 8000"/>
+            </a:avLst>
+          </a:prstGeom>
+          <a:solidFill>
+            <a:srgbClr val="2F3D52"/>
+          </a:solidFill>
+          <a:ln>
+            <a:noFill/>
+          </a:ln>
+          <a:effectLst/>
+        </p:spPr>
+        <p:style>
+          <a:lnRef idx="1">
+            <a:schemeClr val="accent1"/>
+          </a:lnRef>
+          <a:fillRef idx="3">
+            <a:schemeClr val="accent1"/>
+          </a:fillRef>
+          <a:effectRef idx="2">
+            <a:schemeClr val="accent1"/>
+          </a:effectRef>
+          <a:fontRef idx="minor">
+            <a:schemeClr val="lt1"/>
+          </a:fontRef>
+        </p:style>
+        <p:txBody>
+          <a:bodyPr rtlCol="0" anchor="t" wrap="square" lIns="274320" rIns="274320" tIns="228600" bIns="228600"/>
+          <a:lstStyle/>
+          <a:p>
+            <a:pPr algn="ctr">
+              <a:spcAft>
+                <a:spcPts val="800"/>
+              </a:spcAft>
+            </a:pPr>
+            <a:r>
+              <a:rPr sz="2400" b="1">
+                <a:solidFill>
+                  <a:srgbClr val="316CE3"/>
+                </a:solidFill>
+                <a:latin typeface="Arial"/>
+              </a:rPr>
+              <a:t>Pregunta 1</a:t>
+            </a:r>
+          </a:p>
+          <a:p>
+            <a:pPr>
+              <a:spcAft>
+                <a:spcPts val="600"/>
+              </a:spcAft>
+            </a:pPr>
+            <a:r>
+              <a:rPr sz="2100" b="0">
+                <a:solidFill>
+                  <a:srgbClr val="D9E2EC"/>
+                </a:solidFill>
+                <a:latin typeface="Arial"/>
+              </a:rPr>
+              <a:t>¿Qué procesadores usan los nuevos nodos RG de Redshift?</a:t>
+            </a:r>
+          </a:p>
+        </p:txBody>
+      </p:sp>
+      <p:sp>
+        <p:nvSpPr>
+          <p:cNvPr id="11" name="Rounded Rectangle 10"/>
+          <p:cNvSpPr/>
+          <p:nvPr/>
+        </p:nvSpPr>
+        <p:spPr>
+          <a:xfrm>
+            <a:off x="8001000" y="3200400"/>
+            <a:ext cx="6812279" cy="3108960"/>
+          </a:xfrm>
+          <a:prstGeom prst="roundRect">
+            <a:avLst>
+              <a:gd name="adj" fmla="val 8000"/>
+            </a:avLst>
+          </a:prstGeom>
+          <a:solidFill>
+            <a:srgbClr val="2F3D52"/>
+          </a:solidFill>
+          <a:ln>
+            <a:noFill/>
+          </a:ln>
+          <a:effectLst/>
+        </p:spPr>
+        <p:style>
+          <a:lnRef idx="1">
+            <a:schemeClr val="accent1"/>
+          </a:lnRef>
+          <a:fillRef idx="3">
+            <a:schemeClr val="accent1"/>
+          </a:fillRef>
+          <a:effectRef idx="2">
+            <a:schemeClr val="accent1"/>
+          </a:effectRef>
+          <a:fontRef idx="minor">
+            <a:schemeClr val="lt1"/>
+          </a:fontRef>
+        </p:style>
+        <p:txBody>
+          <a:bodyPr rtlCol="0" anchor="t" wrap="square" lIns="274320" rIns="274320" tIns="228600" bIns="228600"/>
+          <a:lstStyle/>
+          <a:p>
+            <a:pPr algn="ctr">
+              <a:spcAft>
+                <a:spcPts val="800"/>
+              </a:spcAft>
+            </a:pPr>
+            <a:r>
+              <a:rPr sz="2400" b="1">
+                <a:solidFill>
+                  <a:srgbClr val="316CE3"/>
+                </a:solidFill>
+                <a:latin typeface="Arial"/>
+              </a:rPr>
+              <a:t>Pregunta 2</a:t>
+            </a:r>
+          </a:p>
+          <a:p>
+            <a:pPr>
+              <a:spcAft>
+                <a:spcPts val="600"/>
+              </a:spcAft>
+            </a:pPr>
+            <a:r>
+              <a:rPr sz="2100" b="0">
+                <a:solidFill>
+                  <a:srgbClr val="D9E2EC"/>
+                </a:solidFill>
+                <a:latin typeface="Arial"/>
+              </a:rPr>
+              <a:t>¿Cuánto menos cuesta RG por vCPU frente a RA3?</a:t>
+            </a:r>
+          </a:p>
+        </p:txBody>
+      </p:sp>
+      <p:sp>
+        <p:nvSpPr>
+          <p:cNvPr id="12" name="TextBox 11"/>
+          <p:cNvSpPr txBox="1"/>
+          <p:nvPr/>
+        </p:nvSpPr>
+        <p:spPr>
+          <a:xfrm>
+            <a:off x="914400" y="6766560"/>
+            <a:ext cx="13898880" cy="914400"/>
+          </a:xfrm>
+          <a:prstGeom prst="rect">
+            <a:avLst/>
+          </a:prstGeom>
+          <a:noFill/>
+        </p:spPr>
+        <p:txBody>
+          <a:bodyPr wrap="square" anchor="t" lIns="0" rIns="0" tIns="0" bIns="0">
+            <a:spAutoFit/>
+          </a:bodyPr>
+          <a:lstStyle/>
+          <a:p>
+            <a:pPr algn="l">
+              <a:spcAft>
+                <a:spcPts val="1000"/>
+              </a:spcAft>
+            </a:pPr>
+            <a:r>
+              <a:rPr sz="2000" b="0">
+                <a:solidFill>
+                  <a:srgbClr val="9FB3C8"/>
+                </a:solidFill>
+                <a:latin typeface="Arial"/>
+              </a:rPr>
+              <a:t>Las respuestas y los comentarios están en las notas.</a:t>
+            </a:r>
+          </a:p>
+        </p:txBody>
+      </p:sp>
+    </p:spTree>
+  </p:cSld>
+  <p:clrMapOvr>
+    <a:masterClrMapping/>
+  </p:clrMapOvr>
+</p:sld>
+</file>
+
+<file path=ppt/slides/slide37.xml><?xml version="1.0" encoding="utf-8"?>
 <p:sld xmlns:p="http://schemas.openxmlformats.org/presentationml/2006/main" xmlns:a="http://schemas.openxmlformats.org/drawingml/2006/main" xmlns:r="http://schemas.openxmlformats.org/officeDocument/2006/relationships">
   <p:cSld>
     <p:bg>

</xml_diff>

<commit_message>
feat(slides): quiz and Kahoot options on the slides, answer in green, one funny option each
Quiz split over two slides (2 questions each) plus Kahoot (38 slides); the
"answers in the notes" line is gone; preguntas.md regenerated.

Co-Authored-By: Claude Opus 5.5 <noreply@anthropic.com>
Claude-Session: https://claude.ai/code/session_01HgWRiJoTFne1e49sP1svEg
</commit_message>
<xml_diff>
--- a/slides/redshift-redemption.pptx
+++ b/slides/redshift-redemption.pptx
@@ -42,6 +42,7 @@
     <p:sldId id="304" r:id="rId59"/>
     <p:sldId id="305" r:id="rId60"/>
     <p:sldId id="306" r:id="rId61"/>
+    <p:sldId id="307" r:id="rId62"/>
   </p:sldIdLst>
   <p:sldSz cx="18288000" cy="10287000"/>
   <p:notesSz cx="6858000" cy="9144000"/>
@@ -4702,7 +4703,7 @@
           <a:lstStyle/>
           <a:p>
             <a:r>
-              <a:t>Quiz. Pregunta 1: ¿Con qué lee RG los datos del data lake? a) Redshift Spectrum; b) Con sus propios nodos, sin Spectrum (correcta); c) Amazon Athena; d) Trabajos de AWS Glue. Comentario: RA3 usa Spectrum, que cobra USD 5 por TB leído; RG lee el data lake con sus propios nodos y sin ese cobro. Pregunta 2: ¿Qué tipo de consultas mejoró más al pasar de RA3 a RG? a) Las de cálculo pesado (ventanas, joins grandes); b) Ninguna, quedaron igual; c) Las que leen y agregan muchos datos (correcta); d) Solo las del data lake. Comentario: 2,28 veces en lectura contra 1,58 en cálculo; el promedio de las 20 consultas fue 1,90. Pregunta 3: Si tienes 4 nodos ra3.4xlarge, ¿cuántos rg.4xlarge recomienda AWS? a) 3 (correcta); b) 4; c) 2; d) 8. Comentario: Un ra3.4xlarge tiene 12 vCPU y un rg.4xlarge, 16: 4 × 12 = 3 × 16 = 48. Migrar uno a uno en ese tamaño deja un tercio de capacidad de más. Pregunta 4: En el simulacro de migración (elastic resize), ¿cuánto tiempo estuvo el clúster sin aceptar escrituras? a) Nada, siempre aceptó escrituras; b) Unos 30 minutos; c) Varias horas; d) Entre 1,5 y 3 minutos (correcta). Comentario: Entre 1 min 35 s y 2 min 42 s; el resize completo tomó 2 min 48 s.</a:t>
+              <a:t>Quiz (1 de 2). ¿Con qué lee RG los datos del data lake? Correcta: b) Con sus propios nodos, sin Spectrum. RA3 usa Spectrum, que cobra USD 5 por TB leído; RG lee el data lake con sus propios nodos y sin ese cobro. ¿Qué tipo de consultas mejoró más al pasar de RA3 a RG? Correcta: c) Las que leen y agregan muchos datos. 2,28 veces en lectura contra 1,58 en cálculo; el promedio de las 20 consultas fue 1,90.</a:t>
             </a:r>
           </a:p>
         </p:txBody>
@@ -4772,7 +4773,7 @@
           <a:lstStyle/>
           <a:p>
             <a:r>
-              <a:t>Kahoot. Pregunta 1: ¿Qué procesadores usan los nuevos nodos RG de Redshift? a) Intel Xeon; b) AMD EPYC; c) AWS Graviton (correcta); d) Apple M. Comentario: RG usa Graviton, los procesadores Arm diseñados por AWS. Pregunta 2: ¿Cuánto menos cuesta RG por vCPU frente a RA3? a) 30 % (correcta); b) 10 %; c) 50 %; d) Cuesta lo mismo. Comentario: USD 1,086 entre 4 vCPU en ra3.xlplus contra 0,7602 entre 4 en rg.xlarge: 30 % menos.</a:t>
+              <a:t>Quiz (2 de 2). Si tienes 4 nodos ra3.4xlarge, ¿cuántos rg.4xlarge recomienda AWS? Correcta: a) 3. Un ra3.4xlarge tiene 12 vCPU y un rg.4xlarge, 16: 4 × 12 = 3 × 16 = 48. Migrar uno a uno en ese tamaño deja un tercio de capacidad de más. En el simulacro de migración (elastic resize), ¿cuánto tiempo estuvo el clúster sin aceptar escrituras? Correcta: d) Entre 1,5 y 3 minutos. Entre 1 min 35 s y 2 min 42 s; el resize completo tomó 2 min 48 s.</a:t>
             </a:r>
           </a:p>
         </p:txBody>
@@ -4798,6 +4799,76 @@
 </file>
 
 <file path=ppt/notesSlides/notesSlide37.xml><?xml version="1.0" encoding="utf-8"?>
+<p:notes xmlns:a="http://schemas.openxmlformats.org/drawingml/2006/main" xmlns:p="http://schemas.openxmlformats.org/presentationml/2006/main" xmlns:r="http://schemas.openxmlformats.org/officeDocument/2006/relationships">
+  <p:cSld>
+    <p:spTree>
+      <p:nvGrpSpPr>
+        <p:cNvPr id="1" name=""/>
+        <p:cNvGrpSpPr/>
+        <p:nvPr/>
+      </p:nvGrpSpPr>
+      <p:grpSpPr>
+        <a:xfrm>
+          <a:off x="0" y="0"/>
+          <a:ext cx="0" cy="0"/>
+          <a:chOff x="0" y="0"/>
+          <a:chExt cx="0" cy="0"/>
+        </a:xfrm>
+      </p:grpSpPr>
+      <p:sp>
+        <p:nvSpPr>
+          <p:cNvPr id="2" name="Slide Image Placeholder 1"/>
+          <p:cNvSpPr>
+            <a:spLocks noGrp="1"/>
+          </p:cNvSpPr>
+          <p:nvPr>
+            <p:ph type="sldImg" idx="2"/>
+          </p:nvPr>
+        </p:nvSpPr>
+        <p:spPr/>
+      </p:sp>
+      <p:sp>
+        <p:nvSpPr>
+          <p:cNvPr id="3" name="Notes Placeholder 2"/>
+          <p:cNvSpPr>
+            <a:spLocks noGrp="1"/>
+          </p:cNvSpPr>
+          <p:nvPr>
+            <p:ph type="body" idx="3" sz="quarter"/>
+          </p:nvPr>
+        </p:nvSpPr>
+        <p:spPr/>
+        <p:txBody>
+          <a:bodyPr/>
+          <a:lstStyle/>
+          <a:p>
+            <a:r>
+              <a:t>Kahoot. ¿Qué procesadores usan los nuevos nodos RG de Redshift? Correcta: c) AWS Graviton. RG usa Graviton, los procesadores Arm diseñados por AWS. ¿Cuánto menos cuesta RG por vCPU frente a RA3? Correcta: a) 30 %. USD 1,086 entre 4 vCPU en ra3.xlplus contra 0,7602 entre 4 en rg.xlarge: 30 % menos.</a:t>
+            </a:r>
+          </a:p>
+        </p:txBody>
+      </p:sp>
+      <p:sp>
+        <p:nvSpPr>
+          <p:cNvPr id="4" name="Slide Number Placeholder 3"/>
+          <p:cNvSpPr>
+            <a:spLocks noGrp="1"/>
+          </p:cNvSpPr>
+          <p:nvPr>
+            <p:ph type="sldNum" idx="5" sz="quarter"/>
+          </p:nvPr>
+        </p:nvSpPr>
+        <p:spPr/>
+      </p:sp>
+    </p:spTree>
+  </p:cSld>
+  <p:clrMapOvr>
+    <a:masterClrMapping/>
+  </p:clrMapOvr>
+</p:notes>
+</file>
+
+<file path=ppt/notesSlides/notesSlide38.xml><?xml version="1.0" encoding="utf-8"?>
 <p:notes xmlns:a="http://schemas.openxmlformats.org/drawingml/2006/main" xmlns:p="http://schemas.openxmlformats.org/presentationml/2006/main" xmlns:r="http://schemas.openxmlformats.org/officeDocument/2006/relationships">
   <p:cSld>
     <p:spTree>
@@ -26547,7 +26618,7 @@
                 <a:cs typeface="Arial Black"/>
                 <a:sym typeface="Arial Black"/>
               </a:rPr>
-              <a:t>Quiz</a:t>
+              <a:t>Quiz (1 de 2)</a:t>
             </a:r>
           </a:p>
         </p:txBody>
@@ -26841,7 +26912,7 @@
         <p:spPr>
           <a:xfrm>
             <a:off x="914400" y="3200400"/>
-            <a:ext cx="3268979" cy="3108960"/>
+            <a:ext cx="6812280" cy="4937760"/>
           </a:xfrm>
           <a:prstGeom prst="roundRect">
             <a:avLst>
@@ -26874,35 +26945,83 @@
           <a:bodyPr rtlCol="0" anchor="t" wrap="square" lIns="274320" rIns="274320" tIns="228600" bIns="228600"/>
           <a:lstStyle/>
           <a:p>
-            <a:pPr algn="ctr">
+            <a:pPr algn="l">
               <a:spcAft>
-                <a:spcPts val="800"/>
+                <a:spcPts val="1800"/>
               </a:spcAft>
             </a:pPr>
             <a:r>
-              <a:rPr sz="2400" b="1">
-                <a:solidFill>
-                  <a:srgbClr val="316CE3"/>
+              <a:rPr sz="2800" b="1">
+                <a:solidFill>
+                  <a:srgbClr val="FFFFFF"/>
                 </a:solidFill>
                 <a:latin typeface="Arial"/>
               </a:rPr>
-              <a:t>Pregunta 1</a:t>
-            </a:r>
-          </a:p>
-          <a:p>
-            <a:pPr>
+              <a:t>1. ¿Con qué lee RG los datos del data lake?</a:t>
+            </a:r>
+          </a:p>
+          <a:p>
+            <a:pPr algn="l">
               <a:spcAft>
-                <a:spcPts val="600"/>
+                <a:spcPts val="1200"/>
               </a:spcAft>
             </a:pPr>
             <a:r>
-              <a:rPr sz="2100" b="0">
+              <a:rPr sz="2700" b="0">
                 <a:solidFill>
                   <a:srgbClr val="D9E2EC"/>
                 </a:solidFill>
                 <a:latin typeface="Arial"/>
               </a:rPr>
-              <a:t>¿Con qué lee RG los datos del data lake?</a:t>
+              <a:t>a) Redshift Spectrum</a:t>
+            </a:r>
+          </a:p>
+          <a:p>
+            <a:pPr algn="l">
+              <a:spcAft>
+                <a:spcPts val="1200"/>
+              </a:spcAft>
+            </a:pPr>
+            <a:r>
+              <a:rPr sz="2700" b="1">
+                <a:solidFill>
+                  <a:srgbClr val="4CC38A"/>
+                </a:solidFill>
+                <a:latin typeface="Arial"/>
+              </a:rPr>
+              <a:t>b) Con sus propios nodos, sin Spectrum</a:t>
+            </a:r>
+          </a:p>
+          <a:p>
+            <a:pPr algn="l">
+              <a:spcAft>
+                <a:spcPts val="1200"/>
+              </a:spcAft>
+            </a:pPr>
+            <a:r>
+              <a:rPr sz="2700" b="0">
+                <a:solidFill>
+                  <a:srgbClr val="D9E2EC"/>
+                </a:solidFill>
+                <a:latin typeface="Arial"/>
+              </a:rPr>
+              <a:t>c) Amazon Athena</a:t>
+            </a:r>
+          </a:p>
+          <a:p>
+            <a:pPr algn="l">
+              <a:spcAft>
+                <a:spcPts val="1200"/>
+              </a:spcAft>
+            </a:pPr>
+            <a:r>
+              <a:rPr sz="2700" b="0">
+                <a:solidFill>
+                  <a:srgbClr val="D9E2EC"/>
+                </a:solidFill>
+                <a:latin typeface="Arial"/>
+              </a:rPr>
+              <a:t>d) Con la Fuerza, como los Jedi</a:t>
             </a:r>
           </a:p>
         </p:txBody>
@@ -26915,8 +27034,8 @@
         </p:nvSpPr>
         <p:spPr>
           <a:xfrm>
-            <a:off x="4457700" y="3200400"/>
-            <a:ext cx="3268979" cy="3108960"/>
+            <a:off x="8001000" y="3200400"/>
+            <a:ext cx="6812280" cy="4937760"/>
           </a:xfrm>
           <a:prstGeom prst="roundRect">
             <a:avLst>
@@ -26949,224 +27068,83 @@
           <a:bodyPr rtlCol="0" anchor="t" wrap="square" lIns="274320" rIns="274320" tIns="228600" bIns="228600"/>
           <a:lstStyle/>
           <a:p>
-            <a:pPr algn="ctr">
+            <a:pPr algn="l">
               <a:spcAft>
-                <a:spcPts val="800"/>
+                <a:spcPts val="1800"/>
               </a:spcAft>
             </a:pPr>
             <a:r>
-              <a:rPr sz="2400" b="1">
-                <a:solidFill>
-                  <a:srgbClr val="316CE3"/>
+              <a:rPr sz="2800" b="1">
+                <a:solidFill>
+                  <a:srgbClr val="FFFFFF"/>
                 </a:solidFill>
                 <a:latin typeface="Arial"/>
               </a:rPr>
-              <a:t>Pregunta 2</a:t>
-            </a:r>
-          </a:p>
-          <a:p>
-            <a:pPr>
+              <a:t>2. ¿Qué tipo de consultas mejoró más al pasar de RA3 a RG?</a:t>
+            </a:r>
+          </a:p>
+          <a:p>
+            <a:pPr algn="l">
               <a:spcAft>
-                <a:spcPts val="600"/>
+                <a:spcPts val="1200"/>
               </a:spcAft>
             </a:pPr>
             <a:r>
-              <a:rPr sz="2100" b="0">
+              <a:rPr sz="2700" b="0">
                 <a:solidFill>
                   <a:srgbClr val="D9E2EC"/>
                 </a:solidFill>
                 <a:latin typeface="Arial"/>
               </a:rPr>
-              <a:t>¿Qué tipo de consultas mejoró más al pasar de RA3 a RG?</a:t>
-            </a:r>
-          </a:p>
-        </p:txBody>
-      </p:sp>
-      <p:sp>
-        <p:nvSpPr>
-          <p:cNvPr id="12" name="Rounded Rectangle 11"/>
-          <p:cNvSpPr/>
-          <p:nvPr/>
-        </p:nvSpPr>
-        <p:spPr>
-          <a:xfrm>
-            <a:off x="8001000" y="3200400"/>
-            <a:ext cx="3268979" cy="3108960"/>
-          </a:xfrm>
-          <a:prstGeom prst="roundRect">
-            <a:avLst>
-              <a:gd name="adj" fmla="val 8000"/>
-            </a:avLst>
-          </a:prstGeom>
-          <a:solidFill>
-            <a:srgbClr val="2F3D52"/>
-          </a:solidFill>
-          <a:ln>
-            <a:noFill/>
-          </a:ln>
-          <a:effectLst/>
-        </p:spPr>
-        <p:style>
-          <a:lnRef idx="1">
-            <a:schemeClr val="accent1"/>
-          </a:lnRef>
-          <a:fillRef idx="3">
-            <a:schemeClr val="accent1"/>
-          </a:fillRef>
-          <a:effectRef idx="2">
-            <a:schemeClr val="accent1"/>
-          </a:effectRef>
-          <a:fontRef idx="minor">
-            <a:schemeClr val="lt1"/>
-          </a:fontRef>
-        </p:style>
-        <p:txBody>
-          <a:bodyPr rtlCol="0" anchor="t" wrap="square" lIns="274320" rIns="274320" tIns="228600" bIns="228600"/>
-          <a:lstStyle/>
-          <a:p>
-            <a:pPr algn="ctr">
+              <a:t>a) Las de cálculo pesado (ventanas, joins grandes)</a:t>
+            </a:r>
+          </a:p>
+          <a:p>
+            <a:pPr algn="l">
               <a:spcAft>
-                <a:spcPts val="800"/>
+                <a:spcPts val="1200"/>
               </a:spcAft>
             </a:pPr>
             <a:r>
-              <a:rPr sz="2400" b="1">
-                <a:solidFill>
-                  <a:srgbClr val="316CE3"/>
+              <a:rPr sz="2700" b="0">
+                <a:solidFill>
+                  <a:srgbClr val="D9E2EC"/>
                 </a:solidFill>
                 <a:latin typeface="Arial"/>
               </a:rPr>
-              <a:t>Pregunta 3</a:t>
-            </a:r>
-          </a:p>
-          <a:p>
-            <a:pPr>
+              <a:t>b) Las escritas en MAYÚSCULAS</a:t>
+            </a:r>
+          </a:p>
+          <a:p>
+            <a:pPr algn="l">
               <a:spcAft>
-                <a:spcPts val="600"/>
+                <a:spcPts val="1200"/>
               </a:spcAft>
             </a:pPr>
             <a:r>
-              <a:rPr sz="2100" b="0">
-                <a:solidFill>
-                  <a:srgbClr val="D9E2EC"/>
+              <a:rPr sz="2700" b="1">
+                <a:solidFill>
+                  <a:srgbClr val="4CC38A"/>
                 </a:solidFill>
                 <a:latin typeface="Arial"/>
               </a:rPr>
-              <a:t>Si tienes 4 nodos ra3.4xlarge, ¿cuántos rg.4xlarge recomienda AWS?</a:t>
-            </a:r>
-          </a:p>
-        </p:txBody>
-      </p:sp>
-      <p:sp>
-        <p:nvSpPr>
-          <p:cNvPr id="13" name="Rounded Rectangle 12"/>
-          <p:cNvSpPr/>
-          <p:nvPr/>
-        </p:nvSpPr>
-        <p:spPr>
-          <a:xfrm>
-            <a:off x="11544299" y="3200400"/>
-            <a:ext cx="3268979" cy="3108960"/>
-          </a:xfrm>
-          <a:prstGeom prst="roundRect">
-            <a:avLst>
-              <a:gd name="adj" fmla="val 8000"/>
-            </a:avLst>
-          </a:prstGeom>
-          <a:solidFill>
-            <a:srgbClr val="2F3D52"/>
-          </a:solidFill>
-          <a:ln>
-            <a:noFill/>
-          </a:ln>
-          <a:effectLst/>
-        </p:spPr>
-        <p:style>
-          <a:lnRef idx="1">
-            <a:schemeClr val="accent1"/>
-          </a:lnRef>
-          <a:fillRef idx="3">
-            <a:schemeClr val="accent1"/>
-          </a:fillRef>
-          <a:effectRef idx="2">
-            <a:schemeClr val="accent1"/>
-          </a:effectRef>
-          <a:fontRef idx="minor">
-            <a:schemeClr val="lt1"/>
-          </a:fontRef>
-        </p:style>
-        <p:txBody>
-          <a:bodyPr rtlCol="0" anchor="t" wrap="square" lIns="274320" rIns="274320" tIns="228600" bIns="228600"/>
-          <a:lstStyle/>
-          <a:p>
-            <a:pPr algn="ctr">
+              <a:t>c) Las que leen y agregan muchos datos</a:t>
+            </a:r>
+          </a:p>
+          <a:p>
+            <a:pPr algn="l">
               <a:spcAft>
-                <a:spcPts val="800"/>
+                <a:spcPts val="1200"/>
               </a:spcAft>
             </a:pPr>
             <a:r>
-              <a:rPr sz="2400" b="1">
-                <a:solidFill>
-                  <a:srgbClr val="316CE3"/>
+              <a:rPr sz="2700" b="0">
+                <a:solidFill>
+                  <a:srgbClr val="D9E2EC"/>
                 </a:solidFill>
                 <a:latin typeface="Arial"/>
               </a:rPr>
-              <a:t>Pregunta 4</a:t>
-            </a:r>
-          </a:p>
-          <a:p>
-            <a:pPr>
-              <a:spcAft>
-                <a:spcPts val="600"/>
-              </a:spcAft>
-            </a:pPr>
-            <a:r>
-              <a:rPr sz="2100" b="0">
-                <a:solidFill>
-                  <a:srgbClr val="D9E2EC"/>
-                </a:solidFill>
-                <a:latin typeface="Arial"/>
-              </a:rPr>
-              <a:t>En el simulacro de migración (elastic resize), ¿cuánto tiempo estuvo el clúster sin aceptar escrituras?</a:t>
-            </a:r>
-          </a:p>
-        </p:txBody>
-      </p:sp>
-      <p:sp>
-        <p:nvSpPr>
-          <p:cNvPr id="14" name="TextBox 13"/>
-          <p:cNvSpPr txBox="1"/>
-          <p:nvPr/>
-        </p:nvSpPr>
-        <p:spPr>
-          <a:xfrm>
-            <a:off x="914400" y="6766560"/>
-            <a:ext cx="13898880" cy="914400"/>
-          </a:xfrm>
-          <a:prstGeom prst="rect">
-            <a:avLst/>
-          </a:prstGeom>
-          <a:noFill/>
-        </p:spPr>
-        <p:txBody>
-          <a:bodyPr wrap="square" anchor="t" lIns="0" rIns="0" tIns="0" bIns="0">
-            <a:spAutoFit/>
-          </a:bodyPr>
-          <a:lstStyle/>
-          <a:p>
-            <a:pPr algn="l">
-              <a:spcAft>
-                <a:spcPts val="1000"/>
-              </a:spcAft>
-            </a:pPr>
-            <a:r>
-              <a:rPr sz="2000" b="0">
-                <a:solidFill>
-                  <a:srgbClr val="9FB3C8"/>
-                </a:solidFill>
-                <a:latin typeface="Arial"/>
-              </a:rPr>
-              <a:t>Las respuestas y los comentarios están en las notas.</a:t>
+              <a:t>d) Solo las del data lake</a:t>
             </a:r>
           </a:p>
         </p:txBody>
@@ -27292,7 +27270,7 @@
                 <a:cs typeface="Arial Black"/>
                 <a:sym typeface="Arial Black"/>
               </a:rPr>
-              <a:t>Kahoot</a:t>
+              <a:t>Quiz (2 de 2)</a:t>
             </a:r>
           </a:p>
         </p:txBody>
@@ -27586,7 +27564,7 @@
         <p:spPr>
           <a:xfrm>
             <a:off x="914400" y="3200400"/>
-            <a:ext cx="6812279" cy="3108960"/>
+            <a:ext cx="6812280" cy="4937760"/>
           </a:xfrm>
           <a:prstGeom prst="roundRect">
             <a:avLst>
@@ -27619,35 +27597,83 @@
           <a:bodyPr rtlCol="0" anchor="t" wrap="square" lIns="274320" rIns="274320" tIns="228600" bIns="228600"/>
           <a:lstStyle/>
           <a:p>
-            <a:pPr algn="ctr">
+            <a:pPr algn="l">
               <a:spcAft>
-                <a:spcPts val="800"/>
+                <a:spcPts val="1800"/>
               </a:spcAft>
             </a:pPr>
             <a:r>
-              <a:rPr sz="2400" b="1">
-                <a:solidFill>
-                  <a:srgbClr val="316CE3"/>
+              <a:rPr sz="2800" b="1">
+                <a:solidFill>
+                  <a:srgbClr val="FFFFFF"/>
                 </a:solidFill>
                 <a:latin typeface="Arial"/>
               </a:rPr>
-              <a:t>Pregunta 1</a:t>
-            </a:r>
-          </a:p>
-          <a:p>
-            <a:pPr>
+              <a:t>3. Si tienes 4 nodos ra3.4xlarge, ¿cuántos rg.4xlarge recomienda AWS?</a:t>
+            </a:r>
+          </a:p>
+          <a:p>
+            <a:pPr algn="l">
               <a:spcAft>
-                <a:spcPts val="600"/>
+                <a:spcPts val="1200"/>
               </a:spcAft>
             </a:pPr>
             <a:r>
-              <a:rPr sz="2100" b="0">
+              <a:rPr sz="2700" b="1">
+                <a:solidFill>
+                  <a:srgbClr val="4CC38A"/>
+                </a:solidFill>
+                <a:latin typeface="Arial"/>
+              </a:rPr>
+              <a:t>a) 3</a:t>
+            </a:r>
+          </a:p>
+          <a:p>
+            <a:pPr algn="l">
+              <a:spcAft>
+                <a:spcPts val="1200"/>
+              </a:spcAft>
+            </a:pPr>
+            <a:r>
+              <a:rPr sz="2700" b="0">
                 <a:solidFill>
                   <a:srgbClr val="D9E2EC"/>
                 </a:solidFill>
                 <a:latin typeface="Arial"/>
               </a:rPr>
-              <a:t>¿Qué procesadores usan los nuevos nodos RG de Redshift?</a:t>
+              <a:t>b) 4</a:t>
+            </a:r>
+          </a:p>
+          <a:p>
+            <a:pPr algn="l">
+              <a:spcAft>
+                <a:spcPts val="1200"/>
+              </a:spcAft>
+            </a:pPr>
+            <a:r>
+              <a:rPr sz="2700" b="0">
+                <a:solidFill>
+                  <a:srgbClr val="D9E2EC"/>
+                </a:solidFill>
+                <a:latin typeface="Arial"/>
+              </a:rPr>
+              <a:t>c) 42, obviamente</a:t>
+            </a:r>
+          </a:p>
+          <a:p>
+            <a:pPr algn="l">
+              <a:spcAft>
+                <a:spcPts val="1200"/>
+              </a:spcAft>
+            </a:pPr>
+            <a:r>
+              <a:rPr sz="2700" b="0">
+                <a:solidFill>
+                  <a:srgbClr val="D9E2EC"/>
+                </a:solidFill>
+                <a:latin typeface="Arial"/>
+              </a:rPr>
+              <a:t>d) 8</a:t>
             </a:r>
           </a:p>
         </p:txBody>
@@ -27661,7 +27687,7 @@
         <p:spPr>
           <a:xfrm>
             <a:off x="8001000" y="3200400"/>
-            <a:ext cx="6812279" cy="3108960"/>
+            <a:ext cx="6812280" cy="4937760"/>
           </a:xfrm>
           <a:prstGeom prst="roundRect">
             <a:avLst>
@@ -27694,74 +27720,83 @@
           <a:bodyPr rtlCol="0" anchor="t" wrap="square" lIns="274320" rIns="274320" tIns="228600" bIns="228600"/>
           <a:lstStyle/>
           <a:p>
-            <a:pPr algn="ctr">
+            <a:pPr algn="l">
               <a:spcAft>
-                <a:spcPts val="800"/>
+                <a:spcPts val="1800"/>
               </a:spcAft>
             </a:pPr>
             <a:r>
-              <a:rPr sz="2400" b="1">
-                <a:solidFill>
-                  <a:srgbClr val="316CE3"/>
+              <a:rPr sz="2800" b="1">
+                <a:solidFill>
+                  <a:srgbClr val="FFFFFF"/>
                 </a:solidFill>
                 <a:latin typeface="Arial"/>
               </a:rPr>
-              <a:t>Pregunta 2</a:t>
-            </a:r>
-          </a:p>
-          <a:p>
-            <a:pPr>
+              <a:t>4. En el simulacro de migración (elastic resize), ¿cuánto tiempo estuvo el clúster sin aceptar escrituras?</a:t>
+            </a:r>
+          </a:p>
+          <a:p>
+            <a:pPr algn="l">
               <a:spcAft>
-                <a:spcPts val="600"/>
+                <a:spcPts val="1200"/>
               </a:spcAft>
             </a:pPr>
             <a:r>
-              <a:rPr sz="2100" b="0">
+              <a:rPr sz="2700" b="0">
                 <a:solidFill>
                   <a:srgbClr val="D9E2EC"/>
                 </a:solidFill>
                 <a:latin typeface="Arial"/>
               </a:rPr>
-              <a:t>¿Cuánto menos cuesta RG por vCPU frente a RA3?</a:t>
-            </a:r>
-          </a:p>
-        </p:txBody>
-      </p:sp>
-      <p:sp>
-        <p:nvSpPr>
-          <p:cNvPr id="12" name="TextBox 11"/>
-          <p:cNvSpPr txBox="1"/>
-          <p:nvPr/>
-        </p:nvSpPr>
-        <p:spPr>
-          <a:xfrm>
-            <a:off x="914400" y="6766560"/>
-            <a:ext cx="13898880" cy="914400"/>
-          </a:xfrm>
-          <a:prstGeom prst="rect">
-            <a:avLst/>
-          </a:prstGeom>
-          <a:noFill/>
-        </p:spPr>
-        <p:txBody>
-          <a:bodyPr wrap="square" anchor="t" lIns="0" rIns="0" tIns="0" bIns="0">
-            <a:spAutoFit/>
-          </a:bodyPr>
-          <a:lstStyle/>
+              <a:t>a) Nada, siempre aceptó escrituras</a:t>
+            </a:r>
+          </a:p>
           <a:p>
             <a:pPr algn="l">
               <a:spcAft>
-                <a:spcPts val="1000"/>
+                <a:spcPts val="1200"/>
               </a:spcAft>
             </a:pPr>
             <a:r>
-              <a:rPr sz="2000" b="0">
-                <a:solidFill>
-                  <a:srgbClr val="9FB3C8"/>
+              <a:rPr sz="2700" b="0">
+                <a:solidFill>
+                  <a:srgbClr val="D9E2EC"/>
                 </a:solidFill>
                 <a:latin typeface="Arial"/>
               </a:rPr>
-              <a:t>Las respuestas y los comentarios están en las notas.</a:t>
+              <a:t>b) Unos 30 minutos</a:t>
+            </a:r>
+          </a:p>
+          <a:p>
+            <a:pPr algn="l">
+              <a:spcAft>
+                <a:spcPts val="1200"/>
+              </a:spcAft>
+            </a:pPr>
+            <a:r>
+              <a:rPr sz="2700" b="0">
+                <a:solidFill>
+                  <a:srgbClr val="D9E2EC"/>
+                </a:solidFill>
+                <a:latin typeface="Arial"/>
+              </a:rPr>
+              <a:t>c) Hasta que terminara esta charla</a:t>
+            </a:r>
+          </a:p>
+          <a:p>
+            <a:pPr algn="l">
+              <a:spcAft>
+                <a:spcPts val="1200"/>
+              </a:spcAft>
+            </a:pPr>
+            <a:r>
+              <a:rPr sz="2700" b="1">
+                <a:solidFill>
+                  <a:srgbClr val="4CC38A"/>
+                </a:solidFill>
+                <a:latin typeface="Arial"/>
+              </a:rPr>
+              <a:t>d) Entre 1,5 y 3 minutos</a:t>
             </a:r>
           </a:p>
         </p:txBody>
@@ -27775,6 +27810,658 @@
 </file>
 
 <file path=ppt/slides/slide37.xml><?xml version="1.0" encoding="utf-8"?>
+<p:sld xmlns:p="http://schemas.openxmlformats.org/presentationml/2006/main" xmlns:a="http://schemas.openxmlformats.org/drawingml/2006/main" xmlns:r="http://schemas.openxmlformats.org/officeDocument/2006/relationships">
+  <p:cSld>
+    <p:bg>
+      <p:bgPr>
+        <a:solidFill>
+          <a:srgbClr val="232E3E"/>
+        </a:solidFill>
+      </p:bgPr>
+    </p:bg>
+    <p:spTree>
+      <p:nvGrpSpPr>
+        <p:cNvPr id="1" name=""/>
+        <p:cNvGrpSpPr/>
+        <p:nvPr/>
+      </p:nvGrpSpPr>
+      <p:grpSpPr>
+        <a:xfrm>
+          <a:off x="0" y="0"/>
+          <a:ext cx="0" cy="0"/>
+          <a:chOff x="0" y="0"/>
+          <a:chExt cx="0" cy="0"/>
+        </a:xfrm>
+      </p:grpSpPr>
+      <p:sp>
+        <p:nvSpPr>
+          <p:cNvPr name="Freeform 2" id="2"/>
+          <p:cNvSpPr/>
+          <p:nvPr/>
+        </p:nvSpPr>
+        <p:spPr>
+          <a:xfrm flipH="false" flipV="false" rot="0">
+            <a:off x="0" y="0"/>
+            <a:ext cx="18288000" cy="10287000"/>
+          </a:xfrm>
+          <a:custGeom>
+            <a:avLst/>
+            <a:gdLst/>
+            <a:ahLst/>
+            <a:cxnLst/>
+            <a:rect r="r" b="b" t="t" l="l"/>
+            <a:pathLst>
+              <a:path h="10287000" w="18288000">
+                <a:moveTo>
+                  <a:pt x="0" y="0"/>
+                </a:moveTo>
+                <a:lnTo>
+                  <a:pt x="18288000" y="0"/>
+                </a:lnTo>
+                <a:lnTo>
+                  <a:pt x="18288000" y="10287000"/>
+                </a:lnTo>
+                <a:lnTo>
+                  <a:pt x="0" y="10287000"/>
+                </a:lnTo>
+                <a:lnTo>
+                  <a:pt x="0" y="0"/>
+                </a:lnTo>
+                <a:close/>
+              </a:path>
+            </a:pathLst>
+          </a:custGeom>
+          <a:blipFill>
+            <a:blip r:embed="rId2"/>
+            <a:stretch>
+              <a:fillRect l="0" t="0" r="0" b="0"/>
+            </a:stretch>
+          </a:blipFill>
+        </p:spPr>
+        <p:txBody>
+          <a:bodyPr/>
+          <a:p/>
+        </p:txBody>
+      </p:sp>
+      <p:sp>
+        <p:nvSpPr>
+          <p:cNvPr name="TextBox 3" id="3"/>
+          <p:cNvSpPr txBox="true"/>
+          <p:nvPr/>
+        </p:nvSpPr>
+        <p:spPr>
+          <a:xfrm rot="0">
+            <a:off x="3520440" y="868680"/>
+            <a:ext cx="12070080" cy="1874519"/>
+          </a:xfrm>
+          <a:prstGeom prst="rect">
+            <a:avLst/>
+          </a:prstGeom>
+        </p:spPr>
+        <p:txBody>
+          <a:bodyPr anchor="ctr" rtlCol="false" tIns="0" lIns="0" bIns="0" rIns="0" wrap="square">
+            <a:spAutoFit/>
+          </a:bodyPr>
+          <a:lstStyle/>
+          <a:p>
+            <a:pPr algn="l" marL="0" indent="0" lvl="0">
+              <a:lnSpc>
+                <a:spcPts val="10481"/>
+              </a:lnSpc>
+              <a:spcBef>
+                <a:spcPct val="0"/>
+              </a:spcBef>
+            </a:pPr>
+            <a:r>
+              <a:rPr lang="en-US" b="0" sz="5400">
+                <a:solidFill>
+                  <a:srgbClr val="FFFFFF"/>
+                </a:solidFill>
+                <a:latin typeface="Arial Black"/>
+                <a:ea typeface="Arial Black"/>
+                <a:cs typeface="Arial Black"/>
+                <a:sym typeface="Arial Black"/>
+              </a:rPr>
+              <a:t>Kahoot</a:t>
+            </a:r>
+          </a:p>
+        </p:txBody>
+      </p:sp>
+      <p:sp>
+        <p:nvSpPr>
+          <p:cNvPr name="Freeform 4" id="4"/>
+          <p:cNvSpPr/>
+          <p:nvPr/>
+        </p:nvSpPr>
+        <p:spPr>
+          <a:xfrm flipH="false" flipV="false" rot="0">
+            <a:off x="536304" y="308054"/>
+            <a:ext cx="650696" cy="409939"/>
+          </a:xfrm>
+          <a:custGeom>
+            <a:avLst/>
+            <a:gdLst/>
+            <a:ahLst/>
+            <a:cxnLst/>
+            <a:rect r="r" b="b" t="t" l="l"/>
+            <a:pathLst>
+              <a:path h="409939" w="650696">
+                <a:moveTo>
+                  <a:pt x="0" y="0"/>
+                </a:moveTo>
+                <a:lnTo>
+                  <a:pt x="650697" y="0"/>
+                </a:lnTo>
+                <a:lnTo>
+                  <a:pt x="650697" y="409938"/>
+                </a:lnTo>
+                <a:lnTo>
+                  <a:pt x="0" y="409938"/>
+                </a:lnTo>
+                <a:lnTo>
+                  <a:pt x="0" y="0"/>
+                </a:lnTo>
+                <a:close/>
+              </a:path>
+            </a:pathLst>
+          </a:custGeom>
+          <a:blipFill>
+            <a:blip r:embed="rId3">
+              <a:extLst>
+                <a:ext uri="{96DAC541-7B7A-43D3-8B79-37D633B846F1}">
+                  <asvg:svgBlip xmlns:asvg="http://schemas.microsoft.com/office/drawing/2016/SVG/main" r:embed="rId4"/>
+                </a:ext>
+              </a:extLst>
+            </a:blip>
+            <a:stretch>
+              <a:fillRect l="0" t="0" r="0" b="0"/>
+            </a:stretch>
+          </a:blipFill>
+        </p:spPr>
+      </p:sp>
+      <p:grpSp>
+        <p:nvGrpSpPr>
+          <p:cNvPr name="Group 5" id="5"/>
+          <p:cNvGrpSpPr/>
+          <p:nvPr/>
+        </p:nvGrpSpPr>
+        <p:grpSpPr>
+          <a:xfrm rot="0">
+            <a:off x="219785" y="9070932"/>
+            <a:ext cx="4151107" cy="986035"/>
+            <a:chOff x="0" y="0"/>
+            <a:chExt cx="5534810" cy="1314713"/>
+          </a:xfrm>
+        </p:grpSpPr>
+        <p:sp>
+          <p:nvSpPr>
+            <p:cNvPr name="Freeform 6" id="6"/>
+            <p:cNvSpPr/>
+            <p:nvPr/>
+          </p:nvSpPr>
+          <p:spPr>
+            <a:xfrm flipH="false" flipV="false" rot="0">
+              <a:off x="0" y="0"/>
+              <a:ext cx="1314713" cy="1314713"/>
+            </a:xfrm>
+            <a:custGeom>
+              <a:avLst/>
+              <a:gdLst/>
+              <a:ahLst/>
+              <a:cxnLst/>
+              <a:rect r="r" b="b" t="t" l="l"/>
+              <a:pathLst>
+                <a:path h="1314713" w="1314713">
+                  <a:moveTo>
+                    <a:pt x="0" y="0"/>
+                  </a:moveTo>
+                  <a:lnTo>
+                    <a:pt x="1314713" y="0"/>
+                  </a:lnTo>
+                  <a:lnTo>
+                    <a:pt x="1314713" y="1314713"/>
+                  </a:lnTo>
+                  <a:lnTo>
+                    <a:pt x="0" y="1314713"/>
+                  </a:lnTo>
+                  <a:lnTo>
+                    <a:pt x="0" y="0"/>
+                  </a:lnTo>
+                  <a:close/>
+                </a:path>
+              </a:pathLst>
+            </a:custGeom>
+            <a:blipFill>
+              <a:blip r:embed="rId5">
+                <a:extLst>
+                  <a:ext uri="{96DAC541-7B7A-43D3-8B79-37D633B846F1}">
+                    <asvg:svgBlip xmlns:asvg="http://schemas.microsoft.com/office/drawing/2016/SVG/main" r:embed="rId6"/>
+                  </a:ext>
+                </a:extLst>
+              </a:blip>
+              <a:stretch>
+                <a:fillRect l="0" t="0" r="0" b="0"/>
+              </a:stretch>
+            </a:blipFill>
+          </p:spPr>
+        </p:sp>
+        <p:sp>
+          <p:nvSpPr>
+            <p:cNvPr name="TextBox 7" id="7"/>
+            <p:cNvSpPr txBox="true"/>
+            <p:nvPr/>
+          </p:nvSpPr>
+          <p:spPr>
+            <a:xfrm rot="0">
+              <a:off x="1455753" y="151974"/>
+              <a:ext cx="3148240" cy="462308"/>
+            </a:xfrm>
+            <a:prstGeom prst="rect">
+              <a:avLst/>
+            </a:prstGeom>
+          </p:spPr>
+          <p:txBody>
+            <a:bodyPr anchor="t" rtlCol="false" tIns="0" lIns="0" bIns="0" rIns="0">
+              <a:spAutoFit/>
+            </a:bodyPr>
+            <a:lstStyle/>
+            <a:p>
+              <a:pPr algn="l">
+                <a:lnSpc>
+                  <a:spcPts val="2702"/>
+                </a:lnSpc>
+              </a:pPr>
+              <a:r>
+                <a:rPr lang="en-US" b="true" sz="2252">
+                  <a:solidFill>
+                    <a:srgbClr val="FFFFFF"/>
+                  </a:solidFill>
+                  <a:latin typeface="Raleway 1 Bold"/>
+                  <a:ea typeface="Raleway 1 Bold"/>
+                  <a:cs typeface="Raleway 1 Bold"/>
+                  <a:sym typeface="Raleway 1 Bold"/>
+                </a:rPr>
+                <a:t>OCTUBRE</a:t>
+              </a:r>
+            </a:p>
+          </p:txBody>
+        </p:sp>
+        <p:sp>
+          <p:nvSpPr>
+            <p:cNvPr name="TextBox 8" id="8"/>
+            <p:cNvSpPr txBox="true"/>
+            <p:nvPr/>
+          </p:nvSpPr>
+          <p:spPr>
+            <a:xfrm rot="0">
+              <a:off x="1468453" y="585710"/>
+              <a:ext cx="4066356" cy="565140"/>
+            </a:xfrm>
+            <a:prstGeom prst="rect">
+              <a:avLst/>
+            </a:prstGeom>
+          </p:spPr>
+          <p:txBody>
+            <a:bodyPr anchor="t" rtlCol="false" tIns="0" lIns="0" bIns="0" rIns="0">
+              <a:spAutoFit/>
+            </a:bodyPr>
+            <a:lstStyle/>
+            <a:p>
+              <a:pPr algn="l">
+                <a:lnSpc>
+                  <a:spcPts val="1130"/>
+                </a:lnSpc>
+              </a:pPr>
+              <a:r>
+                <a:rPr lang="en-US" sz="1097" b="true">
+                  <a:solidFill>
+                    <a:srgbClr val="FFFFFF"/>
+                  </a:solidFill>
+                  <a:latin typeface="Raleway 1 Bold"/>
+                  <a:ea typeface="Raleway 1 Bold"/>
+                  <a:cs typeface="Raleway 1 Bold"/>
+                  <a:sym typeface="Raleway 1 Bold"/>
+                </a:rPr>
+                <a:t>Mes de </a:t>
+              </a:r>
+            </a:p>
+            <a:p>
+              <a:pPr algn="l">
+                <a:lnSpc>
+                  <a:spcPts val="2059"/>
+                </a:lnSpc>
+              </a:pPr>
+              <a:r>
+                <a:rPr lang="en-US" b="true" sz="1999">
+                  <a:solidFill>
+                    <a:srgbClr val="FFFFFF"/>
+                  </a:solidFill>
+                  <a:latin typeface="Raleway 1 Bold"/>
+                  <a:ea typeface="Raleway 1 Bold"/>
+                  <a:cs typeface="Raleway 1 Bold"/>
+                  <a:sym typeface="Raleway 1 Bold"/>
+                </a:rPr>
+                <a:t>HAN SOLO</a:t>
+              </a:r>
+            </a:p>
+          </p:txBody>
+        </p:sp>
+      </p:grpSp>
+      <p:sp>
+        <p:nvSpPr>
+          <p:cNvPr name="TextBox 9" id="9"/>
+          <p:cNvSpPr txBox="true"/>
+          <p:nvPr/>
+        </p:nvSpPr>
+        <p:spPr>
+          <a:xfrm rot="0">
+            <a:off x="1258571" y="221658"/>
+            <a:ext cx="15091730" cy="563680"/>
+          </a:xfrm>
+          <a:prstGeom prst="rect">
+            <a:avLst/>
+          </a:prstGeom>
+        </p:spPr>
+        <p:txBody>
+          <a:bodyPr anchor="t" rtlCol="false" tIns="0" lIns="0" bIns="0" rIns="0">
+            <a:spAutoFit/>
+          </a:bodyPr>
+          <a:lstStyle/>
+          <a:p>
+            <a:pPr algn="l">
+              <a:lnSpc>
+                <a:spcPts val="1760"/>
+              </a:lnSpc>
+            </a:pPr>
+            <a:r>
+              <a:rPr lang="en-US" sz="2000">
+                <a:solidFill>
+                  <a:srgbClr val="316CE3"/>
+                </a:solidFill>
+                <a:latin typeface="Gotham"/>
+                <a:ea typeface="Gotham"/>
+                <a:cs typeface="Gotham"/>
+                <a:sym typeface="Gotham"/>
+              </a:rPr>
+              <a:t>HOY:</a:t>
+            </a:r>
+          </a:p>
+          <a:p>
+            <a:pPr algn="l">
+              <a:lnSpc>
+                <a:spcPts val="2528"/>
+              </a:lnSpc>
+            </a:pPr>
+            <a:r>
+              <a:rPr lang="en-US" sz="2873" b="true">
+                <a:solidFill>
+                  <a:srgbClr val="316CE3"/>
+                </a:solidFill>
+                <a:latin typeface="Gotham Bold"/>
+                <a:ea typeface="Gotham Bold"/>
+                <a:cs typeface="Gotham Bold"/>
+                <a:sym typeface="Gotham Bold"/>
+              </a:rPr>
+              <a:t>Episodio II — El Ataque de los Graviton: Infraestructura y rendimiento</a:t>
+            </a:r>
+          </a:p>
+        </p:txBody>
+      </p:sp>
+      <p:sp>
+        <p:nvSpPr>
+          <p:cNvPr id="10" name="Rounded Rectangle 9"/>
+          <p:cNvSpPr/>
+          <p:nvPr/>
+        </p:nvSpPr>
+        <p:spPr>
+          <a:xfrm>
+            <a:off x="914400" y="3200400"/>
+            <a:ext cx="6812280" cy="4937760"/>
+          </a:xfrm>
+          <a:prstGeom prst="roundRect">
+            <a:avLst>
+              <a:gd name="adj" fmla="val 8000"/>
+            </a:avLst>
+          </a:prstGeom>
+          <a:solidFill>
+            <a:srgbClr val="2F3D52"/>
+          </a:solidFill>
+          <a:ln>
+            <a:noFill/>
+          </a:ln>
+          <a:effectLst/>
+        </p:spPr>
+        <p:style>
+          <a:lnRef idx="1">
+            <a:schemeClr val="accent1"/>
+          </a:lnRef>
+          <a:fillRef idx="3">
+            <a:schemeClr val="accent1"/>
+          </a:fillRef>
+          <a:effectRef idx="2">
+            <a:schemeClr val="accent1"/>
+          </a:effectRef>
+          <a:fontRef idx="minor">
+            <a:schemeClr val="lt1"/>
+          </a:fontRef>
+        </p:style>
+        <p:txBody>
+          <a:bodyPr rtlCol="0" anchor="t" wrap="square" lIns="274320" rIns="274320" tIns="228600" bIns="228600"/>
+          <a:lstStyle/>
+          <a:p>
+            <a:pPr algn="l">
+              <a:spcAft>
+                <a:spcPts val="1800"/>
+              </a:spcAft>
+            </a:pPr>
+            <a:r>
+              <a:rPr sz="2800" b="1">
+                <a:solidFill>
+                  <a:srgbClr val="FFFFFF"/>
+                </a:solidFill>
+                <a:latin typeface="Arial"/>
+              </a:rPr>
+              <a:t>1. ¿Qué procesadores usan los nuevos nodos RG de Redshift?</a:t>
+            </a:r>
+          </a:p>
+          <a:p>
+            <a:pPr algn="l">
+              <a:spcAft>
+                <a:spcPts val="1200"/>
+              </a:spcAft>
+            </a:pPr>
+            <a:r>
+              <a:rPr sz="2700" b="0">
+                <a:solidFill>
+                  <a:srgbClr val="D9E2EC"/>
+                </a:solidFill>
+                <a:latin typeface="Arial"/>
+              </a:rPr>
+              <a:t>a) Intel Xeon</a:t>
+            </a:r>
+          </a:p>
+          <a:p>
+            <a:pPr algn="l">
+              <a:spcAft>
+                <a:spcPts val="1200"/>
+              </a:spcAft>
+            </a:pPr>
+            <a:r>
+              <a:rPr sz="2700" b="0">
+                <a:solidFill>
+                  <a:srgbClr val="D9E2EC"/>
+                </a:solidFill>
+                <a:latin typeface="Arial"/>
+              </a:rPr>
+              <a:t>b) AMD EPYC</a:t>
+            </a:r>
+          </a:p>
+          <a:p>
+            <a:pPr algn="l">
+              <a:spcAft>
+                <a:spcPts val="1200"/>
+              </a:spcAft>
+            </a:pPr>
+            <a:r>
+              <a:rPr sz="2700" b="1">
+                <a:solidFill>
+                  <a:srgbClr val="4CC38A"/>
+                </a:solidFill>
+                <a:latin typeface="Arial"/>
+              </a:rPr>
+              <a:t>c) AWS Graviton</a:t>
+            </a:r>
+          </a:p>
+          <a:p>
+            <a:pPr algn="l">
+              <a:spcAft>
+                <a:spcPts val="1200"/>
+              </a:spcAft>
+            </a:pPr>
+            <a:r>
+              <a:rPr sz="2700" b="0">
+                <a:solidFill>
+                  <a:srgbClr val="D9E2EC"/>
+                </a:solidFill>
+                <a:latin typeface="Arial"/>
+              </a:rPr>
+              <a:t>d) Un hámster muy motivado</a:t>
+            </a:r>
+          </a:p>
+        </p:txBody>
+      </p:sp>
+      <p:sp>
+        <p:nvSpPr>
+          <p:cNvPr id="11" name="Rounded Rectangle 10"/>
+          <p:cNvSpPr/>
+          <p:nvPr/>
+        </p:nvSpPr>
+        <p:spPr>
+          <a:xfrm>
+            <a:off x="8001000" y="3200400"/>
+            <a:ext cx="6812280" cy="4937760"/>
+          </a:xfrm>
+          <a:prstGeom prst="roundRect">
+            <a:avLst>
+              <a:gd name="adj" fmla="val 8000"/>
+            </a:avLst>
+          </a:prstGeom>
+          <a:solidFill>
+            <a:srgbClr val="2F3D52"/>
+          </a:solidFill>
+          <a:ln>
+            <a:noFill/>
+          </a:ln>
+          <a:effectLst/>
+        </p:spPr>
+        <p:style>
+          <a:lnRef idx="1">
+            <a:schemeClr val="accent1"/>
+          </a:lnRef>
+          <a:fillRef idx="3">
+            <a:schemeClr val="accent1"/>
+          </a:fillRef>
+          <a:effectRef idx="2">
+            <a:schemeClr val="accent1"/>
+          </a:effectRef>
+          <a:fontRef idx="minor">
+            <a:schemeClr val="lt1"/>
+          </a:fontRef>
+        </p:style>
+        <p:txBody>
+          <a:bodyPr rtlCol="0" anchor="t" wrap="square" lIns="274320" rIns="274320" tIns="228600" bIns="228600"/>
+          <a:lstStyle/>
+          <a:p>
+            <a:pPr algn="l">
+              <a:spcAft>
+                <a:spcPts val="1800"/>
+              </a:spcAft>
+            </a:pPr>
+            <a:r>
+              <a:rPr sz="2800" b="1">
+                <a:solidFill>
+                  <a:srgbClr val="FFFFFF"/>
+                </a:solidFill>
+                <a:latin typeface="Arial"/>
+              </a:rPr>
+              <a:t>2. ¿Cuánto menos cuesta RG por vCPU frente a RA3?</a:t>
+            </a:r>
+          </a:p>
+          <a:p>
+            <a:pPr algn="l">
+              <a:spcAft>
+                <a:spcPts val="1200"/>
+              </a:spcAft>
+            </a:pPr>
+            <a:r>
+              <a:rPr sz="2700" b="1">
+                <a:solidFill>
+                  <a:srgbClr val="4CC38A"/>
+                </a:solidFill>
+                <a:latin typeface="Arial"/>
+              </a:rPr>
+              <a:t>a) 30 %</a:t>
+            </a:r>
+          </a:p>
+          <a:p>
+            <a:pPr algn="l">
+              <a:spcAft>
+                <a:spcPts val="1200"/>
+              </a:spcAft>
+            </a:pPr>
+            <a:r>
+              <a:rPr sz="2700" b="0">
+                <a:solidFill>
+                  <a:srgbClr val="D9E2EC"/>
+                </a:solidFill>
+                <a:latin typeface="Arial"/>
+              </a:rPr>
+              <a:t>b) 10 %</a:t>
+            </a:r>
+          </a:p>
+          <a:p>
+            <a:pPr algn="l">
+              <a:spcAft>
+                <a:spcPts val="1200"/>
+              </a:spcAft>
+            </a:pPr>
+            <a:r>
+              <a:rPr sz="2700" b="0">
+                <a:solidFill>
+                  <a:srgbClr val="D9E2EC"/>
+                </a:solidFill>
+                <a:latin typeface="Arial"/>
+              </a:rPr>
+              <a:t>c) Te pagan por usarlo</a:t>
+            </a:r>
+          </a:p>
+          <a:p>
+            <a:pPr algn="l">
+              <a:spcAft>
+                <a:spcPts val="1200"/>
+              </a:spcAft>
+            </a:pPr>
+            <a:r>
+              <a:rPr sz="2700" b="0">
+                <a:solidFill>
+                  <a:srgbClr val="D9E2EC"/>
+                </a:solidFill>
+                <a:latin typeface="Arial"/>
+              </a:rPr>
+              <a:t>d) Cuesta lo mismo</a:t>
+            </a:r>
+          </a:p>
+        </p:txBody>
+      </p:sp>
+    </p:spTree>
+  </p:cSld>
+  <p:clrMapOvr>
+    <a:masterClrMapping/>
+  </p:clrMapOvr>
+</p:sld>
+</file>
+
+<file path=ppt/slides/slide38.xml><?xml version="1.0" encoding="utf-8"?>
 <p:sld xmlns:p="http://schemas.openxmlformats.org/presentationml/2006/main" xmlns:a="http://schemas.openxmlformats.org/drawingml/2006/main" xmlns:r="http://schemas.openxmlformats.org/officeDocument/2006/relationships">
   <p:cSld>
     <p:bg>

</xml_diff>